<commit_message>
Clarify mobile HSKK learning experience in report
</commit_message>
<xml_diff>
--- a/reports/HSKK_Harness_Automation_Report.pptx
+++ b/reports/HSKK_Harness_Automation_Report.pptx
@@ -2,15 +2,15 @@
 <file path=ppt/presentation.xml><?xml version="1.0" encoding="utf-8"?>
 <p:presentation xmlns:p="http://schemas.openxmlformats.org/presentationml/2006/main">
   <p:sldMasterIdLst>
-    <p:sldMasterId xmlns:r="http://schemas.openxmlformats.org/officeDocument/2006/relationships" id="2147483648" r:id="R8936dc8f276247a7"/>
+    <p:sldMasterId xmlns:r="http://schemas.openxmlformats.org/officeDocument/2006/relationships" id="2147483648" r:id="R03e3247de61a456d"/>
   </p:sldMasterIdLst>
   <p:notesMasterIdLst>
-    <p:notesMasterId xmlns:r="http://schemas.openxmlformats.org/officeDocument/2006/relationships" r:id="R32239d8a22844637"/>
+    <p:notesMasterId xmlns:r="http://schemas.openxmlformats.org/officeDocument/2006/relationships" r:id="R993b1a4014564f1e"/>
   </p:notesMasterIdLst>
   <p:sldIdLst>
-    <p:sldId xmlns:r="http://schemas.openxmlformats.org/officeDocument/2006/relationships" id="256" r:id="R9272b608fe9d454a"/>
-    <p:sldId xmlns:r="http://schemas.openxmlformats.org/officeDocument/2006/relationships" id="257" r:id="R7cb3df7b5227493a"/>
-    <p:sldId xmlns:r="http://schemas.openxmlformats.org/officeDocument/2006/relationships" id="258" r:id="R9c8af0ffeda34ed2"/>
+    <p:sldId xmlns:r="http://schemas.openxmlformats.org/officeDocument/2006/relationships" id="256" r:id="Rd4801fc07aeb4424"/>
+    <p:sldId xmlns:r="http://schemas.openxmlformats.org/officeDocument/2006/relationships" id="257" r:id="R50eb5d65609b412f"/>
+    <p:sldId xmlns:r="http://schemas.openxmlformats.org/officeDocument/2006/relationships" id="258" r:id="R0a5b8040619b4651"/>
   </p:sldIdLst>
   <p:sldSz cx="12192000" cy="6858000"/>
   <p:notesSz cx="6858000" cy="9144000"/>
@@ -689,7 +689,7 @@
   </p:cSld>
   <p:clrMap bg1="lt1" tx1="dk1" bg2="lt2" tx2="dk2" accent1="accent1" accent2="accent2" accent3="accent3" accent4="accent4" accent5="accent5" accent6="accent6" hlink="hlink" folHlink="folHlink"/>
   <p:sldLayoutIdLst>
-    <p:sldLayoutId xmlns:r="http://schemas.openxmlformats.org/officeDocument/2006/relationships" id="2147483649" r:id="R144ca580b5934610"/>
+    <p:sldLayoutId xmlns:r="http://schemas.openxmlformats.org/officeDocument/2006/relationships" id="2147483649" r:id="R9838a58c83b14387"/>
   </p:sldLayoutIdLst>
   <p:txStyles>
     <p:titleStyle>
@@ -988,7 +988,7 @@
           <p:cNvPr id="1" name="">
             <a:extLst xmlns:a="http://schemas.openxmlformats.org/drawingml/2006/main">
               <a:ext uri="{FF2B5EF4-FFF2-40B4-BE49-F238E27FC236}">
-                <a16:creationId xmlns:a16="http://schemas.microsoft.com/office/drawing/2014/main" id="{CAD61BAA-7440-4E40-A535-4B87D067DA28}"/>
+                <a16:creationId xmlns:a16="http://schemas.microsoft.com/office/drawing/2014/main" id="{C8192444-516D-4B3D-B11E-64363887BC60}"/>
               </a:ext>
             </a:extLst>
           </p:cNvPr>
@@ -1021,7 +1021,7 @@
           <p:cNvPr id="2" name="">
             <a:extLst xmlns:a="http://schemas.openxmlformats.org/drawingml/2006/main">
               <a:ext uri="{FF2B5EF4-FFF2-40B4-BE49-F238E27FC236}">
-                <a16:creationId xmlns:a16="http://schemas.microsoft.com/office/drawing/2014/main" id="{98AF9B63-8A75-4463-8977-878999B9E0E1}"/>
+                <a16:creationId xmlns:a16="http://schemas.microsoft.com/office/drawing/2014/main" id="{4456283F-BE20-4224-83FA-EBD7382FFD24}"/>
               </a:ext>
             </a:extLst>
           </p:cNvPr>
@@ -1054,7 +1054,7 @@
           <p:cNvPr id="3" name="">
             <a:extLst xmlns:a="http://schemas.openxmlformats.org/drawingml/2006/main">
               <a:ext uri="{FF2B5EF4-FFF2-40B4-BE49-F238E27FC236}">
-                <a16:creationId xmlns:a16="http://schemas.microsoft.com/office/drawing/2014/main" id="{FD2D7149-90BE-495E-B647-C68A99CC4649}"/>
+                <a16:creationId xmlns:a16="http://schemas.microsoft.com/office/drawing/2014/main" id="{46EDA063-A198-421B-96AA-94912F1FAC84}"/>
               </a:ext>
             </a:extLst>
           </p:cNvPr>
@@ -1089,7 +1089,7 @@
           <p:cNvPr id="4" name="">
             <a:extLst xmlns:a="http://schemas.openxmlformats.org/drawingml/2006/main">
               <a:ext uri="{FF2B5EF4-FFF2-40B4-BE49-F238E27FC236}">
-                <a16:creationId xmlns:a16="http://schemas.microsoft.com/office/drawing/2014/main" id="{2D1CF106-2177-4F2C-9AA0-02E17274DEE8}"/>
+                <a16:creationId xmlns:a16="http://schemas.microsoft.com/office/drawing/2014/main" id="{7A7F4995-8ADF-4B67-B3DB-634EED2BFDAA}"/>
               </a:ext>
             </a:extLst>
           </p:cNvPr>
@@ -1153,7 +1153,7 @@
           <p:cNvPr id="5" name="">
             <a:extLst xmlns:a="http://schemas.openxmlformats.org/drawingml/2006/main">
               <a:ext uri="{FF2B5EF4-FFF2-40B4-BE49-F238E27FC236}">
-                <a16:creationId xmlns:a16="http://schemas.microsoft.com/office/drawing/2014/main" id="{D0AC0577-09CD-473E-80F0-1EF7E3C8B831}"/>
+                <a16:creationId xmlns:a16="http://schemas.microsoft.com/office/drawing/2014/main" id="{791564F5-4842-482E-BFEE-9C80E080D941}"/>
               </a:ext>
             </a:extLst>
           </p:cNvPr>
@@ -1217,7 +1217,7 @@
           <p:cNvPr id="6" name="">
             <a:extLst xmlns:a="http://schemas.openxmlformats.org/drawingml/2006/main">
               <a:ext uri="{FF2B5EF4-FFF2-40B4-BE49-F238E27FC236}">
-                <a16:creationId xmlns:a16="http://schemas.microsoft.com/office/drawing/2014/main" id="{B66CCC48-F8E1-4327-B4F0-BDB328FE81BC}"/>
+                <a16:creationId xmlns:a16="http://schemas.microsoft.com/office/drawing/2014/main" id="{607333DD-8B0A-4CD7-BD4E-CF61CD715B83}"/>
               </a:ext>
             </a:extLst>
           </p:cNvPr>
@@ -1281,7 +1281,7 @@
           <p:cNvPr id="7" name="">
             <a:extLst xmlns:a="http://schemas.openxmlformats.org/drawingml/2006/main">
               <a:ext uri="{FF2B5EF4-FFF2-40B4-BE49-F238E27FC236}">
-                <a16:creationId xmlns:a16="http://schemas.microsoft.com/office/drawing/2014/main" id="{7E7CDA2B-B0D8-46F6-B3E6-0C2852D98A50}"/>
+                <a16:creationId xmlns:a16="http://schemas.microsoft.com/office/drawing/2014/main" id="{B0624358-486B-4304-9C22-8E57B050FFDB}"/>
               </a:ext>
             </a:extLst>
           </p:cNvPr>
@@ -1368,7 +1368,7 @@
           <p:cNvPr id="8" name="">
             <a:extLst xmlns:a="http://schemas.openxmlformats.org/drawingml/2006/main">
               <a:ext uri="{FF2B5EF4-FFF2-40B4-BE49-F238E27FC236}">
-                <a16:creationId xmlns:a16="http://schemas.microsoft.com/office/drawing/2014/main" id="{EC6E2947-BE95-4976-AEA4-47681AB5F090}"/>
+                <a16:creationId xmlns:a16="http://schemas.microsoft.com/office/drawing/2014/main" id="{5DCC5590-7D38-436F-85BB-1F8EAC6DBA7D}"/>
               </a:ext>
             </a:extLst>
           </p:cNvPr>
@@ -1432,7 +1432,7 @@
           <p:cNvPr id="9" name="">
             <a:extLst xmlns:a="http://schemas.openxmlformats.org/drawingml/2006/main">
               <a:ext uri="{FF2B5EF4-FFF2-40B4-BE49-F238E27FC236}">
-                <a16:creationId xmlns:a16="http://schemas.microsoft.com/office/drawing/2014/main" id="{D074F357-A58E-494B-865B-8C35334BC380}"/>
+                <a16:creationId xmlns:a16="http://schemas.microsoft.com/office/drawing/2014/main" id="{71B494AF-A27E-47D0-8CDB-2E9B444977AA}"/>
               </a:ext>
             </a:extLst>
           </p:cNvPr>
@@ -1519,7 +1519,7 @@
           <p:cNvPr id="10" name="">
             <a:extLst xmlns:a="http://schemas.openxmlformats.org/drawingml/2006/main">
               <a:ext uri="{FF2B5EF4-FFF2-40B4-BE49-F238E27FC236}">
-                <a16:creationId xmlns:a16="http://schemas.microsoft.com/office/drawing/2014/main" id="{6A67E47E-31B0-42FC-A076-8E1D00B052F3}"/>
+                <a16:creationId xmlns:a16="http://schemas.microsoft.com/office/drawing/2014/main" id="{02EA0090-B5A9-4DF4-83FF-EF10D2BF195C}"/>
               </a:ext>
             </a:extLst>
           </p:cNvPr>
@@ -1583,7 +1583,7 @@
           <p:cNvPr id="11" name="">
             <a:extLst xmlns:a="http://schemas.openxmlformats.org/drawingml/2006/main">
               <a:ext uri="{FF2B5EF4-FFF2-40B4-BE49-F238E27FC236}">
-                <a16:creationId xmlns:a16="http://schemas.microsoft.com/office/drawing/2014/main" id="{29F2542D-9EB7-40BB-9914-0AE0E6997A92}"/>
+                <a16:creationId xmlns:a16="http://schemas.microsoft.com/office/drawing/2014/main" id="{9D5F9E7A-34BD-400A-A539-AD29B9CA3362}"/>
               </a:ext>
             </a:extLst>
           </p:cNvPr>
@@ -1670,7 +1670,7 @@
           <p:cNvPr id="12" name="">
             <a:extLst xmlns:a="http://schemas.openxmlformats.org/drawingml/2006/main">
               <a:ext uri="{FF2B5EF4-FFF2-40B4-BE49-F238E27FC236}">
-                <a16:creationId xmlns:a16="http://schemas.microsoft.com/office/drawing/2014/main" id="{3C0D4391-641A-4C73-9CA6-A7D9ED53E44C}"/>
+                <a16:creationId xmlns:a16="http://schemas.microsoft.com/office/drawing/2014/main" id="{6840E336-B4AE-42D8-B764-09A530A4A8FC}"/>
               </a:ext>
             </a:extLst>
           </p:cNvPr>
@@ -1734,7 +1734,7 @@
           <p:cNvPr id="13" name="">
             <a:extLst xmlns:a="http://schemas.openxmlformats.org/drawingml/2006/main">
               <a:ext uri="{FF2B5EF4-FFF2-40B4-BE49-F238E27FC236}">
-                <a16:creationId xmlns:a16="http://schemas.microsoft.com/office/drawing/2014/main" id="{BD4AA4E6-AD74-4871-9B9E-6A6C60426216}"/>
+                <a16:creationId xmlns:a16="http://schemas.microsoft.com/office/drawing/2014/main" id="{572D4533-8B2C-40D0-BBFC-58FB224E2692}"/>
               </a:ext>
             </a:extLst>
           </p:cNvPr>
@@ -1821,7 +1821,7 @@
           <p:cNvPr id="14" name="">
             <a:extLst xmlns:a="http://schemas.openxmlformats.org/drawingml/2006/main">
               <a:ext uri="{FF2B5EF4-FFF2-40B4-BE49-F238E27FC236}">
-                <a16:creationId xmlns:a16="http://schemas.microsoft.com/office/drawing/2014/main" id="{F6A4FDBF-7B1B-4C8C-B7B1-E07F9848240B}"/>
+                <a16:creationId xmlns:a16="http://schemas.microsoft.com/office/drawing/2014/main" id="{D9F43FAB-419C-40F8-816A-05C6AAF44AC0}"/>
               </a:ext>
             </a:extLst>
           </p:cNvPr>
@@ -1856,7 +1856,7 @@
           <p:cNvPr id="15" name="">
             <a:extLst xmlns:a="http://schemas.openxmlformats.org/drawingml/2006/main">
               <a:ext uri="{FF2B5EF4-FFF2-40B4-BE49-F238E27FC236}">
-                <a16:creationId xmlns:a16="http://schemas.microsoft.com/office/drawing/2014/main" id="{E6CBB69F-DFC4-48DB-988F-91AB67CDFEA7}"/>
+                <a16:creationId xmlns:a16="http://schemas.microsoft.com/office/drawing/2014/main" id="{5519ACD8-6EEC-4ACE-90E1-13A616708F17}"/>
               </a:ext>
             </a:extLst>
           </p:cNvPr>
@@ -1920,7 +1920,7 @@
           <p:cNvPr id="16" name="">
             <a:extLst xmlns:a="http://schemas.openxmlformats.org/drawingml/2006/main">
               <a:ext uri="{FF2B5EF4-FFF2-40B4-BE49-F238E27FC236}">
-                <a16:creationId xmlns:a16="http://schemas.microsoft.com/office/drawing/2014/main" id="{AB99A5FC-BC5D-4A18-88FC-D64218A4E30D}"/>
+                <a16:creationId xmlns:a16="http://schemas.microsoft.com/office/drawing/2014/main" id="{F824C52E-3DDF-4DDE-8D81-740A9EB8EFE0}"/>
               </a:ext>
             </a:extLst>
           </p:cNvPr>
@@ -1955,7 +1955,7 @@
           <p:cNvPr id="17" name="">
             <a:extLst xmlns:a="http://schemas.openxmlformats.org/drawingml/2006/main">
               <a:ext uri="{FF2B5EF4-FFF2-40B4-BE49-F238E27FC236}">
-                <a16:creationId xmlns:a16="http://schemas.microsoft.com/office/drawing/2014/main" id="{82C392B6-53CF-445D-BDBD-6BFFACCBC174}"/>
+                <a16:creationId xmlns:a16="http://schemas.microsoft.com/office/drawing/2014/main" id="{7CA32D73-5F5A-4C13-8B2F-D76DD309B4D3}"/>
               </a:ext>
             </a:extLst>
           </p:cNvPr>
@@ -2019,7 +2019,7 @@
           <p:cNvPr id="18" name="">
             <a:extLst xmlns:a="http://schemas.openxmlformats.org/drawingml/2006/main">
               <a:ext uri="{FF2B5EF4-FFF2-40B4-BE49-F238E27FC236}">
-                <a16:creationId xmlns:a16="http://schemas.microsoft.com/office/drawing/2014/main" id="{C083D7CA-CC00-4AB0-9E29-DA03D0DF1249}"/>
+                <a16:creationId xmlns:a16="http://schemas.microsoft.com/office/drawing/2014/main" id="{9C3F5E82-8824-49D5-BB53-CF856E3DE3CA}"/>
               </a:ext>
             </a:extLst>
           </p:cNvPr>
@@ -2052,7 +2052,7 @@
           <p:cNvPr id="19" name="">
             <a:extLst xmlns:a="http://schemas.openxmlformats.org/drawingml/2006/main">
               <a:ext uri="{FF2B5EF4-FFF2-40B4-BE49-F238E27FC236}">
-                <a16:creationId xmlns:a16="http://schemas.microsoft.com/office/drawing/2014/main" id="{1D8F5D23-3355-4E1D-A9DE-D83EE51CB8A0}"/>
+                <a16:creationId xmlns:a16="http://schemas.microsoft.com/office/drawing/2014/main" id="{B7C503D2-FC14-433E-BA35-A5DD8415389B}"/>
               </a:ext>
             </a:extLst>
           </p:cNvPr>
@@ -2087,7 +2087,7 @@
           <p:cNvPr id="20" name="">
             <a:extLst xmlns:a="http://schemas.openxmlformats.org/drawingml/2006/main">
               <a:ext uri="{FF2B5EF4-FFF2-40B4-BE49-F238E27FC236}">
-                <a16:creationId xmlns:a16="http://schemas.microsoft.com/office/drawing/2014/main" id="{BC57AAEC-E6AE-4F3D-8CFB-6D36B6990767}"/>
+                <a16:creationId xmlns:a16="http://schemas.microsoft.com/office/drawing/2014/main" id="{9AB04B23-0D14-44C8-9799-CC60CEB95C11}"/>
               </a:ext>
             </a:extLst>
           </p:cNvPr>
@@ -2151,7 +2151,7 @@
           <p:cNvPr id="21" name="">
             <a:extLst xmlns:a="http://schemas.openxmlformats.org/drawingml/2006/main">
               <a:ext uri="{FF2B5EF4-FFF2-40B4-BE49-F238E27FC236}">
-                <a16:creationId xmlns:a16="http://schemas.microsoft.com/office/drawing/2014/main" id="{8E6E3273-20CD-4E4B-A065-E12A15B8BA14}"/>
+                <a16:creationId xmlns:a16="http://schemas.microsoft.com/office/drawing/2014/main" id="{C3D3DC1C-2462-4AD0-BF12-FD4F2C942757}"/>
               </a:ext>
             </a:extLst>
           </p:cNvPr>
@@ -2184,7 +2184,7 @@
           <p:cNvPr id="22" name="">
             <a:extLst xmlns:a="http://schemas.openxmlformats.org/drawingml/2006/main">
               <a:ext uri="{FF2B5EF4-FFF2-40B4-BE49-F238E27FC236}">
-                <a16:creationId xmlns:a16="http://schemas.microsoft.com/office/drawing/2014/main" id="{DFF48BD4-7C67-40F8-81DA-B82603AD968C}"/>
+                <a16:creationId xmlns:a16="http://schemas.microsoft.com/office/drawing/2014/main" id="{93DBA580-5984-4D71-96C1-7BC3CDE16367}"/>
               </a:ext>
             </a:extLst>
           </p:cNvPr>
@@ -2219,7 +2219,7 @@
           <p:cNvPr id="23" name="">
             <a:extLst xmlns:a="http://schemas.openxmlformats.org/drawingml/2006/main">
               <a:ext uri="{FF2B5EF4-FFF2-40B4-BE49-F238E27FC236}">
-                <a16:creationId xmlns:a16="http://schemas.microsoft.com/office/drawing/2014/main" id="{0BDC85DB-7C72-4ADB-B28C-F858CE0D05D8}"/>
+                <a16:creationId xmlns:a16="http://schemas.microsoft.com/office/drawing/2014/main" id="{F13C90AF-9CA1-454C-8534-190F2B36822C}"/>
               </a:ext>
             </a:extLst>
           </p:cNvPr>
@@ -2283,7 +2283,7 @@
           <p:cNvPr id="24" name="">
             <a:extLst xmlns:a="http://schemas.openxmlformats.org/drawingml/2006/main">
               <a:ext uri="{FF2B5EF4-FFF2-40B4-BE49-F238E27FC236}">
-                <a16:creationId xmlns:a16="http://schemas.microsoft.com/office/drawing/2014/main" id="{A44363A7-20F9-4129-A116-47886FDC0DAD}"/>
+                <a16:creationId xmlns:a16="http://schemas.microsoft.com/office/drawing/2014/main" id="{9D97BFB6-43AF-4591-8881-85F4620EC070}"/>
               </a:ext>
             </a:extLst>
           </p:cNvPr>
@@ -2316,7 +2316,7 @@
           <p:cNvPr id="25" name="">
             <a:extLst xmlns:a="http://schemas.openxmlformats.org/drawingml/2006/main">
               <a:ext uri="{FF2B5EF4-FFF2-40B4-BE49-F238E27FC236}">
-                <a16:creationId xmlns:a16="http://schemas.microsoft.com/office/drawing/2014/main" id="{7F8CF0A7-6FF0-496F-803E-50B7E3666C88}"/>
+                <a16:creationId xmlns:a16="http://schemas.microsoft.com/office/drawing/2014/main" id="{7EFF1CF5-B371-49B2-BB84-64514DEEA3C9}"/>
               </a:ext>
             </a:extLst>
           </p:cNvPr>
@@ -2351,7 +2351,7 @@
           <p:cNvPr id="26" name="">
             <a:extLst xmlns:a="http://schemas.openxmlformats.org/drawingml/2006/main">
               <a:ext uri="{FF2B5EF4-FFF2-40B4-BE49-F238E27FC236}">
-                <a16:creationId xmlns:a16="http://schemas.microsoft.com/office/drawing/2014/main" id="{2218F145-5B23-4216-9712-9B90592FEB6D}"/>
+                <a16:creationId xmlns:a16="http://schemas.microsoft.com/office/drawing/2014/main" id="{0AA60D15-FC88-4ADA-BCA2-8487BF3389C6}"/>
               </a:ext>
             </a:extLst>
           </p:cNvPr>
@@ -2415,7 +2415,7 @@
           <p:cNvPr id="27" name="">
             <a:extLst xmlns:a="http://schemas.openxmlformats.org/drawingml/2006/main">
               <a:ext uri="{FF2B5EF4-FFF2-40B4-BE49-F238E27FC236}">
-                <a16:creationId xmlns:a16="http://schemas.microsoft.com/office/drawing/2014/main" id="{4BA406AA-796C-42FD-ACB5-3E9A62CA9EE7}"/>
+                <a16:creationId xmlns:a16="http://schemas.microsoft.com/office/drawing/2014/main" id="{70AA82F7-8998-4DA0-8385-49ABE0C548EB}"/>
               </a:ext>
             </a:extLst>
           </p:cNvPr>
@@ -2448,7 +2448,7 @@
           <p:cNvPr id="28" name="">
             <a:extLst xmlns:a="http://schemas.openxmlformats.org/drawingml/2006/main">
               <a:ext uri="{FF2B5EF4-FFF2-40B4-BE49-F238E27FC236}">
-                <a16:creationId xmlns:a16="http://schemas.microsoft.com/office/drawing/2014/main" id="{134ED821-6BFE-489F-A328-EC5E9D567068}"/>
+                <a16:creationId xmlns:a16="http://schemas.microsoft.com/office/drawing/2014/main" id="{EF3C8843-BF89-4153-965A-9637ADC1E5BD}"/>
               </a:ext>
             </a:extLst>
           </p:cNvPr>
@@ -2512,7 +2512,7 @@
           <p:cNvPr id="29" name="">
             <a:extLst xmlns:a="http://schemas.openxmlformats.org/drawingml/2006/main">
               <a:ext uri="{FF2B5EF4-FFF2-40B4-BE49-F238E27FC236}">
-                <a16:creationId xmlns:a16="http://schemas.microsoft.com/office/drawing/2014/main" id="{165A0D20-85B7-4833-A040-9FD30DBD80D1}"/>
+                <a16:creationId xmlns:a16="http://schemas.microsoft.com/office/drawing/2014/main" id="{F4DFAFC4-4A4A-4C4E-96ED-8D568CE5D2CF}"/>
               </a:ext>
             </a:extLst>
           </p:cNvPr>
@@ -2574,7 +2574,7 @@
     </p:spTree>
     <p:extLst>
       <p:ext uri="{BB962C8B-B14F-4D97-AF65-F5344CB8AC3E}">
-        <p14:creationId xmlns:p14="http://schemas.microsoft.com/office/powerpoint/2010/main" val="1518501558"/>
+        <p14:creationId xmlns:p14="http://schemas.microsoft.com/office/powerpoint/2010/main" val="1840486998"/>
       </p:ext>
     </p:extLst>
   </p:cSld>
@@ -2598,7 +2598,7 @@
           <p:cNvPr id="1" name="">
             <a:extLst xmlns:a="http://schemas.openxmlformats.org/drawingml/2006/main">
               <a:ext uri="{FF2B5EF4-FFF2-40B4-BE49-F238E27FC236}">
-                <a16:creationId xmlns:a16="http://schemas.microsoft.com/office/drawing/2014/main" id="{31B7B776-55DA-40CC-9167-76CF6FC9173C}"/>
+                <a16:creationId xmlns:a16="http://schemas.microsoft.com/office/drawing/2014/main" id="{2FC29A00-E9EE-45B9-B0EE-FC58DE52C4F6}"/>
               </a:ext>
             </a:extLst>
           </p:cNvPr>
@@ -2631,7 +2631,7 @@
           <p:cNvPr id="2" name="">
             <a:extLst xmlns:a="http://schemas.openxmlformats.org/drawingml/2006/main">
               <a:ext uri="{FF2B5EF4-FFF2-40B4-BE49-F238E27FC236}">
-                <a16:creationId xmlns:a16="http://schemas.microsoft.com/office/drawing/2014/main" id="{B9397D40-339F-4BC0-86E8-AD53097D2706}"/>
+                <a16:creationId xmlns:a16="http://schemas.microsoft.com/office/drawing/2014/main" id="{A255950B-7FD0-418E-9414-544F3185F196}"/>
               </a:ext>
             </a:extLst>
           </p:cNvPr>
@@ -2664,7 +2664,7 @@
           <p:cNvPr id="3" name="">
             <a:extLst xmlns:a="http://schemas.openxmlformats.org/drawingml/2006/main">
               <a:ext uri="{FF2B5EF4-FFF2-40B4-BE49-F238E27FC236}">
-                <a16:creationId xmlns:a16="http://schemas.microsoft.com/office/drawing/2014/main" id="{6D3C2039-7B2D-4523-B3C6-14DCCA27FBC6}"/>
+                <a16:creationId xmlns:a16="http://schemas.microsoft.com/office/drawing/2014/main" id="{1813046C-4D53-43F9-B571-7598B0FCC1BB}"/>
               </a:ext>
             </a:extLst>
           </p:cNvPr>
@@ -2718,7 +2718,7 @@
                 <a:ea typeface="Malgun Gothic"/>
                 <a:cs typeface="Malgun Gothic"/>
               </a:rPr>
-              <a:t>DELIVERED OUTCOMES</a:t>
+              <a:t>MOBILE LEARNING EXPERIENCE</a:t>
             </a:r>
           </a:p>
         </p:txBody>
@@ -2728,7 +2728,7 @@
           <p:cNvPr id="4" name="">
             <a:extLst xmlns:a="http://schemas.openxmlformats.org/drawingml/2006/main">
               <a:ext uri="{FF2B5EF4-FFF2-40B4-BE49-F238E27FC236}">
-                <a16:creationId xmlns:a16="http://schemas.microsoft.com/office/drawing/2014/main" id="{70266E9A-0F74-43FC-80E9-99F199ED1A2B}"/>
+                <a16:creationId xmlns:a16="http://schemas.microsoft.com/office/drawing/2014/main" id="{859EF9C5-84CC-40C0-A2B7-FC47CEDAACAA}"/>
               </a:ext>
             </a:extLst>
           </p:cNvPr>
@@ -2792,7 +2792,7 @@
           <p:cNvPr id="5" name="">
             <a:extLst xmlns:a="http://schemas.openxmlformats.org/drawingml/2006/main">
               <a:ext uri="{FF2B5EF4-FFF2-40B4-BE49-F238E27FC236}">
-                <a16:creationId xmlns:a16="http://schemas.microsoft.com/office/drawing/2014/main" id="{9DAD248A-8BB7-484C-A904-272FBD374FF0}"/>
+                <a16:creationId xmlns:a16="http://schemas.microsoft.com/office/drawing/2014/main" id="{ABD77541-47A6-47B0-8AFE-5EAF2955E56A}"/>
               </a:ext>
             </a:extLst>
           </p:cNvPr>
@@ -2846,7 +2846,7 @@
                 <a:ea typeface="Malgun Gothic"/>
                 <a:cs typeface="Malgun Gothic"/>
               </a:rPr>
-              <a:t>자료 묶음이 아니라, 매일 동작하는 학습 시스템을 만들었습니다.</a:t>
+              <a:t>생성된 학습 페이지를 홈 화면에 추가하고, 매일 아침 카톡으로 다시 만납니다.</a:t>
             </a:r>
           </a:p>
         </p:txBody>
@@ -2856,7 +2856,7 @@
           <p:cNvPr id="6" name="">
             <a:extLst xmlns:a="http://schemas.openxmlformats.org/drawingml/2006/main">
               <a:ext uri="{FF2B5EF4-FFF2-40B4-BE49-F238E27FC236}">
-                <a16:creationId xmlns:a16="http://schemas.microsoft.com/office/drawing/2014/main" id="{F1BCEE39-C2E4-4876-B7D9-9BC596BC91D8}"/>
+                <a16:creationId xmlns:a16="http://schemas.microsoft.com/office/drawing/2014/main" id="{FE12C61B-78C1-4DE0-8371-23BB69E3360E}"/>
               </a:ext>
             </a:extLst>
           </p:cNvPr>
@@ -2910,7 +2910,7 @@
                 <a:ea typeface="Malgun Gothic"/>
                 <a:cs typeface="Malgun Gothic"/>
               </a:rPr>
-              <a:t>학습자가 휴대폰에서 열고 말하면 되는 구조로 과제를 끝까지 연결했습니다.</a:t>
+              <a:t>GitHub Pages URL은 고정됩니다. 사용자는 앱처럼 필요할 때 열고, 오전 8시 알림으로 학습 루틴을 이어갑니다.</a:t>
             </a:r>
           </a:p>
         </p:txBody>
@@ -2920,31 +2920,31 @@
           <p:cNvPr id="7" name="">
             <a:extLst xmlns:a="http://schemas.openxmlformats.org/drawingml/2006/main">
               <a:ext uri="{FF2B5EF4-FFF2-40B4-BE49-F238E27FC236}">
-                <a16:creationId xmlns:a16="http://schemas.microsoft.com/office/drawing/2014/main" id="{CF160F84-DC84-48FA-8917-D4921AC0198A}"/>
-              </a:ext>
-            </a:extLst>
-          </p:cNvPr>
-          <p:cNvSpPr>
-            <a:spLocks xmlns:a="http://schemas.openxmlformats.org/drawingml/2006/main" noGrp="1"/>
-          </p:cNvSpPr>
-          <p:nvPr/>
-        </p:nvSpPr>
-        <p:spPr>
-          <a:xfrm xmlns:a="http://schemas.openxmlformats.org/drawingml/2006/main">
-            <a:off x="723900" y="2381250"/>
-            <a:ext cx="2552700" cy="1428750"/>
+                <a16:creationId xmlns:a16="http://schemas.microsoft.com/office/drawing/2014/main" id="{592453F6-AEDD-42EE-B26B-B39686AFF4C7}"/>
+              </a:ext>
+            </a:extLst>
+          </p:cNvPr>
+          <p:cNvSpPr>
+            <a:spLocks xmlns:a="http://schemas.openxmlformats.org/drawingml/2006/main" noGrp="1"/>
+          </p:cNvSpPr>
+          <p:nvPr/>
+        </p:nvSpPr>
+        <p:spPr>
+          <a:xfrm xmlns:a="http://schemas.openxmlformats.org/drawingml/2006/main">
+            <a:off x="723900" y="2266950"/>
+            <a:ext cx="2076450" cy="3105150"/>
           </a:xfrm>
           <a:prstGeom xmlns:a="http://schemas.openxmlformats.org/drawingml/2006/main" prst="roundRect">
             <a:avLst>
-              <a:gd name="adj" fmla="val 5333"/>
+              <a:gd name="adj" fmla="val 3670"/>
             </a:avLst>
           </a:prstGeom>
           <a:solidFill xmlns:a="http://schemas.openxmlformats.org/drawingml/2006/main">
-            <a:srgbClr val="FFFFFF"/>
-          </a:solidFill>
-          <a:ln xmlns:a="http://schemas.openxmlformats.org/drawingml/2006/main" w="9525">
-            <a:solidFill>
-              <a:srgbClr val="C9D5D8"/>
+            <a:srgbClr val="153438"/>
+          </a:solidFill>
+          <a:ln xmlns:a="http://schemas.openxmlformats.org/drawingml/2006/main" w="0">
+            <a:solidFill>
+              <a:srgbClr val="153438"/>
             </a:solidFill>
             <a:prstDash val="solid"/>
           </a:ln>
@@ -2955,31 +2955,31 @@
           <p:cNvPr id="8" name="">
             <a:extLst xmlns:a="http://schemas.openxmlformats.org/drawingml/2006/main">
               <a:ext uri="{FF2B5EF4-FFF2-40B4-BE49-F238E27FC236}">
-                <a16:creationId xmlns:a16="http://schemas.microsoft.com/office/drawing/2014/main" id="{EFBB8174-D595-4104-AC53-F7B2DE05C43A}"/>
-              </a:ext>
-            </a:extLst>
-          </p:cNvPr>
-          <p:cNvSpPr>
-            <a:spLocks xmlns:a="http://schemas.openxmlformats.org/drawingml/2006/main" noGrp="1"/>
-          </p:cNvSpPr>
-          <p:nvPr/>
-        </p:nvSpPr>
-        <p:spPr>
-          <a:xfrm xmlns:a="http://schemas.openxmlformats.org/drawingml/2006/main">
-            <a:off x="723900" y="2381250"/>
-            <a:ext cx="66675" cy="1428750"/>
+                <a16:creationId xmlns:a16="http://schemas.microsoft.com/office/drawing/2014/main" id="{6C08D76F-A135-4D51-97F1-8860747CB293}"/>
+              </a:ext>
+            </a:extLst>
+          </p:cNvPr>
+          <p:cNvSpPr>
+            <a:spLocks xmlns:a="http://schemas.openxmlformats.org/drawingml/2006/main" noGrp="1"/>
+          </p:cNvSpPr>
+          <p:nvPr/>
+        </p:nvSpPr>
+        <p:spPr>
+          <a:xfrm xmlns:a="http://schemas.openxmlformats.org/drawingml/2006/main">
+            <a:off x="857250" y="2419350"/>
+            <a:ext cx="1809750" cy="2781300"/>
           </a:xfrm>
           <a:prstGeom xmlns:a="http://schemas.openxmlformats.org/drawingml/2006/main" prst="roundRect">
             <a:avLst>
-              <a:gd name="adj" fmla="val 50000"/>
+              <a:gd name="adj" fmla="val 4211"/>
             </a:avLst>
           </a:prstGeom>
           <a:solidFill xmlns:a="http://schemas.openxmlformats.org/drawingml/2006/main">
-            <a:srgbClr val="E76F51"/>
-          </a:solidFill>
-          <a:ln xmlns:a="http://schemas.openxmlformats.org/drawingml/2006/main" w="0">
-            <a:solidFill>
-              <a:srgbClr val="E76F51"/>
+            <a:srgbClr val="FFFFFF"/>
+          </a:solidFill>
+          <a:ln xmlns:a="http://schemas.openxmlformats.org/drawingml/2006/main" w="0">
+            <a:solidFill>
+              <a:srgbClr val="FFFFFF"/>
             </a:solidFill>
             <a:prstDash val="solid"/>
           </a:ln>
@@ -2990,19 +2990,19 @@
           <p:cNvPr id="9" name="">
             <a:extLst xmlns:a="http://schemas.openxmlformats.org/drawingml/2006/main">
               <a:ext uri="{FF2B5EF4-FFF2-40B4-BE49-F238E27FC236}">
-                <a16:creationId xmlns:a16="http://schemas.microsoft.com/office/drawing/2014/main" id="{5EDA713E-EF83-46CD-B592-2BF2560DB8C1}"/>
-              </a:ext>
-            </a:extLst>
-          </p:cNvPr>
-          <p:cNvSpPr>
-            <a:spLocks xmlns:a="http://schemas.openxmlformats.org/drawingml/2006/main" noGrp="1"/>
-          </p:cNvSpPr>
-          <p:nvPr/>
-        </p:nvSpPr>
-        <p:spPr>
-          <a:xfrm xmlns:a="http://schemas.openxmlformats.org/drawingml/2006/main">
-            <a:off x="914400" y="2552700"/>
-            <a:ext cx="2228850" cy="266700"/>
+                <a16:creationId xmlns:a16="http://schemas.microsoft.com/office/drawing/2014/main" id="{B905E03D-412C-4B4A-A476-AD04A9EB804F}"/>
+              </a:ext>
+            </a:extLst>
+          </p:cNvPr>
+          <p:cNvSpPr>
+            <a:spLocks xmlns:a="http://schemas.openxmlformats.org/drawingml/2006/main" noGrp="1"/>
+          </p:cNvSpPr>
+          <p:nvPr/>
+        </p:nvSpPr>
+        <p:spPr>
+          <a:xfrm xmlns:a="http://schemas.openxmlformats.org/drawingml/2006/main">
+            <a:off x="1047750" y="2628900"/>
+            <a:ext cx="1333500" cy="247650"/>
           </a:xfrm>
           <a:prstGeom xmlns:a="http://schemas.openxmlformats.org/drawingml/2006/main" prst="rect">
             <a:avLst/>
@@ -3044,7 +3044,7 @@
                 <a:ea typeface="Malgun Gothic"/>
                 <a:cs typeface="Malgun Gothic"/>
               </a:rPr>
-              <a:t>BEFORE</a:t>
+              <a:t>HSKK Study</a:t>
             </a:r>
           </a:p>
         </p:txBody>
@@ -3054,19 +3054,54 @@
           <p:cNvPr id="10" name="">
             <a:extLst xmlns:a="http://schemas.openxmlformats.org/drawingml/2006/main">
               <a:ext uri="{FF2B5EF4-FFF2-40B4-BE49-F238E27FC236}">
-                <a16:creationId xmlns:a16="http://schemas.microsoft.com/office/drawing/2014/main" id="{EC16DBF5-9306-4D7D-8246-61CBBFE4A410}"/>
-              </a:ext>
-            </a:extLst>
-          </p:cNvPr>
-          <p:cNvSpPr>
-            <a:spLocks xmlns:a="http://schemas.openxmlformats.org/drawingml/2006/main" noGrp="1"/>
-          </p:cNvSpPr>
-          <p:nvPr/>
-        </p:nvSpPr>
-        <p:spPr>
-          <a:xfrm xmlns:a="http://schemas.openxmlformats.org/drawingml/2006/main">
-            <a:off x="914400" y="2895600"/>
-            <a:ext cx="2228850" cy="762000"/>
+                <a16:creationId xmlns:a16="http://schemas.microsoft.com/office/drawing/2014/main" id="{6A0AD9BF-7398-432A-A039-A7D1B951F651}"/>
+              </a:ext>
+            </a:extLst>
+          </p:cNvPr>
+          <p:cNvSpPr>
+            <a:spLocks xmlns:a="http://schemas.openxmlformats.org/drawingml/2006/main" noGrp="1"/>
+          </p:cNvSpPr>
+          <p:nvPr/>
+        </p:nvSpPr>
+        <p:spPr>
+          <a:xfrm xmlns:a="http://schemas.openxmlformats.org/drawingml/2006/main">
+            <a:off x="1047750" y="3105150"/>
+            <a:ext cx="990600" cy="266700"/>
+          </a:xfrm>
+          <a:prstGeom xmlns:a="http://schemas.openxmlformats.org/drawingml/2006/main" prst="roundRect">
+            <a:avLst>
+              <a:gd name="adj" fmla="val 28571"/>
+            </a:avLst>
+          </a:prstGeom>
+          <a:solidFill xmlns:a="http://schemas.openxmlformats.org/drawingml/2006/main">
+            <a:srgbClr val="DFEFEC"/>
+          </a:solidFill>
+          <a:ln xmlns:a="http://schemas.openxmlformats.org/drawingml/2006/main" w="0">
+            <a:solidFill>
+              <a:srgbClr val="DFEFEC"/>
+            </a:solidFill>
+            <a:prstDash val="solid"/>
+          </a:ln>
+        </p:spPr>
+      </p:sp>
+      <p:sp>
+        <p:nvSpPr>
+          <p:cNvPr id="11" name="">
+            <a:extLst xmlns:a="http://schemas.openxmlformats.org/drawingml/2006/main">
+              <a:ext uri="{FF2B5EF4-FFF2-40B4-BE49-F238E27FC236}">
+                <a16:creationId xmlns:a16="http://schemas.microsoft.com/office/drawing/2014/main" id="{42F0C39B-20BC-45E0-9146-E74AC1292AFC}"/>
+              </a:ext>
+            </a:extLst>
+          </p:cNvPr>
+          <p:cNvSpPr>
+            <a:spLocks xmlns:a="http://schemas.openxmlformats.org/drawingml/2006/main" noGrp="1"/>
+          </p:cNvSpPr>
+          <p:nvPr/>
+        </p:nvSpPr>
+        <p:spPr>
+          <a:xfrm xmlns:a="http://schemas.openxmlformats.org/drawingml/2006/main">
+            <a:off x="1047750" y="3152775"/>
+            <a:ext cx="990600" cy="171450"/>
           </a:xfrm>
           <a:prstGeom xmlns:a="http://schemas.openxmlformats.org/drawingml/2006/main" prst="rect">
             <a:avLst/>
@@ -3089,97 +3124,53 @@
           <a:bodyPr xmlns:a="http://schemas.openxmlformats.org/drawingml/2006/main" lIns="0" tIns="0" rIns="0" bIns="0" anchor="t"/>
           <a:lstStyle xmlns:a="http://schemas.openxmlformats.org/drawingml/2006/main"/>
           <a:p xmlns:a="http://schemas.openxmlformats.org/drawingml/2006/main">
-            <a:pPr algn="l">
-              <a:defRPr sz="1125" b="0">
-                <a:solidFill>
-                  <a:srgbClr val="60707A"/>
-                </a:solidFill>
-                <a:latin typeface="Malgun Gothic"/>
-                <a:ea typeface="Malgun Gothic"/>
-                <a:cs typeface="Malgun Gothic"/>
-              </a:defRPr>
-            </a:pPr>
-            <a:r>
-              <a:rPr sz="1125" b="0">
-                <a:solidFill>
-                  <a:srgbClr val="60707A"/>
-                </a:solidFill>
-                <a:latin typeface="Malgun Gothic"/>
-                <a:ea typeface="Malgun Gothic"/>
-                <a:cs typeface="Malgun Gothic"/>
-              </a:rPr>
-              <a:t>Harness 파일은 존재하지만</a:t>
-            </a:r>
-          </a:p>
-          <a:p xmlns:a="http://schemas.openxmlformats.org/drawingml/2006/main">
-            <a:pPr algn="l">
-              <a:defRPr sz="1125" b="0">
-                <a:solidFill>
-                  <a:srgbClr val="60707A"/>
-                </a:solidFill>
-                <a:latin typeface="Malgun Gothic"/>
-                <a:ea typeface="Malgun Gothic"/>
-                <a:cs typeface="Malgun Gothic"/>
-              </a:defRPr>
-            </a:pPr>
-            <a:r>
-              <a:rPr sz="1125" b="0">
-                <a:solidFill>
-                  <a:srgbClr val="60707A"/>
-                </a:solidFill>
-                <a:latin typeface="Malgun Gothic"/>
-                <a:ea typeface="Malgun Gothic"/>
-                <a:cs typeface="Malgun Gothic"/>
-              </a:rPr>
-              <a:t>학습자가 매일 무엇을 열고</a:t>
-            </a:r>
-          </a:p>
-          <a:p xmlns:a="http://schemas.openxmlformats.org/drawingml/2006/main">
-            <a:pPr algn="l">
-              <a:defRPr sz="1125" b="0">
-                <a:solidFill>
-                  <a:srgbClr val="60707A"/>
-                </a:solidFill>
-                <a:latin typeface="Malgun Gothic"/>
-                <a:ea typeface="Malgun Gothic"/>
-                <a:cs typeface="Malgun Gothic"/>
-              </a:defRPr>
-            </a:pPr>
-            <a:r>
-              <a:rPr sz="1125" b="0">
-                <a:solidFill>
-                  <a:srgbClr val="60707A"/>
-                </a:solidFill>
-                <a:latin typeface="Malgun Gothic"/>
-                <a:ea typeface="Malgun Gothic"/>
-                <a:cs typeface="Malgun Gothic"/>
-              </a:rPr>
-              <a:t>어떻게 반복할지 연결이 약함</a:t>
-            </a:r>
-          </a:p>
-        </p:txBody>
-      </p:sp>
-      <p:sp>
-        <p:nvSpPr>
-          <p:cNvPr id="11" name="">
-            <a:extLst xmlns:a="http://schemas.openxmlformats.org/drawingml/2006/main">
-              <a:ext uri="{FF2B5EF4-FFF2-40B4-BE49-F238E27FC236}">
-                <a16:creationId xmlns:a16="http://schemas.microsoft.com/office/drawing/2014/main" id="{520483F8-3597-4D20-8151-4A4F4AF2E1EA}"/>
-              </a:ext>
-            </a:extLst>
-          </p:cNvPr>
-          <p:cNvSpPr>
-            <a:spLocks xmlns:a="http://schemas.openxmlformats.org/drawingml/2006/main" noGrp="1"/>
-          </p:cNvSpPr>
-          <p:nvPr/>
-        </p:nvSpPr>
-        <p:spPr>
-          <a:xfrm xmlns:a="http://schemas.openxmlformats.org/drawingml/2006/main">
-            <a:off x="3562350" y="3000375"/>
-            <a:ext cx="1143000" cy="28575"/>
-          </a:xfrm>
-          <a:prstGeom xmlns:a="http://schemas.openxmlformats.org/drawingml/2006/main" prst="rect">
-            <a:avLst/>
+            <a:pPr algn="ctr">
+              <a:defRPr sz="975" b="1">
+                <a:solidFill>
+                  <a:srgbClr val="0F766E"/>
+                </a:solidFill>
+                <a:latin typeface="Malgun Gothic"/>
+                <a:ea typeface="Malgun Gothic"/>
+                <a:cs typeface="Malgun Gothic"/>
+              </a:defRPr>
+            </a:pPr>
+            <a:r>
+              <a:rPr sz="975" b="1">
+                <a:solidFill>
+                  <a:srgbClr val="0F766E"/>
+                </a:solidFill>
+                <a:latin typeface="Malgun Gothic"/>
+                <a:ea typeface="Malgun Gothic"/>
+                <a:cs typeface="Malgun Gothic"/>
+              </a:rPr>
+              <a:t>HOME SCREEN</a:t>
+            </a:r>
+          </a:p>
+        </p:txBody>
+      </p:sp>
+      <p:sp>
+        <p:nvSpPr>
+          <p:cNvPr id="12" name="">
+            <a:extLst xmlns:a="http://schemas.openxmlformats.org/drawingml/2006/main">
+              <a:ext uri="{FF2B5EF4-FFF2-40B4-BE49-F238E27FC236}">
+                <a16:creationId xmlns:a16="http://schemas.microsoft.com/office/drawing/2014/main" id="{05FF47F1-F12B-4D13-8494-C126FA890D7A}"/>
+              </a:ext>
+            </a:extLst>
+          </p:cNvPr>
+          <p:cNvSpPr>
+            <a:spLocks xmlns:a="http://schemas.openxmlformats.org/drawingml/2006/main" noGrp="1"/>
+          </p:cNvSpPr>
+          <p:nvPr/>
+        </p:nvSpPr>
+        <p:spPr>
+          <a:xfrm xmlns:a="http://schemas.openxmlformats.org/drawingml/2006/main">
+            <a:off x="1047750" y="3600450"/>
+            <a:ext cx="552450" cy="552450"/>
+          </a:xfrm>
+          <a:prstGeom xmlns:a="http://schemas.openxmlformats.org/drawingml/2006/main" prst="roundRect">
+            <a:avLst>
+              <a:gd name="adj" fmla="val 13793"/>
+            </a:avLst>
           </a:prstGeom>
           <a:solidFill xmlns:a="http://schemas.openxmlformats.org/drawingml/2006/main">
             <a:srgbClr val="0F766E"/>
@@ -3194,22 +3185,22 @@
       </p:sp>
       <p:sp>
         <p:nvSpPr>
-          <p:cNvPr id="12" name="">
-            <a:extLst xmlns:a="http://schemas.openxmlformats.org/drawingml/2006/main">
-              <a:ext uri="{FF2B5EF4-FFF2-40B4-BE49-F238E27FC236}">
-                <a16:creationId xmlns:a16="http://schemas.microsoft.com/office/drawing/2014/main" id="{30BE8A89-5239-414A-8E9A-D942AE87C786}"/>
-              </a:ext>
-            </a:extLst>
-          </p:cNvPr>
-          <p:cNvSpPr>
-            <a:spLocks xmlns:a="http://schemas.openxmlformats.org/drawingml/2006/main" noGrp="1"/>
-          </p:cNvSpPr>
-          <p:nvPr/>
-        </p:nvSpPr>
-        <p:spPr>
-          <a:xfrm xmlns:a="http://schemas.openxmlformats.org/drawingml/2006/main">
-            <a:off x="4686300" y="2847975"/>
-            <a:ext cx="209550" cy="323850"/>
+          <p:cNvPr id="13" name="">
+            <a:extLst xmlns:a="http://schemas.openxmlformats.org/drawingml/2006/main">
+              <a:ext uri="{FF2B5EF4-FFF2-40B4-BE49-F238E27FC236}">
+                <a16:creationId xmlns:a16="http://schemas.microsoft.com/office/drawing/2014/main" id="{9C20F484-4508-44BD-A744-C8961E5AC02B}"/>
+              </a:ext>
+            </a:extLst>
+          </p:cNvPr>
+          <p:cNvSpPr>
+            <a:spLocks xmlns:a="http://schemas.openxmlformats.org/drawingml/2006/main" noGrp="1"/>
+          </p:cNvSpPr>
+          <p:nvPr/>
+        </p:nvSpPr>
+        <p:spPr>
+          <a:xfrm xmlns:a="http://schemas.openxmlformats.org/drawingml/2006/main">
+            <a:off x="1047750" y="3781425"/>
+            <a:ext cx="552450" cy="190500"/>
           </a:xfrm>
           <a:prstGeom xmlns:a="http://schemas.openxmlformats.org/drawingml/2006/main" prst="rect">
             <a:avLst/>
@@ -3233,47 +3224,47 @@
           <a:lstStyle xmlns:a="http://schemas.openxmlformats.org/drawingml/2006/main"/>
           <a:p xmlns:a="http://schemas.openxmlformats.org/drawingml/2006/main">
             <a:pPr algn="ctr">
-              <a:defRPr sz="1950" b="1">
-                <a:solidFill>
-                  <a:srgbClr val="0F766E"/>
-                </a:solidFill>
-                <a:latin typeface="Malgun Gothic"/>
-                <a:ea typeface="Malgun Gothic"/>
-                <a:cs typeface="Malgun Gothic"/>
-              </a:defRPr>
-            </a:pPr>
-            <a:r>
-              <a:rPr sz="1950" b="1">
-                <a:solidFill>
-                  <a:srgbClr val="0F766E"/>
-                </a:solidFill>
-                <a:latin typeface="Malgun Gothic"/>
-                <a:ea typeface="Malgun Gothic"/>
-                <a:cs typeface="Malgun Gothic"/>
-              </a:rPr>
-              <a:t>&gt;</a:t>
-            </a:r>
-          </a:p>
-        </p:txBody>
-      </p:sp>
-      <p:sp>
-        <p:nvSpPr>
-          <p:cNvPr id="13" name="">
-            <a:extLst xmlns:a="http://schemas.openxmlformats.org/drawingml/2006/main">
-              <a:ext uri="{FF2B5EF4-FFF2-40B4-BE49-F238E27FC236}">
-                <a16:creationId xmlns:a16="http://schemas.microsoft.com/office/drawing/2014/main" id="{0C1889FD-0503-4D30-A8F4-0EBE8696DE27}"/>
-              </a:ext>
-            </a:extLst>
-          </p:cNvPr>
-          <p:cNvSpPr>
-            <a:spLocks xmlns:a="http://schemas.openxmlformats.org/drawingml/2006/main" noGrp="1"/>
-          </p:cNvSpPr>
-          <p:nvPr/>
-        </p:nvSpPr>
-        <p:spPr>
-          <a:xfrm xmlns:a="http://schemas.openxmlformats.org/drawingml/2006/main">
-            <a:off x="3562350" y="2686050"/>
-            <a:ext cx="1047750" cy="171450"/>
+              <a:defRPr sz="1050" b="1">
+                <a:solidFill>
+                  <a:srgbClr val="FFFFFF"/>
+                </a:solidFill>
+                <a:latin typeface="Malgun Gothic"/>
+                <a:ea typeface="Malgun Gothic"/>
+                <a:cs typeface="Malgun Gothic"/>
+              </a:defRPr>
+            </a:pPr>
+            <a:r>
+              <a:rPr sz="1050" b="1">
+                <a:solidFill>
+                  <a:srgbClr val="FFFFFF"/>
+                </a:solidFill>
+                <a:latin typeface="Malgun Gothic"/>
+                <a:ea typeface="Malgun Gothic"/>
+                <a:cs typeface="Malgun Gothic"/>
+              </a:rPr>
+              <a:t>HSKK</a:t>
+            </a:r>
+          </a:p>
+        </p:txBody>
+      </p:sp>
+      <p:sp>
+        <p:nvSpPr>
+          <p:cNvPr id="14" name="">
+            <a:extLst xmlns:a="http://schemas.openxmlformats.org/drawingml/2006/main">
+              <a:ext uri="{FF2B5EF4-FFF2-40B4-BE49-F238E27FC236}">
+                <a16:creationId xmlns:a16="http://schemas.microsoft.com/office/drawing/2014/main" id="{2FD9F3A4-76FB-4C5B-9FA2-9556A7F4E981}"/>
+              </a:ext>
+            </a:extLst>
+          </p:cNvPr>
+          <p:cNvSpPr>
+            <a:spLocks xmlns:a="http://schemas.openxmlformats.org/drawingml/2006/main" noGrp="1"/>
+          </p:cNvSpPr>
+          <p:nvPr/>
+        </p:nvSpPr>
+        <p:spPr>
+          <a:xfrm xmlns:a="http://schemas.openxmlformats.org/drawingml/2006/main">
+            <a:off x="1047750" y="4324350"/>
+            <a:ext cx="1409700" cy="228600"/>
           </a:xfrm>
           <a:prstGeom xmlns:a="http://schemas.openxmlformats.org/drawingml/2006/main" prst="rect">
             <a:avLst/>
@@ -3296,118 +3287,48 @@
           <a:bodyPr xmlns:a="http://schemas.openxmlformats.org/drawingml/2006/main" lIns="0" tIns="0" rIns="0" bIns="0" anchor="t"/>
           <a:lstStyle xmlns:a="http://schemas.openxmlformats.org/drawingml/2006/main"/>
           <a:p xmlns:a="http://schemas.openxmlformats.org/drawingml/2006/main">
-            <a:pPr algn="ctr">
-              <a:defRPr sz="900" b="1">
-                <a:solidFill>
-                  <a:srgbClr val="60707A"/>
-                </a:solidFill>
-                <a:latin typeface="Malgun Gothic"/>
-                <a:ea typeface="Malgun Gothic"/>
-                <a:cs typeface="Malgun Gothic"/>
-              </a:defRPr>
-            </a:pPr>
-            <a:r>
-              <a:rPr sz="900" b="1">
-                <a:solidFill>
-                  <a:srgbClr val="60707A"/>
-                </a:solidFill>
-                <a:latin typeface="Malgun Gothic"/>
-                <a:ea typeface="Malgun Gothic"/>
-                <a:cs typeface="Malgun Gothic"/>
-              </a:rPr>
-              <a:t>전환</a:t>
-            </a:r>
-          </a:p>
-        </p:txBody>
-      </p:sp>
-      <p:sp>
-        <p:nvSpPr>
-          <p:cNvPr id="14" name="">
-            <a:extLst xmlns:a="http://schemas.openxmlformats.org/drawingml/2006/main">
-              <a:ext uri="{FF2B5EF4-FFF2-40B4-BE49-F238E27FC236}">
-                <a16:creationId xmlns:a16="http://schemas.microsoft.com/office/drawing/2014/main" id="{7864823E-5643-4B85-A9BF-7C20754437D3}"/>
-              </a:ext>
-            </a:extLst>
-          </p:cNvPr>
-          <p:cNvSpPr>
-            <a:spLocks xmlns:a="http://schemas.openxmlformats.org/drawingml/2006/main" noGrp="1"/>
-          </p:cNvSpPr>
-          <p:nvPr/>
-        </p:nvSpPr>
-        <p:spPr>
-          <a:xfrm xmlns:a="http://schemas.openxmlformats.org/drawingml/2006/main">
-            <a:off x="5162550" y="2381250"/>
-            <a:ext cx="2552700" cy="1428750"/>
-          </a:xfrm>
-          <a:prstGeom xmlns:a="http://schemas.openxmlformats.org/drawingml/2006/main" prst="roundRect">
-            <a:avLst>
-              <a:gd name="adj" fmla="val 5333"/>
-            </a:avLst>
-          </a:prstGeom>
-          <a:solidFill xmlns:a="http://schemas.openxmlformats.org/drawingml/2006/main">
-            <a:srgbClr val="FFFFFF"/>
-          </a:solidFill>
-          <a:ln xmlns:a="http://schemas.openxmlformats.org/drawingml/2006/main" w="9525">
-            <a:solidFill>
-              <a:srgbClr val="C9D5D8"/>
-            </a:solidFill>
-            <a:prstDash val="solid"/>
-          </a:ln>
-        </p:spPr>
+            <a:pPr algn="l">
+              <a:defRPr sz="1275" b="1">
+                <a:solidFill>
+                  <a:srgbClr val="172026"/>
+                </a:solidFill>
+                <a:latin typeface="Malgun Gothic"/>
+                <a:ea typeface="Malgun Gothic"/>
+                <a:cs typeface="Malgun Gothic"/>
+              </a:defRPr>
+            </a:pPr>
+            <a:r>
+              <a:rPr sz="1275" b="1">
+                <a:solidFill>
+                  <a:srgbClr val="172026"/>
+                </a:solidFill>
+                <a:latin typeface="Malgun Gothic"/>
+                <a:ea typeface="Malgun Gothic"/>
+                <a:cs typeface="Malgun Gothic"/>
+              </a:rPr>
+              <a:t>홈 화면에 추가</a:t>
+            </a:r>
+          </a:p>
+        </p:txBody>
       </p:sp>
       <p:sp>
         <p:nvSpPr>
           <p:cNvPr id="15" name="">
             <a:extLst xmlns:a="http://schemas.openxmlformats.org/drawingml/2006/main">
               <a:ext uri="{FF2B5EF4-FFF2-40B4-BE49-F238E27FC236}">
-                <a16:creationId xmlns:a16="http://schemas.microsoft.com/office/drawing/2014/main" id="{5FA04D78-5269-4B5F-BD48-D3EB921E1D8F}"/>
-              </a:ext>
-            </a:extLst>
-          </p:cNvPr>
-          <p:cNvSpPr>
-            <a:spLocks xmlns:a="http://schemas.openxmlformats.org/drawingml/2006/main" noGrp="1"/>
-          </p:cNvSpPr>
-          <p:nvPr/>
-        </p:nvSpPr>
-        <p:spPr>
-          <a:xfrm xmlns:a="http://schemas.openxmlformats.org/drawingml/2006/main">
-            <a:off x="5162550" y="2381250"/>
-            <a:ext cx="66675" cy="1428750"/>
-          </a:xfrm>
-          <a:prstGeom xmlns:a="http://schemas.openxmlformats.org/drawingml/2006/main" prst="roundRect">
-            <a:avLst>
-              <a:gd name="adj" fmla="val 50000"/>
-            </a:avLst>
-          </a:prstGeom>
-          <a:solidFill xmlns:a="http://schemas.openxmlformats.org/drawingml/2006/main">
-            <a:srgbClr val="0F766E"/>
-          </a:solidFill>
-          <a:ln xmlns:a="http://schemas.openxmlformats.org/drawingml/2006/main" w="0">
-            <a:solidFill>
-              <a:srgbClr val="0F766E"/>
-            </a:solidFill>
-            <a:prstDash val="solid"/>
-          </a:ln>
-        </p:spPr>
-      </p:sp>
-      <p:sp>
-        <p:nvSpPr>
-          <p:cNvPr id="16" name="">
-            <a:extLst xmlns:a="http://schemas.openxmlformats.org/drawingml/2006/main">
-              <a:ext uri="{FF2B5EF4-FFF2-40B4-BE49-F238E27FC236}">
-                <a16:creationId xmlns:a16="http://schemas.microsoft.com/office/drawing/2014/main" id="{65BDEE6F-DFC2-4162-84A6-B19294A4E218}"/>
-              </a:ext>
-            </a:extLst>
-          </p:cNvPr>
-          <p:cNvSpPr>
-            <a:spLocks xmlns:a="http://schemas.openxmlformats.org/drawingml/2006/main" noGrp="1"/>
-          </p:cNvSpPr>
-          <p:nvPr/>
-        </p:nvSpPr>
-        <p:spPr>
-          <a:xfrm xmlns:a="http://schemas.openxmlformats.org/drawingml/2006/main">
-            <a:off x="5353050" y="2552700"/>
-            <a:ext cx="2228850" cy="266700"/>
+                <a16:creationId xmlns:a16="http://schemas.microsoft.com/office/drawing/2014/main" id="{702A7DCC-9DF4-492D-94FF-5817AE83F2DC}"/>
+              </a:ext>
+            </a:extLst>
+          </p:cNvPr>
+          <p:cNvSpPr>
+            <a:spLocks xmlns:a="http://schemas.openxmlformats.org/drawingml/2006/main" noGrp="1"/>
+          </p:cNvSpPr>
+          <p:nvPr/>
+        </p:nvSpPr>
+        <p:spPr>
+          <a:xfrm xmlns:a="http://schemas.openxmlformats.org/drawingml/2006/main">
+            <a:off x="1047750" y="4648200"/>
+            <a:ext cx="1428750" cy="381000"/>
           </a:xfrm>
           <a:prstGeom xmlns:a="http://schemas.openxmlformats.org/drawingml/2006/main" prst="rect">
             <a:avLst/>
@@ -3431,47 +3352,80 @@
           <a:lstStyle xmlns:a="http://schemas.openxmlformats.org/drawingml/2006/main"/>
           <a:p xmlns:a="http://schemas.openxmlformats.org/drawingml/2006/main">
             <a:pPr algn="l">
-              <a:defRPr sz="1500" b="1">
-                <a:solidFill>
-                  <a:srgbClr val="172026"/>
-                </a:solidFill>
-                <a:latin typeface="Malgun Gothic"/>
-                <a:ea typeface="Malgun Gothic"/>
-                <a:cs typeface="Malgun Gothic"/>
-              </a:defRPr>
-            </a:pPr>
-            <a:r>
-              <a:rPr sz="1500" b="1">
-                <a:solidFill>
-                  <a:srgbClr val="172026"/>
-                </a:solidFill>
-                <a:latin typeface="Malgun Gothic"/>
-                <a:ea typeface="Malgun Gothic"/>
-                <a:cs typeface="Malgun Gothic"/>
-              </a:rPr>
-              <a:t>AFTER</a:t>
-            </a:r>
-          </a:p>
-        </p:txBody>
+              <a:defRPr sz="1050" b="0">
+                <a:solidFill>
+                  <a:srgbClr val="60707A"/>
+                </a:solidFill>
+                <a:latin typeface="Malgun Gothic"/>
+                <a:ea typeface="Malgun Gothic"/>
+                <a:cs typeface="Malgun Gothic"/>
+              </a:defRPr>
+            </a:pPr>
+            <a:r>
+              <a:rPr sz="1050" b="0">
+                <a:solidFill>
+                  <a:srgbClr val="60707A"/>
+                </a:solidFill>
+                <a:latin typeface="Malgun Gothic"/>
+                <a:ea typeface="Malgun Gothic"/>
+                <a:cs typeface="Malgun Gothic"/>
+              </a:rPr>
+              <a:t>GitHub Pages URL을 앱처럼 바로 열기</a:t>
+            </a:r>
+          </a:p>
+        </p:txBody>
+      </p:sp>
+      <p:sp>
+        <p:nvSpPr>
+          <p:cNvPr id="16" name="">
+            <a:extLst xmlns:a="http://schemas.openxmlformats.org/drawingml/2006/main">
+              <a:ext uri="{FF2B5EF4-FFF2-40B4-BE49-F238E27FC236}">
+                <a16:creationId xmlns:a16="http://schemas.microsoft.com/office/drawing/2014/main" id="{A4790AF7-C9F7-45D8-8943-008E75A134C7}"/>
+              </a:ext>
+            </a:extLst>
+          </p:cNvPr>
+          <p:cNvSpPr>
+            <a:spLocks xmlns:a="http://schemas.openxmlformats.org/drawingml/2006/main" noGrp="1"/>
+          </p:cNvSpPr>
+          <p:nvPr/>
+        </p:nvSpPr>
+        <p:spPr>
+          <a:xfrm xmlns:a="http://schemas.openxmlformats.org/drawingml/2006/main">
+            <a:off x="3105150" y="3705225"/>
+            <a:ext cx="552450" cy="28575"/>
+          </a:xfrm>
+          <a:prstGeom xmlns:a="http://schemas.openxmlformats.org/drawingml/2006/main" prst="rect">
+            <a:avLst/>
+          </a:prstGeom>
+          <a:solidFill xmlns:a="http://schemas.openxmlformats.org/drawingml/2006/main">
+            <a:srgbClr val="0F766E"/>
+          </a:solidFill>
+          <a:ln xmlns:a="http://schemas.openxmlformats.org/drawingml/2006/main" w="0">
+            <a:solidFill>
+              <a:srgbClr val="0F766E"/>
+            </a:solidFill>
+            <a:prstDash val="solid"/>
+          </a:ln>
+        </p:spPr>
       </p:sp>
       <p:sp>
         <p:nvSpPr>
           <p:cNvPr id="17" name="">
             <a:extLst xmlns:a="http://schemas.openxmlformats.org/drawingml/2006/main">
               <a:ext uri="{FF2B5EF4-FFF2-40B4-BE49-F238E27FC236}">
-                <a16:creationId xmlns:a16="http://schemas.microsoft.com/office/drawing/2014/main" id="{A12D5E02-D736-4209-812F-FCE44378369E}"/>
-              </a:ext>
-            </a:extLst>
-          </p:cNvPr>
-          <p:cNvSpPr>
-            <a:spLocks xmlns:a="http://schemas.openxmlformats.org/drawingml/2006/main" noGrp="1"/>
-          </p:cNvSpPr>
-          <p:nvPr/>
-        </p:nvSpPr>
-        <p:spPr>
-          <a:xfrm xmlns:a="http://schemas.openxmlformats.org/drawingml/2006/main">
-            <a:off x="5353050" y="2895600"/>
-            <a:ext cx="2228850" cy="762000"/>
+                <a16:creationId xmlns:a16="http://schemas.microsoft.com/office/drawing/2014/main" id="{80DDF6CF-10AD-4F66-8267-042F3A875062}"/>
+              </a:ext>
+            </a:extLst>
+          </p:cNvPr>
+          <p:cNvSpPr>
+            <a:spLocks xmlns:a="http://schemas.openxmlformats.org/drawingml/2006/main" noGrp="1"/>
+          </p:cNvSpPr>
+          <p:nvPr/>
+        </p:nvSpPr>
+        <p:spPr>
+          <a:xfrm xmlns:a="http://schemas.openxmlformats.org/drawingml/2006/main">
+            <a:off x="3638550" y="3552825"/>
+            <a:ext cx="209550" cy="323850"/>
           </a:xfrm>
           <a:prstGeom xmlns:a="http://schemas.openxmlformats.org/drawingml/2006/main" prst="rect">
             <a:avLst/>
@@ -3494,72 +3448,26 @@
           <a:bodyPr xmlns:a="http://schemas.openxmlformats.org/drawingml/2006/main" lIns="0" tIns="0" rIns="0" bIns="0" anchor="t"/>
           <a:lstStyle xmlns:a="http://schemas.openxmlformats.org/drawingml/2006/main"/>
           <a:p xmlns:a="http://schemas.openxmlformats.org/drawingml/2006/main">
-            <a:pPr algn="l">
-              <a:defRPr sz="1125" b="0">
-                <a:solidFill>
-                  <a:srgbClr val="60707A"/>
-                </a:solidFill>
-                <a:latin typeface="Malgun Gothic"/>
-                <a:ea typeface="Malgun Gothic"/>
-                <a:cs typeface="Malgun Gothic"/>
-              </a:defRPr>
-            </a:pPr>
-            <a:r>
-              <a:rPr sz="1125" b="0">
-                <a:solidFill>
-                  <a:srgbClr val="60707A"/>
-                </a:solidFill>
-                <a:latin typeface="Malgun Gothic"/>
-                <a:ea typeface="Malgun Gothic"/>
-                <a:cs typeface="Malgun Gothic"/>
-              </a:rPr>
-              <a:t>오늘의 레슨이 생성되고</a:t>
-            </a:r>
-          </a:p>
-          <a:p xmlns:a="http://schemas.openxmlformats.org/drawingml/2006/main">
-            <a:pPr algn="l">
-              <a:defRPr sz="1125" b="0">
-                <a:solidFill>
-                  <a:srgbClr val="60707A"/>
-                </a:solidFill>
-                <a:latin typeface="Malgun Gothic"/>
-                <a:ea typeface="Malgun Gothic"/>
-                <a:cs typeface="Malgun Gothic"/>
-              </a:defRPr>
-            </a:pPr>
-            <a:r>
-              <a:rPr sz="1125" b="0">
-                <a:solidFill>
-                  <a:srgbClr val="60707A"/>
-                </a:solidFill>
-                <a:latin typeface="Malgun Gothic"/>
-                <a:ea typeface="Malgun Gothic"/>
-                <a:cs typeface="Malgun Gothic"/>
-              </a:rPr>
-              <a:t>모바일 화면에 반영되며</a:t>
-            </a:r>
-          </a:p>
-          <a:p xmlns:a="http://schemas.openxmlformats.org/drawingml/2006/main">
-            <a:pPr algn="l">
-              <a:defRPr sz="1125" b="0">
-                <a:solidFill>
-                  <a:srgbClr val="60707A"/>
-                </a:solidFill>
-                <a:latin typeface="Malgun Gothic"/>
-                <a:ea typeface="Malgun Gothic"/>
-                <a:cs typeface="Malgun Gothic"/>
-              </a:defRPr>
-            </a:pPr>
-            <a:r>
-              <a:rPr sz="1125" b="0">
-                <a:solidFill>
-                  <a:srgbClr val="60707A"/>
-                </a:solidFill>
-                <a:latin typeface="Malgun Gothic"/>
-                <a:ea typeface="Malgun Gothic"/>
-                <a:cs typeface="Malgun Gothic"/>
-              </a:rPr>
-              <a:t>카톡 링크로 다시 도착</a:t>
+            <a:pPr algn="ctr">
+              <a:defRPr sz="1950" b="1">
+                <a:solidFill>
+                  <a:srgbClr val="0F766E"/>
+                </a:solidFill>
+                <a:latin typeface="Malgun Gothic"/>
+                <a:ea typeface="Malgun Gothic"/>
+                <a:cs typeface="Malgun Gothic"/>
+              </a:defRPr>
+            </a:pPr>
+            <a:r>
+              <a:rPr sz="1950" b="1">
+                <a:solidFill>
+                  <a:srgbClr val="0F766E"/>
+                </a:solidFill>
+                <a:latin typeface="Malgun Gothic"/>
+                <a:ea typeface="Malgun Gothic"/>
+                <a:cs typeface="Malgun Gothic"/>
+              </a:rPr>
+              <a:t>&gt;</a:t>
             </a:r>
           </a:p>
         </p:txBody>
@@ -3569,54 +3477,19 @@
           <p:cNvPr id="18" name="">
             <a:extLst xmlns:a="http://schemas.openxmlformats.org/drawingml/2006/main">
               <a:ext uri="{FF2B5EF4-FFF2-40B4-BE49-F238E27FC236}">
-                <a16:creationId xmlns:a16="http://schemas.microsoft.com/office/drawing/2014/main" id="{372588C6-365C-4F4F-BF7B-C89EF0488253}"/>
-              </a:ext>
-            </a:extLst>
-          </p:cNvPr>
-          <p:cNvSpPr>
-            <a:spLocks xmlns:a="http://schemas.openxmlformats.org/drawingml/2006/main" noGrp="1"/>
-          </p:cNvSpPr>
-          <p:nvPr/>
-        </p:nvSpPr>
-        <p:spPr>
-          <a:xfrm xmlns:a="http://schemas.openxmlformats.org/drawingml/2006/main">
-            <a:off x="8096250" y="2266950"/>
-            <a:ext cx="3371850" cy="1771650"/>
-          </a:xfrm>
-          <a:prstGeom xmlns:a="http://schemas.openxmlformats.org/drawingml/2006/main" prst="roundRect">
-            <a:avLst>
-              <a:gd name="adj" fmla="val 4301"/>
-            </a:avLst>
-          </a:prstGeom>
-          <a:solidFill xmlns:a="http://schemas.openxmlformats.org/drawingml/2006/main">
-            <a:srgbClr val="153438"/>
-          </a:solidFill>
-          <a:ln xmlns:a="http://schemas.openxmlformats.org/drawingml/2006/main" w="0">
-            <a:solidFill>
-              <a:srgbClr val="153438"/>
-            </a:solidFill>
-            <a:prstDash val="solid"/>
-          </a:ln>
-        </p:spPr>
-      </p:sp>
-      <p:sp>
-        <p:nvSpPr>
-          <p:cNvPr id="19" name="">
-            <a:extLst xmlns:a="http://schemas.openxmlformats.org/drawingml/2006/main">
-              <a:ext uri="{FF2B5EF4-FFF2-40B4-BE49-F238E27FC236}">
-                <a16:creationId xmlns:a16="http://schemas.microsoft.com/office/drawing/2014/main" id="{585E20D6-DBC8-42D4-9A39-07C80B02F78A}"/>
-              </a:ext>
-            </a:extLst>
-          </p:cNvPr>
-          <p:cNvSpPr>
-            <a:spLocks xmlns:a="http://schemas.openxmlformats.org/drawingml/2006/main" noGrp="1"/>
-          </p:cNvSpPr>
-          <p:nvPr/>
-        </p:nvSpPr>
-        <p:spPr>
-          <a:xfrm xmlns:a="http://schemas.openxmlformats.org/drawingml/2006/main">
-            <a:off x="8401050" y="2571750"/>
-            <a:ext cx="2724150" cy="266700"/>
+                <a16:creationId xmlns:a16="http://schemas.microsoft.com/office/drawing/2014/main" id="{6CC8532D-C1A9-44E4-AB5A-52518DB1239E}"/>
+              </a:ext>
+            </a:extLst>
+          </p:cNvPr>
+          <p:cNvSpPr>
+            <a:spLocks xmlns:a="http://schemas.openxmlformats.org/drawingml/2006/main" noGrp="1"/>
+          </p:cNvSpPr>
+          <p:nvPr/>
+        </p:nvSpPr>
+        <p:spPr>
+          <a:xfrm xmlns:a="http://schemas.openxmlformats.org/drawingml/2006/main">
+            <a:off x="3067050" y="3333750"/>
+            <a:ext cx="819150" cy="190500"/>
           </a:xfrm>
           <a:prstGeom xmlns:a="http://schemas.openxmlformats.org/drawingml/2006/main" prst="rect">
             <a:avLst/>
@@ -3639,48 +3512,118 @@
           <a:bodyPr xmlns:a="http://schemas.openxmlformats.org/drawingml/2006/main" lIns="0" tIns="0" rIns="0" bIns="0" anchor="t"/>
           <a:lstStyle xmlns:a="http://schemas.openxmlformats.org/drawingml/2006/main"/>
           <a:p xmlns:a="http://schemas.openxmlformats.org/drawingml/2006/main">
-            <a:pPr algn="l">
-              <a:defRPr sz="1575" b="1">
-                <a:solidFill>
-                  <a:srgbClr val="FFFFFF"/>
-                </a:solidFill>
-                <a:latin typeface="Malgun Gothic"/>
-                <a:ea typeface="Malgun Gothic"/>
-                <a:cs typeface="Malgun Gothic"/>
-              </a:defRPr>
-            </a:pPr>
-            <a:r>
-              <a:rPr sz="1575" b="1">
-                <a:solidFill>
-                  <a:srgbClr val="FFFFFF"/>
-                </a:solidFill>
-                <a:latin typeface="Malgun Gothic"/>
-                <a:ea typeface="Malgun Gothic"/>
-                <a:cs typeface="Malgun Gothic"/>
-              </a:rPr>
-              <a:t>학습자의 행동은 단순합니다.</a:t>
-            </a:r>
-          </a:p>
-        </p:txBody>
+            <a:pPr algn="ctr">
+              <a:defRPr sz="900" b="1">
+                <a:solidFill>
+                  <a:srgbClr val="60707A"/>
+                </a:solidFill>
+                <a:latin typeface="Malgun Gothic"/>
+                <a:ea typeface="Malgun Gothic"/>
+                <a:cs typeface="Malgun Gothic"/>
+              </a:defRPr>
+            </a:pPr>
+            <a:r>
+              <a:rPr sz="900" b="1">
+                <a:solidFill>
+                  <a:srgbClr val="60707A"/>
+                </a:solidFill>
+                <a:latin typeface="Malgun Gothic"/>
+                <a:ea typeface="Malgun Gothic"/>
+                <a:cs typeface="Malgun Gothic"/>
+              </a:rPr>
+              <a:t>앱처럼 열기</a:t>
+            </a:r>
+          </a:p>
+        </p:txBody>
+      </p:sp>
+      <p:sp>
+        <p:nvSpPr>
+          <p:cNvPr id="19" name="">
+            <a:extLst xmlns:a="http://schemas.openxmlformats.org/drawingml/2006/main">
+              <a:ext uri="{FF2B5EF4-FFF2-40B4-BE49-F238E27FC236}">
+                <a16:creationId xmlns:a16="http://schemas.microsoft.com/office/drawing/2014/main" id="{2949A705-9719-467C-AEC3-2A69A416A065}"/>
+              </a:ext>
+            </a:extLst>
+          </p:cNvPr>
+          <p:cNvSpPr>
+            <a:spLocks xmlns:a="http://schemas.openxmlformats.org/drawingml/2006/main" noGrp="1"/>
+          </p:cNvSpPr>
+          <p:nvPr/>
+        </p:nvSpPr>
+        <p:spPr>
+          <a:xfrm xmlns:a="http://schemas.openxmlformats.org/drawingml/2006/main">
+            <a:off x="4171950" y="2266950"/>
+            <a:ext cx="3124200" cy="3105150"/>
+          </a:xfrm>
+          <a:prstGeom xmlns:a="http://schemas.openxmlformats.org/drawingml/2006/main" prst="roundRect">
+            <a:avLst>
+              <a:gd name="adj" fmla="val 2454"/>
+            </a:avLst>
+          </a:prstGeom>
+          <a:solidFill xmlns:a="http://schemas.openxmlformats.org/drawingml/2006/main">
+            <a:srgbClr val="FFFFFF"/>
+          </a:solidFill>
+          <a:ln xmlns:a="http://schemas.openxmlformats.org/drawingml/2006/main" w="9525">
+            <a:solidFill>
+              <a:srgbClr val="C9D5D8"/>
+            </a:solidFill>
+            <a:prstDash val="solid"/>
+          </a:ln>
+        </p:spPr>
       </p:sp>
       <p:sp>
         <p:nvSpPr>
           <p:cNvPr id="20" name="">
             <a:extLst xmlns:a="http://schemas.openxmlformats.org/drawingml/2006/main">
               <a:ext uri="{FF2B5EF4-FFF2-40B4-BE49-F238E27FC236}">
-                <a16:creationId xmlns:a16="http://schemas.microsoft.com/office/drawing/2014/main" id="{6A04E123-146A-431F-A3E8-85EC39839918}"/>
-              </a:ext>
-            </a:extLst>
-          </p:cNvPr>
-          <p:cNvSpPr>
-            <a:spLocks xmlns:a="http://schemas.openxmlformats.org/drawingml/2006/main" noGrp="1"/>
-          </p:cNvSpPr>
-          <p:nvPr/>
-        </p:nvSpPr>
-        <p:spPr>
-          <a:xfrm xmlns:a="http://schemas.openxmlformats.org/drawingml/2006/main">
-            <a:off x="8401050" y="3067050"/>
-            <a:ext cx="2628900" cy="628650"/>
+                <a16:creationId xmlns:a16="http://schemas.microsoft.com/office/drawing/2014/main" id="{A4E96F4E-618B-427C-966E-9B18DBDE0CB6}"/>
+              </a:ext>
+            </a:extLst>
+          </p:cNvPr>
+          <p:cNvSpPr>
+            <a:spLocks xmlns:a="http://schemas.openxmlformats.org/drawingml/2006/main" noGrp="1"/>
+          </p:cNvSpPr>
+          <p:nvPr/>
+        </p:nvSpPr>
+        <p:spPr>
+          <a:xfrm xmlns:a="http://schemas.openxmlformats.org/drawingml/2006/main">
+            <a:off x="4419600" y="2514600"/>
+            <a:ext cx="1809750" cy="266700"/>
+          </a:xfrm>
+          <a:prstGeom xmlns:a="http://schemas.openxmlformats.org/drawingml/2006/main" prst="roundRect">
+            <a:avLst>
+              <a:gd name="adj" fmla="val 28571"/>
+            </a:avLst>
+          </a:prstGeom>
+          <a:solidFill xmlns:a="http://schemas.openxmlformats.org/drawingml/2006/main">
+            <a:srgbClr val="FBE6DF"/>
+          </a:solidFill>
+          <a:ln xmlns:a="http://schemas.openxmlformats.org/drawingml/2006/main" w="0">
+            <a:solidFill>
+              <a:srgbClr val="FBE6DF"/>
+            </a:solidFill>
+            <a:prstDash val="solid"/>
+          </a:ln>
+        </p:spPr>
+      </p:sp>
+      <p:sp>
+        <p:nvSpPr>
+          <p:cNvPr id="21" name="">
+            <a:extLst xmlns:a="http://schemas.openxmlformats.org/drawingml/2006/main">
+              <a:ext uri="{FF2B5EF4-FFF2-40B4-BE49-F238E27FC236}">
+                <a16:creationId xmlns:a16="http://schemas.microsoft.com/office/drawing/2014/main" id="{E62728F3-CEDF-4244-BC3E-661525A1F4F8}"/>
+              </a:ext>
+            </a:extLst>
+          </p:cNvPr>
+          <p:cNvSpPr>
+            <a:spLocks xmlns:a="http://schemas.openxmlformats.org/drawingml/2006/main" noGrp="1"/>
+          </p:cNvSpPr>
+          <p:nvPr/>
+        </p:nvSpPr>
+        <p:spPr>
+          <a:xfrm xmlns:a="http://schemas.openxmlformats.org/drawingml/2006/main">
+            <a:off x="4419600" y="2562225"/>
+            <a:ext cx="1809750" cy="171450"/>
           </a:xfrm>
           <a:prstGeom xmlns:a="http://schemas.openxmlformats.org/drawingml/2006/main" prst="rect">
             <a:avLst/>
@@ -3703,106 +3646,48 @@
           <a:bodyPr xmlns:a="http://schemas.openxmlformats.org/drawingml/2006/main" lIns="0" tIns="0" rIns="0" bIns="0" anchor="t"/>
           <a:lstStyle xmlns:a="http://schemas.openxmlformats.org/drawingml/2006/main"/>
           <a:p xmlns:a="http://schemas.openxmlformats.org/drawingml/2006/main">
-            <a:pPr algn="l">
-              <a:defRPr sz="1500" b="1">
-                <a:solidFill>
-                  <a:srgbClr val="D8EFEC"/>
-                </a:solidFill>
-                <a:latin typeface="Malgun Gothic"/>
-                <a:ea typeface="Malgun Gothic"/>
-                <a:cs typeface="Malgun Gothic"/>
-              </a:defRPr>
-            </a:pPr>
-            <a:r>
-              <a:rPr sz="1500" b="1">
-                <a:solidFill>
-                  <a:srgbClr val="D8EFEC"/>
-                </a:solidFill>
-                <a:latin typeface="Malgun Gothic"/>
-                <a:ea typeface="Malgun Gothic"/>
-                <a:cs typeface="Malgun Gothic"/>
-              </a:rPr>
-              <a:t>열기  →  병음 보며 말하기</a:t>
-            </a:r>
-          </a:p>
-          <a:p xmlns:a="http://schemas.openxmlformats.org/drawingml/2006/main">
-            <a:pPr algn="l">
-              <a:defRPr sz="1500" b="1">
-                <a:solidFill>
-                  <a:srgbClr val="D8EFEC"/>
-                </a:solidFill>
-                <a:latin typeface="Malgun Gothic"/>
-                <a:ea typeface="Malgun Gothic"/>
-                <a:cs typeface="Malgun Gothic"/>
-              </a:defRPr>
-            </a:pPr>
-            <a:r>
-              <a:rPr sz="1500" b="1">
-                <a:solidFill>
-                  <a:srgbClr val="D8EFEC"/>
-                </a:solidFill>
-                <a:latin typeface="Malgun Gothic"/>
-                <a:ea typeface="Malgun Gothic"/>
-                <a:cs typeface="Malgun Gothic"/>
-              </a:rPr>
-              <a:t>→  자기채점  →  메모 복사</a:t>
-            </a:r>
-          </a:p>
-        </p:txBody>
-      </p:sp>
-      <p:sp>
-        <p:nvSpPr>
-          <p:cNvPr id="21" name="">
-            <a:extLst xmlns:a="http://schemas.openxmlformats.org/drawingml/2006/main">
-              <a:ext uri="{FF2B5EF4-FFF2-40B4-BE49-F238E27FC236}">
-                <a16:creationId xmlns:a16="http://schemas.microsoft.com/office/drawing/2014/main" id="{2D50903F-C4AB-49B6-8746-39C72D12A5CD}"/>
-              </a:ext>
-            </a:extLst>
-          </p:cNvPr>
-          <p:cNvSpPr>
-            <a:spLocks xmlns:a="http://schemas.openxmlformats.org/drawingml/2006/main" noGrp="1"/>
-          </p:cNvSpPr>
-          <p:nvPr/>
-        </p:nvSpPr>
-        <p:spPr>
-          <a:xfrm xmlns:a="http://schemas.openxmlformats.org/drawingml/2006/main">
-            <a:off x="723900" y="4591050"/>
-            <a:ext cx="2400300" cy="1047750"/>
-          </a:xfrm>
-          <a:prstGeom xmlns:a="http://schemas.openxmlformats.org/drawingml/2006/main" prst="roundRect">
-            <a:avLst>
-              <a:gd name="adj" fmla="val 7273"/>
-            </a:avLst>
-          </a:prstGeom>
-          <a:solidFill xmlns:a="http://schemas.openxmlformats.org/drawingml/2006/main">
-            <a:srgbClr val="FFFFFF"/>
-          </a:solidFill>
-          <a:ln xmlns:a="http://schemas.openxmlformats.org/drawingml/2006/main" w="9525">
-            <a:solidFill>
-              <a:srgbClr val="C9D5D8"/>
-            </a:solidFill>
-            <a:prstDash val="solid"/>
-          </a:ln>
-        </p:spPr>
+            <a:pPr algn="ctr">
+              <a:defRPr sz="975" b="1">
+                <a:solidFill>
+                  <a:srgbClr val="E76F51"/>
+                </a:solidFill>
+                <a:latin typeface="Malgun Gothic"/>
+                <a:ea typeface="Malgun Gothic"/>
+                <a:cs typeface="Malgun Gothic"/>
+              </a:defRPr>
+            </a:pPr>
+            <a:r>
+              <a:rPr sz="975" b="1">
+                <a:solidFill>
+                  <a:srgbClr val="E76F51"/>
+                </a:solidFill>
+                <a:latin typeface="Malgun Gothic"/>
+                <a:ea typeface="Malgun Gothic"/>
+                <a:cs typeface="Malgun Gothic"/>
+              </a:rPr>
+              <a:t>TODAY'S LESSON EXAMPLE</a:t>
+            </a:r>
+          </a:p>
+        </p:txBody>
       </p:sp>
       <p:sp>
         <p:nvSpPr>
           <p:cNvPr id="22" name="">
             <a:extLst xmlns:a="http://schemas.openxmlformats.org/drawingml/2006/main">
               <a:ext uri="{FF2B5EF4-FFF2-40B4-BE49-F238E27FC236}">
-                <a16:creationId xmlns:a16="http://schemas.microsoft.com/office/drawing/2014/main" id="{519CDBDF-F3CA-413B-9919-E33A4BC53009}"/>
-              </a:ext>
-            </a:extLst>
-          </p:cNvPr>
-          <p:cNvSpPr>
-            <a:spLocks xmlns:a="http://schemas.openxmlformats.org/drawingml/2006/main" noGrp="1"/>
-          </p:cNvSpPr>
-          <p:nvPr/>
-        </p:nvSpPr>
-        <p:spPr>
-          <a:xfrm xmlns:a="http://schemas.openxmlformats.org/drawingml/2006/main">
-            <a:off x="914400" y="4829175"/>
-            <a:ext cx="533400" cy="438150"/>
+                <a16:creationId xmlns:a16="http://schemas.microsoft.com/office/drawing/2014/main" id="{9FC15C2F-F2A4-4351-B698-12C4BC5FB4C3}"/>
+              </a:ext>
+            </a:extLst>
+          </p:cNvPr>
+          <p:cNvSpPr>
+            <a:spLocks xmlns:a="http://schemas.openxmlformats.org/drawingml/2006/main" noGrp="1"/>
+          </p:cNvSpPr>
+          <p:nvPr/>
+        </p:nvSpPr>
+        <p:spPr>
+          <a:xfrm xmlns:a="http://schemas.openxmlformats.org/drawingml/2006/main">
+            <a:off x="4419600" y="3028950"/>
+            <a:ext cx="2552700" cy="266700"/>
           </a:xfrm>
           <a:prstGeom xmlns:a="http://schemas.openxmlformats.org/drawingml/2006/main" prst="rect">
             <a:avLst/>
@@ -3826,9 +3711,1058 @@
           <a:lstStyle xmlns:a="http://schemas.openxmlformats.org/drawingml/2006/main"/>
           <a:p xmlns:a="http://schemas.openxmlformats.org/drawingml/2006/main">
             <a:pPr algn="l">
-              <a:defRPr sz="2625" b="1">
+              <a:defRPr sz="1650" b="1">
+                <a:solidFill>
+                  <a:srgbClr val="172026"/>
+                </a:solidFill>
+                <a:latin typeface="Malgun Gothic"/>
+                <a:ea typeface="Malgun Gothic"/>
+                <a:cs typeface="Malgun Gothic"/>
+              </a:defRPr>
+            </a:pPr>
+            <a:r>
+              <a:rPr sz="1650" b="1">
+                <a:solidFill>
+                  <a:srgbClr val="172026"/>
+                </a:solidFill>
+                <a:latin typeface="Malgun Gothic"/>
+                <a:ea typeface="Malgun Gothic"/>
+                <a:cs typeface="Malgun Gothic"/>
+              </a:rPr>
+              <a:t>Lesson 02 · 교통과 이동</a:t>
+            </a:r>
+          </a:p>
+        </p:txBody>
+      </p:sp>
+      <p:sp>
+        <p:nvSpPr>
+          <p:cNvPr id="23" name="">
+            <a:extLst xmlns:a="http://schemas.openxmlformats.org/drawingml/2006/main">
+              <a:ext uri="{FF2B5EF4-FFF2-40B4-BE49-F238E27FC236}">
+                <a16:creationId xmlns:a16="http://schemas.microsoft.com/office/drawing/2014/main" id="{9226D707-9D4F-4F01-ABEB-8745B0F214CF}"/>
+              </a:ext>
+            </a:extLst>
+          </p:cNvPr>
+          <p:cNvSpPr>
+            <a:spLocks xmlns:a="http://schemas.openxmlformats.org/drawingml/2006/main" noGrp="1"/>
+          </p:cNvSpPr>
+          <p:nvPr/>
+        </p:nvSpPr>
+        <p:spPr>
+          <a:xfrm xmlns:a="http://schemas.openxmlformats.org/drawingml/2006/main">
+            <a:off x="4419600" y="3638550"/>
+            <a:ext cx="2381250" cy="266700"/>
+          </a:xfrm>
+          <a:prstGeom xmlns:a="http://schemas.openxmlformats.org/drawingml/2006/main" prst="rect">
+            <a:avLst/>
+          </a:prstGeom>
+          <a:solidFill xmlns:a="http://schemas.openxmlformats.org/drawingml/2006/main">
+            <a:srgbClr val="000000">
+              <a:alpha val="0"/>
+            </a:srgbClr>
+          </a:solidFill>
+          <a:ln xmlns:a="http://schemas.openxmlformats.org/drawingml/2006/main" w="0">
+            <a:solidFill>
+              <a:srgbClr val="000000">
+                <a:alpha val="0"/>
+              </a:srgbClr>
+            </a:solidFill>
+            <a:prstDash val="solid"/>
+          </a:ln>
+        </p:spPr>
+        <p:txBody>
+          <a:bodyPr xmlns:a="http://schemas.openxmlformats.org/drawingml/2006/main" lIns="0" tIns="0" rIns="0" bIns="0" anchor="t"/>
+          <a:lstStyle xmlns:a="http://schemas.openxmlformats.org/drawingml/2006/main"/>
+          <a:p xmlns:a="http://schemas.openxmlformats.org/drawingml/2006/main">
+            <a:pPr algn="l">
+              <a:defRPr sz="1650" b="1">
+                <a:solidFill>
+                  <a:srgbClr val="172026"/>
+                </a:solidFill>
+                <a:latin typeface="Malgun Gothic"/>
+                <a:ea typeface="Malgun Gothic"/>
+                <a:cs typeface="Malgun Gothic"/>
+              </a:defRPr>
+            </a:pPr>
+            <a:r>
+              <a:rPr sz="1650" b="1">
+                <a:solidFill>
+                  <a:srgbClr val="172026"/>
+                </a:solidFill>
+                <a:latin typeface="Malgun Gothic"/>
+                <a:ea typeface="Malgun Gothic"/>
+                <a:cs typeface="Malgun Gothic"/>
+              </a:rPr>
+              <a:t>我坐地铁去公司。</a:t>
+            </a:r>
+          </a:p>
+        </p:txBody>
+      </p:sp>
+      <p:sp>
+        <p:nvSpPr>
+          <p:cNvPr id="24" name="">
+            <a:extLst xmlns:a="http://schemas.openxmlformats.org/drawingml/2006/main">
+              <a:ext uri="{FF2B5EF4-FFF2-40B4-BE49-F238E27FC236}">
+                <a16:creationId xmlns:a16="http://schemas.microsoft.com/office/drawing/2014/main" id="{44B9D86D-1F31-4D84-9002-251980B40307}"/>
+              </a:ext>
+            </a:extLst>
+          </p:cNvPr>
+          <p:cNvSpPr>
+            <a:spLocks xmlns:a="http://schemas.openxmlformats.org/drawingml/2006/main" noGrp="1"/>
+          </p:cNvSpPr>
+          <p:nvPr/>
+        </p:nvSpPr>
+        <p:spPr>
+          <a:xfrm xmlns:a="http://schemas.openxmlformats.org/drawingml/2006/main">
+            <a:off x="4419600" y="4019550"/>
+            <a:ext cx="2381250" cy="228600"/>
+          </a:xfrm>
+          <a:prstGeom xmlns:a="http://schemas.openxmlformats.org/drawingml/2006/main" prst="rect">
+            <a:avLst/>
+          </a:prstGeom>
+          <a:solidFill xmlns:a="http://schemas.openxmlformats.org/drawingml/2006/main">
+            <a:srgbClr val="000000">
+              <a:alpha val="0"/>
+            </a:srgbClr>
+          </a:solidFill>
+          <a:ln xmlns:a="http://schemas.openxmlformats.org/drawingml/2006/main" w="0">
+            <a:solidFill>
+              <a:srgbClr val="000000">
+                <a:alpha val="0"/>
+              </a:srgbClr>
+            </a:solidFill>
+            <a:prstDash val="solid"/>
+          </a:ln>
+        </p:spPr>
+        <p:txBody>
+          <a:bodyPr xmlns:a="http://schemas.openxmlformats.org/drawingml/2006/main" lIns="0" tIns="0" rIns="0" bIns="0" anchor="t"/>
+          <a:lstStyle xmlns:a="http://schemas.openxmlformats.org/drawingml/2006/main"/>
+          <a:p xmlns:a="http://schemas.openxmlformats.org/drawingml/2006/main">
+            <a:pPr algn="l">
+              <a:defRPr sz="1275" b="1">
                 <a:solidFill>
                   <a:srgbClr val="0F766E"/>
+                </a:solidFill>
+                <a:latin typeface="Malgun Gothic"/>
+                <a:ea typeface="Malgun Gothic"/>
+                <a:cs typeface="Malgun Gothic"/>
+              </a:defRPr>
+            </a:pPr>
+            <a:r>
+              <a:rPr sz="1275" b="1">
+                <a:solidFill>
+                  <a:srgbClr val="0F766E"/>
+                </a:solidFill>
+                <a:latin typeface="Malgun Gothic"/>
+                <a:ea typeface="Malgun Gothic"/>
+                <a:cs typeface="Malgun Gothic"/>
+              </a:rPr>
+              <a:t>Wǒ zuò dìtiě qù gōngsī.</a:t>
+            </a:r>
+          </a:p>
+        </p:txBody>
+      </p:sp>
+      <p:sp>
+        <p:nvSpPr>
+          <p:cNvPr id="25" name="">
+            <a:extLst xmlns:a="http://schemas.openxmlformats.org/drawingml/2006/main">
+              <a:ext uri="{FF2B5EF4-FFF2-40B4-BE49-F238E27FC236}">
+                <a16:creationId xmlns:a16="http://schemas.microsoft.com/office/drawing/2014/main" id="{5A9CE010-6F31-4490-BC2C-18E58407350B}"/>
+              </a:ext>
+            </a:extLst>
+          </p:cNvPr>
+          <p:cNvSpPr>
+            <a:spLocks xmlns:a="http://schemas.openxmlformats.org/drawingml/2006/main" noGrp="1"/>
+          </p:cNvSpPr>
+          <p:nvPr/>
+        </p:nvSpPr>
+        <p:spPr>
+          <a:xfrm xmlns:a="http://schemas.openxmlformats.org/drawingml/2006/main">
+            <a:off x="4419600" y="4419600"/>
+            <a:ext cx="2571750" cy="209550"/>
+          </a:xfrm>
+          <a:prstGeom xmlns:a="http://schemas.openxmlformats.org/drawingml/2006/main" prst="rect">
+            <a:avLst/>
+          </a:prstGeom>
+          <a:solidFill xmlns:a="http://schemas.openxmlformats.org/drawingml/2006/main">
+            <a:srgbClr val="000000">
+              <a:alpha val="0"/>
+            </a:srgbClr>
+          </a:solidFill>
+          <a:ln xmlns:a="http://schemas.openxmlformats.org/drawingml/2006/main" w="0">
+            <a:solidFill>
+              <a:srgbClr val="000000">
+                <a:alpha val="0"/>
+              </a:srgbClr>
+            </a:solidFill>
+            <a:prstDash val="solid"/>
+          </a:ln>
+        </p:spPr>
+        <p:txBody>
+          <a:bodyPr xmlns:a="http://schemas.openxmlformats.org/drawingml/2006/main" lIns="0" tIns="0" rIns="0" bIns="0" anchor="t"/>
+          <a:lstStyle xmlns:a="http://schemas.openxmlformats.org/drawingml/2006/main"/>
+          <a:p xmlns:a="http://schemas.openxmlformats.org/drawingml/2006/main">
+            <a:pPr algn="l">
+              <a:defRPr sz="1125" b="0">
+                <a:solidFill>
+                  <a:srgbClr val="60707A"/>
+                </a:solidFill>
+                <a:latin typeface="Malgun Gothic"/>
+                <a:ea typeface="Malgun Gothic"/>
+                <a:cs typeface="Malgun Gothic"/>
+              </a:defRPr>
+            </a:pPr>
+            <a:r>
+              <a:rPr sz="1125" b="0">
+                <a:solidFill>
+                  <a:srgbClr val="60707A"/>
+                </a:solidFill>
+                <a:latin typeface="Malgun Gothic"/>
+                <a:ea typeface="Malgun Gothic"/>
+                <a:cs typeface="Malgun Gothic"/>
+              </a:rPr>
+              <a:t>저는 지하철을 타고 회사에 갑니다.</a:t>
+            </a:r>
+          </a:p>
+        </p:txBody>
+      </p:sp>
+      <p:sp>
+        <p:nvSpPr>
+          <p:cNvPr id="26" name="">
+            <a:extLst xmlns:a="http://schemas.openxmlformats.org/drawingml/2006/main">
+              <a:ext uri="{FF2B5EF4-FFF2-40B4-BE49-F238E27FC236}">
+                <a16:creationId xmlns:a16="http://schemas.microsoft.com/office/drawing/2014/main" id="{B953A9C9-FCB8-4EF6-874C-D32AC209E125}"/>
+              </a:ext>
+            </a:extLst>
+          </p:cNvPr>
+          <p:cNvSpPr>
+            <a:spLocks xmlns:a="http://schemas.openxmlformats.org/drawingml/2006/main" noGrp="1"/>
+          </p:cNvSpPr>
+          <p:nvPr/>
+        </p:nvSpPr>
+        <p:spPr>
+          <a:xfrm xmlns:a="http://schemas.openxmlformats.org/drawingml/2006/main">
+            <a:off x="4419600" y="4876800"/>
+            <a:ext cx="2571750" cy="209550"/>
+          </a:xfrm>
+          <a:prstGeom xmlns:a="http://schemas.openxmlformats.org/drawingml/2006/main" prst="rect">
+            <a:avLst/>
+          </a:prstGeom>
+          <a:solidFill xmlns:a="http://schemas.openxmlformats.org/drawingml/2006/main">
+            <a:srgbClr val="000000">
+              <a:alpha val="0"/>
+            </a:srgbClr>
+          </a:solidFill>
+          <a:ln xmlns:a="http://schemas.openxmlformats.org/drawingml/2006/main" w="0">
+            <a:solidFill>
+              <a:srgbClr val="000000">
+                <a:alpha val="0"/>
+              </a:srgbClr>
+            </a:solidFill>
+            <a:prstDash val="solid"/>
+          </a:ln>
+        </p:spPr>
+        <p:txBody>
+          <a:bodyPr xmlns:a="http://schemas.openxmlformats.org/drawingml/2006/main" lIns="0" tIns="0" rIns="0" bIns="0" anchor="t"/>
+          <a:lstStyle xmlns:a="http://schemas.openxmlformats.org/drawingml/2006/main"/>
+          <a:p xmlns:a="http://schemas.openxmlformats.org/drawingml/2006/main">
+            <a:pPr algn="l">
+              <a:defRPr sz="1125" b="1">
+                <a:solidFill>
+                  <a:srgbClr val="E76F51"/>
+                </a:solidFill>
+                <a:latin typeface="Malgun Gothic"/>
+                <a:ea typeface="Malgun Gothic"/>
+                <a:cs typeface="Malgun Gothic"/>
+              </a:defRPr>
+            </a:pPr>
+            <a:r>
+              <a:rPr sz="1125" b="1">
+                <a:solidFill>
+                  <a:srgbClr val="E76F51"/>
+                </a:solidFill>
+                <a:latin typeface="Malgun Gothic"/>
+                <a:ea typeface="Malgun Gothic"/>
+                <a:cs typeface="Malgun Gothic"/>
+              </a:rPr>
+              <a:t>말하기 포인트  ·  교통수단 + 목적지</a:t>
+            </a:r>
+          </a:p>
+        </p:txBody>
+      </p:sp>
+      <p:sp>
+        <p:nvSpPr>
+          <p:cNvPr id="27" name="">
+            <a:extLst xmlns:a="http://schemas.openxmlformats.org/drawingml/2006/main">
+              <a:ext uri="{FF2B5EF4-FFF2-40B4-BE49-F238E27FC236}">
+                <a16:creationId xmlns:a16="http://schemas.microsoft.com/office/drawing/2014/main" id="{4D19DAA2-A3EA-4A54-9D36-B4B7A5E242C8}"/>
+              </a:ext>
+            </a:extLst>
+          </p:cNvPr>
+          <p:cNvSpPr>
+            <a:spLocks xmlns:a="http://schemas.openxmlformats.org/drawingml/2006/main" noGrp="1"/>
+          </p:cNvSpPr>
+          <p:nvPr/>
+        </p:nvSpPr>
+        <p:spPr>
+          <a:xfrm xmlns:a="http://schemas.openxmlformats.org/drawingml/2006/main">
+            <a:off x="7581900" y="3705225"/>
+            <a:ext cx="495300" cy="28575"/>
+          </a:xfrm>
+          <a:prstGeom xmlns:a="http://schemas.openxmlformats.org/drawingml/2006/main" prst="rect">
+            <a:avLst/>
+          </a:prstGeom>
+          <a:solidFill xmlns:a="http://schemas.openxmlformats.org/drawingml/2006/main">
+            <a:srgbClr val="0F766E"/>
+          </a:solidFill>
+          <a:ln xmlns:a="http://schemas.openxmlformats.org/drawingml/2006/main" w="0">
+            <a:solidFill>
+              <a:srgbClr val="0F766E"/>
+            </a:solidFill>
+            <a:prstDash val="solid"/>
+          </a:ln>
+        </p:spPr>
+      </p:sp>
+      <p:sp>
+        <p:nvSpPr>
+          <p:cNvPr id="28" name="">
+            <a:extLst xmlns:a="http://schemas.openxmlformats.org/drawingml/2006/main">
+              <a:ext uri="{FF2B5EF4-FFF2-40B4-BE49-F238E27FC236}">
+                <a16:creationId xmlns:a16="http://schemas.microsoft.com/office/drawing/2014/main" id="{8748FEDE-02A2-4D47-84BC-935FCEEA895C}"/>
+              </a:ext>
+            </a:extLst>
+          </p:cNvPr>
+          <p:cNvSpPr>
+            <a:spLocks xmlns:a="http://schemas.openxmlformats.org/drawingml/2006/main" noGrp="1"/>
+          </p:cNvSpPr>
+          <p:nvPr/>
+        </p:nvSpPr>
+        <p:spPr>
+          <a:xfrm xmlns:a="http://schemas.openxmlformats.org/drawingml/2006/main">
+            <a:off x="8058150" y="3552825"/>
+            <a:ext cx="209550" cy="323850"/>
+          </a:xfrm>
+          <a:prstGeom xmlns:a="http://schemas.openxmlformats.org/drawingml/2006/main" prst="rect">
+            <a:avLst/>
+          </a:prstGeom>
+          <a:solidFill xmlns:a="http://schemas.openxmlformats.org/drawingml/2006/main">
+            <a:srgbClr val="000000">
+              <a:alpha val="0"/>
+            </a:srgbClr>
+          </a:solidFill>
+          <a:ln xmlns:a="http://schemas.openxmlformats.org/drawingml/2006/main" w="0">
+            <a:solidFill>
+              <a:srgbClr val="000000">
+                <a:alpha val="0"/>
+              </a:srgbClr>
+            </a:solidFill>
+            <a:prstDash val="solid"/>
+          </a:ln>
+        </p:spPr>
+        <p:txBody>
+          <a:bodyPr xmlns:a="http://schemas.openxmlformats.org/drawingml/2006/main" lIns="0" tIns="0" rIns="0" bIns="0" anchor="t"/>
+          <a:lstStyle xmlns:a="http://schemas.openxmlformats.org/drawingml/2006/main"/>
+          <a:p xmlns:a="http://schemas.openxmlformats.org/drawingml/2006/main">
+            <a:pPr algn="ctr">
+              <a:defRPr sz="1950" b="1">
+                <a:solidFill>
+                  <a:srgbClr val="0F766E"/>
+                </a:solidFill>
+                <a:latin typeface="Malgun Gothic"/>
+                <a:ea typeface="Malgun Gothic"/>
+                <a:cs typeface="Malgun Gothic"/>
+              </a:defRPr>
+            </a:pPr>
+            <a:r>
+              <a:rPr sz="1950" b="1">
+                <a:solidFill>
+                  <a:srgbClr val="0F766E"/>
+                </a:solidFill>
+                <a:latin typeface="Malgun Gothic"/>
+                <a:ea typeface="Malgun Gothic"/>
+                <a:cs typeface="Malgun Gothic"/>
+              </a:rPr>
+              <a:t>&gt;</a:t>
+            </a:r>
+          </a:p>
+        </p:txBody>
+      </p:sp>
+      <p:sp>
+        <p:nvSpPr>
+          <p:cNvPr id="29" name="">
+            <a:extLst xmlns:a="http://schemas.openxmlformats.org/drawingml/2006/main">
+              <a:ext uri="{FF2B5EF4-FFF2-40B4-BE49-F238E27FC236}">
+                <a16:creationId xmlns:a16="http://schemas.microsoft.com/office/drawing/2014/main" id="{5811F19B-D936-43E9-BCCB-3F1FB582F3E3}"/>
+              </a:ext>
+            </a:extLst>
+          </p:cNvPr>
+          <p:cNvSpPr>
+            <a:spLocks xmlns:a="http://schemas.openxmlformats.org/drawingml/2006/main" noGrp="1"/>
+          </p:cNvSpPr>
+          <p:nvPr/>
+        </p:nvSpPr>
+        <p:spPr>
+          <a:xfrm xmlns:a="http://schemas.openxmlformats.org/drawingml/2006/main">
+            <a:off x="7581900" y="3390900"/>
+            <a:ext cx="400050" cy="171450"/>
+          </a:xfrm>
+          <a:prstGeom xmlns:a="http://schemas.openxmlformats.org/drawingml/2006/main" prst="rect">
+            <a:avLst/>
+          </a:prstGeom>
+          <a:solidFill xmlns:a="http://schemas.openxmlformats.org/drawingml/2006/main">
+            <a:srgbClr val="000000">
+              <a:alpha val="0"/>
+            </a:srgbClr>
+          </a:solidFill>
+          <a:ln xmlns:a="http://schemas.openxmlformats.org/drawingml/2006/main" w="0">
+            <a:solidFill>
+              <a:srgbClr val="000000">
+                <a:alpha val="0"/>
+              </a:srgbClr>
+            </a:solidFill>
+            <a:prstDash val="solid"/>
+          </a:ln>
+        </p:spPr>
+        <p:txBody>
+          <a:bodyPr xmlns:a="http://schemas.openxmlformats.org/drawingml/2006/main" lIns="0" tIns="0" rIns="0" bIns="0" anchor="t"/>
+          <a:lstStyle xmlns:a="http://schemas.openxmlformats.org/drawingml/2006/main"/>
+          <a:p xmlns:a="http://schemas.openxmlformats.org/drawingml/2006/main">
+            <a:pPr algn="ctr">
+              <a:defRPr sz="900" b="1">
+                <a:solidFill>
+                  <a:srgbClr val="60707A"/>
+                </a:solidFill>
+                <a:latin typeface="Malgun Gothic"/>
+                <a:ea typeface="Malgun Gothic"/>
+                <a:cs typeface="Malgun Gothic"/>
+              </a:defRPr>
+            </a:pPr>
+            <a:r>
+              <a:rPr sz="900" b="1">
+                <a:solidFill>
+                  <a:srgbClr val="60707A"/>
+                </a:solidFill>
+                <a:latin typeface="Malgun Gothic"/>
+                <a:ea typeface="Malgun Gothic"/>
+                <a:cs typeface="Malgun Gothic"/>
+              </a:rPr>
+              <a:t>08:00</a:t>
+            </a:r>
+          </a:p>
+        </p:txBody>
+      </p:sp>
+      <p:sp>
+        <p:nvSpPr>
+          <p:cNvPr id="30" name="">
+            <a:extLst xmlns:a="http://schemas.openxmlformats.org/drawingml/2006/main">
+              <a:ext uri="{FF2B5EF4-FFF2-40B4-BE49-F238E27FC236}">
+                <a16:creationId xmlns:a16="http://schemas.microsoft.com/office/drawing/2014/main" id="{E2A938FF-1986-4EDE-AD48-D5873480A3FE}"/>
+              </a:ext>
+            </a:extLst>
+          </p:cNvPr>
+          <p:cNvSpPr>
+            <a:spLocks xmlns:a="http://schemas.openxmlformats.org/drawingml/2006/main" noGrp="1"/>
+          </p:cNvSpPr>
+          <p:nvPr/>
+        </p:nvSpPr>
+        <p:spPr>
+          <a:xfrm xmlns:a="http://schemas.openxmlformats.org/drawingml/2006/main">
+            <a:off x="8591550" y="2266950"/>
+            <a:ext cx="2876550" cy="3105150"/>
+          </a:xfrm>
+          <a:prstGeom xmlns:a="http://schemas.openxmlformats.org/drawingml/2006/main" prst="roundRect">
+            <a:avLst>
+              <a:gd name="adj" fmla="val 2649"/>
+            </a:avLst>
+          </a:prstGeom>
+          <a:solidFill xmlns:a="http://schemas.openxmlformats.org/drawingml/2006/main">
+            <a:srgbClr val="153438"/>
+          </a:solidFill>
+          <a:ln xmlns:a="http://schemas.openxmlformats.org/drawingml/2006/main" w="0">
+            <a:solidFill>
+              <a:srgbClr val="153438"/>
+            </a:solidFill>
+            <a:prstDash val="solid"/>
+          </a:ln>
+        </p:spPr>
+      </p:sp>
+      <p:sp>
+        <p:nvSpPr>
+          <p:cNvPr id="31" name="">
+            <a:extLst xmlns:a="http://schemas.openxmlformats.org/drawingml/2006/main">
+              <a:ext uri="{FF2B5EF4-FFF2-40B4-BE49-F238E27FC236}">
+                <a16:creationId xmlns:a16="http://schemas.microsoft.com/office/drawing/2014/main" id="{8E64B576-2ACD-4B34-805E-D5BC50FE6AD2}"/>
+              </a:ext>
+            </a:extLst>
+          </p:cNvPr>
+          <p:cNvSpPr>
+            <a:spLocks xmlns:a="http://schemas.openxmlformats.org/drawingml/2006/main" noGrp="1"/>
+          </p:cNvSpPr>
+          <p:nvPr/>
+        </p:nvSpPr>
+        <p:spPr>
+          <a:xfrm xmlns:a="http://schemas.openxmlformats.org/drawingml/2006/main">
+            <a:off x="8858250" y="2533650"/>
+            <a:ext cx="1809750" cy="209550"/>
+          </a:xfrm>
+          <a:prstGeom xmlns:a="http://schemas.openxmlformats.org/drawingml/2006/main" prst="rect">
+            <a:avLst/>
+          </a:prstGeom>
+          <a:solidFill xmlns:a="http://schemas.openxmlformats.org/drawingml/2006/main">
+            <a:srgbClr val="000000">
+              <a:alpha val="0"/>
+            </a:srgbClr>
+          </a:solidFill>
+          <a:ln xmlns:a="http://schemas.openxmlformats.org/drawingml/2006/main" w="0">
+            <a:solidFill>
+              <a:srgbClr val="000000">
+                <a:alpha val="0"/>
+              </a:srgbClr>
+            </a:solidFill>
+            <a:prstDash val="solid"/>
+          </a:ln>
+        </p:spPr>
+        <p:txBody>
+          <a:bodyPr xmlns:a="http://schemas.openxmlformats.org/drawingml/2006/main" lIns="0" tIns="0" rIns="0" bIns="0" anchor="t"/>
+          <a:lstStyle xmlns:a="http://schemas.openxmlformats.org/drawingml/2006/main"/>
+          <a:p xmlns:a="http://schemas.openxmlformats.org/drawingml/2006/main">
+            <a:pPr algn="l">
+              <a:defRPr sz="1050" b="1">
+                <a:solidFill>
+                  <a:srgbClr val="D8EFEC"/>
+                </a:solidFill>
+                <a:latin typeface="Malgun Gothic"/>
+                <a:ea typeface="Malgun Gothic"/>
+                <a:cs typeface="Malgun Gothic"/>
+              </a:defRPr>
+            </a:pPr>
+            <a:r>
+              <a:rPr sz="1050" b="1">
+                <a:solidFill>
+                  <a:srgbClr val="D8EFEC"/>
+                </a:solidFill>
+                <a:latin typeface="Malgun Gothic"/>
+                <a:ea typeface="Malgun Gothic"/>
+                <a:cs typeface="Malgun Gothic"/>
+              </a:rPr>
+              <a:t>KAKAO TALK</a:t>
+            </a:r>
+          </a:p>
+        </p:txBody>
+      </p:sp>
+      <p:sp>
+        <p:nvSpPr>
+          <p:cNvPr id="32" name="">
+            <a:extLst xmlns:a="http://schemas.openxmlformats.org/drawingml/2006/main">
+              <a:ext uri="{FF2B5EF4-FFF2-40B4-BE49-F238E27FC236}">
+                <a16:creationId xmlns:a16="http://schemas.microsoft.com/office/drawing/2014/main" id="{FC65B36D-8398-4E39-83AA-365B7DA46EB1}"/>
+              </a:ext>
+            </a:extLst>
+          </p:cNvPr>
+          <p:cNvSpPr>
+            <a:spLocks xmlns:a="http://schemas.openxmlformats.org/drawingml/2006/main" noGrp="1"/>
+          </p:cNvSpPr>
+          <p:nvPr/>
+        </p:nvSpPr>
+        <p:spPr>
+          <a:xfrm xmlns:a="http://schemas.openxmlformats.org/drawingml/2006/main">
+            <a:off x="8858250" y="3009900"/>
+            <a:ext cx="2324100" cy="1657350"/>
+          </a:xfrm>
+          <a:prstGeom xmlns:a="http://schemas.openxmlformats.org/drawingml/2006/main" prst="roundRect">
+            <a:avLst>
+              <a:gd name="adj" fmla="val 4598"/>
+            </a:avLst>
+          </a:prstGeom>
+          <a:solidFill xmlns:a="http://schemas.openxmlformats.org/drawingml/2006/main">
+            <a:srgbClr val="FFFFFF"/>
+          </a:solidFill>
+          <a:ln xmlns:a="http://schemas.openxmlformats.org/drawingml/2006/main" w="0">
+            <a:solidFill>
+              <a:srgbClr val="FFFFFF"/>
+            </a:solidFill>
+            <a:prstDash val="solid"/>
+          </a:ln>
+        </p:spPr>
+      </p:sp>
+      <p:sp>
+        <p:nvSpPr>
+          <p:cNvPr id="33" name="">
+            <a:extLst xmlns:a="http://schemas.openxmlformats.org/drawingml/2006/main">
+              <a:ext uri="{FF2B5EF4-FFF2-40B4-BE49-F238E27FC236}">
+                <a16:creationId xmlns:a16="http://schemas.microsoft.com/office/drawing/2014/main" id="{9E9BBAF0-A274-4080-99A3-26E338CF7A08}"/>
+              </a:ext>
+            </a:extLst>
+          </p:cNvPr>
+          <p:cNvSpPr>
+            <a:spLocks xmlns:a="http://schemas.openxmlformats.org/drawingml/2006/main" noGrp="1"/>
+          </p:cNvSpPr>
+          <p:nvPr/>
+        </p:nvSpPr>
+        <p:spPr>
+          <a:xfrm xmlns:a="http://schemas.openxmlformats.org/drawingml/2006/main">
+            <a:off x="9048750" y="3219450"/>
+            <a:ext cx="1905000" cy="228600"/>
+          </a:xfrm>
+          <a:prstGeom xmlns:a="http://schemas.openxmlformats.org/drawingml/2006/main" prst="rect">
+            <a:avLst/>
+          </a:prstGeom>
+          <a:solidFill xmlns:a="http://schemas.openxmlformats.org/drawingml/2006/main">
+            <a:srgbClr val="000000">
+              <a:alpha val="0"/>
+            </a:srgbClr>
+          </a:solidFill>
+          <a:ln xmlns:a="http://schemas.openxmlformats.org/drawingml/2006/main" w="0">
+            <a:solidFill>
+              <a:srgbClr val="000000">
+                <a:alpha val="0"/>
+              </a:srgbClr>
+            </a:solidFill>
+            <a:prstDash val="solid"/>
+          </a:ln>
+        </p:spPr>
+        <p:txBody>
+          <a:bodyPr xmlns:a="http://schemas.openxmlformats.org/drawingml/2006/main" lIns="0" tIns="0" rIns="0" bIns="0" anchor="t"/>
+          <a:lstStyle xmlns:a="http://schemas.openxmlformats.org/drawingml/2006/main"/>
+          <a:p xmlns:a="http://schemas.openxmlformats.org/drawingml/2006/main">
+            <a:pPr algn="l">
+              <a:defRPr sz="1425" b="1">
+                <a:solidFill>
+                  <a:srgbClr val="172026"/>
+                </a:solidFill>
+                <a:latin typeface="Malgun Gothic"/>
+                <a:ea typeface="Malgun Gothic"/>
+                <a:cs typeface="Malgun Gothic"/>
+              </a:defRPr>
+            </a:pPr>
+            <a:r>
+              <a:rPr sz="1425" b="1">
+                <a:solidFill>
+                  <a:srgbClr val="172026"/>
+                </a:solidFill>
+                <a:latin typeface="Malgun Gothic"/>
+                <a:ea typeface="Malgun Gothic"/>
+                <a:cs typeface="Malgun Gothic"/>
+              </a:rPr>
+              <a:t>오늘의 HSKK 30분</a:t>
+            </a:r>
+          </a:p>
+        </p:txBody>
+      </p:sp>
+      <p:sp>
+        <p:nvSpPr>
+          <p:cNvPr id="34" name="">
+            <a:extLst xmlns:a="http://schemas.openxmlformats.org/drawingml/2006/main">
+              <a:ext uri="{FF2B5EF4-FFF2-40B4-BE49-F238E27FC236}">
+                <a16:creationId xmlns:a16="http://schemas.microsoft.com/office/drawing/2014/main" id="{1C663FDB-9DF5-4869-9A03-48650A60EB0A}"/>
+              </a:ext>
+            </a:extLst>
+          </p:cNvPr>
+          <p:cNvSpPr>
+            <a:spLocks xmlns:a="http://schemas.openxmlformats.org/drawingml/2006/main" noGrp="1"/>
+          </p:cNvSpPr>
+          <p:nvPr/>
+        </p:nvSpPr>
+        <p:spPr>
+          <a:xfrm xmlns:a="http://schemas.openxmlformats.org/drawingml/2006/main">
+            <a:off x="9048750" y="3638550"/>
+            <a:ext cx="1943100" cy="419100"/>
+          </a:xfrm>
+          <a:prstGeom xmlns:a="http://schemas.openxmlformats.org/drawingml/2006/main" prst="rect">
+            <a:avLst/>
+          </a:prstGeom>
+          <a:solidFill xmlns:a="http://schemas.openxmlformats.org/drawingml/2006/main">
+            <a:srgbClr val="000000">
+              <a:alpha val="0"/>
+            </a:srgbClr>
+          </a:solidFill>
+          <a:ln xmlns:a="http://schemas.openxmlformats.org/drawingml/2006/main" w="0">
+            <a:solidFill>
+              <a:srgbClr val="000000">
+                <a:alpha val="0"/>
+              </a:srgbClr>
+            </a:solidFill>
+            <a:prstDash val="solid"/>
+          </a:ln>
+        </p:spPr>
+        <p:txBody>
+          <a:bodyPr xmlns:a="http://schemas.openxmlformats.org/drawingml/2006/main" lIns="0" tIns="0" rIns="0" bIns="0" anchor="t"/>
+          <a:lstStyle xmlns:a="http://schemas.openxmlformats.org/drawingml/2006/main"/>
+          <a:p xmlns:a="http://schemas.openxmlformats.org/drawingml/2006/main">
+            <a:pPr algn="l">
+              <a:defRPr sz="1125" b="0">
+                <a:solidFill>
+                  <a:srgbClr val="60707A"/>
+                </a:solidFill>
+                <a:latin typeface="Malgun Gothic"/>
+                <a:ea typeface="Malgun Gothic"/>
+                <a:cs typeface="Malgun Gothic"/>
+              </a:defRPr>
+            </a:pPr>
+            <a:r>
+              <a:rPr sz="1125" b="0">
+                <a:solidFill>
+                  <a:srgbClr val="60707A"/>
+                </a:solidFill>
+                <a:latin typeface="Malgun Gothic"/>
+                <a:ea typeface="Malgun Gothic"/>
+                <a:cs typeface="Malgun Gothic"/>
+              </a:rPr>
+              <a:t>Lesson 02: 교통과 이동</a:t>
+            </a:r>
+          </a:p>
+          <a:p xmlns:a="http://schemas.openxmlformats.org/drawingml/2006/main">
+            <a:pPr algn="l">
+              <a:defRPr sz="1125" b="0">
+                <a:solidFill>
+                  <a:srgbClr val="60707A"/>
+                </a:solidFill>
+                <a:latin typeface="Malgun Gothic"/>
+                <a:ea typeface="Malgun Gothic"/>
+                <a:cs typeface="Malgun Gothic"/>
+              </a:defRPr>
+            </a:pPr>
+            <a:r>
+              <a:rPr sz="1125" b="0">
+                <a:solidFill>
+                  <a:srgbClr val="60707A"/>
+                </a:solidFill>
+                <a:latin typeface="Malgun Gothic"/>
+                <a:ea typeface="Malgun Gothic"/>
+                <a:cs typeface="Malgun Gothic"/>
+              </a:rPr>
+              <a:t>복습: D+1 문장 3개</a:t>
+            </a:r>
+          </a:p>
+        </p:txBody>
+      </p:sp>
+      <p:sp>
+        <p:nvSpPr>
+          <p:cNvPr id="35" name="">
+            <a:extLst xmlns:a="http://schemas.openxmlformats.org/drawingml/2006/main">
+              <a:ext uri="{FF2B5EF4-FFF2-40B4-BE49-F238E27FC236}">
+                <a16:creationId xmlns:a16="http://schemas.microsoft.com/office/drawing/2014/main" id="{8C7EBD43-ADA2-4C7F-A179-62349E5CBC4F}"/>
+              </a:ext>
+            </a:extLst>
+          </p:cNvPr>
+          <p:cNvSpPr>
+            <a:spLocks xmlns:a="http://schemas.openxmlformats.org/drawingml/2006/main" noGrp="1"/>
+          </p:cNvSpPr>
+          <p:nvPr/>
+        </p:nvSpPr>
+        <p:spPr>
+          <a:xfrm xmlns:a="http://schemas.openxmlformats.org/drawingml/2006/main">
+            <a:off x="9048750" y="4267200"/>
+            <a:ext cx="1466850" cy="285750"/>
+          </a:xfrm>
+          <a:prstGeom xmlns:a="http://schemas.openxmlformats.org/drawingml/2006/main" prst="roundRect">
+            <a:avLst>
+              <a:gd name="adj" fmla="val 26667"/>
+            </a:avLst>
+          </a:prstGeom>
+          <a:solidFill xmlns:a="http://schemas.openxmlformats.org/drawingml/2006/main">
+            <a:srgbClr val="0F766E"/>
+          </a:solidFill>
+          <a:ln xmlns:a="http://schemas.openxmlformats.org/drawingml/2006/main" w="0">
+            <a:solidFill>
+              <a:srgbClr val="0F766E"/>
+            </a:solidFill>
+            <a:prstDash val="solid"/>
+          </a:ln>
+        </p:spPr>
+      </p:sp>
+      <p:sp>
+        <p:nvSpPr>
+          <p:cNvPr id="36" name="">
+            <a:extLst xmlns:a="http://schemas.openxmlformats.org/drawingml/2006/main">
+              <a:ext uri="{FF2B5EF4-FFF2-40B4-BE49-F238E27FC236}">
+                <a16:creationId xmlns:a16="http://schemas.microsoft.com/office/drawing/2014/main" id="{CA5AD0DF-C78F-4956-A7FC-9C0125530174}"/>
+              </a:ext>
+            </a:extLst>
+          </p:cNvPr>
+          <p:cNvSpPr>
+            <a:spLocks xmlns:a="http://schemas.openxmlformats.org/drawingml/2006/main" noGrp="1"/>
+          </p:cNvSpPr>
+          <p:nvPr/>
+        </p:nvSpPr>
+        <p:spPr>
+          <a:xfrm xmlns:a="http://schemas.openxmlformats.org/drawingml/2006/main">
+            <a:off x="9048750" y="4324350"/>
+            <a:ext cx="1466850" cy="171450"/>
+          </a:xfrm>
+          <a:prstGeom xmlns:a="http://schemas.openxmlformats.org/drawingml/2006/main" prst="rect">
+            <a:avLst/>
+          </a:prstGeom>
+          <a:solidFill xmlns:a="http://schemas.openxmlformats.org/drawingml/2006/main">
+            <a:srgbClr val="000000">
+              <a:alpha val="0"/>
+            </a:srgbClr>
+          </a:solidFill>
+          <a:ln xmlns:a="http://schemas.openxmlformats.org/drawingml/2006/main" w="0">
+            <a:solidFill>
+              <a:srgbClr val="000000">
+                <a:alpha val="0"/>
+              </a:srgbClr>
+            </a:solidFill>
+            <a:prstDash val="solid"/>
+          </a:ln>
+        </p:spPr>
+        <p:txBody>
+          <a:bodyPr xmlns:a="http://schemas.openxmlformats.org/drawingml/2006/main" lIns="0" tIns="0" rIns="0" bIns="0" anchor="t"/>
+          <a:lstStyle xmlns:a="http://schemas.openxmlformats.org/drawingml/2006/main"/>
+          <a:p xmlns:a="http://schemas.openxmlformats.org/drawingml/2006/main">
+            <a:pPr algn="ctr">
+              <a:defRPr sz="1050" b="1">
+                <a:solidFill>
+                  <a:srgbClr val="FFFFFF"/>
+                </a:solidFill>
+                <a:latin typeface="Malgun Gothic"/>
+                <a:ea typeface="Malgun Gothic"/>
+                <a:cs typeface="Malgun Gothic"/>
+              </a:defRPr>
+            </a:pPr>
+            <a:r>
+              <a:rPr sz="1050" b="1">
+                <a:solidFill>
+                  <a:srgbClr val="FFFFFF"/>
+                </a:solidFill>
+                <a:latin typeface="Malgun Gothic"/>
+                <a:ea typeface="Malgun Gothic"/>
+                <a:cs typeface="Malgun Gothic"/>
+              </a:rPr>
+              <a:t>모바일 학습 열기</a:t>
+            </a:r>
+          </a:p>
+        </p:txBody>
+      </p:sp>
+      <p:sp>
+        <p:nvSpPr>
+          <p:cNvPr id="37" name="">
+            <a:extLst xmlns:a="http://schemas.openxmlformats.org/drawingml/2006/main">
+              <a:ext uri="{FF2B5EF4-FFF2-40B4-BE49-F238E27FC236}">
+                <a16:creationId xmlns:a16="http://schemas.microsoft.com/office/drawing/2014/main" id="{3E920331-0E3B-4B4F-AEDE-AF0550B5492B}"/>
+              </a:ext>
+            </a:extLst>
+          </p:cNvPr>
+          <p:cNvSpPr>
+            <a:spLocks xmlns:a="http://schemas.openxmlformats.org/drawingml/2006/main" noGrp="1"/>
+          </p:cNvSpPr>
+          <p:nvPr/>
+        </p:nvSpPr>
+        <p:spPr>
+          <a:xfrm xmlns:a="http://schemas.openxmlformats.org/drawingml/2006/main">
+            <a:off x="8858250" y="4781550"/>
+            <a:ext cx="2095500" cy="361950"/>
+          </a:xfrm>
+          <a:prstGeom xmlns:a="http://schemas.openxmlformats.org/drawingml/2006/main" prst="rect">
+            <a:avLst/>
+          </a:prstGeom>
+          <a:solidFill xmlns:a="http://schemas.openxmlformats.org/drawingml/2006/main">
+            <a:srgbClr val="000000">
+              <a:alpha val="0"/>
+            </a:srgbClr>
+          </a:solidFill>
+          <a:ln xmlns:a="http://schemas.openxmlformats.org/drawingml/2006/main" w="0">
+            <a:solidFill>
+              <a:srgbClr val="000000">
+                <a:alpha val="0"/>
+              </a:srgbClr>
+            </a:solidFill>
+            <a:prstDash val="solid"/>
+          </a:ln>
+        </p:spPr>
+        <p:txBody>
+          <a:bodyPr xmlns:a="http://schemas.openxmlformats.org/drawingml/2006/main" lIns="0" tIns="0" rIns="0" bIns="0" anchor="t"/>
+          <a:lstStyle xmlns:a="http://schemas.openxmlformats.org/drawingml/2006/main"/>
+          <a:p xmlns:a="http://schemas.openxmlformats.org/drawingml/2006/main">
+            <a:pPr algn="l">
+              <a:defRPr sz="1200" b="1">
+                <a:solidFill>
+                  <a:srgbClr val="D8EFEC"/>
+                </a:solidFill>
+                <a:latin typeface="Malgun Gothic"/>
+                <a:ea typeface="Malgun Gothic"/>
+                <a:cs typeface="Malgun Gothic"/>
+              </a:defRPr>
+            </a:pPr>
+            <a:r>
+              <a:rPr sz="1200" b="1">
+                <a:solidFill>
+                  <a:srgbClr val="D8EFEC"/>
+                </a:solidFill>
+                <a:latin typeface="Malgun Gothic"/>
+                <a:ea typeface="Malgun Gothic"/>
+                <a:cs typeface="Malgun Gothic"/>
+              </a:rPr>
+              <a:t>매일 아침 카톡으로</a:t>
+            </a:r>
+          </a:p>
+          <a:p xmlns:a="http://schemas.openxmlformats.org/drawingml/2006/main">
+            <a:pPr algn="l">
+              <a:defRPr sz="1200" b="1">
+                <a:solidFill>
+                  <a:srgbClr val="D8EFEC"/>
+                </a:solidFill>
+                <a:latin typeface="Malgun Gothic"/>
+                <a:ea typeface="Malgun Gothic"/>
+                <a:cs typeface="Malgun Gothic"/>
+              </a:defRPr>
+            </a:pPr>
+            <a:r>
+              <a:rPr sz="1200" b="1">
+                <a:solidFill>
+                  <a:srgbClr val="D8EFEC"/>
+                </a:solidFill>
+                <a:latin typeface="Malgun Gothic"/>
+                <a:ea typeface="Malgun Gothic"/>
+                <a:cs typeface="Malgun Gothic"/>
+              </a:rPr>
+              <a:t>오늘의 링크 도착</a:t>
+            </a:r>
+          </a:p>
+        </p:txBody>
+      </p:sp>
+      <p:sp>
+        <p:nvSpPr>
+          <p:cNvPr id="38" name="">
+            <a:extLst xmlns:a="http://schemas.openxmlformats.org/drawingml/2006/main">
+              <a:ext uri="{FF2B5EF4-FFF2-40B4-BE49-F238E27FC236}">
+                <a16:creationId xmlns:a16="http://schemas.microsoft.com/office/drawing/2014/main" id="{6B16438E-8278-4894-AFB8-EE907E080135}"/>
+              </a:ext>
+            </a:extLst>
+          </p:cNvPr>
+          <p:cNvSpPr>
+            <a:spLocks xmlns:a="http://schemas.openxmlformats.org/drawingml/2006/main" noGrp="1"/>
+          </p:cNvSpPr>
+          <p:nvPr/>
+        </p:nvSpPr>
+        <p:spPr>
+          <a:xfrm xmlns:a="http://schemas.openxmlformats.org/drawingml/2006/main">
+            <a:off x="533400" y="6429375"/>
+            <a:ext cx="11125200" cy="9525"/>
+          </a:xfrm>
+          <a:prstGeom xmlns:a="http://schemas.openxmlformats.org/drawingml/2006/main" prst="rect">
+            <a:avLst/>
+          </a:prstGeom>
+          <a:solidFill xmlns:a="http://schemas.openxmlformats.org/drawingml/2006/main">
+            <a:srgbClr val="C9D5D8"/>
+          </a:solidFill>
+          <a:ln xmlns:a="http://schemas.openxmlformats.org/drawingml/2006/main" w="0">
+            <a:solidFill>
+              <a:srgbClr val="C9D5D8"/>
+            </a:solidFill>
+            <a:prstDash val="solid"/>
+          </a:ln>
+        </p:spPr>
+      </p:sp>
+      <p:sp>
+        <p:nvSpPr>
+          <p:cNvPr id="39" name="">
+            <a:extLst xmlns:a="http://schemas.openxmlformats.org/drawingml/2006/main">
+              <a:ext uri="{FF2B5EF4-FFF2-40B4-BE49-F238E27FC236}">
+                <a16:creationId xmlns:a16="http://schemas.microsoft.com/office/drawing/2014/main" id="{A4C348DC-D2CB-444E-B519-41D2BD1CCD58}"/>
+              </a:ext>
+            </a:extLst>
+          </p:cNvPr>
+          <p:cNvSpPr>
+            <a:spLocks xmlns:a="http://schemas.openxmlformats.org/drawingml/2006/main" noGrp="1"/>
+          </p:cNvSpPr>
+          <p:nvPr/>
+        </p:nvSpPr>
+        <p:spPr>
+          <a:xfrm xmlns:a="http://schemas.openxmlformats.org/drawingml/2006/main">
+            <a:off x="533400" y="6534150"/>
+            <a:ext cx="7239000" cy="171450"/>
+          </a:xfrm>
+          <a:prstGeom xmlns:a="http://schemas.openxmlformats.org/drawingml/2006/main" prst="rect">
+            <a:avLst/>
+          </a:prstGeom>
+          <a:solidFill xmlns:a="http://schemas.openxmlformats.org/drawingml/2006/main">
+            <a:srgbClr val="000000">
+              <a:alpha val="0"/>
+            </a:srgbClr>
+          </a:solidFill>
+          <a:ln xmlns:a="http://schemas.openxmlformats.org/drawingml/2006/main" w="0">
+            <a:solidFill>
+              <a:srgbClr val="000000">
+                <a:alpha val="0"/>
+              </a:srgbClr>
+            </a:solidFill>
+            <a:prstDash val="solid"/>
+          </a:ln>
+        </p:spPr>
+        <p:txBody>
+          <a:bodyPr xmlns:a="http://schemas.openxmlformats.org/drawingml/2006/main" lIns="0" tIns="0" rIns="0" bIns="0" anchor="t"/>
+          <a:lstStyle xmlns:a="http://schemas.openxmlformats.org/drawingml/2006/main"/>
+          <a:p xmlns:a="http://schemas.openxmlformats.org/drawingml/2006/main">
+            <a:pPr algn="l">
+              <a:defRPr sz="825" b="0">
+                <a:solidFill>
+                  <a:srgbClr val="60707A"/>
+                </a:solidFill>
+                <a:latin typeface="Malgun Gothic"/>
+                <a:ea typeface="Malgun Gothic"/>
+                <a:cs typeface="Malgun Gothic"/>
+              </a:defRPr>
+            </a:pPr>
+            <a:r>
+              <a:rPr sz="825" b="0">
+                <a:solidFill>
+                  <a:srgbClr val="60707A"/>
+                </a:solidFill>
+                <a:latin typeface="Malgun Gothic"/>
+                <a:ea typeface="Malgun Gothic"/>
+                <a:cs typeface="Malgun Gothic"/>
+              </a:rPr>
+              <a:t>Language Study · HSKK Harness Report</a:t>
+            </a:r>
+          </a:p>
+        </p:txBody>
+      </p:sp>
+      <p:sp>
+        <p:nvSpPr>
+          <p:cNvPr id="40" name="">
+            <a:extLst xmlns:a="http://schemas.openxmlformats.org/drawingml/2006/main">
+              <a:ext uri="{FF2B5EF4-FFF2-40B4-BE49-F238E27FC236}">
+                <a16:creationId xmlns:a16="http://schemas.microsoft.com/office/drawing/2014/main" id="{15A2E02E-42D0-46FB-879B-314A2CAC49B9}"/>
+              </a:ext>
+            </a:extLst>
+          </p:cNvPr>
+          <p:cNvSpPr>
+            <a:spLocks xmlns:a="http://schemas.openxmlformats.org/drawingml/2006/main" noGrp="1"/>
+          </p:cNvSpPr>
+          <p:nvPr/>
+        </p:nvSpPr>
+        <p:spPr>
+          <a:xfrm xmlns:a="http://schemas.openxmlformats.org/drawingml/2006/main">
+            <a:off x="11144250" y="6515100"/>
+            <a:ext cx="514350" cy="171450"/>
+          </a:xfrm>
+          <a:prstGeom xmlns:a="http://schemas.openxmlformats.org/drawingml/2006/main" prst="rect">
+            <a:avLst/>
+          </a:prstGeom>
+          <a:solidFill xmlns:a="http://schemas.openxmlformats.org/drawingml/2006/main">
+            <a:srgbClr val="000000">
+              <a:alpha val="0"/>
+            </a:srgbClr>
+          </a:solidFill>
+          <a:ln xmlns:a="http://schemas.openxmlformats.org/drawingml/2006/main" w="0">
+            <a:solidFill>
+              <a:srgbClr val="000000">
+                <a:alpha val="0"/>
+              </a:srgbClr>
+            </a:solidFill>
+            <a:prstDash val="solid"/>
+          </a:ln>
+        </p:spPr>
+        <p:txBody>
+          <a:bodyPr xmlns:a="http://schemas.openxmlformats.org/drawingml/2006/main" lIns="0" tIns="0" rIns="0" bIns="0" anchor="t"/>
+          <a:lstStyle xmlns:a="http://schemas.openxmlformats.org/drawingml/2006/main"/>
+          <a:p xmlns:a="http://schemas.openxmlformats.org/drawingml/2006/main">
+            <a:pPr algn="r">
+              <a:defRPr sz="825" b="1">
+                <a:solidFill>
+                  <a:srgbClr val="60707A"/>
                 </a:solidFill>
                 <a:latin typeface="Aptos Display"/>
                 <a:ea typeface="Aptos Display"/>
@@ -3836,9 +4770,9 @@
               </a:defRPr>
             </a:pPr>
             <a:r>
-              <a:rPr sz="2625" b="1">
-                <a:solidFill>
-                  <a:srgbClr val="0F766E"/>
+              <a:rPr sz="825" b="1">
+                <a:solidFill>
+                  <a:srgbClr val="60707A"/>
                 </a:solidFill>
                 <a:latin typeface="Aptos Display"/>
                 <a:ea typeface="Aptos Display"/>
@@ -3849,980 +4783,10 @@
           </a:p>
         </p:txBody>
       </p:sp>
-      <p:sp>
-        <p:nvSpPr>
-          <p:cNvPr id="23" name="">
-            <a:extLst xmlns:a="http://schemas.openxmlformats.org/drawingml/2006/main">
-              <a:ext uri="{FF2B5EF4-FFF2-40B4-BE49-F238E27FC236}">
-                <a16:creationId xmlns:a16="http://schemas.microsoft.com/office/drawing/2014/main" id="{CA2C1E81-EC1D-4B81-8EA2-2459D01A7340}"/>
-              </a:ext>
-            </a:extLst>
-          </p:cNvPr>
-          <p:cNvSpPr>
-            <a:spLocks xmlns:a="http://schemas.openxmlformats.org/drawingml/2006/main" noGrp="1"/>
-          </p:cNvSpPr>
-          <p:nvPr/>
-        </p:nvSpPr>
-        <p:spPr>
-          <a:xfrm xmlns:a="http://schemas.openxmlformats.org/drawingml/2006/main">
-            <a:off x="1562100" y="4781550"/>
-            <a:ext cx="1371600" cy="238125"/>
-          </a:xfrm>
-          <a:prstGeom xmlns:a="http://schemas.openxmlformats.org/drawingml/2006/main" prst="rect">
-            <a:avLst/>
-          </a:prstGeom>
-          <a:solidFill xmlns:a="http://schemas.openxmlformats.org/drawingml/2006/main">
-            <a:srgbClr val="000000">
-              <a:alpha val="0"/>
-            </a:srgbClr>
-          </a:solidFill>
-          <a:ln xmlns:a="http://schemas.openxmlformats.org/drawingml/2006/main" w="0">
-            <a:solidFill>
-              <a:srgbClr val="000000">
-                <a:alpha val="0"/>
-              </a:srgbClr>
-            </a:solidFill>
-            <a:prstDash val="solid"/>
-          </a:ln>
-        </p:spPr>
-        <p:txBody>
-          <a:bodyPr xmlns:a="http://schemas.openxmlformats.org/drawingml/2006/main" lIns="0" tIns="0" rIns="0" bIns="0" anchor="t"/>
-          <a:lstStyle xmlns:a="http://schemas.openxmlformats.org/drawingml/2006/main"/>
-          <a:p xmlns:a="http://schemas.openxmlformats.org/drawingml/2006/main">
-            <a:pPr algn="l">
-              <a:defRPr sz="1350" b="1">
-                <a:solidFill>
-                  <a:srgbClr val="172026"/>
-                </a:solidFill>
-                <a:latin typeface="Malgun Gothic"/>
-                <a:ea typeface="Malgun Gothic"/>
-                <a:cs typeface="Malgun Gothic"/>
-              </a:defRPr>
-            </a:pPr>
-            <a:r>
-              <a:rPr sz="1350" b="1">
-                <a:solidFill>
-                  <a:srgbClr val="172026"/>
-                </a:solidFill>
-                <a:latin typeface="Malgun Gothic"/>
-                <a:ea typeface="Malgun Gothic"/>
-                <a:cs typeface="Malgun Gothic"/>
-              </a:rPr>
-              <a:t>자동 생성 레슨</a:t>
-            </a:r>
-          </a:p>
-        </p:txBody>
-      </p:sp>
-      <p:sp>
-        <p:nvSpPr>
-          <p:cNvPr id="24" name="">
-            <a:extLst xmlns:a="http://schemas.openxmlformats.org/drawingml/2006/main">
-              <a:ext uri="{FF2B5EF4-FFF2-40B4-BE49-F238E27FC236}">
-                <a16:creationId xmlns:a16="http://schemas.microsoft.com/office/drawing/2014/main" id="{EB681A9B-48FF-490F-9AA8-8FEA54C6E49C}"/>
-              </a:ext>
-            </a:extLst>
-          </p:cNvPr>
-          <p:cNvSpPr>
-            <a:spLocks xmlns:a="http://schemas.openxmlformats.org/drawingml/2006/main" noGrp="1"/>
-          </p:cNvSpPr>
-          <p:nvPr/>
-        </p:nvSpPr>
-        <p:spPr>
-          <a:xfrm xmlns:a="http://schemas.openxmlformats.org/drawingml/2006/main">
-            <a:off x="1562100" y="5105400"/>
-            <a:ext cx="1371600" cy="381000"/>
-          </a:xfrm>
-          <a:prstGeom xmlns:a="http://schemas.openxmlformats.org/drawingml/2006/main" prst="rect">
-            <a:avLst/>
-          </a:prstGeom>
-          <a:solidFill xmlns:a="http://schemas.openxmlformats.org/drawingml/2006/main">
-            <a:srgbClr val="000000">
-              <a:alpha val="0"/>
-            </a:srgbClr>
-          </a:solidFill>
-          <a:ln xmlns:a="http://schemas.openxmlformats.org/drawingml/2006/main" w="0">
-            <a:solidFill>
-              <a:srgbClr val="000000">
-                <a:alpha val="0"/>
-              </a:srgbClr>
-            </a:solidFill>
-            <a:prstDash val="solid"/>
-          </a:ln>
-        </p:spPr>
-        <p:txBody>
-          <a:bodyPr xmlns:a="http://schemas.openxmlformats.org/drawingml/2006/main" lIns="0" tIns="0" rIns="0" bIns="0" anchor="t"/>
-          <a:lstStyle xmlns:a="http://schemas.openxmlformats.org/drawingml/2006/main"/>
-          <a:p xmlns:a="http://schemas.openxmlformats.org/drawingml/2006/main">
-            <a:pPr algn="l">
-              <a:defRPr sz="1125" b="0">
-                <a:solidFill>
-                  <a:srgbClr val="60707A"/>
-                </a:solidFill>
-                <a:latin typeface="Malgun Gothic"/>
-                <a:ea typeface="Malgun Gothic"/>
-                <a:cs typeface="Malgun Gothic"/>
-              </a:defRPr>
-            </a:pPr>
-            <a:r>
-              <a:rPr sz="1125" b="0">
-                <a:solidFill>
-                  <a:srgbClr val="60707A"/>
-                </a:solidFill>
-                <a:latin typeface="Malgun Gothic"/>
-                <a:ea typeface="Malgun Gothic"/>
-                <a:cs typeface="Malgun Gothic"/>
-              </a:rPr>
-              <a:t>Lesson 02 · 교통과 이동</a:t>
-            </a:r>
-          </a:p>
-        </p:txBody>
-      </p:sp>
-      <p:sp>
-        <p:nvSpPr>
-          <p:cNvPr id="25" name="">
-            <a:extLst xmlns:a="http://schemas.openxmlformats.org/drawingml/2006/main">
-              <a:ext uri="{FF2B5EF4-FFF2-40B4-BE49-F238E27FC236}">
-                <a16:creationId xmlns:a16="http://schemas.microsoft.com/office/drawing/2014/main" id="{B6F7BBCA-12E8-4031-AA01-BDCAFB51E362}"/>
-              </a:ext>
-            </a:extLst>
-          </p:cNvPr>
-          <p:cNvSpPr>
-            <a:spLocks xmlns:a="http://schemas.openxmlformats.org/drawingml/2006/main" noGrp="1"/>
-          </p:cNvSpPr>
-          <p:nvPr/>
-        </p:nvSpPr>
-        <p:spPr>
-          <a:xfrm xmlns:a="http://schemas.openxmlformats.org/drawingml/2006/main">
-            <a:off x="3409950" y="4591050"/>
-            <a:ext cx="2400300" cy="1047750"/>
-          </a:xfrm>
-          <a:prstGeom xmlns:a="http://schemas.openxmlformats.org/drawingml/2006/main" prst="roundRect">
-            <a:avLst>
-              <a:gd name="adj" fmla="val 7273"/>
-            </a:avLst>
-          </a:prstGeom>
-          <a:solidFill xmlns:a="http://schemas.openxmlformats.org/drawingml/2006/main">
-            <a:srgbClr val="FFFFFF"/>
-          </a:solidFill>
-          <a:ln xmlns:a="http://schemas.openxmlformats.org/drawingml/2006/main" w="9525">
-            <a:solidFill>
-              <a:srgbClr val="C9D5D8"/>
-            </a:solidFill>
-            <a:prstDash val="solid"/>
-          </a:ln>
-        </p:spPr>
-      </p:sp>
-      <p:sp>
-        <p:nvSpPr>
-          <p:cNvPr id="26" name="">
-            <a:extLst xmlns:a="http://schemas.openxmlformats.org/drawingml/2006/main">
-              <a:ext uri="{FF2B5EF4-FFF2-40B4-BE49-F238E27FC236}">
-                <a16:creationId xmlns:a16="http://schemas.microsoft.com/office/drawing/2014/main" id="{FFC7FF34-19CA-48E6-A9D5-64468ECC6E9A}"/>
-              </a:ext>
-            </a:extLst>
-          </p:cNvPr>
-          <p:cNvSpPr>
-            <a:spLocks xmlns:a="http://schemas.openxmlformats.org/drawingml/2006/main" noGrp="1"/>
-          </p:cNvSpPr>
-          <p:nvPr/>
-        </p:nvSpPr>
-        <p:spPr>
-          <a:xfrm xmlns:a="http://schemas.openxmlformats.org/drawingml/2006/main">
-            <a:off x="3600450" y="4829175"/>
-            <a:ext cx="533400" cy="438150"/>
-          </a:xfrm>
-          <a:prstGeom xmlns:a="http://schemas.openxmlformats.org/drawingml/2006/main" prst="rect">
-            <a:avLst/>
-          </a:prstGeom>
-          <a:solidFill xmlns:a="http://schemas.openxmlformats.org/drawingml/2006/main">
-            <a:srgbClr val="000000">
-              <a:alpha val="0"/>
-            </a:srgbClr>
-          </a:solidFill>
-          <a:ln xmlns:a="http://schemas.openxmlformats.org/drawingml/2006/main" w="0">
-            <a:solidFill>
-              <a:srgbClr val="000000">
-                <a:alpha val="0"/>
-              </a:srgbClr>
-            </a:solidFill>
-            <a:prstDash val="solid"/>
-          </a:ln>
-        </p:spPr>
-        <p:txBody>
-          <a:bodyPr xmlns:a="http://schemas.openxmlformats.org/drawingml/2006/main" lIns="0" tIns="0" rIns="0" bIns="0" anchor="t"/>
-          <a:lstStyle xmlns:a="http://schemas.openxmlformats.org/drawingml/2006/main"/>
-          <a:p xmlns:a="http://schemas.openxmlformats.org/drawingml/2006/main">
-            <a:pPr algn="l">
-              <a:defRPr sz="2625" b="1">
-                <a:solidFill>
-                  <a:srgbClr val="D9A441"/>
-                </a:solidFill>
-                <a:latin typeface="Aptos Display"/>
-                <a:ea typeface="Aptos Display"/>
-                <a:cs typeface="Aptos Display"/>
-              </a:defRPr>
-            </a:pPr>
-            <a:r>
-              <a:rPr sz="2625" b="1">
-                <a:solidFill>
-                  <a:srgbClr val="D9A441"/>
-                </a:solidFill>
-                <a:latin typeface="Aptos Display"/>
-                <a:ea typeface="Aptos Display"/>
-                <a:cs typeface="Aptos Display"/>
-              </a:rPr>
-              <a:t>14</a:t>
-            </a:r>
-          </a:p>
-        </p:txBody>
-      </p:sp>
-      <p:sp>
-        <p:nvSpPr>
-          <p:cNvPr id="27" name="">
-            <a:extLst xmlns:a="http://schemas.openxmlformats.org/drawingml/2006/main">
-              <a:ext uri="{FF2B5EF4-FFF2-40B4-BE49-F238E27FC236}">
-                <a16:creationId xmlns:a16="http://schemas.microsoft.com/office/drawing/2014/main" id="{2FAAA2F9-10D0-4F35-8B6E-6B09E281F591}"/>
-              </a:ext>
-            </a:extLst>
-          </p:cNvPr>
-          <p:cNvSpPr>
-            <a:spLocks xmlns:a="http://schemas.openxmlformats.org/drawingml/2006/main" noGrp="1"/>
-          </p:cNvSpPr>
-          <p:nvPr/>
-        </p:nvSpPr>
-        <p:spPr>
-          <a:xfrm xmlns:a="http://schemas.openxmlformats.org/drawingml/2006/main">
-            <a:off x="4248150" y="4781550"/>
-            <a:ext cx="1371600" cy="238125"/>
-          </a:xfrm>
-          <a:prstGeom xmlns:a="http://schemas.openxmlformats.org/drawingml/2006/main" prst="rect">
-            <a:avLst/>
-          </a:prstGeom>
-          <a:solidFill xmlns:a="http://schemas.openxmlformats.org/drawingml/2006/main">
-            <a:srgbClr val="000000">
-              <a:alpha val="0"/>
-            </a:srgbClr>
-          </a:solidFill>
-          <a:ln xmlns:a="http://schemas.openxmlformats.org/drawingml/2006/main" w="0">
-            <a:solidFill>
-              <a:srgbClr val="000000">
-                <a:alpha val="0"/>
-              </a:srgbClr>
-            </a:solidFill>
-            <a:prstDash val="solid"/>
-          </a:ln>
-        </p:spPr>
-        <p:txBody>
-          <a:bodyPr xmlns:a="http://schemas.openxmlformats.org/drawingml/2006/main" lIns="0" tIns="0" rIns="0" bIns="0" anchor="t"/>
-          <a:lstStyle xmlns:a="http://schemas.openxmlformats.org/drawingml/2006/main"/>
-          <a:p xmlns:a="http://schemas.openxmlformats.org/drawingml/2006/main">
-            <a:pPr algn="l">
-              <a:defRPr sz="1350" b="1">
-                <a:solidFill>
-                  <a:srgbClr val="172026"/>
-                </a:solidFill>
-                <a:latin typeface="Malgun Gothic"/>
-                <a:ea typeface="Malgun Gothic"/>
-                <a:cs typeface="Malgun Gothic"/>
-              </a:defRPr>
-            </a:pPr>
-            <a:r>
-              <a:rPr sz="1350" b="1">
-                <a:solidFill>
-                  <a:srgbClr val="172026"/>
-                </a:solidFill>
-                <a:latin typeface="Malgun Gothic"/>
-                <a:ea typeface="Malgun Gothic"/>
-                <a:cs typeface="Malgun Gothic"/>
-              </a:rPr>
-              <a:t>HSKK 중급 문항</a:t>
-            </a:r>
-          </a:p>
-        </p:txBody>
-      </p:sp>
-      <p:sp>
-        <p:nvSpPr>
-          <p:cNvPr id="28" name="">
-            <a:extLst xmlns:a="http://schemas.openxmlformats.org/drawingml/2006/main">
-              <a:ext uri="{FF2B5EF4-FFF2-40B4-BE49-F238E27FC236}">
-                <a16:creationId xmlns:a16="http://schemas.microsoft.com/office/drawing/2014/main" id="{C878F29A-C6FD-454D-AFDA-2DDF86778948}"/>
-              </a:ext>
-            </a:extLst>
-          </p:cNvPr>
-          <p:cNvSpPr>
-            <a:spLocks xmlns:a="http://schemas.openxmlformats.org/drawingml/2006/main" noGrp="1"/>
-          </p:cNvSpPr>
-          <p:nvPr/>
-        </p:nvSpPr>
-        <p:spPr>
-          <a:xfrm xmlns:a="http://schemas.openxmlformats.org/drawingml/2006/main">
-            <a:off x="4248150" y="5105400"/>
-            <a:ext cx="1371600" cy="381000"/>
-          </a:xfrm>
-          <a:prstGeom xmlns:a="http://schemas.openxmlformats.org/drawingml/2006/main" prst="rect">
-            <a:avLst/>
-          </a:prstGeom>
-          <a:solidFill xmlns:a="http://schemas.openxmlformats.org/drawingml/2006/main">
-            <a:srgbClr val="000000">
-              <a:alpha val="0"/>
-            </a:srgbClr>
-          </a:solidFill>
-          <a:ln xmlns:a="http://schemas.openxmlformats.org/drawingml/2006/main" w="0">
-            <a:solidFill>
-              <a:srgbClr val="000000">
-                <a:alpha val="0"/>
-              </a:srgbClr>
-            </a:solidFill>
-            <a:prstDash val="solid"/>
-          </a:ln>
-        </p:spPr>
-        <p:txBody>
-          <a:bodyPr xmlns:a="http://schemas.openxmlformats.org/drawingml/2006/main" lIns="0" tIns="0" rIns="0" bIns="0" anchor="t"/>
-          <a:lstStyle xmlns:a="http://schemas.openxmlformats.org/drawingml/2006/main"/>
-          <a:p xmlns:a="http://schemas.openxmlformats.org/drawingml/2006/main">
-            <a:pPr algn="l">
-              <a:defRPr sz="1125" b="0">
-                <a:solidFill>
-                  <a:srgbClr val="60707A"/>
-                </a:solidFill>
-                <a:latin typeface="Malgun Gothic"/>
-                <a:ea typeface="Malgun Gothic"/>
-                <a:cs typeface="Malgun Gothic"/>
-              </a:defRPr>
-            </a:pPr>
-            <a:r>
-              <a:rPr sz="1125" b="0">
-                <a:solidFill>
-                  <a:srgbClr val="60707A"/>
-                </a:solidFill>
-                <a:latin typeface="Malgun Gothic"/>
-                <a:ea typeface="Malgun Gothic"/>
-                <a:cs typeface="Malgun Gothic"/>
-              </a:rPr>
-              <a:t>10 + 2 + 2 구조</a:t>
-            </a:r>
-          </a:p>
-        </p:txBody>
-      </p:sp>
-      <p:sp>
-        <p:nvSpPr>
-          <p:cNvPr id="29" name="">
-            <a:extLst xmlns:a="http://schemas.openxmlformats.org/drawingml/2006/main">
-              <a:ext uri="{FF2B5EF4-FFF2-40B4-BE49-F238E27FC236}">
-                <a16:creationId xmlns:a16="http://schemas.microsoft.com/office/drawing/2014/main" id="{88F03FA9-B4F1-4E7F-BC48-5A27C8514283}"/>
-              </a:ext>
-            </a:extLst>
-          </p:cNvPr>
-          <p:cNvSpPr>
-            <a:spLocks xmlns:a="http://schemas.openxmlformats.org/drawingml/2006/main" noGrp="1"/>
-          </p:cNvSpPr>
-          <p:nvPr/>
-        </p:nvSpPr>
-        <p:spPr>
-          <a:xfrm xmlns:a="http://schemas.openxmlformats.org/drawingml/2006/main">
-            <a:off x="6096000" y="4591050"/>
-            <a:ext cx="2400300" cy="1047750"/>
-          </a:xfrm>
-          <a:prstGeom xmlns:a="http://schemas.openxmlformats.org/drawingml/2006/main" prst="roundRect">
-            <a:avLst>
-              <a:gd name="adj" fmla="val 7273"/>
-            </a:avLst>
-          </a:prstGeom>
-          <a:solidFill xmlns:a="http://schemas.openxmlformats.org/drawingml/2006/main">
-            <a:srgbClr val="FFFFFF"/>
-          </a:solidFill>
-          <a:ln xmlns:a="http://schemas.openxmlformats.org/drawingml/2006/main" w="9525">
-            <a:solidFill>
-              <a:srgbClr val="C9D5D8"/>
-            </a:solidFill>
-            <a:prstDash val="solid"/>
-          </a:ln>
-        </p:spPr>
-      </p:sp>
-      <p:sp>
-        <p:nvSpPr>
-          <p:cNvPr id="30" name="">
-            <a:extLst xmlns:a="http://schemas.openxmlformats.org/drawingml/2006/main">
-              <a:ext uri="{FF2B5EF4-FFF2-40B4-BE49-F238E27FC236}">
-                <a16:creationId xmlns:a16="http://schemas.microsoft.com/office/drawing/2014/main" id="{C5FEC8D1-E8FE-4A53-9055-F6EBD41939E4}"/>
-              </a:ext>
-            </a:extLst>
-          </p:cNvPr>
-          <p:cNvSpPr>
-            <a:spLocks xmlns:a="http://schemas.openxmlformats.org/drawingml/2006/main" noGrp="1"/>
-          </p:cNvSpPr>
-          <p:nvPr/>
-        </p:nvSpPr>
-        <p:spPr>
-          <a:xfrm xmlns:a="http://schemas.openxmlformats.org/drawingml/2006/main">
-            <a:off x="6286500" y="4829175"/>
-            <a:ext cx="533400" cy="438150"/>
-          </a:xfrm>
-          <a:prstGeom xmlns:a="http://schemas.openxmlformats.org/drawingml/2006/main" prst="rect">
-            <a:avLst/>
-          </a:prstGeom>
-          <a:solidFill xmlns:a="http://schemas.openxmlformats.org/drawingml/2006/main">
-            <a:srgbClr val="000000">
-              <a:alpha val="0"/>
-            </a:srgbClr>
-          </a:solidFill>
-          <a:ln xmlns:a="http://schemas.openxmlformats.org/drawingml/2006/main" w="0">
-            <a:solidFill>
-              <a:srgbClr val="000000">
-                <a:alpha val="0"/>
-              </a:srgbClr>
-            </a:solidFill>
-            <a:prstDash val="solid"/>
-          </a:ln>
-        </p:spPr>
-        <p:txBody>
-          <a:bodyPr xmlns:a="http://schemas.openxmlformats.org/drawingml/2006/main" lIns="0" tIns="0" rIns="0" bIns="0" anchor="t"/>
-          <a:lstStyle xmlns:a="http://schemas.openxmlformats.org/drawingml/2006/main"/>
-          <a:p xmlns:a="http://schemas.openxmlformats.org/drawingml/2006/main">
-            <a:pPr algn="l">
-              <a:defRPr sz="2625" b="1">
-                <a:solidFill>
-                  <a:srgbClr val="E76F51"/>
-                </a:solidFill>
-                <a:latin typeface="Aptos Display"/>
-                <a:ea typeface="Aptos Display"/>
-                <a:cs typeface="Aptos Display"/>
-              </a:defRPr>
-            </a:pPr>
-            <a:r>
-              <a:rPr sz="2625" b="1">
-                <a:solidFill>
-                  <a:srgbClr val="E76F51"/>
-                </a:solidFill>
-                <a:latin typeface="Aptos Display"/>
-                <a:ea typeface="Aptos Display"/>
-                <a:cs typeface="Aptos Display"/>
-              </a:rPr>
-              <a:t>05</a:t>
-            </a:r>
-          </a:p>
-        </p:txBody>
-      </p:sp>
-      <p:sp>
-        <p:nvSpPr>
-          <p:cNvPr id="31" name="">
-            <a:extLst xmlns:a="http://schemas.openxmlformats.org/drawingml/2006/main">
-              <a:ext uri="{FF2B5EF4-FFF2-40B4-BE49-F238E27FC236}">
-                <a16:creationId xmlns:a16="http://schemas.microsoft.com/office/drawing/2014/main" id="{25BD0AD8-1D3E-4E64-8A36-546910ADF8EF}"/>
-              </a:ext>
-            </a:extLst>
-          </p:cNvPr>
-          <p:cNvSpPr>
-            <a:spLocks xmlns:a="http://schemas.openxmlformats.org/drawingml/2006/main" noGrp="1"/>
-          </p:cNvSpPr>
-          <p:nvPr/>
-        </p:nvSpPr>
-        <p:spPr>
-          <a:xfrm xmlns:a="http://schemas.openxmlformats.org/drawingml/2006/main">
-            <a:off x="6934200" y="4781550"/>
-            <a:ext cx="1371600" cy="238125"/>
-          </a:xfrm>
-          <a:prstGeom xmlns:a="http://schemas.openxmlformats.org/drawingml/2006/main" prst="rect">
-            <a:avLst/>
-          </a:prstGeom>
-          <a:solidFill xmlns:a="http://schemas.openxmlformats.org/drawingml/2006/main">
-            <a:srgbClr val="000000">
-              <a:alpha val="0"/>
-            </a:srgbClr>
-          </a:solidFill>
-          <a:ln xmlns:a="http://schemas.openxmlformats.org/drawingml/2006/main" w="0">
-            <a:solidFill>
-              <a:srgbClr val="000000">
-                <a:alpha val="0"/>
-              </a:srgbClr>
-            </a:solidFill>
-            <a:prstDash val="solid"/>
-          </a:ln>
-        </p:spPr>
-        <p:txBody>
-          <a:bodyPr xmlns:a="http://schemas.openxmlformats.org/drawingml/2006/main" lIns="0" tIns="0" rIns="0" bIns="0" anchor="t"/>
-          <a:lstStyle xmlns:a="http://schemas.openxmlformats.org/drawingml/2006/main"/>
-          <a:p xmlns:a="http://schemas.openxmlformats.org/drawingml/2006/main">
-            <a:pPr algn="l">
-              <a:defRPr sz="1350" b="1">
-                <a:solidFill>
-                  <a:srgbClr val="172026"/>
-                </a:solidFill>
-                <a:latin typeface="Malgun Gothic"/>
-                <a:ea typeface="Malgun Gothic"/>
-                <a:cs typeface="Malgun Gothic"/>
-              </a:defRPr>
-            </a:pPr>
-            <a:r>
-              <a:rPr sz="1350" b="1">
-                <a:solidFill>
-                  <a:srgbClr val="172026"/>
-                </a:solidFill>
-                <a:latin typeface="Malgun Gothic"/>
-                <a:ea typeface="Malgun Gothic"/>
-                <a:cs typeface="Malgun Gothic"/>
-              </a:rPr>
-              <a:t>일일 주제 Seed</a:t>
-            </a:r>
-          </a:p>
-        </p:txBody>
-      </p:sp>
-      <p:sp>
-        <p:nvSpPr>
-          <p:cNvPr id="32" name="">
-            <a:extLst xmlns:a="http://schemas.openxmlformats.org/drawingml/2006/main">
-              <a:ext uri="{FF2B5EF4-FFF2-40B4-BE49-F238E27FC236}">
-                <a16:creationId xmlns:a16="http://schemas.microsoft.com/office/drawing/2014/main" id="{7C1CF490-9594-4B2C-A06C-42C10266DE5B}"/>
-              </a:ext>
-            </a:extLst>
-          </p:cNvPr>
-          <p:cNvSpPr>
-            <a:spLocks xmlns:a="http://schemas.openxmlformats.org/drawingml/2006/main" noGrp="1"/>
-          </p:cNvSpPr>
-          <p:nvPr/>
-        </p:nvSpPr>
-        <p:spPr>
-          <a:xfrm xmlns:a="http://schemas.openxmlformats.org/drawingml/2006/main">
-            <a:off x="6934200" y="5105400"/>
-            <a:ext cx="1371600" cy="381000"/>
-          </a:xfrm>
-          <a:prstGeom xmlns:a="http://schemas.openxmlformats.org/drawingml/2006/main" prst="rect">
-            <a:avLst/>
-          </a:prstGeom>
-          <a:solidFill xmlns:a="http://schemas.openxmlformats.org/drawingml/2006/main">
-            <a:srgbClr val="000000">
-              <a:alpha val="0"/>
-            </a:srgbClr>
-          </a:solidFill>
-          <a:ln xmlns:a="http://schemas.openxmlformats.org/drawingml/2006/main" w="0">
-            <a:solidFill>
-              <a:srgbClr val="000000">
-                <a:alpha val="0"/>
-              </a:srgbClr>
-            </a:solidFill>
-            <a:prstDash val="solid"/>
-          </a:ln>
-        </p:spPr>
-        <p:txBody>
-          <a:bodyPr xmlns:a="http://schemas.openxmlformats.org/drawingml/2006/main" lIns="0" tIns="0" rIns="0" bIns="0" anchor="t"/>
-          <a:lstStyle xmlns:a="http://schemas.openxmlformats.org/drawingml/2006/main"/>
-          <a:p xmlns:a="http://schemas.openxmlformats.org/drawingml/2006/main">
-            <a:pPr algn="l">
-              <a:defRPr sz="1125" b="0">
-                <a:solidFill>
-                  <a:srgbClr val="60707A"/>
-                </a:solidFill>
-                <a:latin typeface="Malgun Gothic"/>
-                <a:ea typeface="Malgun Gothic"/>
-                <a:cs typeface="Malgun Gothic"/>
-              </a:defRPr>
-            </a:pPr>
-            <a:r>
-              <a:rPr sz="1125" b="0">
-                <a:solidFill>
-                  <a:srgbClr val="60707A"/>
-                </a:solidFill>
-                <a:latin typeface="Malgun Gothic"/>
-                <a:ea typeface="Malgun Gothic"/>
-                <a:cs typeface="Malgun Gothic"/>
-              </a:rPr>
-              <a:t>초/중급 문장 운행</a:t>
-            </a:r>
-          </a:p>
-        </p:txBody>
-      </p:sp>
-      <p:sp>
-        <p:nvSpPr>
-          <p:cNvPr id="33" name="">
-            <a:extLst xmlns:a="http://schemas.openxmlformats.org/drawingml/2006/main">
-              <a:ext uri="{FF2B5EF4-FFF2-40B4-BE49-F238E27FC236}">
-                <a16:creationId xmlns:a16="http://schemas.microsoft.com/office/drawing/2014/main" id="{2AB4FEB3-89BE-48BF-B239-CE8D26A0EBE4}"/>
-              </a:ext>
-            </a:extLst>
-          </p:cNvPr>
-          <p:cNvSpPr>
-            <a:spLocks xmlns:a="http://schemas.openxmlformats.org/drawingml/2006/main" noGrp="1"/>
-          </p:cNvSpPr>
-          <p:nvPr/>
-        </p:nvSpPr>
-        <p:spPr>
-          <a:xfrm xmlns:a="http://schemas.openxmlformats.org/drawingml/2006/main">
-            <a:off x="8782050" y="4591050"/>
-            <a:ext cx="2400300" cy="1047750"/>
-          </a:xfrm>
-          <a:prstGeom xmlns:a="http://schemas.openxmlformats.org/drawingml/2006/main" prst="roundRect">
-            <a:avLst>
-              <a:gd name="adj" fmla="val 7273"/>
-            </a:avLst>
-          </a:prstGeom>
-          <a:solidFill xmlns:a="http://schemas.openxmlformats.org/drawingml/2006/main">
-            <a:srgbClr val="FFFFFF"/>
-          </a:solidFill>
-          <a:ln xmlns:a="http://schemas.openxmlformats.org/drawingml/2006/main" w="9525">
-            <a:solidFill>
-              <a:srgbClr val="C9D5D8"/>
-            </a:solidFill>
-            <a:prstDash val="solid"/>
-          </a:ln>
-        </p:spPr>
-      </p:sp>
-      <p:sp>
-        <p:nvSpPr>
-          <p:cNvPr id="34" name="">
-            <a:extLst xmlns:a="http://schemas.openxmlformats.org/drawingml/2006/main">
-              <a:ext uri="{FF2B5EF4-FFF2-40B4-BE49-F238E27FC236}">
-                <a16:creationId xmlns:a16="http://schemas.microsoft.com/office/drawing/2014/main" id="{303E4364-39AF-4762-A6DE-9AFF0B774EEA}"/>
-              </a:ext>
-            </a:extLst>
-          </p:cNvPr>
-          <p:cNvSpPr>
-            <a:spLocks xmlns:a="http://schemas.openxmlformats.org/drawingml/2006/main" noGrp="1"/>
-          </p:cNvSpPr>
-          <p:nvPr/>
-        </p:nvSpPr>
-        <p:spPr>
-          <a:xfrm xmlns:a="http://schemas.openxmlformats.org/drawingml/2006/main">
-            <a:off x="8972550" y="4829175"/>
-            <a:ext cx="533400" cy="438150"/>
-          </a:xfrm>
-          <a:prstGeom xmlns:a="http://schemas.openxmlformats.org/drawingml/2006/main" prst="rect">
-            <a:avLst/>
-          </a:prstGeom>
-          <a:solidFill xmlns:a="http://schemas.openxmlformats.org/drawingml/2006/main">
-            <a:srgbClr val="000000">
-              <a:alpha val="0"/>
-            </a:srgbClr>
-          </a:solidFill>
-          <a:ln xmlns:a="http://schemas.openxmlformats.org/drawingml/2006/main" w="0">
-            <a:solidFill>
-              <a:srgbClr val="000000">
-                <a:alpha val="0"/>
-              </a:srgbClr>
-            </a:solidFill>
-            <a:prstDash val="solid"/>
-          </a:ln>
-        </p:spPr>
-        <p:txBody>
-          <a:bodyPr xmlns:a="http://schemas.openxmlformats.org/drawingml/2006/main" lIns="0" tIns="0" rIns="0" bIns="0" anchor="t"/>
-          <a:lstStyle xmlns:a="http://schemas.openxmlformats.org/drawingml/2006/main"/>
-          <a:p xmlns:a="http://schemas.openxmlformats.org/drawingml/2006/main">
-            <a:pPr algn="l">
-              <a:defRPr sz="2625" b="1">
-                <a:solidFill>
-                  <a:srgbClr val="0F766E"/>
-                </a:solidFill>
-                <a:latin typeface="Aptos Display"/>
-                <a:ea typeface="Aptos Display"/>
-                <a:cs typeface="Aptos Display"/>
-              </a:defRPr>
-            </a:pPr>
-            <a:r>
-              <a:rPr sz="2625" b="1">
-                <a:solidFill>
-                  <a:srgbClr val="0F766E"/>
-                </a:solidFill>
-                <a:latin typeface="Aptos Display"/>
-                <a:ea typeface="Aptos Display"/>
-                <a:cs typeface="Aptos Display"/>
-              </a:rPr>
-              <a:t>0</a:t>
-            </a:r>
-          </a:p>
-        </p:txBody>
-      </p:sp>
-      <p:sp>
-        <p:nvSpPr>
-          <p:cNvPr id="35" name="">
-            <a:extLst xmlns:a="http://schemas.openxmlformats.org/drawingml/2006/main">
-              <a:ext uri="{FF2B5EF4-FFF2-40B4-BE49-F238E27FC236}">
-                <a16:creationId xmlns:a16="http://schemas.microsoft.com/office/drawing/2014/main" id="{8DA387A8-EC7E-4B4E-A83D-D54E74E3FA40}"/>
-              </a:ext>
-            </a:extLst>
-          </p:cNvPr>
-          <p:cNvSpPr>
-            <a:spLocks xmlns:a="http://schemas.openxmlformats.org/drawingml/2006/main" noGrp="1"/>
-          </p:cNvSpPr>
-          <p:nvPr/>
-        </p:nvSpPr>
-        <p:spPr>
-          <a:xfrm xmlns:a="http://schemas.openxmlformats.org/drawingml/2006/main">
-            <a:off x="9620250" y="4781550"/>
-            <a:ext cx="1371600" cy="238125"/>
-          </a:xfrm>
-          <a:prstGeom xmlns:a="http://schemas.openxmlformats.org/drawingml/2006/main" prst="rect">
-            <a:avLst/>
-          </a:prstGeom>
-          <a:solidFill xmlns:a="http://schemas.openxmlformats.org/drawingml/2006/main">
-            <a:srgbClr val="000000">
-              <a:alpha val="0"/>
-            </a:srgbClr>
-          </a:solidFill>
-          <a:ln xmlns:a="http://schemas.openxmlformats.org/drawingml/2006/main" w="0">
-            <a:solidFill>
-              <a:srgbClr val="000000">
-                <a:alpha val="0"/>
-              </a:srgbClr>
-            </a:solidFill>
-            <a:prstDash val="solid"/>
-          </a:ln>
-        </p:spPr>
-        <p:txBody>
-          <a:bodyPr xmlns:a="http://schemas.openxmlformats.org/drawingml/2006/main" lIns="0" tIns="0" rIns="0" bIns="0" anchor="t"/>
-          <a:lstStyle xmlns:a="http://schemas.openxmlformats.org/drawingml/2006/main"/>
-          <a:p xmlns:a="http://schemas.openxmlformats.org/drawingml/2006/main">
-            <a:pPr algn="l">
-              <a:defRPr sz="1350" b="1">
-                <a:solidFill>
-                  <a:srgbClr val="172026"/>
-                </a:solidFill>
-                <a:latin typeface="Malgun Gothic"/>
-                <a:ea typeface="Malgun Gothic"/>
-                <a:cs typeface="Malgun Gothic"/>
-              </a:defRPr>
-            </a:pPr>
-            <a:r>
-              <a:rPr sz="1350" b="1">
-                <a:solidFill>
-                  <a:srgbClr val="172026"/>
-                </a:solidFill>
-                <a:latin typeface="Malgun Gothic"/>
-                <a:ea typeface="Malgun Gothic"/>
-                <a:cs typeface="Malgun Gothic"/>
-              </a:rPr>
-              <a:t>Kakao API 결과</a:t>
-            </a:r>
-          </a:p>
-        </p:txBody>
-      </p:sp>
-      <p:sp>
-        <p:nvSpPr>
-          <p:cNvPr id="36" name="">
-            <a:extLst xmlns:a="http://schemas.openxmlformats.org/drawingml/2006/main">
-              <a:ext uri="{FF2B5EF4-FFF2-40B4-BE49-F238E27FC236}">
-                <a16:creationId xmlns:a16="http://schemas.microsoft.com/office/drawing/2014/main" id="{587B65E9-42FA-41AF-B893-DECF41BADEEA}"/>
-              </a:ext>
-            </a:extLst>
-          </p:cNvPr>
-          <p:cNvSpPr>
-            <a:spLocks xmlns:a="http://schemas.openxmlformats.org/drawingml/2006/main" noGrp="1"/>
-          </p:cNvSpPr>
-          <p:nvPr/>
-        </p:nvSpPr>
-        <p:spPr>
-          <a:xfrm xmlns:a="http://schemas.openxmlformats.org/drawingml/2006/main">
-            <a:off x="9620250" y="5105400"/>
-            <a:ext cx="1371600" cy="381000"/>
-          </a:xfrm>
-          <a:prstGeom xmlns:a="http://schemas.openxmlformats.org/drawingml/2006/main" prst="rect">
-            <a:avLst/>
-          </a:prstGeom>
-          <a:solidFill xmlns:a="http://schemas.openxmlformats.org/drawingml/2006/main">
-            <a:srgbClr val="000000">
-              <a:alpha val="0"/>
-            </a:srgbClr>
-          </a:solidFill>
-          <a:ln xmlns:a="http://schemas.openxmlformats.org/drawingml/2006/main" w="0">
-            <a:solidFill>
-              <a:srgbClr val="000000">
-                <a:alpha val="0"/>
-              </a:srgbClr>
-            </a:solidFill>
-            <a:prstDash val="solid"/>
-          </a:ln>
-        </p:spPr>
-        <p:txBody>
-          <a:bodyPr xmlns:a="http://schemas.openxmlformats.org/drawingml/2006/main" lIns="0" tIns="0" rIns="0" bIns="0" anchor="t"/>
-          <a:lstStyle xmlns:a="http://schemas.openxmlformats.org/drawingml/2006/main"/>
-          <a:p xmlns:a="http://schemas.openxmlformats.org/drawingml/2006/main">
-            <a:pPr algn="l">
-              <a:defRPr sz="1125" b="0">
-                <a:solidFill>
-                  <a:srgbClr val="60707A"/>
-                </a:solidFill>
-                <a:latin typeface="Malgun Gothic"/>
-                <a:ea typeface="Malgun Gothic"/>
-                <a:cs typeface="Malgun Gothic"/>
-              </a:defRPr>
-            </a:pPr>
-            <a:r>
-              <a:rPr sz="1125" b="0">
-                <a:solidFill>
-                  <a:srgbClr val="60707A"/>
-                </a:solidFill>
-                <a:latin typeface="Malgun Gothic"/>
-                <a:ea typeface="Malgun Gothic"/>
-                <a:cs typeface="Malgun Gothic"/>
-              </a:rPr>
-              <a:t>나에게 보내기 성공</a:t>
-            </a:r>
-          </a:p>
-        </p:txBody>
-      </p:sp>
-      <p:sp>
-        <p:nvSpPr>
-          <p:cNvPr id="37" name="">
-            <a:extLst xmlns:a="http://schemas.openxmlformats.org/drawingml/2006/main">
-              <a:ext uri="{FF2B5EF4-FFF2-40B4-BE49-F238E27FC236}">
-                <a16:creationId xmlns:a16="http://schemas.microsoft.com/office/drawing/2014/main" id="{CE399275-879A-4B59-983F-38DF0423DD54}"/>
-              </a:ext>
-            </a:extLst>
-          </p:cNvPr>
-          <p:cNvSpPr>
-            <a:spLocks xmlns:a="http://schemas.openxmlformats.org/drawingml/2006/main" noGrp="1"/>
-          </p:cNvSpPr>
-          <p:nvPr/>
-        </p:nvSpPr>
-        <p:spPr>
-          <a:xfrm xmlns:a="http://schemas.openxmlformats.org/drawingml/2006/main">
-            <a:off x="533400" y="6429375"/>
-            <a:ext cx="11125200" cy="9525"/>
-          </a:xfrm>
-          <a:prstGeom xmlns:a="http://schemas.openxmlformats.org/drawingml/2006/main" prst="rect">
-            <a:avLst/>
-          </a:prstGeom>
-          <a:solidFill xmlns:a="http://schemas.openxmlformats.org/drawingml/2006/main">
-            <a:srgbClr val="C9D5D8"/>
-          </a:solidFill>
-          <a:ln xmlns:a="http://schemas.openxmlformats.org/drawingml/2006/main" w="0">
-            <a:solidFill>
-              <a:srgbClr val="C9D5D8"/>
-            </a:solidFill>
-            <a:prstDash val="solid"/>
-          </a:ln>
-        </p:spPr>
-      </p:sp>
-      <p:sp>
-        <p:nvSpPr>
-          <p:cNvPr id="38" name="">
-            <a:extLst xmlns:a="http://schemas.openxmlformats.org/drawingml/2006/main">
-              <a:ext uri="{FF2B5EF4-FFF2-40B4-BE49-F238E27FC236}">
-                <a16:creationId xmlns:a16="http://schemas.microsoft.com/office/drawing/2014/main" id="{E564A362-81F4-491E-959D-C3F4CBBE0A4E}"/>
-              </a:ext>
-            </a:extLst>
-          </p:cNvPr>
-          <p:cNvSpPr>
-            <a:spLocks xmlns:a="http://schemas.openxmlformats.org/drawingml/2006/main" noGrp="1"/>
-          </p:cNvSpPr>
-          <p:nvPr/>
-        </p:nvSpPr>
-        <p:spPr>
-          <a:xfrm xmlns:a="http://schemas.openxmlformats.org/drawingml/2006/main">
-            <a:off x="533400" y="6534150"/>
-            <a:ext cx="7239000" cy="171450"/>
-          </a:xfrm>
-          <a:prstGeom xmlns:a="http://schemas.openxmlformats.org/drawingml/2006/main" prst="rect">
-            <a:avLst/>
-          </a:prstGeom>
-          <a:solidFill xmlns:a="http://schemas.openxmlformats.org/drawingml/2006/main">
-            <a:srgbClr val="000000">
-              <a:alpha val="0"/>
-            </a:srgbClr>
-          </a:solidFill>
-          <a:ln xmlns:a="http://schemas.openxmlformats.org/drawingml/2006/main" w="0">
-            <a:solidFill>
-              <a:srgbClr val="000000">
-                <a:alpha val="0"/>
-              </a:srgbClr>
-            </a:solidFill>
-            <a:prstDash val="solid"/>
-          </a:ln>
-        </p:spPr>
-        <p:txBody>
-          <a:bodyPr xmlns:a="http://schemas.openxmlformats.org/drawingml/2006/main" lIns="0" tIns="0" rIns="0" bIns="0" anchor="t"/>
-          <a:lstStyle xmlns:a="http://schemas.openxmlformats.org/drawingml/2006/main"/>
-          <a:p xmlns:a="http://schemas.openxmlformats.org/drawingml/2006/main">
-            <a:pPr algn="l">
-              <a:defRPr sz="825" b="0">
-                <a:solidFill>
-                  <a:srgbClr val="60707A"/>
-                </a:solidFill>
-                <a:latin typeface="Malgun Gothic"/>
-                <a:ea typeface="Malgun Gothic"/>
-                <a:cs typeface="Malgun Gothic"/>
-              </a:defRPr>
-            </a:pPr>
-            <a:r>
-              <a:rPr sz="825" b="0">
-                <a:solidFill>
-                  <a:srgbClr val="60707A"/>
-                </a:solidFill>
-                <a:latin typeface="Malgun Gothic"/>
-                <a:ea typeface="Malgun Gothic"/>
-                <a:cs typeface="Malgun Gothic"/>
-              </a:rPr>
-              <a:t>Language Study · HSKK Harness Report</a:t>
-            </a:r>
-          </a:p>
-        </p:txBody>
-      </p:sp>
-      <p:sp>
-        <p:nvSpPr>
-          <p:cNvPr id="39" name="">
-            <a:extLst xmlns:a="http://schemas.openxmlformats.org/drawingml/2006/main">
-              <a:ext uri="{FF2B5EF4-FFF2-40B4-BE49-F238E27FC236}">
-                <a16:creationId xmlns:a16="http://schemas.microsoft.com/office/drawing/2014/main" id="{A0A46F36-3EB6-45C6-86F4-14B12DD77B51}"/>
-              </a:ext>
-            </a:extLst>
-          </p:cNvPr>
-          <p:cNvSpPr>
-            <a:spLocks xmlns:a="http://schemas.openxmlformats.org/drawingml/2006/main" noGrp="1"/>
-          </p:cNvSpPr>
-          <p:nvPr/>
-        </p:nvSpPr>
-        <p:spPr>
-          <a:xfrm xmlns:a="http://schemas.openxmlformats.org/drawingml/2006/main">
-            <a:off x="11144250" y="6515100"/>
-            <a:ext cx="514350" cy="171450"/>
-          </a:xfrm>
-          <a:prstGeom xmlns:a="http://schemas.openxmlformats.org/drawingml/2006/main" prst="rect">
-            <a:avLst/>
-          </a:prstGeom>
-          <a:solidFill xmlns:a="http://schemas.openxmlformats.org/drawingml/2006/main">
-            <a:srgbClr val="000000">
-              <a:alpha val="0"/>
-            </a:srgbClr>
-          </a:solidFill>
-          <a:ln xmlns:a="http://schemas.openxmlformats.org/drawingml/2006/main" w="0">
-            <a:solidFill>
-              <a:srgbClr val="000000">
-                <a:alpha val="0"/>
-              </a:srgbClr>
-            </a:solidFill>
-            <a:prstDash val="solid"/>
-          </a:ln>
-        </p:spPr>
-        <p:txBody>
-          <a:bodyPr xmlns:a="http://schemas.openxmlformats.org/drawingml/2006/main" lIns="0" tIns="0" rIns="0" bIns="0" anchor="t"/>
-          <a:lstStyle xmlns:a="http://schemas.openxmlformats.org/drawingml/2006/main"/>
-          <a:p xmlns:a="http://schemas.openxmlformats.org/drawingml/2006/main">
-            <a:pPr algn="r">
-              <a:defRPr sz="825" b="1">
-                <a:solidFill>
-                  <a:srgbClr val="60707A"/>
-                </a:solidFill>
-                <a:latin typeface="Aptos Display"/>
-                <a:ea typeface="Aptos Display"/>
-                <a:cs typeface="Aptos Display"/>
-              </a:defRPr>
-            </a:pPr>
-            <a:r>
-              <a:rPr sz="825" b="1">
-                <a:solidFill>
-                  <a:srgbClr val="60707A"/>
-                </a:solidFill>
-                <a:latin typeface="Aptos Display"/>
-                <a:ea typeface="Aptos Display"/>
-                <a:cs typeface="Aptos Display"/>
-              </a:rPr>
-              <a:t>02</a:t>
-            </a:r>
-          </a:p>
-        </p:txBody>
-      </p:sp>
     </p:spTree>
     <p:extLst>
       <p:ext uri="{BB962C8B-B14F-4D97-AF65-F5344CB8AC3E}">
-        <p14:creationId xmlns:p14="http://schemas.microsoft.com/office/powerpoint/2010/main" val="499451190"/>
+        <p14:creationId xmlns:p14="http://schemas.microsoft.com/office/powerpoint/2010/main" val="958087451"/>
       </p:ext>
     </p:extLst>
   </p:cSld>
@@ -4846,7 +4810,7 @@
           <p:cNvPr id="1" name="">
             <a:extLst xmlns:a="http://schemas.openxmlformats.org/drawingml/2006/main">
               <a:ext uri="{FF2B5EF4-FFF2-40B4-BE49-F238E27FC236}">
-                <a16:creationId xmlns:a16="http://schemas.microsoft.com/office/drawing/2014/main" id="{5E661C10-180B-4CC7-9A86-645A5A6747EE}"/>
+                <a16:creationId xmlns:a16="http://schemas.microsoft.com/office/drawing/2014/main" id="{E654755D-42BC-499B-B5A2-D0DA1671C5F3}"/>
               </a:ext>
             </a:extLst>
           </p:cNvPr>
@@ -4879,7 +4843,7 @@
           <p:cNvPr id="2" name="">
             <a:extLst xmlns:a="http://schemas.openxmlformats.org/drawingml/2006/main">
               <a:ext uri="{FF2B5EF4-FFF2-40B4-BE49-F238E27FC236}">
-                <a16:creationId xmlns:a16="http://schemas.microsoft.com/office/drawing/2014/main" id="{BADF1634-39EF-4E70-B4CA-7E73236AE91E}"/>
+                <a16:creationId xmlns:a16="http://schemas.microsoft.com/office/drawing/2014/main" id="{E8AC657A-AAE2-446C-B9EB-6820D849158F}"/>
               </a:ext>
             </a:extLst>
           </p:cNvPr>
@@ -4912,7 +4876,7 @@
           <p:cNvPr id="3" name="">
             <a:extLst xmlns:a="http://schemas.openxmlformats.org/drawingml/2006/main">
               <a:ext uri="{FF2B5EF4-FFF2-40B4-BE49-F238E27FC236}">
-                <a16:creationId xmlns:a16="http://schemas.microsoft.com/office/drawing/2014/main" id="{1229436D-3EC9-4B02-B2C8-C52EE567A627}"/>
+                <a16:creationId xmlns:a16="http://schemas.microsoft.com/office/drawing/2014/main" id="{D24CC30D-8886-4C55-91DD-CE3B57C263EA}"/>
               </a:ext>
             </a:extLst>
           </p:cNvPr>
@@ -4976,7 +4940,7 @@
           <p:cNvPr id="4" name="">
             <a:extLst xmlns:a="http://schemas.openxmlformats.org/drawingml/2006/main">
               <a:ext uri="{FF2B5EF4-FFF2-40B4-BE49-F238E27FC236}">
-                <a16:creationId xmlns:a16="http://schemas.microsoft.com/office/drawing/2014/main" id="{6DA43701-697F-4E2D-8EE1-6FA7BD7C39F6}"/>
+                <a16:creationId xmlns:a16="http://schemas.microsoft.com/office/drawing/2014/main" id="{BC4EFB12-BB52-43A0-B9CB-D52968A505BE}"/>
               </a:ext>
             </a:extLst>
           </p:cNvPr>
@@ -5040,7 +5004,7 @@
           <p:cNvPr id="5" name="">
             <a:extLst xmlns:a="http://schemas.openxmlformats.org/drawingml/2006/main">
               <a:ext uri="{FF2B5EF4-FFF2-40B4-BE49-F238E27FC236}">
-                <a16:creationId xmlns:a16="http://schemas.microsoft.com/office/drawing/2014/main" id="{A3B63145-BC78-4666-B303-081758A5D58E}"/>
+                <a16:creationId xmlns:a16="http://schemas.microsoft.com/office/drawing/2014/main" id="{0F2984B1-F60F-4D65-AA84-116D6C01ECA5}"/>
               </a:ext>
             </a:extLst>
           </p:cNvPr>
@@ -5104,7 +5068,7 @@
           <p:cNvPr id="6" name="">
             <a:extLst xmlns:a="http://schemas.openxmlformats.org/drawingml/2006/main">
               <a:ext uri="{FF2B5EF4-FFF2-40B4-BE49-F238E27FC236}">
-                <a16:creationId xmlns:a16="http://schemas.microsoft.com/office/drawing/2014/main" id="{C9BD16CA-2FD2-49CB-8CE1-19889A724258}"/>
+                <a16:creationId xmlns:a16="http://schemas.microsoft.com/office/drawing/2014/main" id="{4133DABB-9813-4FFF-A936-68B4230883D1}"/>
               </a:ext>
             </a:extLst>
           </p:cNvPr>
@@ -5168,7 +5132,7 @@
           <p:cNvPr id="7" name="">
             <a:extLst xmlns:a="http://schemas.openxmlformats.org/drawingml/2006/main">
               <a:ext uri="{FF2B5EF4-FFF2-40B4-BE49-F238E27FC236}">
-                <a16:creationId xmlns:a16="http://schemas.microsoft.com/office/drawing/2014/main" id="{A0D34888-7581-45A2-8F6F-F24651FE7551}"/>
+                <a16:creationId xmlns:a16="http://schemas.microsoft.com/office/drawing/2014/main" id="{843C9577-722A-4EA7-90C5-E3D054094FF2}"/>
               </a:ext>
             </a:extLst>
           </p:cNvPr>
@@ -5203,7 +5167,7 @@
           <p:cNvPr id="8" name="">
             <a:extLst xmlns:a="http://schemas.openxmlformats.org/drawingml/2006/main">
               <a:ext uri="{FF2B5EF4-FFF2-40B4-BE49-F238E27FC236}">
-                <a16:creationId xmlns:a16="http://schemas.microsoft.com/office/drawing/2014/main" id="{639F9A3A-4162-48BA-A166-CB689A8A675B}"/>
+                <a16:creationId xmlns:a16="http://schemas.microsoft.com/office/drawing/2014/main" id="{5AF4404A-60C1-4DF8-906B-F3DA32737439}"/>
               </a:ext>
             </a:extLst>
           </p:cNvPr>
@@ -5238,7 +5202,7 @@
           <p:cNvPr id="9" name="">
             <a:extLst xmlns:a="http://schemas.openxmlformats.org/drawingml/2006/main">
               <a:ext uri="{FF2B5EF4-FFF2-40B4-BE49-F238E27FC236}">
-                <a16:creationId xmlns:a16="http://schemas.microsoft.com/office/drawing/2014/main" id="{FFFAF46E-9A68-4904-93E8-778BF3B8EE23}"/>
+                <a16:creationId xmlns:a16="http://schemas.microsoft.com/office/drawing/2014/main" id="{AB1457CA-EED7-4110-83DF-FAAAC8D079A4}"/>
               </a:ext>
             </a:extLst>
           </p:cNvPr>
@@ -5302,7 +5266,7 @@
           <p:cNvPr id="10" name="">
             <a:extLst xmlns:a="http://schemas.openxmlformats.org/drawingml/2006/main">
               <a:ext uri="{FF2B5EF4-FFF2-40B4-BE49-F238E27FC236}">
-                <a16:creationId xmlns:a16="http://schemas.microsoft.com/office/drawing/2014/main" id="{1A9F8369-077F-4676-8410-219B30AC03BE}"/>
+                <a16:creationId xmlns:a16="http://schemas.microsoft.com/office/drawing/2014/main" id="{05B787A5-A085-4FD5-AC55-3EC5713D7B5C}"/>
               </a:ext>
             </a:extLst>
           </p:cNvPr>
@@ -5389,7 +5353,7 @@
           <p:cNvPr id="11" name="">
             <a:extLst xmlns:a="http://schemas.openxmlformats.org/drawingml/2006/main">
               <a:ext uri="{FF2B5EF4-FFF2-40B4-BE49-F238E27FC236}">
-                <a16:creationId xmlns:a16="http://schemas.microsoft.com/office/drawing/2014/main" id="{1AE7BBCD-7D1E-401A-A393-B043845191E5}"/>
+                <a16:creationId xmlns:a16="http://schemas.microsoft.com/office/drawing/2014/main" id="{F2752989-7932-45DA-A836-DB972E9408BB}"/>
               </a:ext>
             </a:extLst>
           </p:cNvPr>
@@ -5424,7 +5388,7 @@
           <p:cNvPr id="12" name="">
             <a:extLst xmlns:a="http://schemas.openxmlformats.org/drawingml/2006/main">
               <a:ext uri="{FF2B5EF4-FFF2-40B4-BE49-F238E27FC236}">
-                <a16:creationId xmlns:a16="http://schemas.microsoft.com/office/drawing/2014/main" id="{A87316B7-01B5-4D78-8A8E-563BE479C4AA}"/>
+                <a16:creationId xmlns:a16="http://schemas.microsoft.com/office/drawing/2014/main" id="{65BC2B6D-D02E-411B-925C-866EFCDF87F3}"/>
               </a:ext>
             </a:extLst>
           </p:cNvPr>
@@ -5459,7 +5423,7 @@
           <p:cNvPr id="13" name="">
             <a:extLst xmlns:a="http://schemas.openxmlformats.org/drawingml/2006/main">
               <a:ext uri="{FF2B5EF4-FFF2-40B4-BE49-F238E27FC236}">
-                <a16:creationId xmlns:a16="http://schemas.microsoft.com/office/drawing/2014/main" id="{2AC75261-FBE6-4628-9392-3EA1D27E9E44}"/>
+                <a16:creationId xmlns:a16="http://schemas.microsoft.com/office/drawing/2014/main" id="{B939BDB5-BE17-4883-9151-CDD3EFD19B14}"/>
               </a:ext>
             </a:extLst>
           </p:cNvPr>
@@ -5523,7 +5487,7 @@
           <p:cNvPr id="14" name="">
             <a:extLst xmlns:a="http://schemas.openxmlformats.org/drawingml/2006/main">
               <a:ext uri="{FF2B5EF4-FFF2-40B4-BE49-F238E27FC236}">
-                <a16:creationId xmlns:a16="http://schemas.microsoft.com/office/drawing/2014/main" id="{C36703D5-6E52-4D31-B278-E8251936A453}"/>
+                <a16:creationId xmlns:a16="http://schemas.microsoft.com/office/drawing/2014/main" id="{C9693C83-C946-4721-A51A-AA9C32AFCB7C}"/>
               </a:ext>
             </a:extLst>
           </p:cNvPr>
@@ -5610,7 +5574,7 @@
           <p:cNvPr id="15" name="">
             <a:extLst xmlns:a="http://schemas.openxmlformats.org/drawingml/2006/main">
               <a:ext uri="{FF2B5EF4-FFF2-40B4-BE49-F238E27FC236}">
-                <a16:creationId xmlns:a16="http://schemas.microsoft.com/office/drawing/2014/main" id="{9866F7A0-0DD0-461A-BB18-9412DD2B4C7C}"/>
+                <a16:creationId xmlns:a16="http://schemas.microsoft.com/office/drawing/2014/main" id="{8266B0E6-6CF9-4650-9B5C-0773A1D2D824}"/>
               </a:ext>
             </a:extLst>
           </p:cNvPr>
@@ -5643,7 +5607,7 @@
           <p:cNvPr id="16" name="">
             <a:extLst xmlns:a="http://schemas.openxmlformats.org/drawingml/2006/main">
               <a:ext uri="{FF2B5EF4-FFF2-40B4-BE49-F238E27FC236}">
-                <a16:creationId xmlns:a16="http://schemas.microsoft.com/office/drawing/2014/main" id="{30B638B5-FFB6-429F-A69B-72FB24E50FB8}"/>
+                <a16:creationId xmlns:a16="http://schemas.microsoft.com/office/drawing/2014/main" id="{3FF99127-FB22-48FE-8DD3-24D2B4EB65D0}"/>
               </a:ext>
             </a:extLst>
           </p:cNvPr>
@@ -5707,7 +5671,7 @@
           <p:cNvPr id="17" name="">
             <a:extLst xmlns:a="http://schemas.openxmlformats.org/drawingml/2006/main">
               <a:ext uri="{FF2B5EF4-FFF2-40B4-BE49-F238E27FC236}">
-                <a16:creationId xmlns:a16="http://schemas.microsoft.com/office/drawing/2014/main" id="{7157544C-5AA8-4340-B8F0-23BA34A2E660}"/>
+                <a16:creationId xmlns:a16="http://schemas.microsoft.com/office/drawing/2014/main" id="{6846F6C8-B39B-4EF5-90E2-03AB726617D0}"/>
               </a:ext>
             </a:extLst>
           </p:cNvPr>
@@ -5771,7 +5735,7 @@
           <p:cNvPr id="18" name="">
             <a:extLst xmlns:a="http://schemas.openxmlformats.org/drawingml/2006/main">
               <a:ext uri="{FF2B5EF4-FFF2-40B4-BE49-F238E27FC236}">
-                <a16:creationId xmlns:a16="http://schemas.microsoft.com/office/drawing/2014/main" id="{32A53DD2-5D97-4033-8C41-01532CFB3FFD}"/>
+                <a16:creationId xmlns:a16="http://schemas.microsoft.com/office/drawing/2014/main" id="{EA74F12F-ACA4-40F8-88D9-1B4B2E503F03}"/>
               </a:ext>
             </a:extLst>
           </p:cNvPr>
@@ -5806,7 +5770,7 @@
           <p:cNvPr id="19" name="">
             <a:extLst xmlns:a="http://schemas.openxmlformats.org/drawingml/2006/main">
               <a:ext uri="{FF2B5EF4-FFF2-40B4-BE49-F238E27FC236}">
-                <a16:creationId xmlns:a16="http://schemas.microsoft.com/office/drawing/2014/main" id="{BDA5A96F-F349-4A7D-BE90-9E8EE8048404}"/>
+                <a16:creationId xmlns:a16="http://schemas.microsoft.com/office/drawing/2014/main" id="{EC3E4977-FA16-4B99-83E9-516E464D5785}"/>
               </a:ext>
             </a:extLst>
           </p:cNvPr>
@@ -5893,7 +5857,7 @@
           <p:cNvPr id="20" name="">
             <a:extLst xmlns:a="http://schemas.openxmlformats.org/drawingml/2006/main">
               <a:ext uri="{FF2B5EF4-FFF2-40B4-BE49-F238E27FC236}">
-                <a16:creationId xmlns:a16="http://schemas.microsoft.com/office/drawing/2014/main" id="{ECD62507-754C-438E-AFBA-059DA4F00E36}"/>
+                <a16:creationId xmlns:a16="http://schemas.microsoft.com/office/drawing/2014/main" id="{FDD42FBF-F986-4C3A-BE0C-BCDAD2D94EA4}"/>
               </a:ext>
             </a:extLst>
           </p:cNvPr>
@@ -6026,7 +5990,7 @@
           <p:cNvPr id="21" name="">
             <a:extLst xmlns:a="http://schemas.openxmlformats.org/drawingml/2006/main">
               <a:ext uri="{FF2B5EF4-FFF2-40B4-BE49-F238E27FC236}">
-                <a16:creationId xmlns:a16="http://schemas.microsoft.com/office/drawing/2014/main" id="{19C9C4F3-71D9-4CF7-8D9C-05A74928669C}"/>
+                <a16:creationId xmlns:a16="http://schemas.microsoft.com/office/drawing/2014/main" id="{01CD9ED2-1856-42B7-9048-207ED2808CBD}"/>
               </a:ext>
             </a:extLst>
           </p:cNvPr>
@@ -6059,7 +6023,7 @@
           <p:cNvPr id="22" name="">
             <a:extLst xmlns:a="http://schemas.openxmlformats.org/drawingml/2006/main">
               <a:ext uri="{FF2B5EF4-FFF2-40B4-BE49-F238E27FC236}">
-                <a16:creationId xmlns:a16="http://schemas.microsoft.com/office/drawing/2014/main" id="{556CAFB0-A53E-400D-9BD5-C3FB1BC9137A}"/>
+                <a16:creationId xmlns:a16="http://schemas.microsoft.com/office/drawing/2014/main" id="{C166FF7B-5C86-462F-9BB8-28D60710C8D9}"/>
               </a:ext>
             </a:extLst>
           </p:cNvPr>
@@ -6123,7 +6087,7 @@
           <p:cNvPr id="23" name="">
             <a:extLst xmlns:a="http://schemas.openxmlformats.org/drawingml/2006/main">
               <a:ext uri="{FF2B5EF4-FFF2-40B4-BE49-F238E27FC236}">
-                <a16:creationId xmlns:a16="http://schemas.microsoft.com/office/drawing/2014/main" id="{2076A0F8-50AA-4B1C-9CF6-49AC6A5F1B7C}"/>
+                <a16:creationId xmlns:a16="http://schemas.microsoft.com/office/drawing/2014/main" id="{32AFE20E-CA28-4F77-886E-F35E7DA53B31}"/>
               </a:ext>
             </a:extLst>
           </p:cNvPr>
@@ -6187,7 +6151,7 @@
           <p:cNvPr id="24" name="">
             <a:extLst xmlns:a="http://schemas.openxmlformats.org/drawingml/2006/main">
               <a:ext uri="{FF2B5EF4-FFF2-40B4-BE49-F238E27FC236}">
-                <a16:creationId xmlns:a16="http://schemas.microsoft.com/office/drawing/2014/main" id="{95FB2652-B463-490C-8F85-E476BB320F1D}"/>
+                <a16:creationId xmlns:a16="http://schemas.microsoft.com/office/drawing/2014/main" id="{F6A08E2D-7048-4E74-8DD6-1CC11285315F}"/>
               </a:ext>
             </a:extLst>
           </p:cNvPr>
@@ -6222,7 +6186,7 @@
           <p:cNvPr id="25" name="">
             <a:extLst xmlns:a="http://schemas.openxmlformats.org/drawingml/2006/main">
               <a:ext uri="{FF2B5EF4-FFF2-40B4-BE49-F238E27FC236}">
-                <a16:creationId xmlns:a16="http://schemas.microsoft.com/office/drawing/2014/main" id="{99876B36-E805-43EF-A2A7-AF415E4814EF}"/>
+                <a16:creationId xmlns:a16="http://schemas.microsoft.com/office/drawing/2014/main" id="{916507A6-C225-4563-8F6A-6E6C9003865A}"/>
               </a:ext>
             </a:extLst>
           </p:cNvPr>
@@ -6257,7 +6221,7 @@
           <p:cNvPr id="26" name="">
             <a:extLst xmlns:a="http://schemas.openxmlformats.org/drawingml/2006/main">
               <a:ext uri="{FF2B5EF4-FFF2-40B4-BE49-F238E27FC236}">
-                <a16:creationId xmlns:a16="http://schemas.microsoft.com/office/drawing/2014/main" id="{96423ADA-4496-4317-B1B9-AEE4CDA3E806}"/>
+                <a16:creationId xmlns:a16="http://schemas.microsoft.com/office/drawing/2014/main" id="{550481F0-C263-4B0A-AD97-C95B2565CF7E}"/>
               </a:ext>
             </a:extLst>
           </p:cNvPr>
@@ -6321,7 +6285,7 @@
           <p:cNvPr id="27" name="">
             <a:extLst xmlns:a="http://schemas.openxmlformats.org/drawingml/2006/main">
               <a:ext uri="{FF2B5EF4-FFF2-40B4-BE49-F238E27FC236}">
-                <a16:creationId xmlns:a16="http://schemas.microsoft.com/office/drawing/2014/main" id="{B96BD932-0A82-4579-9A5D-84E998B34AE0}"/>
+                <a16:creationId xmlns:a16="http://schemas.microsoft.com/office/drawing/2014/main" id="{B97F1956-A2A8-457C-B805-382C4AC660FB}"/>
               </a:ext>
             </a:extLst>
           </p:cNvPr>
@@ -6375,7 +6339,30 @@
                 <a:ea typeface="Malgun Gothic"/>
                 <a:cs typeface="Malgun Gothic"/>
               </a:rPr>
-              <a:t>레슨 생성</a:t>
+              <a:t>레슨</a:t>
+            </a:r>
+          </a:p>
+          <a:p xmlns:a="http://schemas.openxmlformats.org/drawingml/2006/main">
+            <a:pPr algn="l">
+              <a:defRPr sz="1350" b="1">
+                <a:solidFill>
+                  <a:srgbClr val="172026"/>
+                </a:solidFill>
+                <a:latin typeface="Malgun Gothic"/>
+                <a:ea typeface="Malgun Gothic"/>
+                <a:cs typeface="Malgun Gothic"/>
+              </a:defRPr>
+            </a:pPr>
+            <a:r>
+              <a:rPr sz="1350" b="1">
+                <a:solidFill>
+                  <a:srgbClr val="172026"/>
+                </a:solidFill>
+                <a:latin typeface="Malgun Gothic"/>
+                <a:ea typeface="Malgun Gothic"/>
+                <a:cs typeface="Malgun Gothic"/>
+              </a:rPr>
+              <a:t>생성</a:t>
             </a:r>
           </a:p>
         </p:txBody>
@@ -6385,7 +6372,7 @@
           <p:cNvPr id="28" name="">
             <a:extLst xmlns:a="http://schemas.openxmlformats.org/drawingml/2006/main">
               <a:ext uri="{FF2B5EF4-FFF2-40B4-BE49-F238E27FC236}">
-                <a16:creationId xmlns:a16="http://schemas.microsoft.com/office/drawing/2014/main" id="{676774B1-8827-4BEA-9679-441245CBDE18}"/>
+                <a16:creationId xmlns:a16="http://schemas.microsoft.com/office/drawing/2014/main" id="{FB2599AB-DE78-49E7-845C-68B96F1B7950}"/>
               </a:ext>
             </a:extLst>
           </p:cNvPr>
@@ -6472,7 +6459,7 @@
           <p:cNvPr id="29" name="">
             <a:extLst xmlns:a="http://schemas.openxmlformats.org/drawingml/2006/main">
               <a:ext uri="{FF2B5EF4-FFF2-40B4-BE49-F238E27FC236}">
-                <a16:creationId xmlns:a16="http://schemas.microsoft.com/office/drawing/2014/main" id="{762C14D3-935C-43C3-9298-4BC11B923073}"/>
+                <a16:creationId xmlns:a16="http://schemas.microsoft.com/office/drawing/2014/main" id="{D1757365-043D-4BEF-A5FD-20EFBD9DE7B8}"/>
               </a:ext>
             </a:extLst>
           </p:cNvPr>
@@ -6505,7 +6492,7 @@
           <p:cNvPr id="30" name="">
             <a:extLst xmlns:a="http://schemas.openxmlformats.org/drawingml/2006/main">
               <a:ext uri="{FF2B5EF4-FFF2-40B4-BE49-F238E27FC236}">
-                <a16:creationId xmlns:a16="http://schemas.microsoft.com/office/drawing/2014/main" id="{C7CE1E83-36CE-4B08-96B9-04E72F6460B0}"/>
+                <a16:creationId xmlns:a16="http://schemas.microsoft.com/office/drawing/2014/main" id="{06FCB89E-D15A-4E08-B9E6-6BED411D34AF}"/>
               </a:ext>
             </a:extLst>
           </p:cNvPr>
@@ -6569,7 +6556,7 @@
           <p:cNvPr id="31" name="">
             <a:extLst xmlns:a="http://schemas.openxmlformats.org/drawingml/2006/main">
               <a:ext uri="{FF2B5EF4-FFF2-40B4-BE49-F238E27FC236}">
-                <a16:creationId xmlns:a16="http://schemas.microsoft.com/office/drawing/2014/main" id="{960A141F-645F-4DFE-AC3C-0FB645221D7B}"/>
+                <a16:creationId xmlns:a16="http://schemas.microsoft.com/office/drawing/2014/main" id="{36C67801-2923-4C73-8478-F6C5B481434A}"/>
               </a:ext>
             </a:extLst>
           </p:cNvPr>
@@ -6604,7 +6591,7 @@
           <p:cNvPr id="32" name="">
             <a:extLst xmlns:a="http://schemas.openxmlformats.org/drawingml/2006/main">
               <a:ext uri="{FF2B5EF4-FFF2-40B4-BE49-F238E27FC236}">
-                <a16:creationId xmlns:a16="http://schemas.microsoft.com/office/drawing/2014/main" id="{8B066CD8-4A29-494E-A6DE-30EE32C4D0E2}"/>
+                <a16:creationId xmlns:a16="http://schemas.microsoft.com/office/drawing/2014/main" id="{8258FD25-9BA4-40FD-8650-82E23379C83D}"/>
               </a:ext>
             </a:extLst>
           </p:cNvPr>
@@ -6639,7 +6626,7 @@
           <p:cNvPr id="33" name="">
             <a:extLst xmlns:a="http://schemas.openxmlformats.org/drawingml/2006/main">
               <a:ext uri="{FF2B5EF4-FFF2-40B4-BE49-F238E27FC236}">
-                <a16:creationId xmlns:a16="http://schemas.microsoft.com/office/drawing/2014/main" id="{96A29E90-2FEE-4740-B4D8-848270F50DAA}"/>
+                <a16:creationId xmlns:a16="http://schemas.microsoft.com/office/drawing/2014/main" id="{A724B99C-4F6C-4CA3-9C25-B4D04B222F17}"/>
               </a:ext>
             </a:extLst>
           </p:cNvPr>
@@ -6703,7 +6690,7 @@
           <p:cNvPr id="34" name="">
             <a:extLst xmlns:a="http://schemas.openxmlformats.org/drawingml/2006/main">
               <a:ext uri="{FF2B5EF4-FFF2-40B4-BE49-F238E27FC236}">
-                <a16:creationId xmlns:a16="http://schemas.microsoft.com/office/drawing/2014/main" id="{EF950CE3-1BC7-40CE-B911-E4105ABB58E8}"/>
+                <a16:creationId xmlns:a16="http://schemas.microsoft.com/office/drawing/2014/main" id="{705878B7-AFC9-47CD-A8E8-0FADDC208186}"/>
               </a:ext>
             </a:extLst>
           </p:cNvPr>
@@ -6757,7 +6744,30 @@
                 <a:ea typeface="Malgun Gothic"/>
                 <a:cs typeface="Malgun Gothic"/>
               </a:rPr>
-              <a:t>모바일 빌드</a:t>
+              <a:t>모바일</a:t>
+            </a:r>
+          </a:p>
+          <a:p xmlns:a="http://schemas.openxmlformats.org/drawingml/2006/main">
+            <a:pPr algn="l">
+              <a:defRPr sz="1350" b="1">
+                <a:solidFill>
+                  <a:srgbClr val="172026"/>
+                </a:solidFill>
+                <a:latin typeface="Malgun Gothic"/>
+                <a:ea typeface="Malgun Gothic"/>
+                <a:cs typeface="Malgun Gothic"/>
+              </a:defRPr>
+            </a:pPr>
+            <a:r>
+              <a:rPr sz="1350" b="1">
+                <a:solidFill>
+                  <a:srgbClr val="172026"/>
+                </a:solidFill>
+                <a:latin typeface="Malgun Gothic"/>
+                <a:ea typeface="Malgun Gothic"/>
+                <a:cs typeface="Malgun Gothic"/>
+              </a:rPr>
+              <a:t>빌드</a:t>
             </a:r>
           </a:p>
         </p:txBody>
@@ -6767,7 +6777,7 @@
           <p:cNvPr id="35" name="">
             <a:extLst xmlns:a="http://schemas.openxmlformats.org/drawingml/2006/main">
               <a:ext uri="{FF2B5EF4-FFF2-40B4-BE49-F238E27FC236}">
-                <a16:creationId xmlns:a16="http://schemas.microsoft.com/office/drawing/2014/main" id="{2EBE5330-E47B-42CD-88E2-89759FBD4630}"/>
+                <a16:creationId xmlns:a16="http://schemas.microsoft.com/office/drawing/2014/main" id="{4561ABEA-8BFB-41A6-A4BD-78BE5F21DAD3}"/>
               </a:ext>
             </a:extLst>
           </p:cNvPr>
@@ -6854,7 +6864,7 @@
           <p:cNvPr id="36" name="">
             <a:extLst xmlns:a="http://schemas.openxmlformats.org/drawingml/2006/main">
               <a:ext uri="{FF2B5EF4-FFF2-40B4-BE49-F238E27FC236}">
-                <a16:creationId xmlns:a16="http://schemas.microsoft.com/office/drawing/2014/main" id="{B9DAD4FB-D7DF-4792-8BF2-0E8265C2EF50}"/>
+                <a16:creationId xmlns:a16="http://schemas.microsoft.com/office/drawing/2014/main" id="{F0C117DC-A261-440C-963C-700FA6C12825}"/>
               </a:ext>
             </a:extLst>
           </p:cNvPr>
@@ -6887,7 +6897,7 @@
           <p:cNvPr id="37" name="">
             <a:extLst xmlns:a="http://schemas.openxmlformats.org/drawingml/2006/main">
               <a:ext uri="{FF2B5EF4-FFF2-40B4-BE49-F238E27FC236}">
-                <a16:creationId xmlns:a16="http://schemas.microsoft.com/office/drawing/2014/main" id="{3DBFE987-7289-46A5-B938-1307B61911ED}"/>
+                <a16:creationId xmlns:a16="http://schemas.microsoft.com/office/drawing/2014/main" id="{3828D083-1905-4A69-AADB-1088291FB0ED}"/>
               </a:ext>
             </a:extLst>
           </p:cNvPr>
@@ -6951,7 +6961,7 @@
           <p:cNvPr id="38" name="">
             <a:extLst xmlns:a="http://schemas.openxmlformats.org/drawingml/2006/main">
               <a:ext uri="{FF2B5EF4-FFF2-40B4-BE49-F238E27FC236}">
-                <a16:creationId xmlns:a16="http://schemas.microsoft.com/office/drawing/2014/main" id="{E76D41DC-7A0A-412A-8BA0-799AA95807D4}"/>
+                <a16:creationId xmlns:a16="http://schemas.microsoft.com/office/drawing/2014/main" id="{6F945B7C-2823-44EB-A126-B3438AE737EC}"/>
               </a:ext>
             </a:extLst>
           </p:cNvPr>
@@ -6986,7 +6996,7 @@
           <p:cNvPr id="39" name="">
             <a:extLst xmlns:a="http://schemas.openxmlformats.org/drawingml/2006/main">
               <a:ext uri="{FF2B5EF4-FFF2-40B4-BE49-F238E27FC236}">
-                <a16:creationId xmlns:a16="http://schemas.microsoft.com/office/drawing/2014/main" id="{C5703F1C-B330-423F-9BD2-EAEA17589055}"/>
+                <a16:creationId xmlns:a16="http://schemas.microsoft.com/office/drawing/2014/main" id="{C25CADA6-4B71-48F3-9A2B-D7E1B8DB2F91}"/>
               </a:ext>
             </a:extLst>
           </p:cNvPr>
@@ -7021,7 +7031,7 @@
           <p:cNvPr id="40" name="">
             <a:extLst xmlns:a="http://schemas.openxmlformats.org/drawingml/2006/main">
               <a:ext uri="{FF2B5EF4-FFF2-40B4-BE49-F238E27FC236}">
-                <a16:creationId xmlns:a16="http://schemas.microsoft.com/office/drawing/2014/main" id="{35057042-E005-4D52-8C53-A60B2C211A8A}"/>
+                <a16:creationId xmlns:a16="http://schemas.microsoft.com/office/drawing/2014/main" id="{1F74F3E2-D7FD-4551-BB8E-79BD7AE52683}"/>
               </a:ext>
             </a:extLst>
           </p:cNvPr>
@@ -7085,7 +7095,7 @@
           <p:cNvPr id="41" name="">
             <a:extLst xmlns:a="http://schemas.openxmlformats.org/drawingml/2006/main">
               <a:ext uri="{FF2B5EF4-FFF2-40B4-BE49-F238E27FC236}">
-                <a16:creationId xmlns:a16="http://schemas.microsoft.com/office/drawing/2014/main" id="{0D1273D6-8F72-4674-9F19-75F595F51AB9}"/>
+                <a16:creationId xmlns:a16="http://schemas.microsoft.com/office/drawing/2014/main" id="{C1689508-F003-41C8-A667-F697239CACF0}"/>
               </a:ext>
             </a:extLst>
           </p:cNvPr>
@@ -7149,7 +7159,7 @@
           <p:cNvPr id="42" name="">
             <a:extLst xmlns:a="http://schemas.openxmlformats.org/drawingml/2006/main">
               <a:ext uri="{FF2B5EF4-FFF2-40B4-BE49-F238E27FC236}">
-                <a16:creationId xmlns:a16="http://schemas.microsoft.com/office/drawing/2014/main" id="{4BC37B9A-7776-44FF-8FC6-A9746443E188}"/>
+                <a16:creationId xmlns:a16="http://schemas.microsoft.com/office/drawing/2014/main" id="{8F804CC9-90C5-4A99-BA62-BE7BC124F1FA}"/>
               </a:ext>
             </a:extLst>
           </p:cNvPr>
@@ -7226,7 +7236,30 @@
                 <a:ea typeface="Malgun Gothic"/>
                 <a:cs typeface="Malgun Gothic"/>
               </a:rPr>
-              <a:t>commit + push</a:t>
+              <a:t>commit +</a:t>
+            </a:r>
+          </a:p>
+          <a:p xmlns:a="http://schemas.openxmlformats.org/drawingml/2006/main">
+            <a:pPr algn="l">
+              <a:defRPr sz="1050" b="0">
+                <a:solidFill>
+                  <a:srgbClr val="60707A"/>
+                </a:solidFill>
+                <a:latin typeface="Malgun Gothic"/>
+                <a:ea typeface="Malgun Gothic"/>
+                <a:cs typeface="Malgun Gothic"/>
+              </a:defRPr>
+            </a:pPr>
+            <a:r>
+              <a:rPr sz="1050" b="0">
+                <a:solidFill>
+                  <a:srgbClr val="60707A"/>
+                </a:solidFill>
+                <a:latin typeface="Malgun Gothic"/>
+                <a:ea typeface="Malgun Gothic"/>
+                <a:cs typeface="Malgun Gothic"/>
+              </a:rPr>
+              <a:t>push</a:t>
             </a:r>
           </a:p>
         </p:txBody>
@@ -7236,7 +7269,7 @@
           <p:cNvPr id="43" name="">
             <a:extLst xmlns:a="http://schemas.openxmlformats.org/drawingml/2006/main">
               <a:ext uri="{FF2B5EF4-FFF2-40B4-BE49-F238E27FC236}">
-                <a16:creationId xmlns:a16="http://schemas.microsoft.com/office/drawing/2014/main" id="{9D510E6A-FCEE-4803-AD23-3EED803017A3}"/>
+                <a16:creationId xmlns:a16="http://schemas.microsoft.com/office/drawing/2014/main" id="{8470CF4A-9388-420A-8926-18579A56E7AB}"/>
               </a:ext>
             </a:extLst>
           </p:cNvPr>
@@ -7269,7 +7302,7 @@
           <p:cNvPr id="44" name="">
             <a:extLst xmlns:a="http://schemas.openxmlformats.org/drawingml/2006/main">
               <a:ext uri="{FF2B5EF4-FFF2-40B4-BE49-F238E27FC236}">
-                <a16:creationId xmlns:a16="http://schemas.microsoft.com/office/drawing/2014/main" id="{D69A0C1A-3942-467E-9FFA-2AE126830DBA}"/>
+                <a16:creationId xmlns:a16="http://schemas.microsoft.com/office/drawing/2014/main" id="{3970DF5E-6A9F-4D1B-AC8A-144201007B3F}"/>
               </a:ext>
             </a:extLst>
           </p:cNvPr>
@@ -7333,7 +7366,7 @@
           <p:cNvPr id="45" name="">
             <a:extLst xmlns:a="http://schemas.openxmlformats.org/drawingml/2006/main">
               <a:ext uri="{FF2B5EF4-FFF2-40B4-BE49-F238E27FC236}">
-                <a16:creationId xmlns:a16="http://schemas.microsoft.com/office/drawing/2014/main" id="{63DD7F10-4C27-40F2-ABA2-CE87EE53BADA}"/>
+                <a16:creationId xmlns:a16="http://schemas.microsoft.com/office/drawing/2014/main" id="{2885D86A-4AF3-4D4D-BC62-3BFADD3E712D}"/>
               </a:ext>
             </a:extLst>
           </p:cNvPr>
@@ -7368,7 +7401,7 @@
           <p:cNvPr id="46" name="">
             <a:extLst xmlns:a="http://schemas.openxmlformats.org/drawingml/2006/main">
               <a:ext uri="{FF2B5EF4-FFF2-40B4-BE49-F238E27FC236}">
-                <a16:creationId xmlns:a16="http://schemas.microsoft.com/office/drawing/2014/main" id="{A49622E8-615C-46F1-8E82-748B8962AB32}"/>
+                <a16:creationId xmlns:a16="http://schemas.microsoft.com/office/drawing/2014/main" id="{7E2F3737-2CEC-4ABA-8E9F-63544BA4E27B}"/>
               </a:ext>
             </a:extLst>
           </p:cNvPr>
@@ -7403,7 +7436,7 @@
           <p:cNvPr id="47" name="">
             <a:extLst xmlns:a="http://schemas.openxmlformats.org/drawingml/2006/main">
               <a:ext uri="{FF2B5EF4-FFF2-40B4-BE49-F238E27FC236}">
-                <a16:creationId xmlns:a16="http://schemas.microsoft.com/office/drawing/2014/main" id="{83FD7A57-F4E8-437F-B8A2-C15DC836F1F1}"/>
+                <a16:creationId xmlns:a16="http://schemas.microsoft.com/office/drawing/2014/main" id="{5A350DC5-8DF9-4E93-AD5D-341E27AEBE8B}"/>
               </a:ext>
             </a:extLst>
           </p:cNvPr>
@@ -7467,7 +7500,7 @@
           <p:cNvPr id="48" name="">
             <a:extLst xmlns:a="http://schemas.openxmlformats.org/drawingml/2006/main">
               <a:ext uri="{FF2B5EF4-FFF2-40B4-BE49-F238E27FC236}">
-                <a16:creationId xmlns:a16="http://schemas.microsoft.com/office/drawing/2014/main" id="{FBB71E08-1622-4940-A614-4158B8181CC3}"/>
+                <a16:creationId xmlns:a16="http://schemas.microsoft.com/office/drawing/2014/main" id="{F9D6F727-4785-4B6D-AF16-3608E1EB4568}"/>
               </a:ext>
             </a:extLst>
           </p:cNvPr>
@@ -7531,7 +7564,7 @@
           <p:cNvPr id="49" name="">
             <a:extLst xmlns:a="http://schemas.openxmlformats.org/drawingml/2006/main">
               <a:ext uri="{FF2B5EF4-FFF2-40B4-BE49-F238E27FC236}">
-                <a16:creationId xmlns:a16="http://schemas.microsoft.com/office/drawing/2014/main" id="{4CF16003-6AA9-48A4-8A44-46C616DB63B8}"/>
+                <a16:creationId xmlns:a16="http://schemas.microsoft.com/office/drawing/2014/main" id="{E208B2C5-5EAB-4A94-89F5-8CD7F7C83BE7}"/>
               </a:ext>
             </a:extLst>
           </p:cNvPr>
@@ -7608,7 +7641,30 @@
                 <a:ea typeface="Malgun Gothic"/>
                 <a:cs typeface="Malgun Gothic"/>
               </a:rPr>
-              <a:t>나에게 보내기</a:t>
+              <a:t>나에게</a:t>
+            </a:r>
+          </a:p>
+          <a:p xmlns:a="http://schemas.openxmlformats.org/drawingml/2006/main">
+            <a:pPr algn="l">
+              <a:defRPr sz="1050" b="0">
+                <a:solidFill>
+                  <a:srgbClr val="60707A"/>
+                </a:solidFill>
+                <a:latin typeface="Malgun Gothic"/>
+                <a:ea typeface="Malgun Gothic"/>
+                <a:cs typeface="Malgun Gothic"/>
+              </a:defRPr>
+            </a:pPr>
+            <a:r>
+              <a:rPr sz="1050" b="0">
+                <a:solidFill>
+                  <a:srgbClr val="60707A"/>
+                </a:solidFill>
+                <a:latin typeface="Malgun Gothic"/>
+                <a:ea typeface="Malgun Gothic"/>
+                <a:cs typeface="Malgun Gothic"/>
+              </a:rPr>
+              <a:t>보내기</a:t>
             </a:r>
           </a:p>
         </p:txBody>
@@ -7618,7 +7674,7 @@
           <p:cNvPr id="50" name="">
             <a:extLst xmlns:a="http://schemas.openxmlformats.org/drawingml/2006/main">
               <a:ext uri="{FF2B5EF4-FFF2-40B4-BE49-F238E27FC236}">
-                <a16:creationId xmlns:a16="http://schemas.microsoft.com/office/drawing/2014/main" id="{561EF8CC-E2EC-4DED-8DDD-36F460E7E35D}"/>
+                <a16:creationId xmlns:a16="http://schemas.microsoft.com/office/drawing/2014/main" id="{A159C921-0ADB-4328-A827-64CF573D068D}"/>
               </a:ext>
             </a:extLst>
           </p:cNvPr>
@@ -7653,7 +7709,7 @@
           <p:cNvPr id="51" name="">
             <a:extLst xmlns:a="http://schemas.openxmlformats.org/drawingml/2006/main">
               <a:ext uri="{FF2B5EF4-FFF2-40B4-BE49-F238E27FC236}">
-                <a16:creationId xmlns:a16="http://schemas.microsoft.com/office/drawing/2014/main" id="{5AF9C338-C74F-4347-93A7-64C929178726}"/>
+                <a16:creationId xmlns:a16="http://schemas.microsoft.com/office/drawing/2014/main" id="{9ADA66C9-66B6-459C-8818-6355B96C3BE7}"/>
               </a:ext>
             </a:extLst>
           </p:cNvPr>
@@ -7688,7 +7744,7 @@
           <p:cNvPr id="52" name="">
             <a:extLst xmlns:a="http://schemas.openxmlformats.org/drawingml/2006/main">
               <a:ext uri="{FF2B5EF4-FFF2-40B4-BE49-F238E27FC236}">
-                <a16:creationId xmlns:a16="http://schemas.microsoft.com/office/drawing/2014/main" id="{A4A0DC94-2163-4C65-AD0F-C45399E22914}"/>
+                <a16:creationId xmlns:a16="http://schemas.microsoft.com/office/drawing/2014/main" id="{ED39D6AA-93D6-4B04-948D-03CEE84EF85A}"/>
               </a:ext>
             </a:extLst>
           </p:cNvPr>
@@ -7752,7 +7808,7 @@
           <p:cNvPr id="53" name="">
             <a:extLst xmlns:a="http://schemas.openxmlformats.org/drawingml/2006/main">
               <a:ext uri="{FF2B5EF4-FFF2-40B4-BE49-F238E27FC236}">
-                <a16:creationId xmlns:a16="http://schemas.microsoft.com/office/drawing/2014/main" id="{780A2238-24DB-477F-B6C3-BA51E0568AEF}"/>
+                <a16:creationId xmlns:a16="http://schemas.microsoft.com/office/drawing/2014/main" id="{556B6269-559D-418E-A4FA-CFB43B6C04BA}"/>
               </a:ext>
             </a:extLst>
           </p:cNvPr>
@@ -7816,7 +7872,7 @@
           <p:cNvPr id="54" name="">
             <a:extLst xmlns:a="http://schemas.openxmlformats.org/drawingml/2006/main">
               <a:ext uri="{FF2B5EF4-FFF2-40B4-BE49-F238E27FC236}">
-                <a16:creationId xmlns:a16="http://schemas.microsoft.com/office/drawing/2014/main" id="{AE0DE930-6646-4443-9C76-3A39861D19A9}"/>
+                <a16:creationId xmlns:a16="http://schemas.microsoft.com/office/drawing/2014/main" id="{77B66251-E690-4CCE-93EA-76A77FB481CB}"/>
               </a:ext>
             </a:extLst>
           </p:cNvPr>
@@ -7849,7 +7905,7 @@
           <p:cNvPr id="55" name="">
             <a:extLst xmlns:a="http://schemas.openxmlformats.org/drawingml/2006/main">
               <a:ext uri="{FF2B5EF4-FFF2-40B4-BE49-F238E27FC236}">
-                <a16:creationId xmlns:a16="http://schemas.microsoft.com/office/drawing/2014/main" id="{7D432E41-7FA7-4F23-B2D5-85A2211C0906}"/>
+                <a16:creationId xmlns:a16="http://schemas.microsoft.com/office/drawing/2014/main" id="{B74A20A8-013A-4A14-83C7-88F2E05C103C}"/>
               </a:ext>
             </a:extLst>
           </p:cNvPr>
@@ -7913,7 +7969,7 @@
           <p:cNvPr id="56" name="">
             <a:extLst xmlns:a="http://schemas.openxmlformats.org/drawingml/2006/main">
               <a:ext uri="{FF2B5EF4-FFF2-40B4-BE49-F238E27FC236}">
-                <a16:creationId xmlns:a16="http://schemas.microsoft.com/office/drawing/2014/main" id="{A0246589-1461-4C0C-9E47-79B983A1A3A4}"/>
+                <a16:creationId xmlns:a16="http://schemas.microsoft.com/office/drawing/2014/main" id="{2D965005-E6E2-4F06-9190-E02192AC7119}"/>
               </a:ext>
             </a:extLst>
           </p:cNvPr>
@@ -7975,7 +8031,7 @@
     </p:spTree>
     <p:extLst>
       <p:ext uri="{BB962C8B-B14F-4D97-AF65-F5344CB8AC3E}">
-        <p14:creationId xmlns:p14="http://schemas.microsoft.com/office/powerpoint/2010/main" val="1512714810"/>
+        <p14:creationId xmlns:p14="http://schemas.microsoft.com/office/powerpoint/2010/main" val="937445830"/>
       </p:ext>
     </p:extLst>
   </p:cSld>

</xml_diff>

<commit_message>
Add harness engineering appendix to report
</commit_message>
<xml_diff>
--- a/reports/HSKK_Harness_Automation_Report.pptx
+++ b/reports/HSKK_Harness_Automation_Report.pptx
@@ -2,15 +2,16 @@
 <file path=ppt/presentation.xml><?xml version="1.0" encoding="utf-8"?>
 <p:presentation xmlns:p="http://schemas.openxmlformats.org/presentationml/2006/main">
   <p:sldMasterIdLst>
-    <p:sldMasterId xmlns:r="http://schemas.openxmlformats.org/officeDocument/2006/relationships" id="2147483648" r:id="R03e3247de61a456d"/>
+    <p:sldMasterId xmlns:r="http://schemas.openxmlformats.org/officeDocument/2006/relationships" id="2147483648" r:id="R937da913994e4c9b"/>
   </p:sldMasterIdLst>
   <p:notesMasterIdLst>
-    <p:notesMasterId xmlns:r="http://schemas.openxmlformats.org/officeDocument/2006/relationships" r:id="R993b1a4014564f1e"/>
+    <p:notesMasterId xmlns:r="http://schemas.openxmlformats.org/officeDocument/2006/relationships" r:id="Re589d9dfd3be40cb"/>
   </p:notesMasterIdLst>
   <p:sldIdLst>
-    <p:sldId xmlns:r="http://schemas.openxmlformats.org/officeDocument/2006/relationships" id="256" r:id="Rd4801fc07aeb4424"/>
-    <p:sldId xmlns:r="http://schemas.openxmlformats.org/officeDocument/2006/relationships" id="257" r:id="R50eb5d65609b412f"/>
-    <p:sldId xmlns:r="http://schemas.openxmlformats.org/officeDocument/2006/relationships" id="258" r:id="R0a5b8040619b4651"/>
+    <p:sldId xmlns:r="http://schemas.openxmlformats.org/officeDocument/2006/relationships" id="256" r:id="R41c9933d215c4a27"/>
+    <p:sldId xmlns:r="http://schemas.openxmlformats.org/officeDocument/2006/relationships" id="257" r:id="R8b78b5a60d834484"/>
+    <p:sldId xmlns:r="http://schemas.openxmlformats.org/officeDocument/2006/relationships" id="258" r:id="R0e1ef7ef8860404e"/>
+    <p:sldId xmlns:r="http://schemas.openxmlformats.org/officeDocument/2006/relationships" id="259" r:id="Rd27cc438eb0c4952"/>
   </p:sldIdLst>
   <p:sldSz cx="12192000" cy="6858000"/>
   <p:notesSz cx="6858000" cy="9144000"/>
@@ -651,6 +652,72 @@
 </p:notes>
 </file>
 
+<file path=ppt/notesSlides/notesSlide4.xml><?xml version="1.0" encoding="utf-8"?>
+<p:notes xmlns:p="http://schemas.openxmlformats.org/presentationml/2006/main">
+  <p:cSld>
+    <p:spTree>
+      <p:nvGrpSpPr>
+        <p:cNvPr id="1" name=""/>
+        <p:cNvGrpSpPr/>
+        <p:nvPr/>
+      </p:nvGrpSpPr>
+      <p:grpSpPr>
+        <a:xfrm xmlns:a="http://schemas.openxmlformats.org/drawingml/2006/main"/>
+      </p:grpSpPr>
+      <p:sp>
+        <p:nvSpPr>
+          <p:cNvPr id="2" name="Slide Image Placeholder 1"/>
+          <p:cNvSpPr>
+            <a:spLocks xmlns:a="http://schemas.openxmlformats.org/drawingml/2006/main" noGrp="1"/>
+          </p:cNvSpPr>
+          <p:nvPr>
+            <p:ph type="sldImg" idx="0"/>
+          </p:nvPr>
+        </p:nvSpPr>
+        <p:spPr/>
+      </p:sp>
+      <p:sp>
+        <p:nvSpPr>
+          <p:cNvPr id="3" name="Notes Placeholder 2"/>
+          <p:cNvSpPr>
+            <a:spLocks xmlns:a="http://schemas.openxmlformats.org/drawingml/2006/main" noGrp="1"/>
+          </p:cNvSpPr>
+          <p:nvPr>
+            <p:ph type="body" idx="1"/>
+          </p:nvPr>
+        </p:nvSpPr>
+        <p:spPr/>
+        <p:txBody>
+          <a:bodyPr xmlns:a="http://schemas.openxmlformats.org/drawingml/2006/main"/>
+          <a:lstStyle xmlns:a="http://schemas.openxmlformats.org/drawingml/2006/main"/>
+          <a:p xmlns:a="http://schemas.openxmlformats.org/drawingml/2006/main"/>
+        </p:txBody>
+      </p:sp>
+      <p:sp>
+        <p:nvSpPr>
+          <p:cNvPr id="4" name="Slide Number Placeholder 3"/>
+          <p:cNvSpPr>
+            <a:spLocks xmlns:a="http://schemas.openxmlformats.org/drawingml/2006/main" noGrp="1"/>
+          </p:cNvSpPr>
+          <p:nvPr>
+            <p:ph type="sldNum" idx="5"/>
+          </p:nvPr>
+        </p:nvSpPr>
+        <p:spPr/>
+        <p:txBody>
+          <a:bodyPr xmlns:a="http://schemas.openxmlformats.org/drawingml/2006/main"/>
+          <a:lstStyle xmlns:a="http://schemas.openxmlformats.org/drawingml/2006/main"/>
+          <a:p xmlns:a="http://schemas.openxmlformats.org/drawingml/2006/main"/>
+        </p:txBody>
+      </p:sp>
+    </p:spTree>
+  </p:cSld>
+  <p:clrMapOvr>
+    <a:masterClrMapping xmlns:a="http://schemas.openxmlformats.org/drawingml/2006/main"/>
+  </p:clrMapOvr>
+</p:notes>
+</file>
+
 <file path=ppt/slideLayouts/slideLayout2.xml><?xml version="1.0" encoding="utf-8"?>
 <p:sldLayout xmlns:p="http://schemas.openxmlformats.org/presentationml/2006/main" type="title">
   <p:cSld name="Title Slide">
@@ -689,7 +756,7 @@
   </p:cSld>
   <p:clrMap bg1="lt1" tx1="dk1" bg2="lt2" tx2="dk2" accent1="accent1" accent2="accent2" accent3="accent3" accent4="accent4" accent5="accent5" accent6="accent6" hlink="hlink" folHlink="folHlink"/>
   <p:sldLayoutIdLst>
-    <p:sldLayoutId xmlns:r="http://schemas.openxmlformats.org/officeDocument/2006/relationships" id="2147483649" r:id="R9838a58c83b14387"/>
+    <p:sldLayoutId xmlns:r="http://schemas.openxmlformats.org/officeDocument/2006/relationships" id="2147483649" r:id="R8443954db7cc42a3"/>
   </p:sldLayoutIdLst>
   <p:txStyles>
     <p:titleStyle>
@@ -988,7 +1055,7 @@
           <p:cNvPr id="1" name="">
             <a:extLst xmlns:a="http://schemas.openxmlformats.org/drawingml/2006/main">
               <a:ext uri="{FF2B5EF4-FFF2-40B4-BE49-F238E27FC236}">
-                <a16:creationId xmlns:a16="http://schemas.microsoft.com/office/drawing/2014/main" id="{C8192444-516D-4B3D-B11E-64363887BC60}"/>
+                <a16:creationId xmlns:a16="http://schemas.microsoft.com/office/drawing/2014/main" id="{9AF2ED93-32D2-462F-BD2E-06244B00A482}"/>
               </a:ext>
             </a:extLst>
           </p:cNvPr>
@@ -1021,7 +1088,7 @@
           <p:cNvPr id="2" name="">
             <a:extLst xmlns:a="http://schemas.openxmlformats.org/drawingml/2006/main">
               <a:ext uri="{FF2B5EF4-FFF2-40B4-BE49-F238E27FC236}">
-                <a16:creationId xmlns:a16="http://schemas.microsoft.com/office/drawing/2014/main" id="{4456283F-BE20-4224-83FA-EBD7382FFD24}"/>
+                <a16:creationId xmlns:a16="http://schemas.microsoft.com/office/drawing/2014/main" id="{1E78B1DF-91A1-4B19-A8F2-489D5A9A285B}"/>
               </a:ext>
             </a:extLst>
           </p:cNvPr>
@@ -1054,7 +1121,7 @@
           <p:cNvPr id="3" name="">
             <a:extLst xmlns:a="http://schemas.openxmlformats.org/drawingml/2006/main">
               <a:ext uri="{FF2B5EF4-FFF2-40B4-BE49-F238E27FC236}">
-                <a16:creationId xmlns:a16="http://schemas.microsoft.com/office/drawing/2014/main" id="{46EDA063-A198-421B-96AA-94912F1FAC84}"/>
+                <a16:creationId xmlns:a16="http://schemas.microsoft.com/office/drawing/2014/main" id="{D55C1701-7613-4B3F-91EF-A2B2365AE87C}"/>
               </a:ext>
             </a:extLst>
           </p:cNvPr>
@@ -1089,7 +1156,7 @@
           <p:cNvPr id="4" name="">
             <a:extLst xmlns:a="http://schemas.openxmlformats.org/drawingml/2006/main">
               <a:ext uri="{FF2B5EF4-FFF2-40B4-BE49-F238E27FC236}">
-                <a16:creationId xmlns:a16="http://schemas.microsoft.com/office/drawing/2014/main" id="{7A7F4995-8ADF-4B67-B3DB-634EED2BFDAA}"/>
+                <a16:creationId xmlns:a16="http://schemas.microsoft.com/office/drawing/2014/main" id="{CCB8B171-BF59-499A-BE5F-E41FB242CD20}"/>
               </a:ext>
             </a:extLst>
           </p:cNvPr>
@@ -1153,7 +1220,7 @@
           <p:cNvPr id="5" name="">
             <a:extLst xmlns:a="http://schemas.openxmlformats.org/drawingml/2006/main">
               <a:ext uri="{FF2B5EF4-FFF2-40B4-BE49-F238E27FC236}">
-                <a16:creationId xmlns:a16="http://schemas.microsoft.com/office/drawing/2014/main" id="{791564F5-4842-482E-BFEE-9C80E080D941}"/>
+                <a16:creationId xmlns:a16="http://schemas.microsoft.com/office/drawing/2014/main" id="{181657FD-ECFC-4641-B29D-B4E835CDB66F}"/>
               </a:ext>
             </a:extLst>
           </p:cNvPr>
@@ -1217,7 +1284,7 @@
           <p:cNvPr id="6" name="">
             <a:extLst xmlns:a="http://schemas.openxmlformats.org/drawingml/2006/main">
               <a:ext uri="{FF2B5EF4-FFF2-40B4-BE49-F238E27FC236}">
-                <a16:creationId xmlns:a16="http://schemas.microsoft.com/office/drawing/2014/main" id="{607333DD-8B0A-4CD7-BD4E-CF61CD715B83}"/>
+                <a16:creationId xmlns:a16="http://schemas.microsoft.com/office/drawing/2014/main" id="{AC43FC9C-A5FC-4AD7-A6FE-4E13A9BFB6C2}"/>
               </a:ext>
             </a:extLst>
           </p:cNvPr>
@@ -1281,7 +1348,7 @@
           <p:cNvPr id="7" name="">
             <a:extLst xmlns:a="http://schemas.openxmlformats.org/drawingml/2006/main">
               <a:ext uri="{FF2B5EF4-FFF2-40B4-BE49-F238E27FC236}">
-                <a16:creationId xmlns:a16="http://schemas.microsoft.com/office/drawing/2014/main" id="{B0624358-486B-4304-9C22-8E57B050FFDB}"/>
+                <a16:creationId xmlns:a16="http://schemas.microsoft.com/office/drawing/2014/main" id="{4C832770-3ED5-48C4-AE0D-87C4590C33EA}"/>
               </a:ext>
             </a:extLst>
           </p:cNvPr>
@@ -1368,7 +1435,7 @@
           <p:cNvPr id="8" name="">
             <a:extLst xmlns:a="http://schemas.openxmlformats.org/drawingml/2006/main">
               <a:ext uri="{FF2B5EF4-FFF2-40B4-BE49-F238E27FC236}">
-                <a16:creationId xmlns:a16="http://schemas.microsoft.com/office/drawing/2014/main" id="{5DCC5590-7D38-436F-85BB-1F8EAC6DBA7D}"/>
+                <a16:creationId xmlns:a16="http://schemas.microsoft.com/office/drawing/2014/main" id="{2F5DF23D-4550-45C9-B5B2-13C4CD5AED46}"/>
               </a:ext>
             </a:extLst>
           </p:cNvPr>
@@ -1432,7 +1499,7 @@
           <p:cNvPr id="9" name="">
             <a:extLst xmlns:a="http://schemas.openxmlformats.org/drawingml/2006/main">
               <a:ext uri="{FF2B5EF4-FFF2-40B4-BE49-F238E27FC236}">
-                <a16:creationId xmlns:a16="http://schemas.microsoft.com/office/drawing/2014/main" id="{71B494AF-A27E-47D0-8CDB-2E9B444977AA}"/>
+                <a16:creationId xmlns:a16="http://schemas.microsoft.com/office/drawing/2014/main" id="{AC51AEEB-B06F-4BA8-A656-8C1579A56ACE}"/>
               </a:ext>
             </a:extLst>
           </p:cNvPr>
@@ -1519,7 +1586,7 @@
           <p:cNvPr id="10" name="">
             <a:extLst xmlns:a="http://schemas.openxmlformats.org/drawingml/2006/main">
               <a:ext uri="{FF2B5EF4-FFF2-40B4-BE49-F238E27FC236}">
-                <a16:creationId xmlns:a16="http://schemas.microsoft.com/office/drawing/2014/main" id="{02EA0090-B5A9-4DF4-83FF-EF10D2BF195C}"/>
+                <a16:creationId xmlns:a16="http://schemas.microsoft.com/office/drawing/2014/main" id="{CEEF20B0-A6DC-430F-9069-774E2FA66139}"/>
               </a:ext>
             </a:extLst>
           </p:cNvPr>
@@ -1583,7 +1650,7 @@
           <p:cNvPr id="11" name="">
             <a:extLst xmlns:a="http://schemas.openxmlformats.org/drawingml/2006/main">
               <a:ext uri="{FF2B5EF4-FFF2-40B4-BE49-F238E27FC236}">
-                <a16:creationId xmlns:a16="http://schemas.microsoft.com/office/drawing/2014/main" id="{9D5F9E7A-34BD-400A-A539-AD29B9CA3362}"/>
+                <a16:creationId xmlns:a16="http://schemas.microsoft.com/office/drawing/2014/main" id="{2FBA3F89-D97C-4C7F-93AD-C29BB98F66FD}"/>
               </a:ext>
             </a:extLst>
           </p:cNvPr>
@@ -1670,7 +1737,7 @@
           <p:cNvPr id="12" name="">
             <a:extLst xmlns:a="http://schemas.openxmlformats.org/drawingml/2006/main">
               <a:ext uri="{FF2B5EF4-FFF2-40B4-BE49-F238E27FC236}">
-                <a16:creationId xmlns:a16="http://schemas.microsoft.com/office/drawing/2014/main" id="{6840E336-B4AE-42D8-B764-09A530A4A8FC}"/>
+                <a16:creationId xmlns:a16="http://schemas.microsoft.com/office/drawing/2014/main" id="{F49DAE25-31DA-47C2-8A29-67FDD94B17F1}"/>
               </a:ext>
             </a:extLst>
           </p:cNvPr>
@@ -1734,7 +1801,7 @@
           <p:cNvPr id="13" name="">
             <a:extLst xmlns:a="http://schemas.openxmlformats.org/drawingml/2006/main">
               <a:ext uri="{FF2B5EF4-FFF2-40B4-BE49-F238E27FC236}">
-                <a16:creationId xmlns:a16="http://schemas.microsoft.com/office/drawing/2014/main" id="{572D4533-8B2C-40D0-BBFC-58FB224E2692}"/>
+                <a16:creationId xmlns:a16="http://schemas.microsoft.com/office/drawing/2014/main" id="{AA33999F-3A56-410E-AE16-35C11C1CE4B2}"/>
               </a:ext>
             </a:extLst>
           </p:cNvPr>
@@ -1821,7 +1888,7 @@
           <p:cNvPr id="14" name="">
             <a:extLst xmlns:a="http://schemas.openxmlformats.org/drawingml/2006/main">
               <a:ext uri="{FF2B5EF4-FFF2-40B4-BE49-F238E27FC236}">
-                <a16:creationId xmlns:a16="http://schemas.microsoft.com/office/drawing/2014/main" id="{D9F43FAB-419C-40F8-816A-05C6AAF44AC0}"/>
+                <a16:creationId xmlns:a16="http://schemas.microsoft.com/office/drawing/2014/main" id="{3439355F-E1F4-4E8B-8959-2F85614F4A62}"/>
               </a:ext>
             </a:extLst>
           </p:cNvPr>
@@ -1856,7 +1923,7 @@
           <p:cNvPr id="15" name="">
             <a:extLst xmlns:a="http://schemas.openxmlformats.org/drawingml/2006/main">
               <a:ext uri="{FF2B5EF4-FFF2-40B4-BE49-F238E27FC236}">
-                <a16:creationId xmlns:a16="http://schemas.microsoft.com/office/drawing/2014/main" id="{5519ACD8-6EEC-4ACE-90E1-13A616708F17}"/>
+                <a16:creationId xmlns:a16="http://schemas.microsoft.com/office/drawing/2014/main" id="{84E5FB52-0225-4B05-8AB6-D217FDDA7045}"/>
               </a:ext>
             </a:extLst>
           </p:cNvPr>
@@ -1920,7 +1987,7 @@
           <p:cNvPr id="16" name="">
             <a:extLst xmlns:a="http://schemas.openxmlformats.org/drawingml/2006/main">
               <a:ext uri="{FF2B5EF4-FFF2-40B4-BE49-F238E27FC236}">
-                <a16:creationId xmlns:a16="http://schemas.microsoft.com/office/drawing/2014/main" id="{F824C52E-3DDF-4DDE-8D81-740A9EB8EFE0}"/>
+                <a16:creationId xmlns:a16="http://schemas.microsoft.com/office/drawing/2014/main" id="{131FD839-A7E4-4C58-8DDB-95A20EE90031}"/>
               </a:ext>
             </a:extLst>
           </p:cNvPr>
@@ -1955,7 +2022,7 @@
           <p:cNvPr id="17" name="">
             <a:extLst xmlns:a="http://schemas.openxmlformats.org/drawingml/2006/main">
               <a:ext uri="{FF2B5EF4-FFF2-40B4-BE49-F238E27FC236}">
-                <a16:creationId xmlns:a16="http://schemas.microsoft.com/office/drawing/2014/main" id="{7CA32D73-5F5A-4C13-8B2F-D76DD309B4D3}"/>
+                <a16:creationId xmlns:a16="http://schemas.microsoft.com/office/drawing/2014/main" id="{87466601-FAD0-4106-BFE0-7D62DB840160}"/>
               </a:ext>
             </a:extLst>
           </p:cNvPr>
@@ -2019,7 +2086,7 @@
           <p:cNvPr id="18" name="">
             <a:extLst xmlns:a="http://schemas.openxmlformats.org/drawingml/2006/main">
               <a:ext uri="{FF2B5EF4-FFF2-40B4-BE49-F238E27FC236}">
-                <a16:creationId xmlns:a16="http://schemas.microsoft.com/office/drawing/2014/main" id="{9C3F5E82-8824-49D5-BB53-CF856E3DE3CA}"/>
+                <a16:creationId xmlns:a16="http://schemas.microsoft.com/office/drawing/2014/main" id="{33B46579-4E19-48A3-B4FD-1AEAD4977C9F}"/>
               </a:ext>
             </a:extLst>
           </p:cNvPr>
@@ -2052,7 +2119,7 @@
           <p:cNvPr id="19" name="">
             <a:extLst xmlns:a="http://schemas.openxmlformats.org/drawingml/2006/main">
               <a:ext uri="{FF2B5EF4-FFF2-40B4-BE49-F238E27FC236}">
-                <a16:creationId xmlns:a16="http://schemas.microsoft.com/office/drawing/2014/main" id="{B7C503D2-FC14-433E-BA35-A5DD8415389B}"/>
+                <a16:creationId xmlns:a16="http://schemas.microsoft.com/office/drawing/2014/main" id="{8645AC1F-8C05-4A51-864C-C69255848D3D}"/>
               </a:ext>
             </a:extLst>
           </p:cNvPr>
@@ -2087,7 +2154,7 @@
           <p:cNvPr id="20" name="">
             <a:extLst xmlns:a="http://schemas.openxmlformats.org/drawingml/2006/main">
               <a:ext uri="{FF2B5EF4-FFF2-40B4-BE49-F238E27FC236}">
-                <a16:creationId xmlns:a16="http://schemas.microsoft.com/office/drawing/2014/main" id="{9AB04B23-0D14-44C8-9799-CC60CEB95C11}"/>
+                <a16:creationId xmlns:a16="http://schemas.microsoft.com/office/drawing/2014/main" id="{9920E497-7666-4E71-A9E0-43FD62C10B1D}"/>
               </a:ext>
             </a:extLst>
           </p:cNvPr>
@@ -2151,7 +2218,7 @@
           <p:cNvPr id="21" name="">
             <a:extLst xmlns:a="http://schemas.openxmlformats.org/drawingml/2006/main">
               <a:ext uri="{FF2B5EF4-FFF2-40B4-BE49-F238E27FC236}">
-                <a16:creationId xmlns:a16="http://schemas.microsoft.com/office/drawing/2014/main" id="{C3D3DC1C-2462-4AD0-BF12-FD4F2C942757}"/>
+                <a16:creationId xmlns:a16="http://schemas.microsoft.com/office/drawing/2014/main" id="{54B57E3B-0125-4F38-9B2C-3EE769CF9C2E}"/>
               </a:ext>
             </a:extLst>
           </p:cNvPr>
@@ -2184,7 +2251,7 @@
           <p:cNvPr id="22" name="">
             <a:extLst xmlns:a="http://schemas.openxmlformats.org/drawingml/2006/main">
               <a:ext uri="{FF2B5EF4-FFF2-40B4-BE49-F238E27FC236}">
-                <a16:creationId xmlns:a16="http://schemas.microsoft.com/office/drawing/2014/main" id="{93DBA580-5984-4D71-96C1-7BC3CDE16367}"/>
+                <a16:creationId xmlns:a16="http://schemas.microsoft.com/office/drawing/2014/main" id="{6D140963-5578-419A-A948-1FBD2A9B0FBD}"/>
               </a:ext>
             </a:extLst>
           </p:cNvPr>
@@ -2219,7 +2286,7 @@
           <p:cNvPr id="23" name="">
             <a:extLst xmlns:a="http://schemas.openxmlformats.org/drawingml/2006/main">
               <a:ext uri="{FF2B5EF4-FFF2-40B4-BE49-F238E27FC236}">
-                <a16:creationId xmlns:a16="http://schemas.microsoft.com/office/drawing/2014/main" id="{F13C90AF-9CA1-454C-8534-190F2B36822C}"/>
+                <a16:creationId xmlns:a16="http://schemas.microsoft.com/office/drawing/2014/main" id="{0BF6D01E-49F4-47EA-855F-6BE1210A624B}"/>
               </a:ext>
             </a:extLst>
           </p:cNvPr>
@@ -2283,7 +2350,7 @@
           <p:cNvPr id="24" name="">
             <a:extLst xmlns:a="http://schemas.openxmlformats.org/drawingml/2006/main">
               <a:ext uri="{FF2B5EF4-FFF2-40B4-BE49-F238E27FC236}">
-                <a16:creationId xmlns:a16="http://schemas.microsoft.com/office/drawing/2014/main" id="{9D97BFB6-43AF-4591-8881-85F4620EC070}"/>
+                <a16:creationId xmlns:a16="http://schemas.microsoft.com/office/drawing/2014/main" id="{544389FC-9BBF-4861-9A45-9312516545F1}"/>
               </a:ext>
             </a:extLst>
           </p:cNvPr>
@@ -2316,7 +2383,7 @@
           <p:cNvPr id="25" name="">
             <a:extLst xmlns:a="http://schemas.openxmlformats.org/drawingml/2006/main">
               <a:ext uri="{FF2B5EF4-FFF2-40B4-BE49-F238E27FC236}">
-                <a16:creationId xmlns:a16="http://schemas.microsoft.com/office/drawing/2014/main" id="{7EFF1CF5-B371-49B2-BB84-64514DEEA3C9}"/>
+                <a16:creationId xmlns:a16="http://schemas.microsoft.com/office/drawing/2014/main" id="{135819B0-F250-40A4-9EB1-4A647F10FF28}"/>
               </a:ext>
             </a:extLst>
           </p:cNvPr>
@@ -2351,7 +2418,7 @@
           <p:cNvPr id="26" name="">
             <a:extLst xmlns:a="http://schemas.openxmlformats.org/drawingml/2006/main">
               <a:ext uri="{FF2B5EF4-FFF2-40B4-BE49-F238E27FC236}">
-                <a16:creationId xmlns:a16="http://schemas.microsoft.com/office/drawing/2014/main" id="{0AA60D15-FC88-4ADA-BCA2-8487BF3389C6}"/>
+                <a16:creationId xmlns:a16="http://schemas.microsoft.com/office/drawing/2014/main" id="{D6B0BD70-4637-4C6A-B583-614381B1916E}"/>
               </a:ext>
             </a:extLst>
           </p:cNvPr>
@@ -2415,7 +2482,7 @@
           <p:cNvPr id="27" name="">
             <a:extLst xmlns:a="http://schemas.openxmlformats.org/drawingml/2006/main">
               <a:ext uri="{FF2B5EF4-FFF2-40B4-BE49-F238E27FC236}">
-                <a16:creationId xmlns:a16="http://schemas.microsoft.com/office/drawing/2014/main" id="{70AA82F7-8998-4DA0-8385-49ABE0C548EB}"/>
+                <a16:creationId xmlns:a16="http://schemas.microsoft.com/office/drawing/2014/main" id="{0E1D458F-640A-4E64-B8E2-C1ADA7D57EBF}"/>
               </a:ext>
             </a:extLst>
           </p:cNvPr>
@@ -2448,7 +2515,7 @@
           <p:cNvPr id="28" name="">
             <a:extLst xmlns:a="http://schemas.openxmlformats.org/drawingml/2006/main">
               <a:ext uri="{FF2B5EF4-FFF2-40B4-BE49-F238E27FC236}">
-                <a16:creationId xmlns:a16="http://schemas.microsoft.com/office/drawing/2014/main" id="{EF3C8843-BF89-4153-965A-9637ADC1E5BD}"/>
+                <a16:creationId xmlns:a16="http://schemas.microsoft.com/office/drawing/2014/main" id="{21CCBA8F-8D98-46AF-9458-82F74C2BF66B}"/>
               </a:ext>
             </a:extLst>
           </p:cNvPr>
@@ -2512,7 +2579,7 @@
           <p:cNvPr id="29" name="">
             <a:extLst xmlns:a="http://schemas.openxmlformats.org/drawingml/2006/main">
               <a:ext uri="{FF2B5EF4-FFF2-40B4-BE49-F238E27FC236}">
-                <a16:creationId xmlns:a16="http://schemas.microsoft.com/office/drawing/2014/main" id="{F4DFAFC4-4A4A-4C4E-96ED-8D568CE5D2CF}"/>
+                <a16:creationId xmlns:a16="http://schemas.microsoft.com/office/drawing/2014/main" id="{95CB2433-FED0-4731-970A-87650C158296}"/>
               </a:ext>
             </a:extLst>
           </p:cNvPr>
@@ -2574,7 +2641,7 @@
     </p:spTree>
     <p:extLst>
       <p:ext uri="{BB962C8B-B14F-4D97-AF65-F5344CB8AC3E}">
-        <p14:creationId xmlns:p14="http://schemas.microsoft.com/office/powerpoint/2010/main" val="1840486998"/>
+        <p14:creationId xmlns:p14="http://schemas.microsoft.com/office/powerpoint/2010/main" val="1918662971"/>
       </p:ext>
     </p:extLst>
   </p:cSld>
@@ -2598,7 +2665,7 @@
           <p:cNvPr id="1" name="">
             <a:extLst xmlns:a="http://schemas.openxmlformats.org/drawingml/2006/main">
               <a:ext uri="{FF2B5EF4-FFF2-40B4-BE49-F238E27FC236}">
-                <a16:creationId xmlns:a16="http://schemas.microsoft.com/office/drawing/2014/main" id="{2FC29A00-E9EE-45B9-B0EE-FC58DE52C4F6}"/>
+                <a16:creationId xmlns:a16="http://schemas.microsoft.com/office/drawing/2014/main" id="{0DD9DFA0-C1A7-4046-B84B-E1242378B17A}"/>
               </a:ext>
             </a:extLst>
           </p:cNvPr>
@@ -2631,7 +2698,7 @@
           <p:cNvPr id="2" name="">
             <a:extLst xmlns:a="http://schemas.openxmlformats.org/drawingml/2006/main">
               <a:ext uri="{FF2B5EF4-FFF2-40B4-BE49-F238E27FC236}">
-                <a16:creationId xmlns:a16="http://schemas.microsoft.com/office/drawing/2014/main" id="{A255950B-7FD0-418E-9414-544F3185F196}"/>
+                <a16:creationId xmlns:a16="http://schemas.microsoft.com/office/drawing/2014/main" id="{9C9DFD07-17FB-4E3F-935A-503DA0D0C0D1}"/>
               </a:ext>
             </a:extLst>
           </p:cNvPr>
@@ -2664,7 +2731,7 @@
           <p:cNvPr id="3" name="">
             <a:extLst xmlns:a="http://schemas.openxmlformats.org/drawingml/2006/main">
               <a:ext uri="{FF2B5EF4-FFF2-40B4-BE49-F238E27FC236}">
-                <a16:creationId xmlns:a16="http://schemas.microsoft.com/office/drawing/2014/main" id="{1813046C-4D53-43F9-B571-7598B0FCC1BB}"/>
+                <a16:creationId xmlns:a16="http://schemas.microsoft.com/office/drawing/2014/main" id="{50E98C98-B432-4380-B3B7-23500B728505}"/>
               </a:ext>
             </a:extLst>
           </p:cNvPr>
@@ -2676,7 +2743,7 @@
         <p:spPr>
           <a:xfrm xmlns:a="http://schemas.openxmlformats.org/drawingml/2006/main">
             <a:off x="752475" y="371475"/>
-            <a:ext cx="4000500" cy="209550"/>
+            <a:ext cx="4762500" cy="209550"/>
           </a:xfrm>
           <a:prstGeom xmlns:a="http://schemas.openxmlformats.org/drawingml/2006/main" prst="rect">
             <a:avLst/>
@@ -2728,7 +2795,7 @@
           <p:cNvPr id="4" name="">
             <a:extLst xmlns:a="http://schemas.openxmlformats.org/drawingml/2006/main">
               <a:ext uri="{FF2B5EF4-FFF2-40B4-BE49-F238E27FC236}">
-                <a16:creationId xmlns:a16="http://schemas.microsoft.com/office/drawing/2014/main" id="{859EF9C5-84CC-40C0-A2B7-FC47CEDAACAA}"/>
+                <a16:creationId xmlns:a16="http://schemas.microsoft.com/office/drawing/2014/main" id="{8F4F93F1-E225-4708-A9A1-626BF0CC0D95}"/>
               </a:ext>
             </a:extLst>
           </p:cNvPr>
@@ -2792,7 +2859,7 @@
           <p:cNvPr id="5" name="">
             <a:extLst xmlns:a="http://schemas.openxmlformats.org/drawingml/2006/main">
               <a:ext uri="{FF2B5EF4-FFF2-40B4-BE49-F238E27FC236}">
-                <a16:creationId xmlns:a16="http://schemas.microsoft.com/office/drawing/2014/main" id="{ABD77541-47A6-47B0-8AFE-5EAF2955E56A}"/>
+                <a16:creationId xmlns:a16="http://schemas.microsoft.com/office/drawing/2014/main" id="{631DCAED-865A-4D1F-9D9F-1577374CD9EB}"/>
               </a:ext>
             </a:extLst>
           </p:cNvPr>
@@ -2856,7 +2923,7 @@
           <p:cNvPr id="6" name="">
             <a:extLst xmlns:a="http://schemas.openxmlformats.org/drawingml/2006/main">
               <a:ext uri="{FF2B5EF4-FFF2-40B4-BE49-F238E27FC236}">
-                <a16:creationId xmlns:a16="http://schemas.microsoft.com/office/drawing/2014/main" id="{FE12C61B-78C1-4DE0-8371-23BB69E3360E}"/>
+                <a16:creationId xmlns:a16="http://schemas.microsoft.com/office/drawing/2014/main" id="{CC3C4C39-4063-4C7A-A4CF-0CD24A4A58B4}"/>
               </a:ext>
             </a:extLst>
           </p:cNvPr>
@@ -2868,7 +2935,7 @@
         <p:spPr>
           <a:xfrm xmlns:a="http://schemas.openxmlformats.org/drawingml/2006/main">
             <a:off x="552450" y="1657350"/>
-            <a:ext cx="10191750" cy="400050"/>
+            <a:ext cx="10477500" cy="400050"/>
           </a:xfrm>
           <a:prstGeom xmlns:a="http://schemas.openxmlformats.org/drawingml/2006/main" prst="rect">
             <a:avLst/>
@@ -2920,7 +2987,7 @@
           <p:cNvPr id="7" name="">
             <a:extLst xmlns:a="http://schemas.openxmlformats.org/drawingml/2006/main">
               <a:ext uri="{FF2B5EF4-FFF2-40B4-BE49-F238E27FC236}">
-                <a16:creationId xmlns:a16="http://schemas.microsoft.com/office/drawing/2014/main" id="{592453F6-AEDD-42EE-B26B-B39686AFF4C7}"/>
+                <a16:creationId xmlns:a16="http://schemas.microsoft.com/office/drawing/2014/main" id="{E5E3F335-5E51-48FA-9230-9ED7C568E168}"/>
               </a:ext>
             </a:extLst>
           </p:cNvPr>
@@ -2955,7 +3022,7 @@
           <p:cNvPr id="8" name="">
             <a:extLst xmlns:a="http://schemas.openxmlformats.org/drawingml/2006/main">
               <a:ext uri="{FF2B5EF4-FFF2-40B4-BE49-F238E27FC236}">
-                <a16:creationId xmlns:a16="http://schemas.microsoft.com/office/drawing/2014/main" id="{6C08D76F-A135-4D51-97F1-8860747CB293}"/>
+                <a16:creationId xmlns:a16="http://schemas.microsoft.com/office/drawing/2014/main" id="{224AEFFE-5E50-4D16-8E0C-7C5BF69E5AD8}"/>
               </a:ext>
             </a:extLst>
           </p:cNvPr>
@@ -2990,7 +3057,7 @@
           <p:cNvPr id="9" name="">
             <a:extLst xmlns:a="http://schemas.openxmlformats.org/drawingml/2006/main">
               <a:ext uri="{FF2B5EF4-FFF2-40B4-BE49-F238E27FC236}">
-                <a16:creationId xmlns:a16="http://schemas.microsoft.com/office/drawing/2014/main" id="{B905E03D-412C-4B4A-A476-AD04A9EB804F}"/>
+                <a16:creationId xmlns:a16="http://schemas.microsoft.com/office/drawing/2014/main" id="{6735A143-0236-440C-9644-B46BB8319E72}"/>
               </a:ext>
             </a:extLst>
           </p:cNvPr>
@@ -3054,7 +3121,7 @@
           <p:cNvPr id="10" name="">
             <a:extLst xmlns:a="http://schemas.openxmlformats.org/drawingml/2006/main">
               <a:ext uri="{FF2B5EF4-FFF2-40B4-BE49-F238E27FC236}">
-                <a16:creationId xmlns:a16="http://schemas.microsoft.com/office/drawing/2014/main" id="{6A0AD9BF-7398-432A-A039-A7D1B951F651}"/>
+                <a16:creationId xmlns:a16="http://schemas.microsoft.com/office/drawing/2014/main" id="{C98E708E-E4E5-4DCE-A13E-293AF9AD25C1}"/>
               </a:ext>
             </a:extLst>
           </p:cNvPr>
@@ -3089,7 +3156,7 @@
           <p:cNvPr id="11" name="">
             <a:extLst xmlns:a="http://schemas.openxmlformats.org/drawingml/2006/main">
               <a:ext uri="{FF2B5EF4-FFF2-40B4-BE49-F238E27FC236}">
-                <a16:creationId xmlns:a16="http://schemas.microsoft.com/office/drawing/2014/main" id="{42F0C39B-20BC-45E0-9146-E74AC1292AFC}"/>
+                <a16:creationId xmlns:a16="http://schemas.microsoft.com/office/drawing/2014/main" id="{51EF85E4-D4FD-4CE3-8E75-D6C571124F89}"/>
               </a:ext>
             </a:extLst>
           </p:cNvPr>
@@ -3153,7 +3220,7 @@
           <p:cNvPr id="12" name="">
             <a:extLst xmlns:a="http://schemas.openxmlformats.org/drawingml/2006/main">
               <a:ext uri="{FF2B5EF4-FFF2-40B4-BE49-F238E27FC236}">
-                <a16:creationId xmlns:a16="http://schemas.microsoft.com/office/drawing/2014/main" id="{05FF47F1-F12B-4D13-8494-C126FA890D7A}"/>
+                <a16:creationId xmlns:a16="http://schemas.microsoft.com/office/drawing/2014/main" id="{71D94D8F-5AD8-4168-896C-FEB992FD253D}"/>
               </a:ext>
             </a:extLst>
           </p:cNvPr>
@@ -3188,7 +3255,7 @@
           <p:cNvPr id="13" name="">
             <a:extLst xmlns:a="http://schemas.openxmlformats.org/drawingml/2006/main">
               <a:ext uri="{FF2B5EF4-FFF2-40B4-BE49-F238E27FC236}">
-                <a16:creationId xmlns:a16="http://schemas.microsoft.com/office/drawing/2014/main" id="{9C20F484-4508-44BD-A744-C8961E5AC02B}"/>
+                <a16:creationId xmlns:a16="http://schemas.microsoft.com/office/drawing/2014/main" id="{A9987EF3-7F5D-420D-83D8-815712757629}"/>
               </a:ext>
             </a:extLst>
           </p:cNvPr>
@@ -3252,7 +3319,7 @@
           <p:cNvPr id="14" name="">
             <a:extLst xmlns:a="http://schemas.openxmlformats.org/drawingml/2006/main">
               <a:ext uri="{FF2B5EF4-FFF2-40B4-BE49-F238E27FC236}">
-                <a16:creationId xmlns:a16="http://schemas.microsoft.com/office/drawing/2014/main" id="{2FD9F3A4-76FB-4C5B-9FA2-9556A7F4E981}"/>
+                <a16:creationId xmlns:a16="http://schemas.microsoft.com/office/drawing/2014/main" id="{2EFE3C7C-743A-41CF-A82A-7D8C5A572144}"/>
               </a:ext>
             </a:extLst>
           </p:cNvPr>
@@ -3316,7 +3383,7 @@
           <p:cNvPr id="15" name="">
             <a:extLst xmlns:a="http://schemas.openxmlformats.org/drawingml/2006/main">
               <a:ext uri="{FF2B5EF4-FFF2-40B4-BE49-F238E27FC236}">
-                <a16:creationId xmlns:a16="http://schemas.microsoft.com/office/drawing/2014/main" id="{702A7DCC-9DF4-492D-94FF-5817AE83F2DC}"/>
+                <a16:creationId xmlns:a16="http://schemas.microsoft.com/office/drawing/2014/main" id="{59750652-A0E8-4767-996C-57982627EB9E}"/>
               </a:ext>
             </a:extLst>
           </p:cNvPr>
@@ -3380,7 +3447,7 @@
           <p:cNvPr id="16" name="">
             <a:extLst xmlns:a="http://schemas.openxmlformats.org/drawingml/2006/main">
               <a:ext uri="{FF2B5EF4-FFF2-40B4-BE49-F238E27FC236}">
-                <a16:creationId xmlns:a16="http://schemas.microsoft.com/office/drawing/2014/main" id="{A4790AF7-C9F7-45D8-8943-008E75A134C7}"/>
+                <a16:creationId xmlns:a16="http://schemas.microsoft.com/office/drawing/2014/main" id="{557191CC-1190-44B5-89ED-926190A7BD1B}"/>
               </a:ext>
             </a:extLst>
           </p:cNvPr>
@@ -3413,7 +3480,7 @@
           <p:cNvPr id="17" name="">
             <a:extLst xmlns:a="http://schemas.openxmlformats.org/drawingml/2006/main">
               <a:ext uri="{FF2B5EF4-FFF2-40B4-BE49-F238E27FC236}">
-                <a16:creationId xmlns:a16="http://schemas.microsoft.com/office/drawing/2014/main" id="{80DDF6CF-10AD-4F66-8267-042F3A875062}"/>
+                <a16:creationId xmlns:a16="http://schemas.microsoft.com/office/drawing/2014/main" id="{F1F6876C-D459-44AB-BB69-0A51BC821DFC}"/>
               </a:ext>
             </a:extLst>
           </p:cNvPr>
@@ -3477,7 +3544,7 @@
           <p:cNvPr id="18" name="">
             <a:extLst xmlns:a="http://schemas.openxmlformats.org/drawingml/2006/main">
               <a:ext uri="{FF2B5EF4-FFF2-40B4-BE49-F238E27FC236}">
-                <a16:creationId xmlns:a16="http://schemas.microsoft.com/office/drawing/2014/main" id="{6CC8532D-C1A9-44E4-AB5A-52518DB1239E}"/>
+                <a16:creationId xmlns:a16="http://schemas.microsoft.com/office/drawing/2014/main" id="{480A522A-B2D4-4B0F-BE09-55FAF7D3317C}"/>
               </a:ext>
             </a:extLst>
           </p:cNvPr>
@@ -3541,7 +3608,7 @@
           <p:cNvPr id="19" name="">
             <a:extLst xmlns:a="http://schemas.openxmlformats.org/drawingml/2006/main">
               <a:ext uri="{FF2B5EF4-FFF2-40B4-BE49-F238E27FC236}">
-                <a16:creationId xmlns:a16="http://schemas.microsoft.com/office/drawing/2014/main" id="{2949A705-9719-467C-AEC3-2A69A416A065}"/>
+                <a16:creationId xmlns:a16="http://schemas.microsoft.com/office/drawing/2014/main" id="{D260A41C-00E6-492F-952A-C48AE8205527}"/>
               </a:ext>
             </a:extLst>
           </p:cNvPr>
@@ -3576,7 +3643,7 @@
           <p:cNvPr id="20" name="">
             <a:extLst xmlns:a="http://schemas.openxmlformats.org/drawingml/2006/main">
               <a:ext uri="{FF2B5EF4-FFF2-40B4-BE49-F238E27FC236}">
-                <a16:creationId xmlns:a16="http://schemas.microsoft.com/office/drawing/2014/main" id="{A4E96F4E-618B-427C-966E-9B18DBDE0CB6}"/>
+                <a16:creationId xmlns:a16="http://schemas.microsoft.com/office/drawing/2014/main" id="{8CF3E959-1D56-40F6-BE04-953537ADBAA7}"/>
               </a:ext>
             </a:extLst>
           </p:cNvPr>
@@ -3611,7 +3678,7 @@
           <p:cNvPr id="21" name="">
             <a:extLst xmlns:a="http://schemas.openxmlformats.org/drawingml/2006/main">
               <a:ext uri="{FF2B5EF4-FFF2-40B4-BE49-F238E27FC236}">
-                <a16:creationId xmlns:a16="http://schemas.microsoft.com/office/drawing/2014/main" id="{E62728F3-CEDF-4244-BC3E-661525A1F4F8}"/>
+                <a16:creationId xmlns:a16="http://schemas.microsoft.com/office/drawing/2014/main" id="{47D1E49A-6EAF-49A8-BCBE-615B85243B3F}"/>
               </a:ext>
             </a:extLst>
           </p:cNvPr>
@@ -3675,7 +3742,7 @@
           <p:cNvPr id="22" name="">
             <a:extLst xmlns:a="http://schemas.openxmlformats.org/drawingml/2006/main">
               <a:ext uri="{FF2B5EF4-FFF2-40B4-BE49-F238E27FC236}">
-                <a16:creationId xmlns:a16="http://schemas.microsoft.com/office/drawing/2014/main" id="{9FC15C2F-F2A4-4351-B698-12C4BC5FB4C3}"/>
+                <a16:creationId xmlns:a16="http://schemas.microsoft.com/office/drawing/2014/main" id="{D7A3E646-FF07-4A22-A63B-993142F564D0}"/>
               </a:ext>
             </a:extLst>
           </p:cNvPr>
@@ -3739,7 +3806,7 @@
           <p:cNvPr id="23" name="">
             <a:extLst xmlns:a="http://schemas.openxmlformats.org/drawingml/2006/main">
               <a:ext uri="{FF2B5EF4-FFF2-40B4-BE49-F238E27FC236}">
-                <a16:creationId xmlns:a16="http://schemas.microsoft.com/office/drawing/2014/main" id="{9226D707-9D4F-4F01-ABEB-8745B0F214CF}"/>
+                <a16:creationId xmlns:a16="http://schemas.microsoft.com/office/drawing/2014/main" id="{7D3E38AC-8E9F-4457-B5B5-24E3CAAB8FF8}"/>
               </a:ext>
             </a:extLst>
           </p:cNvPr>
@@ -3803,7 +3870,7 @@
           <p:cNvPr id="24" name="">
             <a:extLst xmlns:a="http://schemas.openxmlformats.org/drawingml/2006/main">
               <a:ext uri="{FF2B5EF4-FFF2-40B4-BE49-F238E27FC236}">
-                <a16:creationId xmlns:a16="http://schemas.microsoft.com/office/drawing/2014/main" id="{44B9D86D-1F31-4D84-9002-251980B40307}"/>
+                <a16:creationId xmlns:a16="http://schemas.microsoft.com/office/drawing/2014/main" id="{0DABCDCB-6B68-4302-AD0C-9486C1FAE749}"/>
               </a:ext>
             </a:extLst>
           </p:cNvPr>
@@ -3867,7 +3934,7 @@
           <p:cNvPr id="25" name="">
             <a:extLst xmlns:a="http://schemas.openxmlformats.org/drawingml/2006/main">
               <a:ext uri="{FF2B5EF4-FFF2-40B4-BE49-F238E27FC236}">
-                <a16:creationId xmlns:a16="http://schemas.microsoft.com/office/drawing/2014/main" id="{5A9CE010-6F31-4490-BC2C-18E58407350B}"/>
+                <a16:creationId xmlns:a16="http://schemas.microsoft.com/office/drawing/2014/main" id="{2B433DA7-E2A1-4CC5-A3A3-F393B68F5D64}"/>
               </a:ext>
             </a:extLst>
           </p:cNvPr>
@@ -3931,7 +3998,7 @@
           <p:cNvPr id="26" name="">
             <a:extLst xmlns:a="http://schemas.openxmlformats.org/drawingml/2006/main">
               <a:ext uri="{FF2B5EF4-FFF2-40B4-BE49-F238E27FC236}">
-                <a16:creationId xmlns:a16="http://schemas.microsoft.com/office/drawing/2014/main" id="{B953A9C9-FCB8-4EF6-874C-D32AC209E125}"/>
+                <a16:creationId xmlns:a16="http://schemas.microsoft.com/office/drawing/2014/main" id="{AF481C56-4A86-4835-A18A-F95FE94FF378}"/>
               </a:ext>
             </a:extLst>
           </p:cNvPr>
@@ -3995,7 +4062,7 @@
           <p:cNvPr id="27" name="">
             <a:extLst xmlns:a="http://schemas.openxmlformats.org/drawingml/2006/main">
               <a:ext uri="{FF2B5EF4-FFF2-40B4-BE49-F238E27FC236}">
-                <a16:creationId xmlns:a16="http://schemas.microsoft.com/office/drawing/2014/main" id="{4D19DAA2-A3EA-4A54-9D36-B4B7A5E242C8}"/>
+                <a16:creationId xmlns:a16="http://schemas.microsoft.com/office/drawing/2014/main" id="{4B80F24A-DA05-4C7B-A4C1-37536324A0D8}"/>
               </a:ext>
             </a:extLst>
           </p:cNvPr>
@@ -4028,7 +4095,7 @@
           <p:cNvPr id="28" name="">
             <a:extLst xmlns:a="http://schemas.openxmlformats.org/drawingml/2006/main">
               <a:ext uri="{FF2B5EF4-FFF2-40B4-BE49-F238E27FC236}">
-                <a16:creationId xmlns:a16="http://schemas.microsoft.com/office/drawing/2014/main" id="{8748FEDE-02A2-4D47-84BC-935FCEEA895C}"/>
+                <a16:creationId xmlns:a16="http://schemas.microsoft.com/office/drawing/2014/main" id="{44238A1C-C515-46CE-9CE2-FF20A956724F}"/>
               </a:ext>
             </a:extLst>
           </p:cNvPr>
@@ -4092,7 +4159,7 @@
           <p:cNvPr id="29" name="">
             <a:extLst xmlns:a="http://schemas.openxmlformats.org/drawingml/2006/main">
               <a:ext uri="{FF2B5EF4-FFF2-40B4-BE49-F238E27FC236}">
-                <a16:creationId xmlns:a16="http://schemas.microsoft.com/office/drawing/2014/main" id="{5811F19B-D936-43E9-BCCB-3F1FB582F3E3}"/>
+                <a16:creationId xmlns:a16="http://schemas.microsoft.com/office/drawing/2014/main" id="{AC43B983-0E9E-4222-BE52-F57807949E6D}"/>
               </a:ext>
             </a:extLst>
           </p:cNvPr>
@@ -4156,7 +4223,7 @@
           <p:cNvPr id="30" name="">
             <a:extLst xmlns:a="http://schemas.openxmlformats.org/drawingml/2006/main">
               <a:ext uri="{FF2B5EF4-FFF2-40B4-BE49-F238E27FC236}">
-                <a16:creationId xmlns:a16="http://schemas.microsoft.com/office/drawing/2014/main" id="{E2A938FF-1986-4EDE-AD48-D5873480A3FE}"/>
+                <a16:creationId xmlns:a16="http://schemas.microsoft.com/office/drawing/2014/main" id="{0E382AFE-F454-4C05-8D40-B9A8EF74E433}"/>
               </a:ext>
             </a:extLst>
           </p:cNvPr>
@@ -4191,7 +4258,7 @@
           <p:cNvPr id="31" name="">
             <a:extLst xmlns:a="http://schemas.openxmlformats.org/drawingml/2006/main">
               <a:ext uri="{FF2B5EF4-FFF2-40B4-BE49-F238E27FC236}">
-                <a16:creationId xmlns:a16="http://schemas.microsoft.com/office/drawing/2014/main" id="{8E64B576-2ACD-4B34-805E-D5BC50FE6AD2}"/>
+                <a16:creationId xmlns:a16="http://schemas.microsoft.com/office/drawing/2014/main" id="{94FAC8FB-638C-4890-B6F2-1F809521A11E}"/>
               </a:ext>
             </a:extLst>
           </p:cNvPr>
@@ -4255,7 +4322,7 @@
           <p:cNvPr id="32" name="">
             <a:extLst xmlns:a="http://schemas.openxmlformats.org/drawingml/2006/main">
               <a:ext uri="{FF2B5EF4-FFF2-40B4-BE49-F238E27FC236}">
-                <a16:creationId xmlns:a16="http://schemas.microsoft.com/office/drawing/2014/main" id="{FC65B36D-8398-4E39-83AA-365B7DA46EB1}"/>
+                <a16:creationId xmlns:a16="http://schemas.microsoft.com/office/drawing/2014/main" id="{6C8A95DA-2B5E-4CDF-9D26-51CA4D06CC8E}"/>
               </a:ext>
             </a:extLst>
           </p:cNvPr>
@@ -4290,7 +4357,7 @@
           <p:cNvPr id="33" name="">
             <a:extLst xmlns:a="http://schemas.openxmlformats.org/drawingml/2006/main">
               <a:ext uri="{FF2B5EF4-FFF2-40B4-BE49-F238E27FC236}">
-                <a16:creationId xmlns:a16="http://schemas.microsoft.com/office/drawing/2014/main" id="{9E9BBAF0-A274-4080-99A3-26E338CF7A08}"/>
+                <a16:creationId xmlns:a16="http://schemas.microsoft.com/office/drawing/2014/main" id="{C418FECA-17C3-4275-9A59-933C230FBEF4}"/>
               </a:ext>
             </a:extLst>
           </p:cNvPr>
@@ -4354,7 +4421,7 @@
           <p:cNvPr id="34" name="">
             <a:extLst xmlns:a="http://schemas.openxmlformats.org/drawingml/2006/main">
               <a:ext uri="{FF2B5EF4-FFF2-40B4-BE49-F238E27FC236}">
-                <a16:creationId xmlns:a16="http://schemas.microsoft.com/office/drawing/2014/main" id="{1C663FDB-9DF5-4869-9A03-48650A60EB0A}"/>
+                <a16:creationId xmlns:a16="http://schemas.microsoft.com/office/drawing/2014/main" id="{697CCBC3-F141-4097-8A03-0B4688C48A92}"/>
               </a:ext>
             </a:extLst>
           </p:cNvPr>
@@ -4441,7 +4508,7 @@
           <p:cNvPr id="35" name="">
             <a:extLst xmlns:a="http://schemas.openxmlformats.org/drawingml/2006/main">
               <a:ext uri="{FF2B5EF4-FFF2-40B4-BE49-F238E27FC236}">
-                <a16:creationId xmlns:a16="http://schemas.microsoft.com/office/drawing/2014/main" id="{8C7EBD43-ADA2-4C7F-A179-62349E5CBC4F}"/>
+                <a16:creationId xmlns:a16="http://schemas.microsoft.com/office/drawing/2014/main" id="{F2DE9B15-5919-4FC7-9D50-2D3A724AA66D}"/>
               </a:ext>
             </a:extLst>
           </p:cNvPr>
@@ -4476,7 +4543,7 @@
           <p:cNvPr id="36" name="">
             <a:extLst xmlns:a="http://schemas.openxmlformats.org/drawingml/2006/main">
               <a:ext uri="{FF2B5EF4-FFF2-40B4-BE49-F238E27FC236}">
-                <a16:creationId xmlns:a16="http://schemas.microsoft.com/office/drawing/2014/main" id="{CA5AD0DF-C78F-4956-A7FC-9C0125530174}"/>
+                <a16:creationId xmlns:a16="http://schemas.microsoft.com/office/drawing/2014/main" id="{0964C600-912E-4466-9BB9-746DE9099CA1}"/>
               </a:ext>
             </a:extLst>
           </p:cNvPr>
@@ -4540,7 +4607,7 @@
           <p:cNvPr id="37" name="">
             <a:extLst xmlns:a="http://schemas.openxmlformats.org/drawingml/2006/main">
               <a:ext uri="{FF2B5EF4-FFF2-40B4-BE49-F238E27FC236}">
-                <a16:creationId xmlns:a16="http://schemas.microsoft.com/office/drawing/2014/main" id="{3E920331-0E3B-4B4F-AEDE-AF0550B5492B}"/>
+                <a16:creationId xmlns:a16="http://schemas.microsoft.com/office/drawing/2014/main" id="{D1EBDEC2-6A8E-4D8C-BECF-DEF4B8C0C2C9}"/>
               </a:ext>
             </a:extLst>
           </p:cNvPr>
@@ -4627,7 +4694,7 @@
           <p:cNvPr id="38" name="">
             <a:extLst xmlns:a="http://schemas.openxmlformats.org/drawingml/2006/main">
               <a:ext uri="{FF2B5EF4-FFF2-40B4-BE49-F238E27FC236}">
-                <a16:creationId xmlns:a16="http://schemas.microsoft.com/office/drawing/2014/main" id="{6B16438E-8278-4894-AFB8-EE907E080135}"/>
+                <a16:creationId xmlns:a16="http://schemas.microsoft.com/office/drawing/2014/main" id="{499ED90B-D98E-4EFF-9B3F-3A8C196B88D6}"/>
               </a:ext>
             </a:extLst>
           </p:cNvPr>
@@ -4660,7 +4727,7 @@
           <p:cNvPr id="39" name="">
             <a:extLst xmlns:a="http://schemas.openxmlformats.org/drawingml/2006/main">
               <a:ext uri="{FF2B5EF4-FFF2-40B4-BE49-F238E27FC236}">
-                <a16:creationId xmlns:a16="http://schemas.microsoft.com/office/drawing/2014/main" id="{A4C348DC-D2CB-444E-B519-41D2BD1CCD58}"/>
+                <a16:creationId xmlns:a16="http://schemas.microsoft.com/office/drawing/2014/main" id="{E74DE969-3273-4043-B0CE-1D1567BA5FED}"/>
               </a:ext>
             </a:extLst>
           </p:cNvPr>
@@ -4724,7 +4791,7 @@
           <p:cNvPr id="40" name="">
             <a:extLst xmlns:a="http://schemas.openxmlformats.org/drawingml/2006/main">
               <a:ext uri="{FF2B5EF4-FFF2-40B4-BE49-F238E27FC236}">
-                <a16:creationId xmlns:a16="http://schemas.microsoft.com/office/drawing/2014/main" id="{15A2E02E-42D0-46FB-879B-314A2CAC49B9}"/>
+                <a16:creationId xmlns:a16="http://schemas.microsoft.com/office/drawing/2014/main" id="{1E387019-4BA4-43B8-AC27-6C8C51FCE593}"/>
               </a:ext>
             </a:extLst>
           </p:cNvPr>
@@ -4786,7 +4853,7 @@
     </p:spTree>
     <p:extLst>
       <p:ext uri="{BB962C8B-B14F-4D97-AF65-F5344CB8AC3E}">
-        <p14:creationId xmlns:p14="http://schemas.microsoft.com/office/powerpoint/2010/main" val="958087451"/>
+        <p14:creationId xmlns:p14="http://schemas.microsoft.com/office/powerpoint/2010/main" val="1025681082"/>
       </p:ext>
     </p:extLst>
   </p:cSld>
@@ -4810,7 +4877,7 @@
           <p:cNvPr id="1" name="">
             <a:extLst xmlns:a="http://schemas.openxmlformats.org/drawingml/2006/main">
               <a:ext uri="{FF2B5EF4-FFF2-40B4-BE49-F238E27FC236}">
-                <a16:creationId xmlns:a16="http://schemas.microsoft.com/office/drawing/2014/main" id="{E654755D-42BC-499B-B5A2-D0DA1671C5F3}"/>
+                <a16:creationId xmlns:a16="http://schemas.microsoft.com/office/drawing/2014/main" id="{9D6BE384-EBA0-421D-AFA8-D55B59936A5D}"/>
               </a:ext>
             </a:extLst>
           </p:cNvPr>
@@ -4843,7 +4910,7 @@
           <p:cNvPr id="2" name="">
             <a:extLst xmlns:a="http://schemas.openxmlformats.org/drawingml/2006/main">
               <a:ext uri="{FF2B5EF4-FFF2-40B4-BE49-F238E27FC236}">
-                <a16:creationId xmlns:a16="http://schemas.microsoft.com/office/drawing/2014/main" id="{E8AC657A-AAE2-446C-B9EB-6820D849158F}"/>
+                <a16:creationId xmlns:a16="http://schemas.microsoft.com/office/drawing/2014/main" id="{9F25EA45-008E-4EED-A5DE-E3A382E639A5}"/>
               </a:ext>
             </a:extLst>
           </p:cNvPr>
@@ -4876,7 +4943,7 @@
           <p:cNvPr id="3" name="">
             <a:extLst xmlns:a="http://schemas.openxmlformats.org/drawingml/2006/main">
               <a:ext uri="{FF2B5EF4-FFF2-40B4-BE49-F238E27FC236}">
-                <a16:creationId xmlns:a16="http://schemas.microsoft.com/office/drawing/2014/main" id="{D24CC30D-8886-4C55-91DD-CE3B57C263EA}"/>
+                <a16:creationId xmlns:a16="http://schemas.microsoft.com/office/drawing/2014/main" id="{5BA58570-721A-463D-AC78-A23E8A776E4F}"/>
               </a:ext>
             </a:extLst>
           </p:cNvPr>
@@ -4888,7 +4955,7 @@
         <p:spPr>
           <a:xfrm xmlns:a="http://schemas.openxmlformats.org/drawingml/2006/main">
             <a:off x="752475" y="371475"/>
-            <a:ext cx="4000500" cy="209550"/>
+            <a:ext cx="4762500" cy="209550"/>
           </a:xfrm>
           <a:prstGeom xmlns:a="http://schemas.openxmlformats.org/drawingml/2006/main" prst="rect">
             <a:avLst/>
@@ -4940,7 +5007,7 @@
           <p:cNvPr id="4" name="">
             <a:extLst xmlns:a="http://schemas.openxmlformats.org/drawingml/2006/main">
               <a:ext uri="{FF2B5EF4-FFF2-40B4-BE49-F238E27FC236}">
-                <a16:creationId xmlns:a16="http://schemas.microsoft.com/office/drawing/2014/main" id="{BC4EFB12-BB52-43A0-B9CB-D52968A505BE}"/>
+                <a16:creationId xmlns:a16="http://schemas.microsoft.com/office/drawing/2014/main" id="{F76043AE-91AC-43EB-A18E-9F2A262AAE44}"/>
               </a:ext>
             </a:extLst>
           </p:cNvPr>
@@ -5004,7 +5071,7 @@
           <p:cNvPr id="5" name="">
             <a:extLst xmlns:a="http://schemas.openxmlformats.org/drawingml/2006/main">
               <a:ext uri="{FF2B5EF4-FFF2-40B4-BE49-F238E27FC236}">
-                <a16:creationId xmlns:a16="http://schemas.microsoft.com/office/drawing/2014/main" id="{0F2984B1-F60F-4D65-AA84-116D6C01ECA5}"/>
+                <a16:creationId xmlns:a16="http://schemas.microsoft.com/office/drawing/2014/main" id="{2DF2D64E-5909-4430-A9A0-7C903F953F7B}"/>
               </a:ext>
             </a:extLst>
           </p:cNvPr>
@@ -5068,7 +5135,7 @@
           <p:cNvPr id="6" name="">
             <a:extLst xmlns:a="http://schemas.openxmlformats.org/drawingml/2006/main">
               <a:ext uri="{FF2B5EF4-FFF2-40B4-BE49-F238E27FC236}">
-                <a16:creationId xmlns:a16="http://schemas.microsoft.com/office/drawing/2014/main" id="{4133DABB-9813-4FFF-A936-68B4230883D1}"/>
+                <a16:creationId xmlns:a16="http://schemas.microsoft.com/office/drawing/2014/main" id="{934AA3D9-5A5B-4C53-AE71-C5318EBE7EB2}"/>
               </a:ext>
             </a:extLst>
           </p:cNvPr>
@@ -5080,7 +5147,7 @@
         <p:spPr>
           <a:xfrm xmlns:a="http://schemas.openxmlformats.org/drawingml/2006/main">
             <a:off x="552450" y="1657350"/>
-            <a:ext cx="10191750" cy="400050"/>
+            <a:ext cx="10477500" cy="400050"/>
           </a:xfrm>
           <a:prstGeom xmlns:a="http://schemas.openxmlformats.org/drawingml/2006/main" prst="rect">
             <a:avLst/>
@@ -5132,7 +5199,7 @@
           <p:cNvPr id="7" name="">
             <a:extLst xmlns:a="http://schemas.openxmlformats.org/drawingml/2006/main">
               <a:ext uri="{FF2B5EF4-FFF2-40B4-BE49-F238E27FC236}">
-                <a16:creationId xmlns:a16="http://schemas.microsoft.com/office/drawing/2014/main" id="{843C9577-722A-4EA7-90C5-E3D054094FF2}"/>
+                <a16:creationId xmlns:a16="http://schemas.microsoft.com/office/drawing/2014/main" id="{92C3760B-864A-4E6F-ACCE-4619199AC753}"/>
               </a:ext>
             </a:extLst>
           </p:cNvPr>
@@ -5167,7 +5234,7 @@
           <p:cNvPr id="8" name="">
             <a:extLst xmlns:a="http://schemas.openxmlformats.org/drawingml/2006/main">
               <a:ext uri="{FF2B5EF4-FFF2-40B4-BE49-F238E27FC236}">
-                <a16:creationId xmlns:a16="http://schemas.microsoft.com/office/drawing/2014/main" id="{5AF4404A-60C1-4DF8-906B-F3DA32737439}"/>
+                <a16:creationId xmlns:a16="http://schemas.microsoft.com/office/drawing/2014/main" id="{9D160732-CD58-4EA7-AFBA-E259DF864AA7}"/>
               </a:ext>
             </a:extLst>
           </p:cNvPr>
@@ -5202,7 +5269,7 @@
           <p:cNvPr id="9" name="">
             <a:extLst xmlns:a="http://schemas.openxmlformats.org/drawingml/2006/main">
               <a:ext uri="{FF2B5EF4-FFF2-40B4-BE49-F238E27FC236}">
-                <a16:creationId xmlns:a16="http://schemas.microsoft.com/office/drawing/2014/main" id="{AB1457CA-EED7-4110-83DF-FAAAC8D079A4}"/>
+                <a16:creationId xmlns:a16="http://schemas.microsoft.com/office/drawing/2014/main" id="{1A5285D7-18B3-427B-B4E3-AD1E4CA82916}"/>
               </a:ext>
             </a:extLst>
           </p:cNvPr>
@@ -5266,7 +5333,7 @@
           <p:cNvPr id="10" name="">
             <a:extLst xmlns:a="http://schemas.openxmlformats.org/drawingml/2006/main">
               <a:ext uri="{FF2B5EF4-FFF2-40B4-BE49-F238E27FC236}">
-                <a16:creationId xmlns:a16="http://schemas.microsoft.com/office/drawing/2014/main" id="{05B787A5-A085-4FD5-AC55-3EC5713D7B5C}"/>
+                <a16:creationId xmlns:a16="http://schemas.microsoft.com/office/drawing/2014/main" id="{64BDBF61-E2EF-456E-8216-E33E3AED61BA}"/>
               </a:ext>
             </a:extLst>
           </p:cNvPr>
@@ -5353,7 +5420,7 @@
           <p:cNvPr id="11" name="">
             <a:extLst xmlns:a="http://schemas.openxmlformats.org/drawingml/2006/main">
               <a:ext uri="{FF2B5EF4-FFF2-40B4-BE49-F238E27FC236}">
-                <a16:creationId xmlns:a16="http://schemas.microsoft.com/office/drawing/2014/main" id="{F2752989-7932-45DA-A836-DB972E9408BB}"/>
+                <a16:creationId xmlns:a16="http://schemas.microsoft.com/office/drawing/2014/main" id="{5D0C5A34-FF8B-4887-92B0-189B99F5D267}"/>
               </a:ext>
             </a:extLst>
           </p:cNvPr>
@@ -5388,7 +5455,7 @@
           <p:cNvPr id="12" name="">
             <a:extLst xmlns:a="http://schemas.openxmlformats.org/drawingml/2006/main">
               <a:ext uri="{FF2B5EF4-FFF2-40B4-BE49-F238E27FC236}">
-                <a16:creationId xmlns:a16="http://schemas.microsoft.com/office/drawing/2014/main" id="{65BC2B6D-D02E-411B-925C-866EFCDF87F3}"/>
+                <a16:creationId xmlns:a16="http://schemas.microsoft.com/office/drawing/2014/main" id="{0C8755F1-283B-44B1-A0B6-FB1D8CE86AB1}"/>
               </a:ext>
             </a:extLst>
           </p:cNvPr>
@@ -5423,7 +5490,7 @@
           <p:cNvPr id="13" name="">
             <a:extLst xmlns:a="http://schemas.openxmlformats.org/drawingml/2006/main">
               <a:ext uri="{FF2B5EF4-FFF2-40B4-BE49-F238E27FC236}">
-                <a16:creationId xmlns:a16="http://schemas.microsoft.com/office/drawing/2014/main" id="{B939BDB5-BE17-4883-9151-CDD3EFD19B14}"/>
+                <a16:creationId xmlns:a16="http://schemas.microsoft.com/office/drawing/2014/main" id="{3E214411-6301-4CE7-A5BA-B662617ABCB1}"/>
               </a:ext>
             </a:extLst>
           </p:cNvPr>
@@ -5487,7 +5554,7 @@
           <p:cNvPr id="14" name="">
             <a:extLst xmlns:a="http://schemas.openxmlformats.org/drawingml/2006/main">
               <a:ext uri="{FF2B5EF4-FFF2-40B4-BE49-F238E27FC236}">
-                <a16:creationId xmlns:a16="http://schemas.microsoft.com/office/drawing/2014/main" id="{C9693C83-C946-4721-A51A-AA9C32AFCB7C}"/>
+                <a16:creationId xmlns:a16="http://schemas.microsoft.com/office/drawing/2014/main" id="{CF095A62-D5E4-40BB-B2FF-13E6A932F7F4}"/>
               </a:ext>
             </a:extLst>
           </p:cNvPr>
@@ -5574,7 +5641,7 @@
           <p:cNvPr id="15" name="">
             <a:extLst xmlns:a="http://schemas.openxmlformats.org/drawingml/2006/main">
               <a:ext uri="{FF2B5EF4-FFF2-40B4-BE49-F238E27FC236}">
-                <a16:creationId xmlns:a16="http://schemas.microsoft.com/office/drawing/2014/main" id="{8266B0E6-6CF9-4650-9B5C-0773A1D2D824}"/>
+                <a16:creationId xmlns:a16="http://schemas.microsoft.com/office/drawing/2014/main" id="{407B4535-AE14-4585-A5EE-5A22AF77ABBB}"/>
               </a:ext>
             </a:extLst>
           </p:cNvPr>
@@ -5607,7 +5674,7 @@
           <p:cNvPr id="16" name="">
             <a:extLst xmlns:a="http://schemas.openxmlformats.org/drawingml/2006/main">
               <a:ext uri="{FF2B5EF4-FFF2-40B4-BE49-F238E27FC236}">
-                <a16:creationId xmlns:a16="http://schemas.microsoft.com/office/drawing/2014/main" id="{3FF99127-FB22-48FE-8DD3-24D2B4EB65D0}"/>
+                <a16:creationId xmlns:a16="http://schemas.microsoft.com/office/drawing/2014/main" id="{FDF89EC7-3D29-4D82-9370-493ABCA406E4}"/>
               </a:ext>
             </a:extLst>
           </p:cNvPr>
@@ -5671,7 +5738,7 @@
           <p:cNvPr id="17" name="">
             <a:extLst xmlns:a="http://schemas.openxmlformats.org/drawingml/2006/main">
               <a:ext uri="{FF2B5EF4-FFF2-40B4-BE49-F238E27FC236}">
-                <a16:creationId xmlns:a16="http://schemas.microsoft.com/office/drawing/2014/main" id="{6846F6C8-B39B-4EF5-90E2-03AB726617D0}"/>
+                <a16:creationId xmlns:a16="http://schemas.microsoft.com/office/drawing/2014/main" id="{87191726-5F6B-46E3-97C1-7E5D2B23B1AB}"/>
               </a:ext>
             </a:extLst>
           </p:cNvPr>
@@ -5735,7 +5802,7 @@
           <p:cNvPr id="18" name="">
             <a:extLst xmlns:a="http://schemas.openxmlformats.org/drawingml/2006/main">
               <a:ext uri="{FF2B5EF4-FFF2-40B4-BE49-F238E27FC236}">
-                <a16:creationId xmlns:a16="http://schemas.microsoft.com/office/drawing/2014/main" id="{EA74F12F-ACA4-40F8-88D9-1B4B2E503F03}"/>
+                <a16:creationId xmlns:a16="http://schemas.microsoft.com/office/drawing/2014/main" id="{066DF35D-0227-4E0E-8A4A-C9B13A28B26E}"/>
               </a:ext>
             </a:extLst>
           </p:cNvPr>
@@ -5770,7 +5837,7 @@
           <p:cNvPr id="19" name="">
             <a:extLst xmlns:a="http://schemas.openxmlformats.org/drawingml/2006/main">
               <a:ext uri="{FF2B5EF4-FFF2-40B4-BE49-F238E27FC236}">
-                <a16:creationId xmlns:a16="http://schemas.microsoft.com/office/drawing/2014/main" id="{EC3E4977-FA16-4B99-83E9-516E464D5785}"/>
+                <a16:creationId xmlns:a16="http://schemas.microsoft.com/office/drawing/2014/main" id="{8F2E198D-F5C4-497F-8D5B-65656DBD069D}"/>
               </a:ext>
             </a:extLst>
           </p:cNvPr>
@@ -5857,7 +5924,7 @@
           <p:cNvPr id="20" name="">
             <a:extLst xmlns:a="http://schemas.openxmlformats.org/drawingml/2006/main">
               <a:ext uri="{FF2B5EF4-FFF2-40B4-BE49-F238E27FC236}">
-                <a16:creationId xmlns:a16="http://schemas.microsoft.com/office/drawing/2014/main" id="{FDD42FBF-F986-4C3A-BE0C-BCDAD2D94EA4}"/>
+                <a16:creationId xmlns:a16="http://schemas.microsoft.com/office/drawing/2014/main" id="{4F500F4B-2A26-4F04-8E2E-6AE2B23FC210}"/>
               </a:ext>
             </a:extLst>
           </p:cNvPr>
@@ -5990,7 +6057,7 @@
           <p:cNvPr id="21" name="">
             <a:extLst xmlns:a="http://schemas.openxmlformats.org/drawingml/2006/main">
               <a:ext uri="{FF2B5EF4-FFF2-40B4-BE49-F238E27FC236}">
-                <a16:creationId xmlns:a16="http://schemas.microsoft.com/office/drawing/2014/main" id="{01CD9ED2-1856-42B7-9048-207ED2808CBD}"/>
+                <a16:creationId xmlns:a16="http://schemas.microsoft.com/office/drawing/2014/main" id="{DCD1AB01-9EC6-40E4-942C-E60D6D59C353}"/>
               </a:ext>
             </a:extLst>
           </p:cNvPr>
@@ -6023,7 +6090,7 @@
           <p:cNvPr id="22" name="">
             <a:extLst xmlns:a="http://schemas.openxmlformats.org/drawingml/2006/main">
               <a:ext uri="{FF2B5EF4-FFF2-40B4-BE49-F238E27FC236}">
-                <a16:creationId xmlns:a16="http://schemas.microsoft.com/office/drawing/2014/main" id="{C166FF7B-5C86-462F-9BB8-28D60710C8D9}"/>
+                <a16:creationId xmlns:a16="http://schemas.microsoft.com/office/drawing/2014/main" id="{C6197B48-F083-4BE6-A567-2BF3C346F73B}"/>
               </a:ext>
             </a:extLst>
           </p:cNvPr>
@@ -6087,7 +6154,7 @@
           <p:cNvPr id="23" name="">
             <a:extLst xmlns:a="http://schemas.openxmlformats.org/drawingml/2006/main">
               <a:ext uri="{FF2B5EF4-FFF2-40B4-BE49-F238E27FC236}">
-                <a16:creationId xmlns:a16="http://schemas.microsoft.com/office/drawing/2014/main" id="{32AFE20E-CA28-4F77-886E-F35E7DA53B31}"/>
+                <a16:creationId xmlns:a16="http://schemas.microsoft.com/office/drawing/2014/main" id="{EF013B77-2646-414D-92FA-43EE01600157}"/>
               </a:ext>
             </a:extLst>
           </p:cNvPr>
@@ -6151,7 +6218,7 @@
           <p:cNvPr id="24" name="">
             <a:extLst xmlns:a="http://schemas.openxmlformats.org/drawingml/2006/main">
               <a:ext uri="{FF2B5EF4-FFF2-40B4-BE49-F238E27FC236}">
-                <a16:creationId xmlns:a16="http://schemas.microsoft.com/office/drawing/2014/main" id="{F6A08E2D-7048-4E74-8DD6-1CC11285315F}"/>
+                <a16:creationId xmlns:a16="http://schemas.microsoft.com/office/drawing/2014/main" id="{BD7F35B2-C9EB-41BF-A50B-96384580A335}"/>
               </a:ext>
             </a:extLst>
           </p:cNvPr>
@@ -6186,7 +6253,7 @@
           <p:cNvPr id="25" name="">
             <a:extLst xmlns:a="http://schemas.openxmlformats.org/drawingml/2006/main">
               <a:ext uri="{FF2B5EF4-FFF2-40B4-BE49-F238E27FC236}">
-                <a16:creationId xmlns:a16="http://schemas.microsoft.com/office/drawing/2014/main" id="{916507A6-C225-4563-8F6A-6E6C9003865A}"/>
+                <a16:creationId xmlns:a16="http://schemas.microsoft.com/office/drawing/2014/main" id="{E391C272-2A3A-4D5E-89EA-9B4F7BBBEBBF}"/>
               </a:ext>
             </a:extLst>
           </p:cNvPr>
@@ -6221,7 +6288,7 @@
           <p:cNvPr id="26" name="">
             <a:extLst xmlns:a="http://schemas.openxmlformats.org/drawingml/2006/main">
               <a:ext uri="{FF2B5EF4-FFF2-40B4-BE49-F238E27FC236}">
-                <a16:creationId xmlns:a16="http://schemas.microsoft.com/office/drawing/2014/main" id="{550481F0-C263-4B0A-AD97-C95B2565CF7E}"/>
+                <a16:creationId xmlns:a16="http://schemas.microsoft.com/office/drawing/2014/main" id="{95EF0B87-4A1C-4384-8747-D41728A4824F}"/>
               </a:ext>
             </a:extLst>
           </p:cNvPr>
@@ -6285,7 +6352,7 @@
           <p:cNvPr id="27" name="">
             <a:extLst xmlns:a="http://schemas.openxmlformats.org/drawingml/2006/main">
               <a:ext uri="{FF2B5EF4-FFF2-40B4-BE49-F238E27FC236}">
-                <a16:creationId xmlns:a16="http://schemas.microsoft.com/office/drawing/2014/main" id="{B97F1956-A2A8-457C-B805-382C4AC660FB}"/>
+                <a16:creationId xmlns:a16="http://schemas.microsoft.com/office/drawing/2014/main" id="{F5B7F78B-FD24-4878-9782-3AB77AF53E8B}"/>
               </a:ext>
             </a:extLst>
           </p:cNvPr>
@@ -6372,7 +6439,7 @@
           <p:cNvPr id="28" name="">
             <a:extLst xmlns:a="http://schemas.openxmlformats.org/drawingml/2006/main">
               <a:ext uri="{FF2B5EF4-FFF2-40B4-BE49-F238E27FC236}">
-                <a16:creationId xmlns:a16="http://schemas.microsoft.com/office/drawing/2014/main" id="{FB2599AB-DE78-49E7-845C-68B96F1B7950}"/>
+                <a16:creationId xmlns:a16="http://schemas.microsoft.com/office/drawing/2014/main" id="{ACF54FD2-D5E6-46F4-B38E-C6CA12EAC055}"/>
               </a:ext>
             </a:extLst>
           </p:cNvPr>
@@ -6459,7 +6526,7 @@
           <p:cNvPr id="29" name="">
             <a:extLst xmlns:a="http://schemas.openxmlformats.org/drawingml/2006/main">
               <a:ext uri="{FF2B5EF4-FFF2-40B4-BE49-F238E27FC236}">
-                <a16:creationId xmlns:a16="http://schemas.microsoft.com/office/drawing/2014/main" id="{D1757365-043D-4BEF-A5FD-20EFBD9DE7B8}"/>
+                <a16:creationId xmlns:a16="http://schemas.microsoft.com/office/drawing/2014/main" id="{DC6A77F8-2360-46D7-A652-82F44BD0ECEE}"/>
               </a:ext>
             </a:extLst>
           </p:cNvPr>
@@ -6492,7 +6559,7 @@
           <p:cNvPr id="30" name="">
             <a:extLst xmlns:a="http://schemas.openxmlformats.org/drawingml/2006/main">
               <a:ext uri="{FF2B5EF4-FFF2-40B4-BE49-F238E27FC236}">
-                <a16:creationId xmlns:a16="http://schemas.microsoft.com/office/drawing/2014/main" id="{06FCB89E-D15A-4E08-B9E6-6BED411D34AF}"/>
+                <a16:creationId xmlns:a16="http://schemas.microsoft.com/office/drawing/2014/main" id="{5FADA285-931B-4BDA-95B1-BFF002F247BC}"/>
               </a:ext>
             </a:extLst>
           </p:cNvPr>
@@ -6556,7 +6623,7 @@
           <p:cNvPr id="31" name="">
             <a:extLst xmlns:a="http://schemas.openxmlformats.org/drawingml/2006/main">
               <a:ext uri="{FF2B5EF4-FFF2-40B4-BE49-F238E27FC236}">
-                <a16:creationId xmlns:a16="http://schemas.microsoft.com/office/drawing/2014/main" id="{36C67801-2923-4C73-8478-F6C5B481434A}"/>
+                <a16:creationId xmlns:a16="http://schemas.microsoft.com/office/drawing/2014/main" id="{FA637BB5-68E7-47CB-B079-78F8EA1F0690}"/>
               </a:ext>
             </a:extLst>
           </p:cNvPr>
@@ -6591,7 +6658,7 @@
           <p:cNvPr id="32" name="">
             <a:extLst xmlns:a="http://schemas.openxmlformats.org/drawingml/2006/main">
               <a:ext uri="{FF2B5EF4-FFF2-40B4-BE49-F238E27FC236}">
-                <a16:creationId xmlns:a16="http://schemas.microsoft.com/office/drawing/2014/main" id="{8258FD25-9BA4-40FD-8650-82E23379C83D}"/>
+                <a16:creationId xmlns:a16="http://schemas.microsoft.com/office/drawing/2014/main" id="{BDA3DD83-C41A-467D-BE70-CCBB23DE3F7D}"/>
               </a:ext>
             </a:extLst>
           </p:cNvPr>
@@ -6626,7 +6693,7 @@
           <p:cNvPr id="33" name="">
             <a:extLst xmlns:a="http://schemas.openxmlformats.org/drawingml/2006/main">
               <a:ext uri="{FF2B5EF4-FFF2-40B4-BE49-F238E27FC236}">
-                <a16:creationId xmlns:a16="http://schemas.microsoft.com/office/drawing/2014/main" id="{A724B99C-4F6C-4CA3-9C25-B4D04B222F17}"/>
+                <a16:creationId xmlns:a16="http://schemas.microsoft.com/office/drawing/2014/main" id="{AA836CB5-A376-4B41-949C-68540B54E8B7}"/>
               </a:ext>
             </a:extLst>
           </p:cNvPr>
@@ -6690,7 +6757,7 @@
           <p:cNvPr id="34" name="">
             <a:extLst xmlns:a="http://schemas.openxmlformats.org/drawingml/2006/main">
               <a:ext uri="{FF2B5EF4-FFF2-40B4-BE49-F238E27FC236}">
-                <a16:creationId xmlns:a16="http://schemas.microsoft.com/office/drawing/2014/main" id="{705878B7-AFC9-47CD-A8E8-0FADDC208186}"/>
+                <a16:creationId xmlns:a16="http://schemas.microsoft.com/office/drawing/2014/main" id="{EA562AB2-B06A-41BD-A12E-A91EA3F7A48A}"/>
               </a:ext>
             </a:extLst>
           </p:cNvPr>
@@ -6777,7 +6844,7 @@
           <p:cNvPr id="35" name="">
             <a:extLst xmlns:a="http://schemas.openxmlformats.org/drawingml/2006/main">
               <a:ext uri="{FF2B5EF4-FFF2-40B4-BE49-F238E27FC236}">
-                <a16:creationId xmlns:a16="http://schemas.microsoft.com/office/drawing/2014/main" id="{4561ABEA-8BFB-41A6-A4BD-78BE5F21DAD3}"/>
+                <a16:creationId xmlns:a16="http://schemas.microsoft.com/office/drawing/2014/main" id="{72FCAB19-4805-4AFA-937E-F93B97ED3581}"/>
               </a:ext>
             </a:extLst>
           </p:cNvPr>
@@ -6864,7 +6931,7 @@
           <p:cNvPr id="36" name="">
             <a:extLst xmlns:a="http://schemas.openxmlformats.org/drawingml/2006/main">
               <a:ext uri="{FF2B5EF4-FFF2-40B4-BE49-F238E27FC236}">
-                <a16:creationId xmlns:a16="http://schemas.microsoft.com/office/drawing/2014/main" id="{F0C117DC-A261-440C-963C-700FA6C12825}"/>
+                <a16:creationId xmlns:a16="http://schemas.microsoft.com/office/drawing/2014/main" id="{2100969D-7538-4500-AD59-024BC851EB19}"/>
               </a:ext>
             </a:extLst>
           </p:cNvPr>
@@ -6897,7 +6964,7 @@
           <p:cNvPr id="37" name="">
             <a:extLst xmlns:a="http://schemas.openxmlformats.org/drawingml/2006/main">
               <a:ext uri="{FF2B5EF4-FFF2-40B4-BE49-F238E27FC236}">
-                <a16:creationId xmlns:a16="http://schemas.microsoft.com/office/drawing/2014/main" id="{3828D083-1905-4A69-AADB-1088291FB0ED}"/>
+                <a16:creationId xmlns:a16="http://schemas.microsoft.com/office/drawing/2014/main" id="{8B0A44BF-A0A0-4130-A4F6-B930DE9278C8}"/>
               </a:ext>
             </a:extLst>
           </p:cNvPr>
@@ -6961,7 +7028,7 @@
           <p:cNvPr id="38" name="">
             <a:extLst xmlns:a="http://schemas.openxmlformats.org/drawingml/2006/main">
               <a:ext uri="{FF2B5EF4-FFF2-40B4-BE49-F238E27FC236}">
-                <a16:creationId xmlns:a16="http://schemas.microsoft.com/office/drawing/2014/main" id="{6F945B7C-2823-44EB-A126-B3438AE737EC}"/>
+                <a16:creationId xmlns:a16="http://schemas.microsoft.com/office/drawing/2014/main" id="{B2D4FFFE-EBAC-4355-A3B5-1C5E024CC240}"/>
               </a:ext>
             </a:extLst>
           </p:cNvPr>
@@ -6996,7 +7063,7 @@
           <p:cNvPr id="39" name="">
             <a:extLst xmlns:a="http://schemas.openxmlformats.org/drawingml/2006/main">
               <a:ext uri="{FF2B5EF4-FFF2-40B4-BE49-F238E27FC236}">
-                <a16:creationId xmlns:a16="http://schemas.microsoft.com/office/drawing/2014/main" id="{C25CADA6-4B71-48F3-9A2B-D7E1B8DB2F91}"/>
+                <a16:creationId xmlns:a16="http://schemas.microsoft.com/office/drawing/2014/main" id="{5F2A70E6-78F8-40E5-901C-148CCC7E1F89}"/>
               </a:ext>
             </a:extLst>
           </p:cNvPr>
@@ -7031,7 +7098,7 @@
           <p:cNvPr id="40" name="">
             <a:extLst xmlns:a="http://schemas.openxmlformats.org/drawingml/2006/main">
               <a:ext uri="{FF2B5EF4-FFF2-40B4-BE49-F238E27FC236}">
-                <a16:creationId xmlns:a16="http://schemas.microsoft.com/office/drawing/2014/main" id="{1F74F3E2-D7FD-4551-BB8E-79BD7AE52683}"/>
+                <a16:creationId xmlns:a16="http://schemas.microsoft.com/office/drawing/2014/main" id="{82F71BA6-F2A3-4432-A145-66AAAE224E19}"/>
               </a:ext>
             </a:extLst>
           </p:cNvPr>
@@ -7095,7 +7162,7 @@
           <p:cNvPr id="41" name="">
             <a:extLst xmlns:a="http://schemas.openxmlformats.org/drawingml/2006/main">
               <a:ext uri="{FF2B5EF4-FFF2-40B4-BE49-F238E27FC236}">
-                <a16:creationId xmlns:a16="http://schemas.microsoft.com/office/drawing/2014/main" id="{C1689508-F003-41C8-A667-F697239CACF0}"/>
+                <a16:creationId xmlns:a16="http://schemas.microsoft.com/office/drawing/2014/main" id="{F0BDB20B-2B17-4D20-9229-3B66D05EDCAF}"/>
               </a:ext>
             </a:extLst>
           </p:cNvPr>
@@ -7159,7 +7226,7 @@
           <p:cNvPr id="42" name="">
             <a:extLst xmlns:a="http://schemas.openxmlformats.org/drawingml/2006/main">
               <a:ext uri="{FF2B5EF4-FFF2-40B4-BE49-F238E27FC236}">
-                <a16:creationId xmlns:a16="http://schemas.microsoft.com/office/drawing/2014/main" id="{8F804CC9-90C5-4A99-BA62-BE7BC124F1FA}"/>
+                <a16:creationId xmlns:a16="http://schemas.microsoft.com/office/drawing/2014/main" id="{D001A9CC-B517-428C-933C-5A863E45464D}"/>
               </a:ext>
             </a:extLst>
           </p:cNvPr>
@@ -7269,7 +7336,7 @@
           <p:cNvPr id="43" name="">
             <a:extLst xmlns:a="http://schemas.openxmlformats.org/drawingml/2006/main">
               <a:ext uri="{FF2B5EF4-FFF2-40B4-BE49-F238E27FC236}">
-                <a16:creationId xmlns:a16="http://schemas.microsoft.com/office/drawing/2014/main" id="{8470CF4A-9388-420A-8926-18579A56E7AB}"/>
+                <a16:creationId xmlns:a16="http://schemas.microsoft.com/office/drawing/2014/main" id="{824D98DC-387B-4CFA-995D-966F6C07753B}"/>
               </a:ext>
             </a:extLst>
           </p:cNvPr>
@@ -7302,7 +7369,7 @@
           <p:cNvPr id="44" name="">
             <a:extLst xmlns:a="http://schemas.openxmlformats.org/drawingml/2006/main">
               <a:ext uri="{FF2B5EF4-FFF2-40B4-BE49-F238E27FC236}">
-                <a16:creationId xmlns:a16="http://schemas.microsoft.com/office/drawing/2014/main" id="{3970DF5E-6A9F-4D1B-AC8A-144201007B3F}"/>
+                <a16:creationId xmlns:a16="http://schemas.microsoft.com/office/drawing/2014/main" id="{55C4D7A0-ED6F-4AC9-8702-4691BD4D793A}"/>
               </a:ext>
             </a:extLst>
           </p:cNvPr>
@@ -7366,7 +7433,7 @@
           <p:cNvPr id="45" name="">
             <a:extLst xmlns:a="http://schemas.openxmlformats.org/drawingml/2006/main">
               <a:ext uri="{FF2B5EF4-FFF2-40B4-BE49-F238E27FC236}">
-                <a16:creationId xmlns:a16="http://schemas.microsoft.com/office/drawing/2014/main" id="{2885D86A-4AF3-4D4D-BC62-3BFADD3E712D}"/>
+                <a16:creationId xmlns:a16="http://schemas.microsoft.com/office/drawing/2014/main" id="{7AE91A93-B303-4795-B780-7A7C0FF1D014}"/>
               </a:ext>
             </a:extLst>
           </p:cNvPr>
@@ -7401,7 +7468,7 @@
           <p:cNvPr id="46" name="">
             <a:extLst xmlns:a="http://schemas.openxmlformats.org/drawingml/2006/main">
               <a:ext uri="{FF2B5EF4-FFF2-40B4-BE49-F238E27FC236}">
-                <a16:creationId xmlns:a16="http://schemas.microsoft.com/office/drawing/2014/main" id="{7E2F3737-2CEC-4ABA-8E9F-63544BA4E27B}"/>
+                <a16:creationId xmlns:a16="http://schemas.microsoft.com/office/drawing/2014/main" id="{16DB6F9F-EE27-478D-8F39-300D10638B8D}"/>
               </a:ext>
             </a:extLst>
           </p:cNvPr>
@@ -7436,7 +7503,7 @@
           <p:cNvPr id="47" name="">
             <a:extLst xmlns:a="http://schemas.openxmlformats.org/drawingml/2006/main">
               <a:ext uri="{FF2B5EF4-FFF2-40B4-BE49-F238E27FC236}">
-                <a16:creationId xmlns:a16="http://schemas.microsoft.com/office/drawing/2014/main" id="{5A350DC5-8DF9-4E93-AD5D-341E27AEBE8B}"/>
+                <a16:creationId xmlns:a16="http://schemas.microsoft.com/office/drawing/2014/main" id="{9CBEAF12-FFF5-449E-9D65-A005A0F90D47}"/>
               </a:ext>
             </a:extLst>
           </p:cNvPr>
@@ -7500,7 +7567,7 @@
           <p:cNvPr id="48" name="">
             <a:extLst xmlns:a="http://schemas.openxmlformats.org/drawingml/2006/main">
               <a:ext uri="{FF2B5EF4-FFF2-40B4-BE49-F238E27FC236}">
-                <a16:creationId xmlns:a16="http://schemas.microsoft.com/office/drawing/2014/main" id="{F9D6F727-4785-4B6D-AF16-3608E1EB4568}"/>
+                <a16:creationId xmlns:a16="http://schemas.microsoft.com/office/drawing/2014/main" id="{D570DF17-D61F-4CF4-B357-E9AF32E95370}"/>
               </a:ext>
             </a:extLst>
           </p:cNvPr>
@@ -7564,7 +7631,7 @@
           <p:cNvPr id="49" name="">
             <a:extLst xmlns:a="http://schemas.openxmlformats.org/drawingml/2006/main">
               <a:ext uri="{FF2B5EF4-FFF2-40B4-BE49-F238E27FC236}">
-                <a16:creationId xmlns:a16="http://schemas.microsoft.com/office/drawing/2014/main" id="{E208B2C5-5EAB-4A94-89F5-8CD7F7C83BE7}"/>
+                <a16:creationId xmlns:a16="http://schemas.microsoft.com/office/drawing/2014/main" id="{71818FB8-0781-462A-986D-82DD90B1BE4F}"/>
               </a:ext>
             </a:extLst>
           </p:cNvPr>
@@ -7674,7 +7741,7 @@
           <p:cNvPr id="50" name="">
             <a:extLst xmlns:a="http://schemas.openxmlformats.org/drawingml/2006/main">
               <a:ext uri="{FF2B5EF4-FFF2-40B4-BE49-F238E27FC236}">
-                <a16:creationId xmlns:a16="http://schemas.microsoft.com/office/drawing/2014/main" id="{A159C921-0ADB-4328-A827-64CF573D068D}"/>
+                <a16:creationId xmlns:a16="http://schemas.microsoft.com/office/drawing/2014/main" id="{9AB9C137-B20F-4807-935A-EEB761E510F8}"/>
               </a:ext>
             </a:extLst>
           </p:cNvPr>
@@ -7709,7 +7776,7 @@
           <p:cNvPr id="51" name="">
             <a:extLst xmlns:a="http://schemas.openxmlformats.org/drawingml/2006/main">
               <a:ext uri="{FF2B5EF4-FFF2-40B4-BE49-F238E27FC236}">
-                <a16:creationId xmlns:a16="http://schemas.microsoft.com/office/drawing/2014/main" id="{9ADA66C9-66B6-459C-8818-6355B96C3BE7}"/>
+                <a16:creationId xmlns:a16="http://schemas.microsoft.com/office/drawing/2014/main" id="{EEEB7CB7-02A8-4B1B-846B-D0734CC8BFFB}"/>
               </a:ext>
             </a:extLst>
           </p:cNvPr>
@@ -7744,7 +7811,7 @@
           <p:cNvPr id="52" name="">
             <a:extLst xmlns:a="http://schemas.openxmlformats.org/drawingml/2006/main">
               <a:ext uri="{FF2B5EF4-FFF2-40B4-BE49-F238E27FC236}">
-                <a16:creationId xmlns:a16="http://schemas.microsoft.com/office/drawing/2014/main" id="{ED39D6AA-93D6-4B04-948D-03CEE84EF85A}"/>
+                <a16:creationId xmlns:a16="http://schemas.microsoft.com/office/drawing/2014/main" id="{AFA92BC0-5419-487F-BEAF-981674F7269D}"/>
               </a:ext>
             </a:extLst>
           </p:cNvPr>
@@ -7808,7 +7875,7 @@
           <p:cNvPr id="53" name="">
             <a:extLst xmlns:a="http://schemas.openxmlformats.org/drawingml/2006/main">
               <a:ext uri="{FF2B5EF4-FFF2-40B4-BE49-F238E27FC236}">
-                <a16:creationId xmlns:a16="http://schemas.microsoft.com/office/drawing/2014/main" id="{556B6269-559D-418E-A4FA-CFB43B6C04BA}"/>
+                <a16:creationId xmlns:a16="http://schemas.microsoft.com/office/drawing/2014/main" id="{2F589695-29BF-4A11-AD7F-AF62E661B795}"/>
               </a:ext>
             </a:extLst>
           </p:cNvPr>
@@ -7872,7 +7939,7 @@
           <p:cNvPr id="54" name="">
             <a:extLst xmlns:a="http://schemas.openxmlformats.org/drawingml/2006/main">
               <a:ext uri="{FF2B5EF4-FFF2-40B4-BE49-F238E27FC236}">
-                <a16:creationId xmlns:a16="http://schemas.microsoft.com/office/drawing/2014/main" id="{77B66251-E690-4CCE-93EA-76A77FB481CB}"/>
+                <a16:creationId xmlns:a16="http://schemas.microsoft.com/office/drawing/2014/main" id="{B5C6AB26-4828-49AB-85A7-90FB125EF23B}"/>
               </a:ext>
             </a:extLst>
           </p:cNvPr>
@@ -7905,7 +7972,7 @@
           <p:cNvPr id="55" name="">
             <a:extLst xmlns:a="http://schemas.openxmlformats.org/drawingml/2006/main">
               <a:ext uri="{FF2B5EF4-FFF2-40B4-BE49-F238E27FC236}">
-                <a16:creationId xmlns:a16="http://schemas.microsoft.com/office/drawing/2014/main" id="{B74A20A8-013A-4A14-83C7-88F2E05C103C}"/>
+                <a16:creationId xmlns:a16="http://schemas.microsoft.com/office/drawing/2014/main" id="{28B5A792-83BC-43A0-862E-58C79B7CB6EB}"/>
               </a:ext>
             </a:extLst>
           </p:cNvPr>
@@ -7969,7 +8036,7 @@
           <p:cNvPr id="56" name="">
             <a:extLst xmlns:a="http://schemas.openxmlformats.org/drawingml/2006/main">
               <a:ext uri="{FF2B5EF4-FFF2-40B4-BE49-F238E27FC236}">
-                <a16:creationId xmlns:a16="http://schemas.microsoft.com/office/drawing/2014/main" id="{2D965005-E6E2-4F06-9190-E02192AC7119}"/>
+                <a16:creationId xmlns:a16="http://schemas.microsoft.com/office/drawing/2014/main" id="{7508863B-033E-4FFB-BF80-6B3A6C4878BF}"/>
               </a:ext>
             </a:extLst>
           </p:cNvPr>
@@ -8031,7 +8098,2258 @@
     </p:spTree>
     <p:extLst>
       <p:ext uri="{BB962C8B-B14F-4D97-AF65-F5344CB8AC3E}">
-        <p14:creationId xmlns:p14="http://schemas.microsoft.com/office/powerpoint/2010/main" val="937445830"/>
+        <p14:creationId xmlns:p14="http://schemas.microsoft.com/office/powerpoint/2010/main" val="974150890"/>
+      </p:ext>
+    </p:extLst>
+  </p:cSld>
+</p:sld>
+</file>
+
+<file path=ppt/slides/slide4.xml><?xml version="1.0" encoding="utf-8"?>
+<p:sld xmlns:p="http://schemas.openxmlformats.org/presentationml/2006/main">
+  <p:cSld>
+    <p:spTree>
+      <p:nvGrpSpPr>
+        <p:cNvPr id="1" name=""/>
+        <p:cNvGrpSpPr/>
+        <p:nvPr/>
+      </p:nvGrpSpPr>
+      <p:grpSpPr>
+        <a:xfrm xmlns:a="http://schemas.openxmlformats.org/drawingml/2006/main"/>
+      </p:grpSpPr>
+      <p:sp>
+        <p:nvSpPr>
+          <p:cNvPr id="1" name="">
+            <a:extLst xmlns:a="http://schemas.openxmlformats.org/drawingml/2006/main">
+              <a:ext uri="{FF2B5EF4-FFF2-40B4-BE49-F238E27FC236}">
+                <a16:creationId xmlns:a16="http://schemas.microsoft.com/office/drawing/2014/main" id="{2B7C68CB-04FE-4D76-A5B2-69D74334B2CF}"/>
+              </a:ext>
+            </a:extLst>
+          </p:cNvPr>
+          <p:cNvSpPr>
+            <a:spLocks xmlns:a="http://schemas.openxmlformats.org/drawingml/2006/main" noGrp="1"/>
+          </p:cNvSpPr>
+          <p:nvPr/>
+        </p:nvSpPr>
+        <p:spPr>
+          <a:xfrm xmlns:a="http://schemas.openxmlformats.org/drawingml/2006/main">
+            <a:off x="0" y="0"/>
+            <a:ext cx="12192000" cy="6858000"/>
+          </a:xfrm>
+          <a:prstGeom xmlns:a="http://schemas.openxmlformats.org/drawingml/2006/main" prst="rect">
+            <a:avLst/>
+          </a:prstGeom>
+          <a:solidFill xmlns:a="http://schemas.openxmlformats.org/drawingml/2006/main">
+            <a:srgbClr val="F7F5F0"/>
+          </a:solidFill>
+          <a:ln xmlns:a="http://schemas.openxmlformats.org/drawingml/2006/main" w="0">
+            <a:solidFill>
+              <a:srgbClr val="F7F5F0"/>
+            </a:solidFill>
+            <a:prstDash val="solid"/>
+          </a:ln>
+        </p:spPr>
+      </p:sp>
+      <p:sp>
+        <p:nvSpPr>
+          <p:cNvPr id="2" name="">
+            <a:extLst xmlns:a="http://schemas.openxmlformats.org/drawingml/2006/main">
+              <a:ext uri="{FF2B5EF4-FFF2-40B4-BE49-F238E27FC236}">
+                <a16:creationId xmlns:a16="http://schemas.microsoft.com/office/drawing/2014/main" id="{3203131A-D080-40EF-97A6-6A4C829BF732}"/>
+              </a:ext>
+            </a:extLst>
+          </p:cNvPr>
+          <p:cNvSpPr>
+            <a:spLocks xmlns:a="http://schemas.openxmlformats.org/drawingml/2006/main" noGrp="1"/>
+          </p:cNvSpPr>
+          <p:nvPr/>
+        </p:nvSpPr>
+        <p:spPr>
+          <a:xfrm xmlns:a="http://schemas.openxmlformats.org/drawingml/2006/main">
+            <a:off x="533400" y="400050"/>
+            <a:ext cx="123825" cy="123825"/>
+          </a:xfrm>
+          <a:prstGeom xmlns:a="http://schemas.openxmlformats.org/drawingml/2006/main" prst="rect">
+            <a:avLst/>
+          </a:prstGeom>
+          <a:solidFill xmlns:a="http://schemas.openxmlformats.org/drawingml/2006/main">
+            <a:srgbClr val="E76F51"/>
+          </a:solidFill>
+          <a:ln xmlns:a="http://schemas.openxmlformats.org/drawingml/2006/main" w="0">
+            <a:solidFill>
+              <a:srgbClr val="E76F51"/>
+            </a:solidFill>
+            <a:prstDash val="solid"/>
+          </a:ln>
+        </p:spPr>
+      </p:sp>
+      <p:sp>
+        <p:nvSpPr>
+          <p:cNvPr id="3" name="">
+            <a:extLst xmlns:a="http://schemas.openxmlformats.org/drawingml/2006/main">
+              <a:ext uri="{FF2B5EF4-FFF2-40B4-BE49-F238E27FC236}">
+                <a16:creationId xmlns:a16="http://schemas.microsoft.com/office/drawing/2014/main" id="{7512516E-37CD-40DE-B279-1490F2CDE4BD}"/>
+              </a:ext>
+            </a:extLst>
+          </p:cNvPr>
+          <p:cNvSpPr>
+            <a:spLocks xmlns:a="http://schemas.openxmlformats.org/drawingml/2006/main" noGrp="1"/>
+          </p:cNvSpPr>
+          <p:nvPr/>
+        </p:nvSpPr>
+        <p:spPr>
+          <a:xfrm xmlns:a="http://schemas.openxmlformats.org/drawingml/2006/main">
+            <a:off x="752475" y="371475"/>
+            <a:ext cx="4762500" cy="209550"/>
+          </a:xfrm>
+          <a:prstGeom xmlns:a="http://schemas.openxmlformats.org/drawingml/2006/main" prst="rect">
+            <a:avLst/>
+          </a:prstGeom>
+          <a:solidFill xmlns:a="http://schemas.openxmlformats.org/drawingml/2006/main">
+            <a:srgbClr val="000000">
+              <a:alpha val="0"/>
+            </a:srgbClr>
+          </a:solidFill>
+          <a:ln xmlns:a="http://schemas.openxmlformats.org/drawingml/2006/main" w="0">
+            <a:solidFill>
+              <a:srgbClr val="000000">
+                <a:alpha val="0"/>
+              </a:srgbClr>
+            </a:solidFill>
+            <a:prstDash val="solid"/>
+          </a:ln>
+        </p:spPr>
+        <p:txBody>
+          <a:bodyPr xmlns:a="http://schemas.openxmlformats.org/drawingml/2006/main" lIns="0" tIns="0" rIns="0" bIns="0" anchor="t"/>
+          <a:lstStyle xmlns:a="http://schemas.openxmlformats.org/drawingml/2006/main"/>
+          <a:p xmlns:a="http://schemas.openxmlformats.org/drawingml/2006/main">
+            <a:pPr algn="l">
+              <a:defRPr sz="1050" b="1">
+                <a:solidFill>
+                  <a:srgbClr val="0F766E"/>
+                </a:solidFill>
+                <a:latin typeface="Malgun Gothic"/>
+                <a:ea typeface="Malgun Gothic"/>
+                <a:cs typeface="Malgun Gothic"/>
+              </a:defRPr>
+            </a:pPr>
+            <a:r>
+              <a:rPr sz="1050" b="1">
+                <a:solidFill>
+                  <a:srgbClr val="0F766E"/>
+                </a:solidFill>
+                <a:latin typeface="Malgun Gothic"/>
+                <a:ea typeface="Malgun Gothic"/>
+                <a:cs typeface="Malgun Gothic"/>
+              </a:rPr>
+              <a:t>APPENDIX · WHAT IS A HARNESS?</a:t>
+            </a:r>
+          </a:p>
+        </p:txBody>
+      </p:sp>
+      <p:sp>
+        <p:nvSpPr>
+          <p:cNvPr id="4" name="">
+            <a:extLst xmlns:a="http://schemas.openxmlformats.org/drawingml/2006/main">
+              <a:ext uri="{FF2B5EF4-FFF2-40B4-BE49-F238E27FC236}">
+                <a16:creationId xmlns:a16="http://schemas.microsoft.com/office/drawing/2014/main" id="{FD010271-36D7-48A2-B28E-962D7A40D0AD}"/>
+              </a:ext>
+            </a:extLst>
+          </p:cNvPr>
+          <p:cNvSpPr>
+            <a:spLocks xmlns:a="http://schemas.openxmlformats.org/drawingml/2006/main" noGrp="1"/>
+          </p:cNvSpPr>
+          <p:nvPr/>
+        </p:nvSpPr>
+        <p:spPr>
+          <a:xfrm xmlns:a="http://schemas.openxmlformats.org/drawingml/2006/main">
+            <a:off x="11144250" y="400050"/>
+            <a:ext cx="514350" cy="190500"/>
+          </a:xfrm>
+          <a:prstGeom xmlns:a="http://schemas.openxmlformats.org/drawingml/2006/main" prst="rect">
+            <a:avLst/>
+          </a:prstGeom>
+          <a:solidFill xmlns:a="http://schemas.openxmlformats.org/drawingml/2006/main">
+            <a:srgbClr val="000000">
+              <a:alpha val="0"/>
+            </a:srgbClr>
+          </a:solidFill>
+          <a:ln xmlns:a="http://schemas.openxmlformats.org/drawingml/2006/main" w="0">
+            <a:solidFill>
+              <a:srgbClr val="000000">
+                <a:alpha val="0"/>
+              </a:srgbClr>
+            </a:solidFill>
+            <a:prstDash val="solid"/>
+          </a:ln>
+        </p:spPr>
+        <p:txBody>
+          <a:bodyPr xmlns:a="http://schemas.openxmlformats.org/drawingml/2006/main" lIns="0" tIns="0" rIns="0" bIns="0" anchor="t"/>
+          <a:lstStyle xmlns:a="http://schemas.openxmlformats.org/drawingml/2006/main"/>
+          <a:p xmlns:a="http://schemas.openxmlformats.org/drawingml/2006/main">
+            <a:pPr algn="r">
+              <a:defRPr sz="975" b="1">
+                <a:solidFill>
+                  <a:srgbClr val="60707A"/>
+                </a:solidFill>
+                <a:latin typeface="Aptos Display"/>
+                <a:ea typeface="Aptos Display"/>
+                <a:cs typeface="Aptos Display"/>
+              </a:defRPr>
+            </a:pPr>
+            <a:r>
+              <a:rPr sz="975" b="1">
+                <a:solidFill>
+                  <a:srgbClr val="60707A"/>
+                </a:solidFill>
+                <a:latin typeface="Aptos Display"/>
+                <a:ea typeface="Aptos Display"/>
+                <a:cs typeface="Aptos Display"/>
+              </a:rPr>
+              <a:t>04</a:t>
+            </a:r>
+          </a:p>
+        </p:txBody>
+      </p:sp>
+      <p:sp>
+        <p:nvSpPr>
+          <p:cNvPr id="5" name="">
+            <a:extLst xmlns:a="http://schemas.openxmlformats.org/drawingml/2006/main">
+              <a:ext uri="{FF2B5EF4-FFF2-40B4-BE49-F238E27FC236}">
+                <a16:creationId xmlns:a16="http://schemas.microsoft.com/office/drawing/2014/main" id="{3ADBA0C0-70DC-492C-A53A-8B53CB0DA37F}"/>
+              </a:ext>
+            </a:extLst>
+          </p:cNvPr>
+          <p:cNvSpPr>
+            <a:spLocks xmlns:a="http://schemas.openxmlformats.org/drawingml/2006/main" noGrp="1"/>
+          </p:cNvSpPr>
+          <p:nvPr/>
+        </p:nvSpPr>
+        <p:spPr>
+          <a:xfrm xmlns:a="http://schemas.openxmlformats.org/drawingml/2006/main">
+            <a:off x="533400" y="781050"/>
+            <a:ext cx="10668000" cy="857250"/>
+          </a:xfrm>
+          <a:prstGeom xmlns:a="http://schemas.openxmlformats.org/drawingml/2006/main" prst="rect">
+            <a:avLst/>
+          </a:prstGeom>
+          <a:solidFill xmlns:a="http://schemas.openxmlformats.org/drawingml/2006/main">
+            <a:srgbClr val="000000">
+              <a:alpha val="0"/>
+            </a:srgbClr>
+          </a:solidFill>
+          <a:ln xmlns:a="http://schemas.openxmlformats.org/drawingml/2006/main" w="0">
+            <a:solidFill>
+              <a:srgbClr val="000000">
+                <a:alpha val="0"/>
+              </a:srgbClr>
+            </a:solidFill>
+            <a:prstDash val="solid"/>
+          </a:ln>
+        </p:spPr>
+        <p:txBody>
+          <a:bodyPr xmlns:a="http://schemas.openxmlformats.org/drawingml/2006/main" lIns="0" tIns="0" rIns="0" bIns="0" anchor="t"/>
+          <a:lstStyle xmlns:a="http://schemas.openxmlformats.org/drawingml/2006/main"/>
+          <a:p xmlns:a="http://schemas.openxmlformats.org/drawingml/2006/main">
+            <a:pPr algn="l">
+              <a:defRPr sz="2850" b="1">
+                <a:solidFill>
+                  <a:srgbClr val="172026"/>
+                </a:solidFill>
+                <a:latin typeface="Malgun Gothic"/>
+                <a:ea typeface="Malgun Gothic"/>
+                <a:cs typeface="Malgun Gothic"/>
+              </a:defRPr>
+            </a:pPr>
+            <a:r>
+              <a:rPr sz="2850" b="1">
+                <a:solidFill>
+                  <a:srgbClr val="172026"/>
+                </a:solidFill>
+                <a:latin typeface="Malgun Gothic"/>
+                <a:ea typeface="Malgun Gothic"/>
+                <a:cs typeface="Malgun Gothic"/>
+              </a:rPr>
+              <a:t>Harness Engineering은 AI가 반복해서 일할 수 있는 실행 환경을 설계합니다.</a:t>
+            </a:r>
+          </a:p>
+        </p:txBody>
+      </p:sp>
+      <p:sp>
+        <p:nvSpPr>
+          <p:cNvPr id="6" name="">
+            <a:extLst xmlns:a="http://schemas.openxmlformats.org/drawingml/2006/main">
+              <a:ext uri="{FF2B5EF4-FFF2-40B4-BE49-F238E27FC236}">
+                <a16:creationId xmlns:a16="http://schemas.microsoft.com/office/drawing/2014/main" id="{0AD05E09-FD87-489D-84FA-DC5495B20D1A}"/>
+              </a:ext>
+            </a:extLst>
+          </p:cNvPr>
+          <p:cNvSpPr>
+            <a:spLocks xmlns:a="http://schemas.openxmlformats.org/drawingml/2006/main" noGrp="1"/>
+          </p:cNvSpPr>
+          <p:nvPr/>
+        </p:nvSpPr>
+        <p:spPr>
+          <a:xfrm xmlns:a="http://schemas.openxmlformats.org/drawingml/2006/main">
+            <a:off x="552450" y="1657350"/>
+            <a:ext cx="10477500" cy="400050"/>
+          </a:xfrm>
+          <a:prstGeom xmlns:a="http://schemas.openxmlformats.org/drawingml/2006/main" prst="rect">
+            <a:avLst/>
+          </a:prstGeom>
+          <a:solidFill xmlns:a="http://schemas.openxmlformats.org/drawingml/2006/main">
+            <a:srgbClr val="000000">
+              <a:alpha val="0"/>
+            </a:srgbClr>
+          </a:solidFill>
+          <a:ln xmlns:a="http://schemas.openxmlformats.org/drawingml/2006/main" w="0">
+            <a:solidFill>
+              <a:srgbClr val="000000">
+                <a:alpha val="0"/>
+              </a:srgbClr>
+            </a:solidFill>
+            <a:prstDash val="solid"/>
+          </a:ln>
+        </p:spPr>
+        <p:txBody>
+          <a:bodyPr xmlns:a="http://schemas.openxmlformats.org/drawingml/2006/main" lIns="0" tIns="0" rIns="0" bIns="0" anchor="t"/>
+          <a:lstStyle xmlns:a="http://schemas.openxmlformats.org/drawingml/2006/main"/>
+          <a:p xmlns:a="http://schemas.openxmlformats.org/drawingml/2006/main">
+            <a:pPr algn="l">
+              <a:defRPr sz="1350" b="0">
+                <a:solidFill>
+                  <a:srgbClr val="60707A"/>
+                </a:solidFill>
+                <a:latin typeface="Malgun Gothic"/>
+                <a:ea typeface="Malgun Gothic"/>
+                <a:cs typeface="Malgun Gothic"/>
+              </a:defRPr>
+            </a:pPr>
+            <a:r>
+              <a:rPr sz="1350" b="0">
+                <a:solidFill>
+                  <a:srgbClr val="60707A"/>
+                </a:solidFill>
+                <a:latin typeface="Malgun Gothic"/>
+                <a:ea typeface="Malgun Gothic"/>
+                <a:cs typeface="Malgun Gothic"/>
+              </a:rPr>
+              <a:t>Vibe Coding은 한 번의 요청을 잘 쓰는 것에서 시작해, 컨텍스트·실행 구조·역할 분담을 설계하는 방향으로 확장됩니다.</a:t>
+            </a:r>
+          </a:p>
+        </p:txBody>
+      </p:sp>
+      <p:sp>
+        <p:nvSpPr>
+          <p:cNvPr id="7" name="">
+            <a:extLst xmlns:a="http://schemas.openxmlformats.org/drawingml/2006/main">
+              <a:ext uri="{FF2B5EF4-FFF2-40B4-BE49-F238E27FC236}">
+                <a16:creationId xmlns:a16="http://schemas.microsoft.com/office/drawing/2014/main" id="{8C01B852-9AE3-40E2-AAC3-4BA3F806B653}"/>
+              </a:ext>
+            </a:extLst>
+          </p:cNvPr>
+          <p:cNvSpPr>
+            <a:spLocks xmlns:a="http://schemas.openxmlformats.org/drawingml/2006/main" noGrp="1"/>
+          </p:cNvSpPr>
+          <p:nvPr/>
+        </p:nvSpPr>
+        <p:spPr>
+          <a:xfrm xmlns:a="http://schemas.openxmlformats.org/drawingml/2006/main">
+            <a:off x="533400" y="2076450"/>
+            <a:ext cx="11125200" cy="628650"/>
+          </a:xfrm>
+          <a:prstGeom xmlns:a="http://schemas.openxmlformats.org/drawingml/2006/main" prst="roundRect">
+            <a:avLst>
+              <a:gd name="adj" fmla="val 12121"/>
+            </a:avLst>
+          </a:prstGeom>
+          <a:solidFill xmlns:a="http://schemas.openxmlformats.org/drawingml/2006/main">
+            <a:srgbClr val="153438"/>
+          </a:solidFill>
+          <a:ln xmlns:a="http://schemas.openxmlformats.org/drawingml/2006/main" w="0">
+            <a:solidFill>
+              <a:srgbClr val="153438"/>
+            </a:solidFill>
+            <a:prstDash val="solid"/>
+          </a:ln>
+        </p:spPr>
+      </p:sp>
+      <p:sp>
+        <p:nvSpPr>
+          <p:cNvPr id="8" name="">
+            <a:extLst xmlns:a="http://schemas.openxmlformats.org/drawingml/2006/main">
+              <a:ext uri="{FF2B5EF4-FFF2-40B4-BE49-F238E27FC236}">
+                <a16:creationId xmlns:a16="http://schemas.microsoft.com/office/drawing/2014/main" id="{8E421F7F-96F8-4737-AFE1-9ED9E9C29B86}"/>
+              </a:ext>
+            </a:extLst>
+          </p:cNvPr>
+          <p:cNvSpPr>
+            <a:spLocks xmlns:a="http://schemas.openxmlformats.org/drawingml/2006/main" noGrp="1"/>
+          </p:cNvSpPr>
+          <p:nvPr/>
+        </p:nvSpPr>
+        <p:spPr>
+          <a:xfrm xmlns:a="http://schemas.openxmlformats.org/drawingml/2006/main">
+            <a:off x="781050" y="2266950"/>
+            <a:ext cx="1257300" cy="228600"/>
+          </a:xfrm>
+          <a:prstGeom xmlns:a="http://schemas.openxmlformats.org/drawingml/2006/main" prst="rect">
+            <a:avLst/>
+          </a:prstGeom>
+          <a:solidFill xmlns:a="http://schemas.openxmlformats.org/drawingml/2006/main">
+            <a:srgbClr val="000000">
+              <a:alpha val="0"/>
+            </a:srgbClr>
+          </a:solidFill>
+          <a:ln xmlns:a="http://schemas.openxmlformats.org/drawingml/2006/main" w="0">
+            <a:solidFill>
+              <a:srgbClr val="000000">
+                <a:alpha val="0"/>
+              </a:srgbClr>
+            </a:solidFill>
+            <a:prstDash val="solid"/>
+          </a:ln>
+        </p:spPr>
+        <p:txBody>
+          <a:bodyPr xmlns:a="http://schemas.openxmlformats.org/drawingml/2006/main" lIns="0" tIns="0" rIns="0" bIns="0" anchor="t"/>
+          <a:lstStyle xmlns:a="http://schemas.openxmlformats.org/drawingml/2006/main"/>
+          <a:p xmlns:a="http://schemas.openxmlformats.org/drawingml/2006/main">
+            <a:pPr algn="l">
+              <a:defRPr sz="1500" b="1">
+                <a:solidFill>
+                  <a:srgbClr val="FFFFFF"/>
+                </a:solidFill>
+                <a:latin typeface="Malgun Gothic"/>
+                <a:ea typeface="Malgun Gothic"/>
+                <a:cs typeface="Malgun Gothic"/>
+              </a:defRPr>
+            </a:pPr>
+            <a:r>
+              <a:rPr sz="1500" b="1">
+                <a:solidFill>
+                  <a:srgbClr val="FFFFFF"/>
+                </a:solidFill>
+                <a:latin typeface="Malgun Gothic"/>
+                <a:ea typeface="Malgun Gothic"/>
+                <a:cs typeface="Malgun Gothic"/>
+              </a:rPr>
+              <a:t>Harness란?</a:t>
+            </a:r>
+          </a:p>
+        </p:txBody>
+      </p:sp>
+      <p:sp>
+        <p:nvSpPr>
+          <p:cNvPr id="9" name="">
+            <a:extLst xmlns:a="http://schemas.openxmlformats.org/drawingml/2006/main">
+              <a:ext uri="{FF2B5EF4-FFF2-40B4-BE49-F238E27FC236}">
+                <a16:creationId xmlns:a16="http://schemas.microsoft.com/office/drawing/2014/main" id="{85852918-9B9F-4624-BD02-36D36ECAB9AA}"/>
+              </a:ext>
+            </a:extLst>
+          </p:cNvPr>
+          <p:cNvSpPr>
+            <a:spLocks xmlns:a="http://schemas.openxmlformats.org/drawingml/2006/main" noGrp="1"/>
+          </p:cNvSpPr>
+          <p:nvPr/>
+        </p:nvSpPr>
+        <p:spPr>
+          <a:xfrm xmlns:a="http://schemas.openxmlformats.org/drawingml/2006/main">
+            <a:off x="2209800" y="2276475"/>
+            <a:ext cx="8896350" cy="228600"/>
+          </a:xfrm>
+          <a:prstGeom xmlns:a="http://schemas.openxmlformats.org/drawingml/2006/main" prst="rect">
+            <a:avLst/>
+          </a:prstGeom>
+          <a:solidFill xmlns:a="http://schemas.openxmlformats.org/drawingml/2006/main">
+            <a:srgbClr val="000000">
+              <a:alpha val="0"/>
+            </a:srgbClr>
+          </a:solidFill>
+          <a:ln xmlns:a="http://schemas.openxmlformats.org/drawingml/2006/main" w="0">
+            <a:solidFill>
+              <a:srgbClr val="000000">
+                <a:alpha val="0"/>
+              </a:srgbClr>
+            </a:solidFill>
+            <a:prstDash val="solid"/>
+          </a:ln>
+        </p:spPr>
+        <p:txBody>
+          <a:bodyPr xmlns:a="http://schemas.openxmlformats.org/drawingml/2006/main" lIns="0" tIns="0" rIns="0" bIns="0" anchor="t"/>
+          <a:lstStyle xmlns:a="http://schemas.openxmlformats.org/drawingml/2006/main"/>
+          <a:p xmlns:a="http://schemas.openxmlformats.org/drawingml/2006/main">
+            <a:pPr algn="l">
+              <a:defRPr sz="1350" b="1">
+                <a:solidFill>
+                  <a:srgbClr val="D8EFEC"/>
+                </a:solidFill>
+                <a:latin typeface="Malgun Gothic"/>
+                <a:ea typeface="Malgun Gothic"/>
+                <a:cs typeface="Malgun Gothic"/>
+              </a:defRPr>
+            </a:pPr>
+            <a:r>
+              <a:rPr sz="1350" b="1">
+                <a:solidFill>
+                  <a:srgbClr val="D8EFEC"/>
+                </a:solidFill>
+                <a:latin typeface="Malgun Gothic"/>
+                <a:ea typeface="Malgun Gothic"/>
+                <a:cs typeface="Malgun Gothic"/>
+              </a:rPr>
+              <a:t>여러 에이전트, 파일, 규칙, 도구, 자동 실행을 묶어 같은 품질의 작업을 반복 가능하게 만드는 운영 장치</a:t>
+            </a:r>
+          </a:p>
+        </p:txBody>
+      </p:sp>
+      <p:sp>
+        <p:nvSpPr>
+          <p:cNvPr id="10" name="">
+            <a:extLst xmlns:a="http://schemas.openxmlformats.org/drawingml/2006/main">
+              <a:ext uri="{FF2B5EF4-FFF2-40B4-BE49-F238E27FC236}">
+                <a16:creationId xmlns:a16="http://schemas.microsoft.com/office/drawing/2014/main" id="{26853634-A6B5-4073-B266-D79DCB644123}"/>
+              </a:ext>
+            </a:extLst>
+          </p:cNvPr>
+          <p:cNvSpPr>
+            <a:spLocks xmlns:a="http://schemas.openxmlformats.org/drawingml/2006/main" noGrp="1"/>
+          </p:cNvSpPr>
+          <p:nvPr/>
+        </p:nvSpPr>
+        <p:spPr>
+          <a:xfrm xmlns:a="http://schemas.openxmlformats.org/drawingml/2006/main">
+            <a:off x="666750" y="3028950"/>
+            <a:ext cx="1790700" cy="209550"/>
+          </a:xfrm>
+          <a:prstGeom xmlns:a="http://schemas.openxmlformats.org/drawingml/2006/main" prst="rect">
+            <a:avLst/>
+          </a:prstGeom>
+          <a:solidFill xmlns:a="http://schemas.openxmlformats.org/drawingml/2006/main">
+            <a:srgbClr val="000000">
+              <a:alpha val="0"/>
+            </a:srgbClr>
+          </a:solidFill>
+          <a:ln xmlns:a="http://schemas.openxmlformats.org/drawingml/2006/main" w="0">
+            <a:solidFill>
+              <a:srgbClr val="000000">
+                <a:alpha val="0"/>
+              </a:srgbClr>
+            </a:solidFill>
+            <a:prstDash val="solid"/>
+          </a:ln>
+        </p:spPr>
+        <p:txBody>
+          <a:bodyPr xmlns:a="http://schemas.openxmlformats.org/drawingml/2006/main" lIns="0" tIns="0" rIns="0" bIns="0" anchor="t"/>
+          <a:lstStyle xmlns:a="http://schemas.openxmlformats.org/drawingml/2006/main"/>
+          <a:p xmlns:a="http://schemas.openxmlformats.org/drawingml/2006/main">
+            <a:pPr algn="l">
+              <a:defRPr sz="1125" b="1">
+                <a:solidFill>
+                  <a:srgbClr val="0F766E"/>
+                </a:solidFill>
+                <a:latin typeface="Malgun Gothic"/>
+                <a:ea typeface="Malgun Gothic"/>
+                <a:cs typeface="Malgun Gothic"/>
+              </a:defRPr>
+            </a:pPr>
+            <a:r>
+              <a:rPr sz="1125" b="1">
+                <a:solidFill>
+                  <a:srgbClr val="0F766E"/>
+                </a:solidFill>
+                <a:latin typeface="Malgun Gothic"/>
+                <a:ea typeface="Malgun Gothic"/>
+                <a:cs typeface="Malgun Gothic"/>
+              </a:rPr>
+              <a:t>구분</a:t>
+            </a:r>
+          </a:p>
+        </p:txBody>
+      </p:sp>
+      <p:sp>
+        <p:nvSpPr>
+          <p:cNvPr id="11" name="">
+            <a:extLst xmlns:a="http://schemas.openxmlformats.org/drawingml/2006/main">
+              <a:ext uri="{FF2B5EF4-FFF2-40B4-BE49-F238E27FC236}">
+                <a16:creationId xmlns:a16="http://schemas.microsoft.com/office/drawing/2014/main" id="{11C7F028-F721-4280-A2A4-B938D787FFEA}"/>
+              </a:ext>
+            </a:extLst>
+          </p:cNvPr>
+          <p:cNvSpPr>
+            <a:spLocks xmlns:a="http://schemas.openxmlformats.org/drawingml/2006/main" noGrp="1"/>
+          </p:cNvSpPr>
+          <p:nvPr/>
+        </p:nvSpPr>
+        <p:spPr>
+          <a:xfrm xmlns:a="http://schemas.openxmlformats.org/drawingml/2006/main">
+            <a:off x="2571750" y="3028950"/>
+            <a:ext cx="2247900" cy="209550"/>
+          </a:xfrm>
+          <a:prstGeom xmlns:a="http://schemas.openxmlformats.org/drawingml/2006/main" prst="rect">
+            <a:avLst/>
+          </a:prstGeom>
+          <a:solidFill xmlns:a="http://schemas.openxmlformats.org/drawingml/2006/main">
+            <a:srgbClr val="000000">
+              <a:alpha val="0"/>
+            </a:srgbClr>
+          </a:solidFill>
+          <a:ln xmlns:a="http://schemas.openxmlformats.org/drawingml/2006/main" w="0">
+            <a:solidFill>
+              <a:srgbClr val="000000">
+                <a:alpha val="0"/>
+              </a:srgbClr>
+            </a:solidFill>
+            <a:prstDash val="solid"/>
+          </a:ln>
+        </p:spPr>
+        <p:txBody>
+          <a:bodyPr xmlns:a="http://schemas.openxmlformats.org/drawingml/2006/main" lIns="0" tIns="0" rIns="0" bIns="0" anchor="t"/>
+          <a:lstStyle xmlns:a="http://schemas.openxmlformats.org/drawingml/2006/main"/>
+          <a:p xmlns:a="http://schemas.openxmlformats.org/drawingml/2006/main">
+            <a:pPr algn="l">
+              <a:defRPr sz="1125" b="1">
+                <a:solidFill>
+                  <a:srgbClr val="0F766E"/>
+                </a:solidFill>
+                <a:latin typeface="Malgun Gothic"/>
+                <a:ea typeface="Malgun Gothic"/>
+                <a:cs typeface="Malgun Gothic"/>
+              </a:defRPr>
+            </a:pPr>
+            <a:r>
+              <a:rPr sz="1125" b="1">
+                <a:solidFill>
+                  <a:srgbClr val="0F766E"/>
+                </a:solidFill>
+                <a:latin typeface="Malgun Gothic"/>
+                <a:ea typeface="Malgun Gothic"/>
+                <a:cs typeface="Malgun Gothic"/>
+              </a:rPr>
+              <a:t>무엇을 설계하나</a:t>
+            </a:r>
+          </a:p>
+        </p:txBody>
+      </p:sp>
+      <p:sp>
+        <p:nvSpPr>
+          <p:cNvPr id="12" name="">
+            <a:extLst xmlns:a="http://schemas.openxmlformats.org/drawingml/2006/main">
+              <a:ext uri="{FF2B5EF4-FFF2-40B4-BE49-F238E27FC236}">
+                <a16:creationId xmlns:a16="http://schemas.microsoft.com/office/drawing/2014/main" id="{2277A91A-26F0-41BC-8470-F498292D4FFE}"/>
+              </a:ext>
+            </a:extLst>
+          </p:cNvPr>
+          <p:cNvSpPr>
+            <a:spLocks xmlns:a="http://schemas.openxmlformats.org/drawingml/2006/main" noGrp="1"/>
+          </p:cNvSpPr>
+          <p:nvPr/>
+        </p:nvSpPr>
+        <p:spPr>
+          <a:xfrm xmlns:a="http://schemas.openxmlformats.org/drawingml/2006/main">
+            <a:off x="4933950" y="3028950"/>
+            <a:ext cx="2457450" cy="209550"/>
+          </a:xfrm>
+          <a:prstGeom xmlns:a="http://schemas.openxmlformats.org/drawingml/2006/main" prst="rect">
+            <a:avLst/>
+          </a:prstGeom>
+          <a:solidFill xmlns:a="http://schemas.openxmlformats.org/drawingml/2006/main">
+            <a:srgbClr val="000000">
+              <a:alpha val="0"/>
+            </a:srgbClr>
+          </a:solidFill>
+          <a:ln xmlns:a="http://schemas.openxmlformats.org/drawingml/2006/main" w="0">
+            <a:solidFill>
+              <a:srgbClr val="000000">
+                <a:alpha val="0"/>
+              </a:srgbClr>
+            </a:solidFill>
+            <a:prstDash val="solid"/>
+          </a:ln>
+        </p:spPr>
+        <p:txBody>
+          <a:bodyPr xmlns:a="http://schemas.openxmlformats.org/drawingml/2006/main" lIns="0" tIns="0" rIns="0" bIns="0" anchor="t"/>
+          <a:lstStyle xmlns:a="http://schemas.openxmlformats.org/drawingml/2006/main"/>
+          <a:p xmlns:a="http://schemas.openxmlformats.org/drawingml/2006/main">
+            <a:pPr algn="l">
+              <a:defRPr sz="1125" b="1">
+                <a:solidFill>
+                  <a:srgbClr val="0F766E"/>
+                </a:solidFill>
+                <a:latin typeface="Malgun Gothic"/>
+                <a:ea typeface="Malgun Gothic"/>
+                <a:cs typeface="Malgun Gothic"/>
+              </a:defRPr>
+            </a:pPr>
+            <a:r>
+              <a:rPr sz="1125" b="1">
+                <a:solidFill>
+                  <a:srgbClr val="0F766E"/>
+                </a:solidFill>
+                <a:latin typeface="Malgun Gothic"/>
+                <a:ea typeface="Malgun Gothic"/>
+                <a:cs typeface="Malgun Gothic"/>
+              </a:rPr>
+              <a:t>핵심 질문</a:t>
+            </a:r>
+          </a:p>
+        </p:txBody>
+      </p:sp>
+      <p:sp>
+        <p:nvSpPr>
+          <p:cNvPr id="13" name="">
+            <a:extLst xmlns:a="http://schemas.openxmlformats.org/drawingml/2006/main">
+              <a:ext uri="{FF2B5EF4-FFF2-40B4-BE49-F238E27FC236}">
+                <a16:creationId xmlns:a16="http://schemas.microsoft.com/office/drawing/2014/main" id="{B528CECA-0342-4A26-AAC5-B73528FAF970}"/>
+              </a:ext>
+            </a:extLst>
+          </p:cNvPr>
+          <p:cNvSpPr>
+            <a:spLocks xmlns:a="http://schemas.openxmlformats.org/drawingml/2006/main" noGrp="1"/>
+          </p:cNvSpPr>
+          <p:nvPr/>
+        </p:nvSpPr>
+        <p:spPr>
+          <a:xfrm xmlns:a="http://schemas.openxmlformats.org/drawingml/2006/main">
+            <a:off x="7486650" y="3028950"/>
+            <a:ext cx="3886200" cy="209550"/>
+          </a:xfrm>
+          <a:prstGeom xmlns:a="http://schemas.openxmlformats.org/drawingml/2006/main" prst="rect">
+            <a:avLst/>
+          </a:prstGeom>
+          <a:solidFill xmlns:a="http://schemas.openxmlformats.org/drawingml/2006/main">
+            <a:srgbClr val="000000">
+              <a:alpha val="0"/>
+            </a:srgbClr>
+          </a:solidFill>
+          <a:ln xmlns:a="http://schemas.openxmlformats.org/drawingml/2006/main" w="0">
+            <a:solidFill>
+              <a:srgbClr val="000000">
+                <a:alpha val="0"/>
+              </a:srgbClr>
+            </a:solidFill>
+            <a:prstDash val="solid"/>
+          </a:ln>
+        </p:spPr>
+        <p:txBody>
+          <a:bodyPr xmlns:a="http://schemas.openxmlformats.org/drawingml/2006/main" lIns="0" tIns="0" rIns="0" bIns="0" anchor="t"/>
+          <a:lstStyle xmlns:a="http://schemas.openxmlformats.org/drawingml/2006/main"/>
+          <a:p xmlns:a="http://schemas.openxmlformats.org/drawingml/2006/main">
+            <a:pPr algn="l">
+              <a:defRPr sz="1125" b="1">
+                <a:solidFill>
+                  <a:srgbClr val="0F766E"/>
+                </a:solidFill>
+                <a:latin typeface="Malgun Gothic"/>
+                <a:ea typeface="Malgun Gothic"/>
+                <a:cs typeface="Malgun Gothic"/>
+              </a:defRPr>
+            </a:pPr>
+            <a:r>
+              <a:rPr sz="1125" b="1">
+                <a:solidFill>
+                  <a:srgbClr val="0F766E"/>
+                </a:solidFill>
+                <a:latin typeface="Malgun Gothic"/>
+                <a:ea typeface="Malgun Gothic"/>
+                <a:cs typeface="Malgun Gothic"/>
+              </a:rPr>
+              <a:t>HSKK 과제 예시</a:t>
+            </a:r>
+          </a:p>
+        </p:txBody>
+      </p:sp>
+      <p:sp>
+        <p:nvSpPr>
+          <p:cNvPr id="14" name="">
+            <a:extLst xmlns:a="http://schemas.openxmlformats.org/drawingml/2006/main">
+              <a:ext uri="{FF2B5EF4-FFF2-40B4-BE49-F238E27FC236}">
+                <a16:creationId xmlns:a16="http://schemas.microsoft.com/office/drawing/2014/main" id="{36F3389E-41F1-4E86-B155-A09878068E04}"/>
+              </a:ext>
+            </a:extLst>
+          </p:cNvPr>
+          <p:cNvSpPr>
+            <a:spLocks xmlns:a="http://schemas.openxmlformats.org/drawingml/2006/main" noGrp="1"/>
+          </p:cNvSpPr>
+          <p:nvPr/>
+        </p:nvSpPr>
+        <p:spPr>
+          <a:xfrm xmlns:a="http://schemas.openxmlformats.org/drawingml/2006/main">
+            <a:off x="533400" y="3238500"/>
+            <a:ext cx="11125200" cy="514350"/>
+          </a:xfrm>
+          <a:prstGeom xmlns:a="http://schemas.openxmlformats.org/drawingml/2006/main" prst="roundRect">
+            <a:avLst>
+              <a:gd name="adj" fmla="val 14815"/>
+            </a:avLst>
+          </a:prstGeom>
+          <a:solidFill xmlns:a="http://schemas.openxmlformats.org/drawingml/2006/main">
+            <a:srgbClr val="FFFFFF"/>
+          </a:solidFill>
+          <a:ln xmlns:a="http://schemas.openxmlformats.org/drawingml/2006/main" w="9525">
+            <a:solidFill>
+              <a:srgbClr val="C9D5D8"/>
+            </a:solidFill>
+            <a:prstDash val="solid"/>
+          </a:ln>
+        </p:spPr>
+      </p:sp>
+      <p:sp>
+        <p:nvSpPr>
+          <p:cNvPr id="15" name="">
+            <a:extLst xmlns:a="http://schemas.openxmlformats.org/drawingml/2006/main">
+              <a:ext uri="{FF2B5EF4-FFF2-40B4-BE49-F238E27FC236}">
+                <a16:creationId xmlns:a16="http://schemas.microsoft.com/office/drawing/2014/main" id="{39AC7A59-A88B-4166-905F-7D190C57C5B5}"/>
+              </a:ext>
+            </a:extLst>
+          </p:cNvPr>
+          <p:cNvSpPr>
+            <a:spLocks xmlns:a="http://schemas.openxmlformats.org/drawingml/2006/main" noGrp="1"/>
+          </p:cNvSpPr>
+          <p:nvPr/>
+        </p:nvSpPr>
+        <p:spPr>
+          <a:xfrm xmlns:a="http://schemas.openxmlformats.org/drawingml/2006/main">
+            <a:off x="666750" y="3381375"/>
+            <a:ext cx="1790700" cy="209550"/>
+          </a:xfrm>
+          <a:prstGeom xmlns:a="http://schemas.openxmlformats.org/drawingml/2006/main" prst="rect">
+            <a:avLst/>
+          </a:prstGeom>
+          <a:solidFill xmlns:a="http://schemas.openxmlformats.org/drawingml/2006/main">
+            <a:srgbClr val="000000">
+              <a:alpha val="0"/>
+            </a:srgbClr>
+          </a:solidFill>
+          <a:ln xmlns:a="http://schemas.openxmlformats.org/drawingml/2006/main" w="0">
+            <a:solidFill>
+              <a:srgbClr val="000000">
+                <a:alpha val="0"/>
+              </a:srgbClr>
+            </a:solidFill>
+            <a:prstDash val="solid"/>
+          </a:ln>
+        </p:spPr>
+        <p:txBody>
+          <a:bodyPr xmlns:a="http://schemas.openxmlformats.org/drawingml/2006/main" lIns="0" tIns="0" rIns="0" bIns="0" anchor="t"/>
+          <a:lstStyle xmlns:a="http://schemas.openxmlformats.org/drawingml/2006/main"/>
+          <a:p xmlns:a="http://schemas.openxmlformats.org/drawingml/2006/main">
+            <a:pPr algn="l">
+              <a:defRPr sz="1200" b="1">
+                <a:solidFill>
+                  <a:srgbClr val="172026"/>
+                </a:solidFill>
+                <a:latin typeface="Malgun Gothic"/>
+                <a:ea typeface="Malgun Gothic"/>
+                <a:cs typeface="Malgun Gothic"/>
+              </a:defRPr>
+            </a:pPr>
+            <a:r>
+              <a:rPr sz="1200" b="1">
+                <a:solidFill>
+                  <a:srgbClr val="172026"/>
+                </a:solidFill>
+                <a:latin typeface="Malgun Gothic"/>
+                <a:ea typeface="Malgun Gothic"/>
+                <a:cs typeface="Malgun Gothic"/>
+              </a:rPr>
+              <a:t>Prompt Engineering</a:t>
+            </a:r>
+          </a:p>
+        </p:txBody>
+      </p:sp>
+      <p:sp>
+        <p:nvSpPr>
+          <p:cNvPr id="16" name="">
+            <a:extLst xmlns:a="http://schemas.openxmlformats.org/drawingml/2006/main">
+              <a:ext uri="{FF2B5EF4-FFF2-40B4-BE49-F238E27FC236}">
+                <a16:creationId xmlns:a16="http://schemas.microsoft.com/office/drawing/2014/main" id="{017FFCBA-1E2A-4DB2-90AB-F99E4533FF4B}"/>
+              </a:ext>
+            </a:extLst>
+          </p:cNvPr>
+          <p:cNvSpPr>
+            <a:spLocks xmlns:a="http://schemas.openxmlformats.org/drawingml/2006/main" noGrp="1"/>
+          </p:cNvSpPr>
+          <p:nvPr/>
+        </p:nvSpPr>
+        <p:spPr>
+          <a:xfrm xmlns:a="http://schemas.openxmlformats.org/drawingml/2006/main">
+            <a:off x="2571750" y="3381375"/>
+            <a:ext cx="2247900" cy="209550"/>
+          </a:xfrm>
+          <a:prstGeom xmlns:a="http://schemas.openxmlformats.org/drawingml/2006/main" prst="rect">
+            <a:avLst/>
+          </a:prstGeom>
+          <a:solidFill xmlns:a="http://schemas.openxmlformats.org/drawingml/2006/main">
+            <a:srgbClr val="000000">
+              <a:alpha val="0"/>
+            </a:srgbClr>
+          </a:solidFill>
+          <a:ln xmlns:a="http://schemas.openxmlformats.org/drawingml/2006/main" w="0">
+            <a:solidFill>
+              <a:srgbClr val="000000">
+                <a:alpha val="0"/>
+              </a:srgbClr>
+            </a:solidFill>
+            <a:prstDash val="solid"/>
+          </a:ln>
+        </p:spPr>
+        <p:txBody>
+          <a:bodyPr xmlns:a="http://schemas.openxmlformats.org/drawingml/2006/main" lIns="0" tIns="0" rIns="0" bIns="0" anchor="t"/>
+          <a:lstStyle xmlns:a="http://schemas.openxmlformats.org/drawingml/2006/main"/>
+          <a:p xmlns:a="http://schemas.openxmlformats.org/drawingml/2006/main">
+            <a:pPr algn="l">
+              <a:defRPr sz="1125" b="0">
+                <a:solidFill>
+                  <a:srgbClr val="172026"/>
+                </a:solidFill>
+                <a:latin typeface="Malgun Gothic"/>
+                <a:ea typeface="Malgun Gothic"/>
+                <a:cs typeface="Malgun Gothic"/>
+              </a:defRPr>
+            </a:pPr>
+            <a:r>
+              <a:rPr sz="1125" b="0">
+                <a:solidFill>
+                  <a:srgbClr val="172026"/>
+                </a:solidFill>
+                <a:latin typeface="Malgun Gothic"/>
+                <a:ea typeface="Malgun Gothic"/>
+                <a:cs typeface="Malgun Gothic"/>
+              </a:rPr>
+              <a:t>AI에게 주는 요청문</a:t>
+            </a:r>
+          </a:p>
+        </p:txBody>
+      </p:sp>
+      <p:sp>
+        <p:nvSpPr>
+          <p:cNvPr id="17" name="">
+            <a:extLst xmlns:a="http://schemas.openxmlformats.org/drawingml/2006/main">
+              <a:ext uri="{FF2B5EF4-FFF2-40B4-BE49-F238E27FC236}">
+                <a16:creationId xmlns:a16="http://schemas.microsoft.com/office/drawing/2014/main" id="{8419918E-52DD-4317-8E62-2C8B923B99A0}"/>
+              </a:ext>
+            </a:extLst>
+          </p:cNvPr>
+          <p:cNvSpPr>
+            <a:spLocks xmlns:a="http://schemas.openxmlformats.org/drawingml/2006/main" noGrp="1"/>
+          </p:cNvSpPr>
+          <p:nvPr/>
+        </p:nvSpPr>
+        <p:spPr>
+          <a:xfrm xmlns:a="http://schemas.openxmlformats.org/drawingml/2006/main">
+            <a:off x="4933950" y="3381375"/>
+            <a:ext cx="2457450" cy="209550"/>
+          </a:xfrm>
+          <a:prstGeom xmlns:a="http://schemas.openxmlformats.org/drawingml/2006/main" prst="rect">
+            <a:avLst/>
+          </a:prstGeom>
+          <a:solidFill xmlns:a="http://schemas.openxmlformats.org/drawingml/2006/main">
+            <a:srgbClr val="000000">
+              <a:alpha val="0"/>
+            </a:srgbClr>
+          </a:solidFill>
+          <a:ln xmlns:a="http://schemas.openxmlformats.org/drawingml/2006/main" w="0">
+            <a:solidFill>
+              <a:srgbClr val="000000">
+                <a:alpha val="0"/>
+              </a:srgbClr>
+            </a:solidFill>
+            <a:prstDash val="solid"/>
+          </a:ln>
+        </p:spPr>
+        <p:txBody>
+          <a:bodyPr xmlns:a="http://schemas.openxmlformats.org/drawingml/2006/main" lIns="0" tIns="0" rIns="0" bIns="0" anchor="t"/>
+          <a:lstStyle xmlns:a="http://schemas.openxmlformats.org/drawingml/2006/main"/>
+          <a:p xmlns:a="http://schemas.openxmlformats.org/drawingml/2006/main">
+            <a:pPr algn="l">
+              <a:defRPr sz="1125" b="0">
+                <a:solidFill>
+                  <a:srgbClr val="172026"/>
+                </a:solidFill>
+                <a:latin typeface="Malgun Gothic"/>
+                <a:ea typeface="Malgun Gothic"/>
+                <a:cs typeface="Malgun Gothic"/>
+              </a:defRPr>
+            </a:pPr>
+            <a:r>
+              <a:rPr sz="1125" b="0">
+                <a:solidFill>
+                  <a:srgbClr val="172026"/>
+                </a:solidFill>
+                <a:latin typeface="Malgun Gothic"/>
+                <a:ea typeface="Malgun Gothic"/>
+                <a:cs typeface="Malgun Gothic"/>
+              </a:rPr>
+              <a:t>무엇을 만들어 달라고 할까?</a:t>
+            </a:r>
+          </a:p>
+        </p:txBody>
+      </p:sp>
+      <p:sp>
+        <p:nvSpPr>
+          <p:cNvPr id="18" name="">
+            <a:extLst xmlns:a="http://schemas.openxmlformats.org/drawingml/2006/main">
+              <a:ext uri="{FF2B5EF4-FFF2-40B4-BE49-F238E27FC236}">
+                <a16:creationId xmlns:a16="http://schemas.microsoft.com/office/drawing/2014/main" id="{ED844165-AB7A-4D61-8EFC-E6AD2D8DFAF7}"/>
+              </a:ext>
+            </a:extLst>
+          </p:cNvPr>
+          <p:cNvSpPr>
+            <a:spLocks xmlns:a="http://schemas.openxmlformats.org/drawingml/2006/main" noGrp="1"/>
+          </p:cNvSpPr>
+          <p:nvPr/>
+        </p:nvSpPr>
+        <p:spPr>
+          <a:xfrm xmlns:a="http://schemas.openxmlformats.org/drawingml/2006/main">
+            <a:off x="7486650" y="3352800"/>
+            <a:ext cx="3886200" cy="285750"/>
+          </a:xfrm>
+          <a:prstGeom xmlns:a="http://schemas.openxmlformats.org/drawingml/2006/main" prst="rect">
+            <a:avLst/>
+          </a:prstGeom>
+          <a:solidFill xmlns:a="http://schemas.openxmlformats.org/drawingml/2006/main">
+            <a:srgbClr val="000000">
+              <a:alpha val="0"/>
+            </a:srgbClr>
+          </a:solidFill>
+          <a:ln xmlns:a="http://schemas.openxmlformats.org/drawingml/2006/main" w="0">
+            <a:solidFill>
+              <a:srgbClr val="000000">
+                <a:alpha val="0"/>
+              </a:srgbClr>
+            </a:solidFill>
+            <a:prstDash val="solid"/>
+          </a:ln>
+        </p:spPr>
+        <p:txBody>
+          <a:bodyPr xmlns:a="http://schemas.openxmlformats.org/drawingml/2006/main" lIns="0" tIns="0" rIns="0" bIns="0" anchor="t"/>
+          <a:lstStyle xmlns:a="http://schemas.openxmlformats.org/drawingml/2006/main"/>
+          <a:p xmlns:a="http://schemas.openxmlformats.org/drawingml/2006/main">
+            <a:pPr algn="l">
+              <a:defRPr sz="1050" b="0">
+                <a:solidFill>
+                  <a:srgbClr val="60707A"/>
+                </a:solidFill>
+                <a:latin typeface="Malgun Gothic"/>
+                <a:ea typeface="Malgun Gothic"/>
+                <a:cs typeface="Malgun Gothic"/>
+              </a:defRPr>
+            </a:pPr>
+            <a:r>
+              <a:rPr sz="1050" b="0">
+                <a:solidFill>
+                  <a:srgbClr val="60707A"/>
+                </a:solidFill>
+                <a:latin typeface="Malgun Gothic"/>
+                <a:ea typeface="Malgun Gothic"/>
+                <a:cs typeface="Malgun Gothic"/>
+              </a:rPr>
+              <a:t>'초/중급 HSKK 문장을 병음과 뜻을 포함해 생성해줘'</a:t>
+            </a:r>
+          </a:p>
+        </p:txBody>
+      </p:sp>
+      <p:sp>
+        <p:nvSpPr>
+          <p:cNvPr id="19" name="">
+            <a:extLst xmlns:a="http://schemas.openxmlformats.org/drawingml/2006/main">
+              <a:ext uri="{FF2B5EF4-FFF2-40B4-BE49-F238E27FC236}">
+                <a16:creationId xmlns:a16="http://schemas.microsoft.com/office/drawing/2014/main" id="{98B5B0D9-FF71-4DC8-828A-CE527705220E}"/>
+              </a:ext>
+            </a:extLst>
+          </p:cNvPr>
+          <p:cNvSpPr>
+            <a:spLocks xmlns:a="http://schemas.openxmlformats.org/drawingml/2006/main" noGrp="1"/>
+          </p:cNvSpPr>
+          <p:nvPr/>
+        </p:nvSpPr>
+        <p:spPr>
+          <a:xfrm xmlns:a="http://schemas.openxmlformats.org/drawingml/2006/main">
+            <a:off x="533400" y="3771900"/>
+            <a:ext cx="11125200" cy="514350"/>
+          </a:xfrm>
+          <a:prstGeom xmlns:a="http://schemas.openxmlformats.org/drawingml/2006/main" prst="roundRect">
+            <a:avLst>
+              <a:gd name="adj" fmla="val 14815"/>
+            </a:avLst>
+          </a:prstGeom>
+          <a:solidFill xmlns:a="http://schemas.openxmlformats.org/drawingml/2006/main">
+            <a:srgbClr val="FFFFFF"/>
+          </a:solidFill>
+          <a:ln xmlns:a="http://schemas.openxmlformats.org/drawingml/2006/main" w="9525">
+            <a:solidFill>
+              <a:srgbClr val="C9D5D8"/>
+            </a:solidFill>
+            <a:prstDash val="solid"/>
+          </a:ln>
+        </p:spPr>
+      </p:sp>
+      <p:sp>
+        <p:nvSpPr>
+          <p:cNvPr id="20" name="">
+            <a:extLst xmlns:a="http://schemas.openxmlformats.org/drawingml/2006/main">
+              <a:ext uri="{FF2B5EF4-FFF2-40B4-BE49-F238E27FC236}">
+                <a16:creationId xmlns:a16="http://schemas.microsoft.com/office/drawing/2014/main" id="{1DCE5B45-4942-449A-9B00-29DB7D13B88A}"/>
+              </a:ext>
+            </a:extLst>
+          </p:cNvPr>
+          <p:cNvSpPr>
+            <a:spLocks xmlns:a="http://schemas.openxmlformats.org/drawingml/2006/main" noGrp="1"/>
+          </p:cNvSpPr>
+          <p:nvPr/>
+        </p:nvSpPr>
+        <p:spPr>
+          <a:xfrm xmlns:a="http://schemas.openxmlformats.org/drawingml/2006/main">
+            <a:off x="666750" y="3914775"/>
+            <a:ext cx="1790700" cy="209550"/>
+          </a:xfrm>
+          <a:prstGeom xmlns:a="http://schemas.openxmlformats.org/drawingml/2006/main" prst="rect">
+            <a:avLst/>
+          </a:prstGeom>
+          <a:solidFill xmlns:a="http://schemas.openxmlformats.org/drawingml/2006/main">
+            <a:srgbClr val="000000">
+              <a:alpha val="0"/>
+            </a:srgbClr>
+          </a:solidFill>
+          <a:ln xmlns:a="http://schemas.openxmlformats.org/drawingml/2006/main" w="0">
+            <a:solidFill>
+              <a:srgbClr val="000000">
+                <a:alpha val="0"/>
+              </a:srgbClr>
+            </a:solidFill>
+            <a:prstDash val="solid"/>
+          </a:ln>
+        </p:spPr>
+        <p:txBody>
+          <a:bodyPr xmlns:a="http://schemas.openxmlformats.org/drawingml/2006/main" lIns="0" tIns="0" rIns="0" bIns="0" anchor="t"/>
+          <a:lstStyle xmlns:a="http://schemas.openxmlformats.org/drawingml/2006/main"/>
+          <a:p xmlns:a="http://schemas.openxmlformats.org/drawingml/2006/main">
+            <a:pPr algn="l">
+              <a:defRPr sz="1200" b="1">
+                <a:solidFill>
+                  <a:srgbClr val="172026"/>
+                </a:solidFill>
+                <a:latin typeface="Malgun Gothic"/>
+                <a:ea typeface="Malgun Gothic"/>
+                <a:cs typeface="Malgun Gothic"/>
+              </a:defRPr>
+            </a:pPr>
+            <a:r>
+              <a:rPr sz="1200" b="1">
+                <a:solidFill>
+                  <a:srgbClr val="172026"/>
+                </a:solidFill>
+                <a:latin typeface="Malgun Gothic"/>
+                <a:ea typeface="Malgun Gothic"/>
+                <a:cs typeface="Malgun Gothic"/>
+              </a:rPr>
+              <a:t>Context Engineering</a:t>
+            </a:r>
+          </a:p>
+        </p:txBody>
+      </p:sp>
+      <p:sp>
+        <p:nvSpPr>
+          <p:cNvPr id="21" name="">
+            <a:extLst xmlns:a="http://schemas.openxmlformats.org/drawingml/2006/main">
+              <a:ext uri="{FF2B5EF4-FFF2-40B4-BE49-F238E27FC236}">
+                <a16:creationId xmlns:a16="http://schemas.microsoft.com/office/drawing/2014/main" id="{9158CCB0-9E2F-4A14-B469-6377393E9D11}"/>
+              </a:ext>
+            </a:extLst>
+          </p:cNvPr>
+          <p:cNvSpPr>
+            <a:spLocks xmlns:a="http://schemas.openxmlformats.org/drawingml/2006/main" noGrp="1"/>
+          </p:cNvSpPr>
+          <p:nvPr/>
+        </p:nvSpPr>
+        <p:spPr>
+          <a:xfrm xmlns:a="http://schemas.openxmlformats.org/drawingml/2006/main">
+            <a:off x="2571750" y="3914775"/>
+            <a:ext cx="2247900" cy="209550"/>
+          </a:xfrm>
+          <a:prstGeom xmlns:a="http://schemas.openxmlformats.org/drawingml/2006/main" prst="rect">
+            <a:avLst/>
+          </a:prstGeom>
+          <a:solidFill xmlns:a="http://schemas.openxmlformats.org/drawingml/2006/main">
+            <a:srgbClr val="000000">
+              <a:alpha val="0"/>
+            </a:srgbClr>
+          </a:solidFill>
+          <a:ln xmlns:a="http://schemas.openxmlformats.org/drawingml/2006/main" w="0">
+            <a:solidFill>
+              <a:srgbClr val="000000">
+                <a:alpha val="0"/>
+              </a:srgbClr>
+            </a:solidFill>
+            <a:prstDash val="solid"/>
+          </a:ln>
+        </p:spPr>
+        <p:txBody>
+          <a:bodyPr xmlns:a="http://schemas.openxmlformats.org/drawingml/2006/main" lIns="0" tIns="0" rIns="0" bIns="0" anchor="t"/>
+          <a:lstStyle xmlns:a="http://schemas.openxmlformats.org/drawingml/2006/main"/>
+          <a:p xmlns:a="http://schemas.openxmlformats.org/drawingml/2006/main">
+            <a:pPr algn="l">
+              <a:defRPr sz="1125" b="0">
+                <a:solidFill>
+                  <a:srgbClr val="172026"/>
+                </a:solidFill>
+                <a:latin typeface="Malgun Gothic"/>
+                <a:ea typeface="Malgun Gothic"/>
+                <a:cs typeface="Malgun Gothic"/>
+              </a:defRPr>
+            </a:pPr>
+            <a:r>
+              <a:rPr sz="1125" b="0">
+                <a:solidFill>
+                  <a:srgbClr val="172026"/>
+                </a:solidFill>
+                <a:latin typeface="Malgun Gothic"/>
+                <a:ea typeface="Malgun Gothic"/>
+                <a:cs typeface="Malgun Gothic"/>
+              </a:rPr>
+              <a:t>AI가 참고할 정보</a:t>
+            </a:r>
+          </a:p>
+        </p:txBody>
+      </p:sp>
+      <p:sp>
+        <p:nvSpPr>
+          <p:cNvPr id="22" name="">
+            <a:extLst xmlns:a="http://schemas.openxmlformats.org/drawingml/2006/main">
+              <a:ext uri="{FF2B5EF4-FFF2-40B4-BE49-F238E27FC236}">
+                <a16:creationId xmlns:a16="http://schemas.microsoft.com/office/drawing/2014/main" id="{6D8449F5-7FC3-46A3-898B-8971D837A42D}"/>
+              </a:ext>
+            </a:extLst>
+          </p:cNvPr>
+          <p:cNvSpPr>
+            <a:spLocks xmlns:a="http://schemas.openxmlformats.org/drawingml/2006/main" noGrp="1"/>
+          </p:cNvSpPr>
+          <p:nvPr/>
+        </p:nvSpPr>
+        <p:spPr>
+          <a:xfrm xmlns:a="http://schemas.openxmlformats.org/drawingml/2006/main">
+            <a:off x="4933950" y="3914775"/>
+            <a:ext cx="2457450" cy="209550"/>
+          </a:xfrm>
+          <a:prstGeom xmlns:a="http://schemas.openxmlformats.org/drawingml/2006/main" prst="rect">
+            <a:avLst/>
+          </a:prstGeom>
+          <a:solidFill xmlns:a="http://schemas.openxmlformats.org/drawingml/2006/main">
+            <a:srgbClr val="000000">
+              <a:alpha val="0"/>
+            </a:srgbClr>
+          </a:solidFill>
+          <a:ln xmlns:a="http://schemas.openxmlformats.org/drawingml/2006/main" w="0">
+            <a:solidFill>
+              <a:srgbClr val="000000">
+                <a:alpha val="0"/>
+              </a:srgbClr>
+            </a:solidFill>
+            <a:prstDash val="solid"/>
+          </a:ln>
+        </p:spPr>
+        <p:txBody>
+          <a:bodyPr xmlns:a="http://schemas.openxmlformats.org/drawingml/2006/main" lIns="0" tIns="0" rIns="0" bIns="0" anchor="t"/>
+          <a:lstStyle xmlns:a="http://schemas.openxmlformats.org/drawingml/2006/main"/>
+          <a:p xmlns:a="http://schemas.openxmlformats.org/drawingml/2006/main">
+            <a:pPr algn="l">
+              <a:defRPr sz="1125" b="0">
+                <a:solidFill>
+                  <a:srgbClr val="172026"/>
+                </a:solidFill>
+                <a:latin typeface="Malgun Gothic"/>
+                <a:ea typeface="Malgun Gothic"/>
+                <a:cs typeface="Malgun Gothic"/>
+              </a:defRPr>
+            </a:pPr>
+            <a:r>
+              <a:rPr sz="1125" b="0">
+                <a:solidFill>
+                  <a:srgbClr val="172026"/>
+                </a:solidFill>
+                <a:latin typeface="Malgun Gothic"/>
+                <a:ea typeface="Malgun Gothic"/>
+                <a:cs typeface="Malgun Gothic"/>
+              </a:rPr>
+              <a:t>무엇을 알고 작업해야 할까?</a:t>
+            </a:r>
+          </a:p>
+        </p:txBody>
+      </p:sp>
+      <p:sp>
+        <p:nvSpPr>
+          <p:cNvPr id="23" name="">
+            <a:extLst xmlns:a="http://schemas.openxmlformats.org/drawingml/2006/main">
+              <a:ext uri="{FF2B5EF4-FFF2-40B4-BE49-F238E27FC236}">
+                <a16:creationId xmlns:a16="http://schemas.microsoft.com/office/drawing/2014/main" id="{AA737B0A-64E8-403E-B180-051D1AB28E6E}"/>
+              </a:ext>
+            </a:extLst>
+          </p:cNvPr>
+          <p:cNvSpPr>
+            <a:spLocks xmlns:a="http://schemas.openxmlformats.org/drawingml/2006/main" noGrp="1"/>
+          </p:cNvSpPr>
+          <p:nvPr/>
+        </p:nvSpPr>
+        <p:spPr>
+          <a:xfrm xmlns:a="http://schemas.openxmlformats.org/drawingml/2006/main">
+            <a:off x="7486650" y="3886200"/>
+            <a:ext cx="3886200" cy="285750"/>
+          </a:xfrm>
+          <a:prstGeom xmlns:a="http://schemas.openxmlformats.org/drawingml/2006/main" prst="rect">
+            <a:avLst/>
+          </a:prstGeom>
+          <a:solidFill xmlns:a="http://schemas.openxmlformats.org/drawingml/2006/main">
+            <a:srgbClr val="000000">
+              <a:alpha val="0"/>
+            </a:srgbClr>
+          </a:solidFill>
+          <a:ln xmlns:a="http://schemas.openxmlformats.org/drawingml/2006/main" w="0">
+            <a:solidFill>
+              <a:srgbClr val="000000">
+                <a:alpha val="0"/>
+              </a:srgbClr>
+            </a:solidFill>
+            <a:prstDash val="solid"/>
+          </a:ln>
+        </p:spPr>
+        <p:txBody>
+          <a:bodyPr xmlns:a="http://schemas.openxmlformats.org/drawingml/2006/main" lIns="0" tIns="0" rIns="0" bIns="0" anchor="t"/>
+          <a:lstStyle xmlns:a="http://schemas.openxmlformats.org/drawingml/2006/main"/>
+          <a:p xmlns:a="http://schemas.openxmlformats.org/drawingml/2006/main">
+            <a:pPr algn="l">
+              <a:defRPr sz="1050" b="0">
+                <a:solidFill>
+                  <a:srgbClr val="60707A"/>
+                </a:solidFill>
+                <a:latin typeface="Malgun Gothic"/>
+                <a:ea typeface="Malgun Gothic"/>
+                <a:cs typeface="Malgun Gothic"/>
+              </a:defRPr>
+            </a:pPr>
+            <a:r>
+              <a:rPr sz="1050" b="0">
+                <a:solidFill>
+                  <a:srgbClr val="60707A"/>
+                </a:solidFill>
+                <a:latin typeface="Malgun Gothic"/>
+                <a:ea typeface="Malgun Gothic"/>
+                <a:cs typeface="Malgun Gothic"/>
+              </a:rPr>
+              <a:t>시험 형식, 학습 수준, 복습 이력, 오답 메모를 제공</a:t>
+            </a:r>
+          </a:p>
+        </p:txBody>
+      </p:sp>
+      <p:sp>
+        <p:nvSpPr>
+          <p:cNvPr id="24" name="">
+            <a:extLst xmlns:a="http://schemas.openxmlformats.org/drawingml/2006/main">
+              <a:ext uri="{FF2B5EF4-FFF2-40B4-BE49-F238E27FC236}">
+                <a16:creationId xmlns:a16="http://schemas.microsoft.com/office/drawing/2014/main" id="{E9FED231-C741-4A0F-913E-B59EA1E78960}"/>
+              </a:ext>
+            </a:extLst>
+          </p:cNvPr>
+          <p:cNvSpPr>
+            <a:spLocks xmlns:a="http://schemas.openxmlformats.org/drawingml/2006/main" noGrp="1"/>
+          </p:cNvSpPr>
+          <p:nvPr/>
+        </p:nvSpPr>
+        <p:spPr>
+          <a:xfrm xmlns:a="http://schemas.openxmlformats.org/drawingml/2006/main">
+            <a:off x="533400" y="4305300"/>
+            <a:ext cx="11125200" cy="514350"/>
+          </a:xfrm>
+          <a:prstGeom xmlns:a="http://schemas.openxmlformats.org/drawingml/2006/main" prst="roundRect">
+            <a:avLst>
+              <a:gd name="adj" fmla="val 14815"/>
+            </a:avLst>
+          </a:prstGeom>
+          <a:solidFill xmlns:a="http://schemas.openxmlformats.org/drawingml/2006/main">
+            <a:srgbClr val="DFEFEC"/>
+          </a:solidFill>
+          <a:ln xmlns:a="http://schemas.openxmlformats.org/drawingml/2006/main" w="9525">
+            <a:solidFill>
+              <a:srgbClr val="0F766E"/>
+            </a:solidFill>
+            <a:prstDash val="solid"/>
+          </a:ln>
+        </p:spPr>
+      </p:sp>
+      <p:sp>
+        <p:nvSpPr>
+          <p:cNvPr id="25" name="">
+            <a:extLst xmlns:a="http://schemas.openxmlformats.org/drawingml/2006/main">
+              <a:ext uri="{FF2B5EF4-FFF2-40B4-BE49-F238E27FC236}">
+                <a16:creationId xmlns:a16="http://schemas.microsoft.com/office/drawing/2014/main" id="{7BD3818B-34B9-4834-BBBF-491D3A19BE40}"/>
+              </a:ext>
+            </a:extLst>
+          </p:cNvPr>
+          <p:cNvSpPr>
+            <a:spLocks xmlns:a="http://schemas.openxmlformats.org/drawingml/2006/main" noGrp="1"/>
+          </p:cNvSpPr>
+          <p:nvPr/>
+        </p:nvSpPr>
+        <p:spPr>
+          <a:xfrm xmlns:a="http://schemas.openxmlformats.org/drawingml/2006/main">
+            <a:off x="666750" y="4448175"/>
+            <a:ext cx="1790700" cy="209550"/>
+          </a:xfrm>
+          <a:prstGeom xmlns:a="http://schemas.openxmlformats.org/drawingml/2006/main" prst="rect">
+            <a:avLst/>
+          </a:prstGeom>
+          <a:solidFill xmlns:a="http://schemas.openxmlformats.org/drawingml/2006/main">
+            <a:srgbClr val="000000">
+              <a:alpha val="0"/>
+            </a:srgbClr>
+          </a:solidFill>
+          <a:ln xmlns:a="http://schemas.openxmlformats.org/drawingml/2006/main" w="0">
+            <a:solidFill>
+              <a:srgbClr val="000000">
+                <a:alpha val="0"/>
+              </a:srgbClr>
+            </a:solidFill>
+            <a:prstDash val="solid"/>
+          </a:ln>
+        </p:spPr>
+        <p:txBody>
+          <a:bodyPr xmlns:a="http://schemas.openxmlformats.org/drawingml/2006/main" lIns="0" tIns="0" rIns="0" bIns="0" anchor="t"/>
+          <a:lstStyle xmlns:a="http://schemas.openxmlformats.org/drawingml/2006/main"/>
+          <a:p xmlns:a="http://schemas.openxmlformats.org/drawingml/2006/main">
+            <a:pPr algn="l">
+              <a:defRPr sz="1200" b="1">
+                <a:solidFill>
+                  <a:srgbClr val="0F766E"/>
+                </a:solidFill>
+                <a:latin typeface="Malgun Gothic"/>
+                <a:ea typeface="Malgun Gothic"/>
+                <a:cs typeface="Malgun Gothic"/>
+              </a:defRPr>
+            </a:pPr>
+            <a:r>
+              <a:rPr sz="1200" b="1">
+                <a:solidFill>
+                  <a:srgbClr val="0F766E"/>
+                </a:solidFill>
+                <a:latin typeface="Malgun Gothic"/>
+                <a:ea typeface="Malgun Gothic"/>
+                <a:cs typeface="Malgun Gothic"/>
+              </a:rPr>
+              <a:t>Harness Engineering</a:t>
+            </a:r>
+          </a:p>
+        </p:txBody>
+      </p:sp>
+      <p:sp>
+        <p:nvSpPr>
+          <p:cNvPr id="26" name="">
+            <a:extLst xmlns:a="http://schemas.openxmlformats.org/drawingml/2006/main">
+              <a:ext uri="{FF2B5EF4-FFF2-40B4-BE49-F238E27FC236}">
+                <a16:creationId xmlns:a16="http://schemas.microsoft.com/office/drawing/2014/main" id="{2CAA9895-C0C0-4890-A8C0-59BFE49B57B1}"/>
+              </a:ext>
+            </a:extLst>
+          </p:cNvPr>
+          <p:cNvSpPr>
+            <a:spLocks xmlns:a="http://schemas.openxmlformats.org/drawingml/2006/main" noGrp="1"/>
+          </p:cNvSpPr>
+          <p:nvPr/>
+        </p:nvSpPr>
+        <p:spPr>
+          <a:xfrm xmlns:a="http://schemas.openxmlformats.org/drawingml/2006/main">
+            <a:off x="2571750" y="4448175"/>
+            <a:ext cx="2247900" cy="209550"/>
+          </a:xfrm>
+          <a:prstGeom xmlns:a="http://schemas.openxmlformats.org/drawingml/2006/main" prst="rect">
+            <a:avLst/>
+          </a:prstGeom>
+          <a:solidFill xmlns:a="http://schemas.openxmlformats.org/drawingml/2006/main">
+            <a:srgbClr val="000000">
+              <a:alpha val="0"/>
+            </a:srgbClr>
+          </a:solidFill>
+          <a:ln xmlns:a="http://schemas.openxmlformats.org/drawingml/2006/main" w="0">
+            <a:solidFill>
+              <a:srgbClr val="000000">
+                <a:alpha val="0"/>
+              </a:srgbClr>
+            </a:solidFill>
+            <a:prstDash val="solid"/>
+          </a:ln>
+        </p:spPr>
+        <p:txBody>
+          <a:bodyPr xmlns:a="http://schemas.openxmlformats.org/drawingml/2006/main" lIns="0" tIns="0" rIns="0" bIns="0" anchor="t"/>
+          <a:lstStyle xmlns:a="http://schemas.openxmlformats.org/drawingml/2006/main"/>
+          <a:p xmlns:a="http://schemas.openxmlformats.org/drawingml/2006/main">
+            <a:pPr algn="l">
+              <a:defRPr sz="1125" b="0">
+                <a:solidFill>
+                  <a:srgbClr val="172026"/>
+                </a:solidFill>
+                <a:latin typeface="Malgun Gothic"/>
+                <a:ea typeface="Malgun Gothic"/>
+                <a:cs typeface="Malgun Gothic"/>
+              </a:defRPr>
+            </a:pPr>
+            <a:r>
+              <a:rPr sz="1125" b="0">
+                <a:solidFill>
+                  <a:srgbClr val="172026"/>
+                </a:solidFill>
+                <a:latin typeface="Malgun Gothic"/>
+                <a:ea typeface="Malgun Gothic"/>
+                <a:cs typeface="Malgun Gothic"/>
+              </a:rPr>
+              <a:t>반복 실행 환경</a:t>
+            </a:r>
+          </a:p>
+        </p:txBody>
+      </p:sp>
+      <p:sp>
+        <p:nvSpPr>
+          <p:cNvPr id="27" name="">
+            <a:extLst xmlns:a="http://schemas.openxmlformats.org/drawingml/2006/main">
+              <a:ext uri="{FF2B5EF4-FFF2-40B4-BE49-F238E27FC236}">
+                <a16:creationId xmlns:a16="http://schemas.microsoft.com/office/drawing/2014/main" id="{F03BD459-F530-441D-9619-6F9B9CBCCD0D}"/>
+              </a:ext>
+            </a:extLst>
+          </p:cNvPr>
+          <p:cNvSpPr>
+            <a:spLocks xmlns:a="http://schemas.openxmlformats.org/drawingml/2006/main" noGrp="1"/>
+          </p:cNvSpPr>
+          <p:nvPr/>
+        </p:nvSpPr>
+        <p:spPr>
+          <a:xfrm xmlns:a="http://schemas.openxmlformats.org/drawingml/2006/main">
+            <a:off x="4933950" y="4448175"/>
+            <a:ext cx="2457450" cy="209550"/>
+          </a:xfrm>
+          <a:prstGeom xmlns:a="http://schemas.openxmlformats.org/drawingml/2006/main" prst="rect">
+            <a:avLst/>
+          </a:prstGeom>
+          <a:solidFill xmlns:a="http://schemas.openxmlformats.org/drawingml/2006/main">
+            <a:srgbClr val="000000">
+              <a:alpha val="0"/>
+            </a:srgbClr>
+          </a:solidFill>
+          <a:ln xmlns:a="http://schemas.openxmlformats.org/drawingml/2006/main" w="0">
+            <a:solidFill>
+              <a:srgbClr val="000000">
+                <a:alpha val="0"/>
+              </a:srgbClr>
+            </a:solidFill>
+            <a:prstDash val="solid"/>
+          </a:ln>
+        </p:spPr>
+        <p:txBody>
+          <a:bodyPr xmlns:a="http://schemas.openxmlformats.org/drawingml/2006/main" lIns="0" tIns="0" rIns="0" bIns="0" anchor="t"/>
+          <a:lstStyle xmlns:a="http://schemas.openxmlformats.org/drawingml/2006/main"/>
+          <a:p xmlns:a="http://schemas.openxmlformats.org/drawingml/2006/main">
+            <a:pPr algn="l">
+              <a:defRPr sz="1125" b="0">
+                <a:solidFill>
+                  <a:srgbClr val="172026"/>
+                </a:solidFill>
+                <a:latin typeface="Malgun Gothic"/>
+                <a:ea typeface="Malgun Gothic"/>
+                <a:cs typeface="Malgun Gothic"/>
+              </a:defRPr>
+            </a:pPr>
+            <a:r>
+              <a:rPr sz="1125" b="0">
+                <a:solidFill>
+                  <a:srgbClr val="172026"/>
+                </a:solidFill>
+                <a:latin typeface="Malgun Gothic"/>
+                <a:ea typeface="Malgun Gothic"/>
+                <a:cs typeface="Malgun Gothic"/>
+              </a:rPr>
+              <a:t>매일 같은 품질로 어떻게 실행할까?</a:t>
+            </a:r>
+          </a:p>
+        </p:txBody>
+      </p:sp>
+      <p:sp>
+        <p:nvSpPr>
+          <p:cNvPr id="28" name="">
+            <a:extLst xmlns:a="http://schemas.openxmlformats.org/drawingml/2006/main">
+              <a:ext uri="{FF2B5EF4-FFF2-40B4-BE49-F238E27FC236}">
+                <a16:creationId xmlns:a16="http://schemas.microsoft.com/office/drawing/2014/main" id="{192A9808-32F5-461D-8099-2FE88B96C592}"/>
+              </a:ext>
+            </a:extLst>
+          </p:cNvPr>
+          <p:cNvSpPr>
+            <a:spLocks xmlns:a="http://schemas.openxmlformats.org/drawingml/2006/main" noGrp="1"/>
+          </p:cNvSpPr>
+          <p:nvPr/>
+        </p:nvSpPr>
+        <p:spPr>
+          <a:xfrm xmlns:a="http://schemas.openxmlformats.org/drawingml/2006/main">
+            <a:off x="7486650" y="4419600"/>
+            <a:ext cx="3886200" cy="285750"/>
+          </a:xfrm>
+          <a:prstGeom xmlns:a="http://schemas.openxmlformats.org/drawingml/2006/main" prst="rect">
+            <a:avLst/>
+          </a:prstGeom>
+          <a:solidFill xmlns:a="http://schemas.openxmlformats.org/drawingml/2006/main">
+            <a:srgbClr val="000000">
+              <a:alpha val="0"/>
+            </a:srgbClr>
+          </a:solidFill>
+          <a:ln xmlns:a="http://schemas.openxmlformats.org/drawingml/2006/main" w="0">
+            <a:solidFill>
+              <a:srgbClr val="000000">
+                <a:alpha val="0"/>
+              </a:srgbClr>
+            </a:solidFill>
+            <a:prstDash val="solid"/>
+          </a:ln>
+        </p:spPr>
+        <p:txBody>
+          <a:bodyPr xmlns:a="http://schemas.openxmlformats.org/drawingml/2006/main" lIns="0" tIns="0" rIns="0" bIns="0" anchor="t"/>
+          <a:lstStyle xmlns:a="http://schemas.openxmlformats.org/drawingml/2006/main"/>
+          <a:p xmlns:a="http://schemas.openxmlformats.org/drawingml/2006/main">
+            <a:pPr algn="l">
+              <a:defRPr sz="1050" b="0">
+                <a:solidFill>
+                  <a:srgbClr val="60707A"/>
+                </a:solidFill>
+                <a:latin typeface="Malgun Gothic"/>
+                <a:ea typeface="Malgun Gothic"/>
+                <a:cs typeface="Malgun Gothic"/>
+              </a:defRPr>
+            </a:pPr>
+            <a:r>
+              <a:rPr sz="1050" b="0">
+                <a:solidFill>
+                  <a:srgbClr val="60707A"/>
+                </a:solidFill>
+                <a:latin typeface="Malgun Gothic"/>
+                <a:ea typeface="Malgun Gothic"/>
+                <a:cs typeface="Malgun Gothic"/>
+              </a:rPr>
+              <a:t>56·57 Harness 병합 → 레슨 생성 → Pages 반영 → 카톡 발송</a:t>
+            </a:r>
+          </a:p>
+        </p:txBody>
+      </p:sp>
+      <p:sp>
+        <p:nvSpPr>
+          <p:cNvPr id="29" name="">
+            <a:extLst xmlns:a="http://schemas.openxmlformats.org/drawingml/2006/main">
+              <a:ext uri="{FF2B5EF4-FFF2-40B4-BE49-F238E27FC236}">
+                <a16:creationId xmlns:a16="http://schemas.microsoft.com/office/drawing/2014/main" id="{EE2E971D-9FBC-40A7-806D-720473F7128E}"/>
+              </a:ext>
+            </a:extLst>
+          </p:cNvPr>
+          <p:cNvSpPr>
+            <a:spLocks xmlns:a="http://schemas.openxmlformats.org/drawingml/2006/main" noGrp="1"/>
+          </p:cNvSpPr>
+          <p:nvPr/>
+        </p:nvSpPr>
+        <p:spPr>
+          <a:xfrm xmlns:a="http://schemas.openxmlformats.org/drawingml/2006/main">
+            <a:off x="533400" y="4838700"/>
+            <a:ext cx="11125200" cy="514350"/>
+          </a:xfrm>
+          <a:prstGeom xmlns:a="http://schemas.openxmlformats.org/drawingml/2006/main" prst="roundRect">
+            <a:avLst>
+              <a:gd name="adj" fmla="val 14815"/>
+            </a:avLst>
+          </a:prstGeom>
+          <a:solidFill xmlns:a="http://schemas.openxmlformats.org/drawingml/2006/main">
+            <a:srgbClr val="FFFFFF"/>
+          </a:solidFill>
+          <a:ln xmlns:a="http://schemas.openxmlformats.org/drawingml/2006/main" w="9525">
+            <a:solidFill>
+              <a:srgbClr val="C9D5D8"/>
+            </a:solidFill>
+            <a:prstDash val="solid"/>
+          </a:ln>
+        </p:spPr>
+      </p:sp>
+      <p:sp>
+        <p:nvSpPr>
+          <p:cNvPr id="30" name="">
+            <a:extLst xmlns:a="http://schemas.openxmlformats.org/drawingml/2006/main">
+              <a:ext uri="{FF2B5EF4-FFF2-40B4-BE49-F238E27FC236}">
+                <a16:creationId xmlns:a16="http://schemas.microsoft.com/office/drawing/2014/main" id="{7BB3A2A1-EED0-44B8-ADB0-0B48FFA0F47B}"/>
+              </a:ext>
+            </a:extLst>
+          </p:cNvPr>
+          <p:cNvSpPr>
+            <a:spLocks xmlns:a="http://schemas.openxmlformats.org/drawingml/2006/main" noGrp="1"/>
+          </p:cNvSpPr>
+          <p:nvPr/>
+        </p:nvSpPr>
+        <p:spPr>
+          <a:xfrm xmlns:a="http://schemas.openxmlformats.org/drawingml/2006/main">
+            <a:off x="666750" y="4981575"/>
+            <a:ext cx="1790700" cy="209550"/>
+          </a:xfrm>
+          <a:prstGeom xmlns:a="http://schemas.openxmlformats.org/drawingml/2006/main" prst="rect">
+            <a:avLst/>
+          </a:prstGeom>
+          <a:solidFill xmlns:a="http://schemas.openxmlformats.org/drawingml/2006/main">
+            <a:srgbClr val="000000">
+              <a:alpha val="0"/>
+            </a:srgbClr>
+          </a:solidFill>
+          <a:ln xmlns:a="http://schemas.openxmlformats.org/drawingml/2006/main" w="0">
+            <a:solidFill>
+              <a:srgbClr val="000000">
+                <a:alpha val="0"/>
+              </a:srgbClr>
+            </a:solidFill>
+            <a:prstDash val="solid"/>
+          </a:ln>
+        </p:spPr>
+        <p:txBody>
+          <a:bodyPr xmlns:a="http://schemas.openxmlformats.org/drawingml/2006/main" lIns="0" tIns="0" rIns="0" bIns="0" anchor="t"/>
+          <a:lstStyle xmlns:a="http://schemas.openxmlformats.org/drawingml/2006/main"/>
+          <a:p xmlns:a="http://schemas.openxmlformats.org/drawingml/2006/main">
+            <a:pPr algn="l">
+              <a:defRPr sz="1200" b="1">
+                <a:solidFill>
+                  <a:srgbClr val="172026"/>
+                </a:solidFill>
+                <a:latin typeface="Malgun Gothic"/>
+                <a:ea typeface="Malgun Gothic"/>
+                <a:cs typeface="Malgun Gothic"/>
+              </a:defRPr>
+            </a:pPr>
+            <a:r>
+              <a:rPr sz="1200" b="1">
+                <a:solidFill>
+                  <a:srgbClr val="172026"/>
+                </a:solidFill>
+                <a:latin typeface="Malgun Gothic"/>
+                <a:ea typeface="Malgun Gothic"/>
+                <a:cs typeface="Malgun Gothic"/>
+              </a:rPr>
+              <a:t>Agent Engineering</a:t>
+            </a:r>
+          </a:p>
+        </p:txBody>
+      </p:sp>
+      <p:sp>
+        <p:nvSpPr>
+          <p:cNvPr id="31" name="">
+            <a:extLst xmlns:a="http://schemas.openxmlformats.org/drawingml/2006/main">
+              <a:ext uri="{FF2B5EF4-FFF2-40B4-BE49-F238E27FC236}">
+                <a16:creationId xmlns:a16="http://schemas.microsoft.com/office/drawing/2014/main" id="{706BEC64-FF3C-4DA6-9947-E353CBA9588B}"/>
+              </a:ext>
+            </a:extLst>
+          </p:cNvPr>
+          <p:cNvSpPr>
+            <a:spLocks xmlns:a="http://schemas.openxmlformats.org/drawingml/2006/main" noGrp="1"/>
+          </p:cNvSpPr>
+          <p:nvPr/>
+        </p:nvSpPr>
+        <p:spPr>
+          <a:xfrm xmlns:a="http://schemas.openxmlformats.org/drawingml/2006/main">
+            <a:off x="2571750" y="4981575"/>
+            <a:ext cx="2247900" cy="209550"/>
+          </a:xfrm>
+          <a:prstGeom xmlns:a="http://schemas.openxmlformats.org/drawingml/2006/main" prst="rect">
+            <a:avLst/>
+          </a:prstGeom>
+          <a:solidFill xmlns:a="http://schemas.openxmlformats.org/drawingml/2006/main">
+            <a:srgbClr val="000000">
+              <a:alpha val="0"/>
+            </a:srgbClr>
+          </a:solidFill>
+          <a:ln xmlns:a="http://schemas.openxmlformats.org/drawingml/2006/main" w="0">
+            <a:solidFill>
+              <a:srgbClr val="000000">
+                <a:alpha val="0"/>
+              </a:srgbClr>
+            </a:solidFill>
+            <a:prstDash val="solid"/>
+          </a:ln>
+        </p:spPr>
+        <p:txBody>
+          <a:bodyPr xmlns:a="http://schemas.openxmlformats.org/drawingml/2006/main" lIns="0" tIns="0" rIns="0" bIns="0" anchor="t"/>
+          <a:lstStyle xmlns:a="http://schemas.openxmlformats.org/drawingml/2006/main"/>
+          <a:p xmlns:a="http://schemas.openxmlformats.org/drawingml/2006/main">
+            <a:pPr algn="l">
+              <a:defRPr sz="1125" b="0">
+                <a:solidFill>
+                  <a:srgbClr val="172026"/>
+                </a:solidFill>
+                <a:latin typeface="Malgun Gothic"/>
+                <a:ea typeface="Malgun Gothic"/>
+                <a:cs typeface="Malgun Gothic"/>
+              </a:defRPr>
+            </a:pPr>
+            <a:r>
+              <a:rPr sz="1125" b="0">
+                <a:solidFill>
+                  <a:srgbClr val="172026"/>
+                </a:solidFill>
+                <a:latin typeface="Malgun Gothic"/>
+                <a:ea typeface="Malgun Gothic"/>
+                <a:cs typeface="Malgun Gothic"/>
+              </a:rPr>
+              <a:t>역할과 협업 방식</a:t>
+            </a:r>
+          </a:p>
+        </p:txBody>
+      </p:sp>
+      <p:sp>
+        <p:nvSpPr>
+          <p:cNvPr id="32" name="">
+            <a:extLst xmlns:a="http://schemas.openxmlformats.org/drawingml/2006/main">
+              <a:ext uri="{FF2B5EF4-FFF2-40B4-BE49-F238E27FC236}">
+                <a16:creationId xmlns:a16="http://schemas.microsoft.com/office/drawing/2014/main" id="{F6F5D0E0-A88F-4062-8749-3A9563C35690}"/>
+              </a:ext>
+            </a:extLst>
+          </p:cNvPr>
+          <p:cNvSpPr>
+            <a:spLocks xmlns:a="http://schemas.openxmlformats.org/drawingml/2006/main" noGrp="1"/>
+          </p:cNvSpPr>
+          <p:nvPr/>
+        </p:nvSpPr>
+        <p:spPr>
+          <a:xfrm xmlns:a="http://schemas.openxmlformats.org/drawingml/2006/main">
+            <a:off x="4933950" y="4981575"/>
+            <a:ext cx="2457450" cy="209550"/>
+          </a:xfrm>
+          <a:prstGeom xmlns:a="http://schemas.openxmlformats.org/drawingml/2006/main" prst="rect">
+            <a:avLst/>
+          </a:prstGeom>
+          <a:solidFill xmlns:a="http://schemas.openxmlformats.org/drawingml/2006/main">
+            <a:srgbClr val="000000">
+              <a:alpha val="0"/>
+            </a:srgbClr>
+          </a:solidFill>
+          <a:ln xmlns:a="http://schemas.openxmlformats.org/drawingml/2006/main" w="0">
+            <a:solidFill>
+              <a:srgbClr val="000000">
+                <a:alpha val="0"/>
+              </a:srgbClr>
+            </a:solidFill>
+            <a:prstDash val="solid"/>
+          </a:ln>
+        </p:spPr>
+        <p:txBody>
+          <a:bodyPr xmlns:a="http://schemas.openxmlformats.org/drawingml/2006/main" lIns="0" tIns="0" rIns="0" bIns="0" anchor="t"/>
+          <a:lstStyle xmlns:a="http://schemas.openxmlformats.org/drawingml/2006/main"/>
+          <a:p xmlns:a="http://schemas.openxmlformats.org/drawingml/2006/main">
+            <a:pPr algn="l">
+              <a:defRPr sz="1125" b="0">
+                <a:solidFill>
+                  <a:srgbClr val="172026"/>
+                </a:solidFill>
+                <a:latin typeface="Malgun Gothic"/>
+                <a:ea typeface="Malgun Gothic"/>
+                <a:cs typeface="Malgun Gothic"/>
+              </a:defRPr>
+            </a:pPr>
+            <a:r>
+              <a:rPr sz="1125" b="0">
+                <a:solidFill>
+                  <a:srgbClr val="172026"/>
+                </a:solidFill>
+                <a:latin typeface="Malgun Gothic"/>
+                <a:ea typeface="Malgun Gothic"/>
+                <a:cs typeface="Malgun Gothic"/>
+              </a:rPr>
+              <a:t>어떤 역할이 판단하고 검증할까?</a:t>
+            </a:r>
+          </a:p>
+        </p:txBody>
+      </p:sp>
+      <p:sp>
+        <p:nvSpPr>
+          <p:cNvPr id="33" name="">
+            <a:extLst xmlns:a="http://schemas.openxmlformats.org/drawingml/2006/main">
+              <a:ext uri="{FF2B5EF4-FFF2-40B4-BE49-F238E27FC236}">
+                <a16:creationId xmlns:a16="http://schemas.microsoft.com/office/drawing/2014/main" id="{1182A8AE-DED2-4EB1-8C32-81744A843EE2}"/>
+              </a:ext>
+            </a:extLst>
+          </p:cNvPr>
+          <p:cNvSpPr>
+            <a:spLocks xmlns:a="http://schemas.openxmlformats.org/drawingml/2006/main" noGrp="1"/>
+          </p:cNvSpPr>
+          <p:nvPr/>
+        </p:nvSpPr>
+        <p:spPr>
+          <a:xfrm xmlns:a="http://schemas.openxmlformats.org/drawingml/2006/main">
+            <a:off x="7486650" y="4953000"/>
+            <a:ext cx="3886200" cy="285750"/>
+          </a:xfrm>
+          <a:prstGeom xmlns:a="http://schemas.openxmlformats.org/drawingml/2006/main" prst="rect">
+            <a:avLst/>
+          </a:prstGeom>
+          <a:solidFill xmlns:a="http://schemas.openxmlformats.org/drawingml/2006/main">
+            <a:srgbClr val="000000">
+              <a:alpha val="0"/>
+            </a:srgbClr>
+          </a:solidFill>
+          <a:ln xmlns:a="http://schemas.openxmlformats.org/drawingml/2006/main" w="0">
+            <a:solidFill>
+              <a:srgbClr val="000000">
+                <a:alpha val="0"/>
+              </a:srgbClr>
+            </a:solidFill>
+            <a:prstDash val="solid"/>
+          </a:ln>
+        </p:spPr>
+        <p:txBody>
+          <a:bodyPr xmlns:a="http://schemas.openxmlformats.org/drawingml/2006/main" lIns="0" tIns="0" rIns="0" bIns="0" anchor="t"/>
+          <a:lstStyle xmlns:a="http://schemas.openxmlformats.org/drawingml/2006/main"/>
+          <a:p xmlns:a="http://schemas.openxmlformats.org/drawingml/2006/main">
+            <a:pPr algn="l">
+              <a:defRPr sz="1050" b="0">
+                <a:solidFill>
+                  <a:srgbClr val="60707A"/>
+                </a:solidFill>
+                <a:latin typeface="Malgun Gothic"/>
+                <a:ea typeface="Malgun Gothic"/>
+                <a:cs typeface="Malgun Gothic"/>
+              </a:defRPr>
+            </a:pPr>
+            <a:r>
+              <a:rPr sz="1050" b="0">
+                <a:solidFill>
+                  <a:srgbClr val="60707A"/>
+                </a:solidFill>
+                <a:latin typeface="Malgun Gothic"/>
+                <a:ea typeface="Malgun Gothic"/>
+                <a:cs typeface="Malgun Gothic"/>
+              </a:rPr>
+              <a:t>lesson-tutor, examiner, error-analyst가 역할별로 작업</a:t>
+            </a:r>
+          </a:p>
+        </p:txBody>
+      </p:sp>
+      <p:sp>
+        <p:nvSpPr>
+          <p:cNvPr id="34" name="">
+            <a:extLst xmlns:a="http://schemas.openxmlformats.org/drawingml/2006/main">
+              <a:ext uri="{FF2B5EF4-FFF2-40B4-BE49-F238E27FC236}">
+                <a16:creationId xmlns:a16="http://schemas.microsoft.com/office/drawing/2014/main" id="{24CF3492-00A1-4268-A445-84F09F01B169}"/>
+              </a:ext>
+            </a:extLst>
+          </p:cNvPr>
+          <p:cNvSpPr>
+            <a:spLocks xmlns:a="http://schemas.openxmlformats.org/drawingml/2006/main" noGrp="1"/>
+          </p:cNvSpPr>
+          <p:nvPr/>
+        </p:nvSpPr>
+        <p:spPr>
+          <a:xfrm xmlns:a="http://schemas.openxmlformats.org/drawingml/2006/main">
+            <a:off x="666750" y="5562600"/>
+            <a:ext cx="1028700" cy="266700"/>
+          </a:xfrm>
+          <a:prstGeom xmlns:a="http://schemas.openxmlformats.org/drawingml/2006/main" prst="roundRect">
+            <a:avLst>
+              <a:gd name="adj" fmla="val 28571"/>
+            </a:avLst>
+          </a:prstGeom>
+          <a:solidFill xmlns:a="http://schemas.openxmlformats.org/drawingml/2006/main">
+            <a:srgbClr val="E76F51"/>
+          </a:solidFill>
+          <a:ln xmlns:a="http://schemas.openxmlformats.org/drawingml/2006/main" w="0">
+            <a:solidFill>
+              <a:srgbClr val="E76F51"/>
+            </a:solidFill>
+            <a:prstDash val="solid"/>
+          </a:ln>
+        </p:spPr>
+      </p:sp>
+      <p:sp>
+        <p:nvSpPr>
+          <p:cNvPr id="35" name="">
+            <a:extLst xmlns:a="http://schemas.openxmlformats.org/drawingml/2006/main">
+              <a:ext uri="{FF2B5EF4-FFF2-40B4-BE49-F238E27FC236}">
+                <a16:creationId xmlns:a16="http://schemas.microsoft.com/office/drawing/2014/main" id="{B477292B-C1DF-4BF9-81DF-E59E8F4DD697}"/>
+              </a:ext>
+            </a:extLst>
+          </p:cNvPr>
+          <p:cNvSpPr>
+            <a:spLocks xmlns:a="http://schemas.openxmlformats.org/drawingml/2006/main" noGrp="1"/>
+          </p:cNvSpPr>
+          <p:nvPr/>
+        </p:nvSpPr>
+        <p:spPr>
+          <a:xfrm xmlns:a="http://schemas.openxmlformats.org/drawingml/2006/main">
+            <a:off x="666750" y="5610225"/>
+            <a:ext cx="1028700" cy="171450"/>
+          </a:xfrm>
+          <a:prstGeom xmlns:a="http://schemas.openxmlformats.org/drawingml/2006/main" prst="rect">
+            <a:avLst/>
+          </a:prstGeom>
+          <a:solidFill xmlns:a="http://schemas.openxmlformats.org/drawingml/2006/main">
+            <a:srgbClr val="000000">
+              <a:alpha val="0"/>
+            </a:srgbClr>
+          </a:solidFill>
+          <a:ln xmlns:a="http://schemas.openxmlformats.org/drawingml/2006/main" w="0">
+            <a:solidFill>
+              <a:srgbClr val="000000">
+                <a:alpha val="0"/>
+              </a:srgbClr>
+            </a:solidFill>
+            <a:prstDash val="solid"/>
+          </a:ln>
+        </p:spPr>
+        <p:txBody>
+          <a:bodyPr xmlns:a="http://schemas.openxmlformats.org/drawingml/2006/main" lIns="0" tIns="0" rIns="0" bIns="0" anchor="t"/>
+          <a:lstStyle xmlns:a="http://schemas.openxmlformats.org/drawingml/2006/main"/>
+          <a:p xmlns:a="http://schemas.openxmlformats.org/drawingml/2006/main">
+            <a:pPr algn="ctr">
+              <a:defRPr sz="975" b="1">
+                <a:solidFill>
+                  <a:srgbClr val="FFFFFF"/>
+                </a:solidFill>
+                <a:latin typeface="Malgun Gothic"/>
+                <a:ea typeface="Malgun Gothic"/>
+                <a:cs typeface="Malgun Gothic"/>
+              </a:defRPr>
+            </a:pPr>
+            <a:r>
+              <a:rPr sz="975" b="1">
+                <a:solidFill>
+                  <a:srgbClr val="FFFFFF"/>
+                </a:solidFill>
+                <a:latin typeface="Malgun Gothic"/>
+                <a:ea typeface="Malgun Gothic"/>
+                <a:cs typeface="Malgun Gothic"/>
+              </a:rPr>
+              <a:t>THIS PROJECT</a:t>
+            </a:r>
+          </a:p>
+        </p:txBody>
+      </p:sp>
+      <p:sp>
+        <p:nvSpPr>
+          <p:cNvPr id="36" name="">
+            <a:extLst xmlns:a="http://schemas.openxmlformats.org/drawingml/2006/main">
+              <a:ext uri="{FF2B5EF4-FFF2-40B4-BE49-F238E27FC236}">
+                <a16:creationId xmlns:a16="http://schemas.microsoft.com/office/drawing/2014/main" id="{5ADD97D8-6B76-4C5C-991C-F8090CAF6F33}"/>
+              </a:ext>
+            </a:extLst>
+          </p:cNvPr>
+          <p:cNvSpPr>
+            <a:spLocks xmlns:a="http://schemas.openxmlformats.org/drawingml/2006/main" noGrp="1"/>
+          </p:cNvSpPr>
+          <p:nvPr/>
+        </p:nvSpPr>
+        <p:spPr>
+          <a:xfrm xmlns:a="http://schemas.openxmlformats.org/drawingml/2006/main">
+            <a:off x="1866900" y="5619750"/>
+            <a:ext cx="8096250" cy="209550"/>
+          </a:xfrm>
+          <a:prstGeom xmlns:a="http://schemas.openxmlformats.org/drawingml/2006/main" prst="rect">
+            <a:avLst/>
+          </a:prstGeom>
+          <a:solidFill xmlns:a="http://schemas.openxmlformats.org/drawingml/2006/main">
+            <a:srgbClr val="000000">
+              <a:alpha val="0"/>
+            </a:srgbClr>
+          </a:solidFill>
+          <a:ln xmlns:a="http://schemas.openxmlformats.org/drawingml/2006/main" w="0">
+            <a:solidFill>
+              <a:srgbClr val="000000">
+                <a:alpha val="0"/>
+              </a:srgbClr>
+            </a:solidFill>
+            <a:prstDash val="solid"/>
+          </a:ln>
+        </p:spPr>
+        <p:txBody>
+          <a:bodyPr xmlns:a="http://schemas.openxmlformats.org/drawingml/2006/main" lIns="0" tIns="0" rIns="0" bIns="0" anchor="t"/>
+          <a:lstStyle xmlns:a="http://schemas.openxmlformats.org/drawingml/2006/main"/>
+          <a:p xmlns:a="http://schemas.openxmlformats.org/drawingml/2006/main">
+            <a:pPr algn="l">
+              <a:defRPr sz="1275" b="1">
+                <a:solidFill>
+                  <a:srgbClr val="172026"/>
+                </a:solidFill>
+                <a:latin typeface="Malgun Gothic"/>
+                <a:ea typeface="Malgun Gothic"/>
+                <a:cs typeface="Malgun Gothic"/>
+              </a:defRPr>
+            </a:pPr>
+            <a:r>
+              <a:rPr sz="1275" b="1">
+                <a:solidFill>
+                  <a:srgbClr val="172026"/>
+                </a:solidFill>
+                <a:latin typeface="Malgun Gothic"/>
+                <a:ea typeface="Malgun Gothic"/>
+                <a:cs typeface="Malgun Gothic"/>
+              </a:rPr>
+              <a:t>핵심은 좋은 프롬프트 1개가 아니라, 학습이 매일 도착하도록 만든 Harness입니다.</a:t>
+            </a:r>
+          </a:p>
+        </p:txBody>
+      </p:sp>
+      <p:sp>
+        <p:nvSpPr>
+          <p:cNvPr id="37" name="">
+            <a:extLst xmlns:a="http://schemas.openxmlformats.org/drawingml/2006/main">
+              <a:ext uri="{FF2B5EF4-FFF2-40B4-BE49-F238E27FC236}">
+                <a16:creationId xmlns:a16="http://schemas.microsoft.com/office/drawing/2014/main" id="{682C62C5-933C-4BDB-9E05-66F6A2066ACF}"/>
+              </a:ext>
+            </a:extLst>
+          </p:cNvPr>
+          <p:cNvSpPr>
+            <a:spLocks xmlns:a="http://schemas.openxmlformats.org/drawingml/2006/main" noGrp="1"/>
+          </p:cNvSpPr>
+          <p:nvPr/>
+        </p:nvSpPr>
+        <p:spPr>
+          <a:xfrm xmlns:a="http://schemas.openxmlformats.org/drawingml/2006/main">
+            <a:off x="533400" y="6429375"/>
+            <a:ext cx="11125200" cy="9525"/>
+          </a:xfrm>
+          <a:prstGeom xmlns:a="http://schemas.openxmlformats.org/drawingml/2006/main" prst="rect">
+            <a:avLst/>
+          </a:prstGeom>
+          <a:solidFill xmlns:a="http://schemas.openxmlformats.org/drawingml/2006/main">
+            <a:srgbClr val="C9D5D8"/>
+          </a:solidFill>
+          <a:ln xmlns:a="http://schemas.openxmlformats.org/drawingml/2006/main" w="0">
+            <a:solidFill>
+              <a:srgbClr val="C9D5D8"/>
+            </a:solidFill>
+            <a:prstDash val="solid"/>
+          </a:ln>
+        </p:spPr>
+      </p:sp>
+      <p:sp>
+        <p:nvSpPr>
+          <p:cNvPr id="38" name="">
+            <a:extLst xmlns:a="http://schemas.openxmlformats.org/drawingml/2006/main">
+              <a:ext uri="{FF2B5EF4-FFF2-40B4-BE49-F238E27FC236}">
+                <a16:creationId xmlns:a16="http://schemas.microsoft.com/office/drawing/2014/main" id="{B57B7590-8C0D-473E-B38F-8CEC8492206B}"/>
+              </a:ext>
+            </a:extLst>
+          </p:cNvPr>
+          <p:cNvSpPr>
+            <a:spLocks xmlns:a="http://schemas.openxmlformats.org/drawingml/2006/main" noGrp="1"/>
+          </p:cNvSpPr>
+          <p:nvPr/>
+        </p:nvSpPr>
+        <p:spPr>
+          <a:xfrm xmlns:a="http://schemas.openxmlformats.org/drawingml/2006/main">
+            <a:off x="533400" y="6534150"/>
+            <a:ext cx="7239000" cy="171450"/>
+          </a:xfrm>
+          <a:prstGeom xmlns:a="http://schemas.openxmlformats.org/drawingml/2006/main" prst="rect">
+            <a:avLst/>
+          </a:prstGeom>
+          <a:solidFill xmlns:a="http://schemas.openxmlformats.org/drawingml/2006/main">
+            <a:srgbClr val="000000">
+              <a:alpha val="0"/>
+            </a:srgbClr>
+          </a:solidFill>
+          <a:ln xmlns:a="http://schemas.openxmlformats.org/drawingml/2006/main" w="0">
+            <a:solidFill>
+              <a:srgbClr val="000000">
+                <a:alpha val="0"/>
+              </a:srgbClr>
+            </a:solidFill>
+            <a:prstDash val="solid"/>
+          </a:ln>
+        </p:spPr>
+        <p:txBody>
+          <a:bodyPr xmlns:a="http://schemas.openxmlformats.org/drawingml/2006/main" lIns="0" tIns="0" rIns="0" bIns="0" anchor="t"/>
+          <a:lstStyle xmlns:a="http://schemas.openxmlformats.org/drawingml/2006/main"/>
+          <a:p xmlns:a="http://schemas.openxmlformats.org/drawingml/2006/main">
+            <a:pPr algn="l">
+              <a:defRPr sz="825" b="0">
+                <a:solidFill>
+                  <a:srgbClr val="60707A"/>
+                </a:solidFill>
+                <a:latin typeface="Malgun Gothic"/>
+                <a:ea typeface="Malgun Gothic"/>
+                <a:cs typeface="Malgun Gothic"/>
+              </a:defRPr>
+            </a:pPr>
+            <a:r>
+              <a:rPr sz="825" b="0">
+                <a:solidFill>
+                  <a:srgbClr val="60707A"/>
+                </a:solidFill>
+                <a:latin typeface="Malgun Gothic"/>
+                <a:ea typeface="Malgun Gothic"/>
+                <a:cs typeface="Malgun Gothic"/>
+              </a:rPr>
+              <a:t>Language Study · Appendix</a:t>
+            </a:r>
+          </a:p>
+        </p:txBody>
+      </p:sp>
+      <p:sp>
+        <p:nvSpPr>
+          <p:cNvPr id="39" name="">
+            <a:extLst xmlns:a="http://schemas.openxmlformats.org/drawingml/2006/main">
+              <a:ext uri="{FF2B5EF4-FFF2-40B4-BE49-F238E27FC236}">
+                <a16:creationId xmlns:a16="http://schemas.microsoft.com/office/drawing/2014/main" id="{7B2DBA5B-EB89-478E-BE8C-E14E7785109A}"/>
+              </a:ext>
+            </a:extLst>
+          </p:cNvPr>
+          <p:cNvSpPr>
+            <a:spLocks xmlns:a="http://schemas.openxmlformats.org/drawingml/2006/main" noGrp="1"/>
+          </p:cNvSpPr>
+          <p:nvPr/>
+        </p:nvSpPr>
+        <p:spPr>
+          <a:xfrm xmlns:a="http://schemas.openxmlformats.org/drawingml/2006/main">
+            <a:off x="11144250" y="6515100"/>
+            <a:ext cx="514350" cy="171450"/>
+          </a:xfrm>
+          <a:prstGeom xmlns:a="http://schemas.openxmlformats.org/drawingml/2006/main" prst="rect">
+            <a:avLst/>
+          </a:prstGeom>
+          <a:solidFill xmlns:a="http://schemas.openxmlformats.org/drawingml/2006/main">
+            <a:srgbClr val="000000">
+              <a:alpha val="0"/>
+            </a:srgbClr>
+          </a:solidFill>
+          <a:ln xmlns:a="http://schemas.openxmlformats.org/drawingml/2006/main" w="0">
+            <a:solidFill>
+              <a:srgbClr val="000000">
+                <a:alpha val="0"/>
+              </a:srgbClr>
+            </a:solidFill>
+            <a:prstDash val="solid"/>
+          </a:ln>
+        </p:spPr>
+        <p:txBody>
+          <a:bodyPr xmlns:a="http://schemas.openxmlformats.org/drawingml/2006/main" lIns="0" tIns="0" rIns="0" bIns="0" anchor="t"/>
+          <a:lstStyle xmlns:a="http://schemas.openxmlformats.org/drawingml/2006/main"/>
+          <a:p xmlns:a="http://schemas.openxmlformats.org/drawingml/2006/main">
+            <a:pPr algn="r">
+              <a:defRPr sz="825" b="1">
+                <a:solidFill>
+                  <a:srgbClr val="60707A"/>
+                </a:solidFill>
+                <a:latin typeface="Aptos Display"/>
+                <a:ea typeface="Aptos Display"/>
+                <a:cs typeface="Aptos Display"/>
+              </a:defRPr>
+            </a:pPr>
+            <a:r>
+              <a:rPr sz="825" b="1">
+                <a:solidFill>
+                  <a:srgbClr val="60707A"/>
+                </a:solidFill>
+                <a:latin typeface="Aptos Display"/>
+                <a:ea typeface="Aptos Display"/>
+                <a:cs typeface="Aptos Display"/>
+              </a:rPr>
+              <a:t>04</a:t>
+            </a:r>
+          </a:p>
+        </p:txBody>
+      </p:sp>
+    </p:spTree>
+    <p:extLst>
+      <p:ext uri="{BB962C8B-B14F-4D97-AF65-F5344CB8AC3E}">
+        <p14:creationId xmlns:p14="http://schemas.microsoft.com/office/powerpoint/2010/main" val="1499281852"/>
       </p:ext>
     </p:extLst>
   </p:cSld>

</xml_diff>